<commit_message>
Deck: cut filler text, enlarge key visuals (close-ups, duplicate pair, heatmaps, missed example, dashboard)
Co-Authored-By: Claude Opus 5.5 <noreply@anthropic.com>
</commit_message>
<xml_diff>
--- a/docs/submission/BatteryVision_발표.pptx
+++ b/docs/submission/BatteryVision_발표.pptx
@@ -116,13 +116,13 @@
   <p:extLst>
     <p:ext uri="{521415D9-36F7-43E2-AB2F-B90AF26B5E84}">
       <p14:sectionLst xmlns:p14="http://schemas.microsoft.com/office/powerpoint/2010/main">
-        <p14:section name="도입" id="{fde2eb51-ee1a-0a59-9971-5fe9a83b519f}">
+        <p14:section name="도입" id="{bb454593-116b-a06a-9ff6-363bac965195}">
           <p14:sldIdLst>
             <p14:sldId id="256"/>
             <p14:sldId id="257"/>
           </p14:sldIdLst>
         </p14:section>
-        <p14:section name="실험" id="{b8de3005-0c15-3584-11a4-6e3697357e65}">
+        <p14:section name="실험" id="{c6f94ea2-1a58-32b7-37ea-201e44d4d77a}">
           <p14:sldIdLst>
             <p14:sldId id="258"/>
             <p14:sldId id="259"/>
@@ -130,17 +130,17 @@
             <p14:sldId id="261"/>
           </p14:sldIdLst>
         </p14:section>
-        <p14:section name="최적화" id="{126eb760-b783-7f4b-d3bf-fdc764f0ed74}">
+        <p14:section name="최적화" id="{102d892e-0fef-e090-1c18-a23803b32489}">
           <p14:sldIdLst>
             <p14:sldId id="262"/>
           </p14:sldIdLst>
         </p14:section>
-        <p14:section name="검증" id="{0919a729-0b52-4760-548c-32a4fbfd86ad}">
+        <p14:section name="검증" id="{41b6718e-cc93-73b0-8754-2ba65256846e}">
           <p14:sldIdLst>
             <p14:sldId id="263"/>
           </p14:sldIdLst>
         </p14:section>
-        <p14:section name="정리" id="{e13845a6-9f4e-b63b-1147-a6d6b0cb9c57}">
+        <p14:section name="정리" id="{1f389ea8-297a-f3fe-897f-76397c938f0c}">
           <p14:sldIdLst>
             <p14:sldId id="264"/>
             <p14:sldId id="265"/>
@@ -386,7 +386,7 @@
           <c:showBubbleSize val="0"/>
           <c:showLeaderLines val="0"/>
         </c:dLbls>
-        <c:gapWidth val="60"/>
+        <c:gapWidth val="50"/>
         <c:overlap val="0"/>
         <c:axId val="2094734554"/>
         <c:axId val="2094734552"/>
@@ -2909,8 +2909,8 @@
         </p:blipFill>
         <p:spPr>
           <a:xfrm>
-            <a:off x="548640" y="1645920"/>
-            <a:ext cx="7680960" cy="3816301"/>
+            <a:off x="548640" y="1600200"/>
+            <a:ext cx="8321040" cy="4134326"/>
           </a:xfrm>
           <a:prstGeom prst="rect">
             <a:avLst/>
@@ -2925,12 +2925,12 @@
         </p:nvSpPr>
         <p:spPr>
           <a:xfrm>
-            <a:off x="8458200" y="1645920"/>
-            <a:ext cx="3182112" cy="3816301"/>
+            <a:off x="9052560" y="1600200"/>
+            <a:ext cx="2587752" cy="4134326"/>
           </a:xfrm>
           <a:prstGeom prst="roundRect">
             <a:avLst>
-              <a:gd name="adj" fmla="val 2299"/>
+              <a:gd name="adj" fmla="val 2827"/>
             </a:avLst>
           </a:prstGeom>
           <a:solidFill>
@@ -2947,8 +2947,8 @@
         </p:nvSpPr>
         <p:spPr>
           <a:xfrm>
-            <a:off x="8686800" y="1874520"/>
-            <a:ext cx="2788920" cy="3383280"/>
+            <a:off x="9281160" y="1828800"/>
+            <a:ext cx="2240280" cy="3657600"/>
           </a:xfrm>
           <a:prstGeom prst="rect">
             <a:avLst/>
@@ -2973,7 +2973,7 @@
                   <a:schemeClr val="tx1"/>
                 </a:solidFill>
               </a:rPr>
-              <a:t>카메라 → 모델 → PASS · REVIEW · REJECT 분류</a:t>
+              <a:t>카메라 → 모델 → 판정</a:t>
             </a:r>
             <a:endParaRPr lang="en-US" sz="1400" dirty="0"/>
           </a:p>
@@ -2991,7 +2991,7 @@
                   <a:schemeClr val="tx1"/>
                 </a:solidFill>
               </a:rPr>
-              <a:t>결함 위치 heatmap과 모델 해시를 기록</a:t>
+              <a:t>heatmap · 해시 기록</a:t>
             </a:r>
             <a:endParaRPr lang="en-US" sz="1400" dirty="0"/>
           </a:p>
@@ -3009,7 +3009,7 @@
                   <a:schemeClr val="tx1"/>
                 </a:solidFill>
               </a:rPr>
-              <a:t>로트별 결함 추적 (Batches)</a:t>
+              <a:t>로트별 추적</a:t>
             </a:r>
             <a:endParaRPr lang="en-US" sz="1400" dirty="0"/>
           </a:p>
@@ -3027,7 +3027,7 @@
                   <a:schemeClr val="tx2"/>
                 </a:solidFill>
               </a:rPr>
-              <a:t>가상 라인이며 실제 장비와 연결되지 않음</a:t>
+              <a:t>실제 장비 미연결</a:t>
             </a:r>
             <a:endParaRPr lang="en-US" sz="1400" dirty="0"/>
           </a:p>
@@ -3255,8 +3255,8 @@
         </p:blipFill>
         <p:spPr>
           <a:xfrm>
-            <a:off x="548640" y="1691640"/>
-            <a:ext cx="2651760" cy="2651760"/>
+            <a:off x="548640" y="1645920"/>
+            <a:ext cx="3108960" cy="3108960"/>
           </a:xfrm>
           <a:prstGeom prst="rect">
             <a:avLst/>
@@ -3271,7 +3271,7 @@
         </p:nvSpPr>
         <p:spPr>
           <a:xfrm>
-            <a:off x="548640" y="4526280"/>
+            <a:off x="548640" y="4956048"/>
             <a:ext cx="146304" cy="146304"/>
           </a:xfrm>
           <a:prstGeom prst="ellipse">
@@ -3291,8 +3291,8 @@
         </p:nvSpPr>
         <p:spPr>
           <a:xfrm>
-            <a:off x="786384" y="4453128"/>
-            <a:ext cx="2377440" cy="292608"/>
+            <a:off x="786384" y="4882896"/>
+            <a:ext cx="2834640" cy="292608"/>
           </a:xfrm>
           <a:prstGeom prst="rect">
             <a:avLst/>
@@ -3346,8 +3346,8 @@
         </p:blipFill>
         <p:spPr>
           <a:xfrm>
-            <a:off x="3383280" y="1691640"/>
-            <a:ext cx="2651760" cy="2651760"/>
+            <a:off x="3794760" y="1645920"/>
+            <a:ext cx="3108960" cy="3108960"/>
           </a:xfrm>
           <a:prstGeom prst="rect">
             <a:avLst/>
@@ -3362,7 +3362,7 @@
         </p:nvSpPr>
         <p:spPr>
           <a:xfrm>
-            <a:off x="3383280" y="4526280"/>
+            <a:off x="3794760" y="4956048"/>
             <a:ext cx="146304" cy="146304"/>
           </a:xfrm>
           <a:prstGeom prst="ellipse">
@@ -3382,8 +3382,8 @@
         </p:nvSpPr>
         <p:spPr>
           <a:xfrm>
-            <a:off x="3621024" y="4453128"/>
-            <a:ext cx="2377440" cy="292608"/>
+            <a:off x="4032504" y="4882896"/>
+            <a:ext cx="2834640" cy="292608"/>
           </a:xfrm>
           <a:prstGeom prst="rect">
             <a:avLst/>
@@ -3429,8 +3429,8 @@
         </p:nvSpPr>
         <p:spPr>
           <a:xfrm>
-            <a:off x="548640" y="4983480"/>
-            <a:ext cx="5486400" cy="292608"/>
+            <a:off x="548640" y="5486400"/>
+            <a:ext cx="6309360" cy="365760"/>
           </a:xfrm>
           <a:prstGeom prst="rect">
             <a:avLst/>
@@ -3446,98 +3446,37 @@
               <a:buNone/>
             </a:pPr>
             <a:r>
-              <a:rPr lang="en-US" sz="1300" dirty="0">
+              <a:rPr lang="en-US" sz="1600" dirty="0">
                 <a:solidFill>
                   <a:schemeClr val="tx2"/>
                 </a:solidFill>
               </a:rPr>
-              <a:t>박스 크기 (중앙값): crack 0.39% · scratch 0.44%</a:t>
-            </a:r>
-            <a:endParaRPr lang="en-US" sz="1300" dirty="0"/>
-          </a:p>
-        </p:txBody>
-      </p:sp>
-      <p:sp>
-        <p:nvSpPr>
-          <p:cNvPr id="13" name="takeaway-card"/>
-          <p:cNvSpPr/>
-          <p:nvPr/>
-        </p:nvSpPr>
-        <p:spPr>
-          <a:xfrm>
-            <a:off x="548640" y="5440680"/>
-            <a:ext cx="5486400" cy="777240"/>
-          </a:xfrm>
-          <a:prstGeom prst="roundRect">
-            <a:avLst>
-              <a:gd name="adj" fmla="val 9412"/>
-            </a:avLst>
-          </a:prstGeom>
-          <a:solidFill>
-            <a:schemeClr val="bg2"/>
-          </a:solidFill>
-          <a:ln/>
-        </p:spPr>
-      </p:sp>
-      <p:sp>
-        <p:nvSpPr>
-          <p:cNvPr id="14" name="takeaway"/>
-          <p:cNvSpPr txBox="1"/>
-          <p:nvPr/>
-        </p:nvSpPr>
-        <p:spPr>
-          <a:xfrm>
-            <a:off x="822960" y="5504688"/>
-            <a:ext cx="5029200" cy="658368"/>
-          </a:xfrm>
-          <a:prstGeom prst="rect">
-            <a:avLst/>
-          </a:prstGeom>
-          <a:noFill/>
-          <a:ln/>
-        </p:spPr>
-        <p:txBody>
-          <a:bodyPr wrap="square" lIns="0" tIns="0" rIns="0" bIns="0" rtlCol="0" anchor="ctr"/>
-          <a:lstStyle/>
-          <a:p>
+              <a:t>박스 크기 중앙값  </a:t>
+            </a:r>
             <a:pPr indent="0" marL="0">
               <a:buNone/>
             </a:pPr>
             <a:r>
-              <a:rPr lang="en-US" sz="1400" b="1" dirty="0">
-                <a:solidFill>
-                  <a:schemeClr val="accent3"/>
+              <a:rPr lang="en-US" sz="1600" b="1" dirty="0">
+                <a:solidFill>
+                  <a:schemeClr val="tx1"/>
                 </a:solidFill>
               </a:rPr>
-              <a:t>crack AP 1.00 · scratch AP 0.66–0.86</a:t>
-            </a:r>
-            <a:endParaRPr lang="en-US" sz="1400" dirty="0"/>
-          </a:p>
-          <a:p>
-            <a:pPr indent="0" marL="0">
-              <a:buNone/>
-            </a:pPr>
-            <a:r>
-              <a:rPr lang="en-US" sz="1400" dirty="0">
-                <a:solidFill>
-                  <a:schemeClr val="tx2"/>
-                </a:solidFill>
-              </a:rPr>
-              <a:t>이후 오류는 대부분 scratch</a:t>
-            </a:r>
-            <a:endParaRPr lang="en-US" sz="1400" dirty="0"/>
+              <a:t>crack 0.39% · scratch 0.44%</a:t>
+            </a:r>
+            <a:endParaRPr lang="en-US" sz="1600" dirty="0"/>
           </a:p>
         </p:txBody>
       </p:sp>
       <p:graphicFrame>
         <p:nvGraphicFramePr>
-          <p:cNvPr id="15" name="ap-chart" descr=""/>
+          <p:cNvPr id="13" name="ap-chart" descr=""/>
           <p:cNvGraphicFramePr/>
           <p:nvPr/>
         </p:nvGraphicFramePr>
         <p:xfrm>
-          <a:off x="6355080" y="1691640"/>
-          <a:ext cx="5285232" cy="4526280"/>
+          <a:off x="7223760" y="1645920"/>
+          <a:ext cx="4416552" cy="4572000"/>
         </p:xfrm>
         <a:graphic xmlns:a="http://schemas.openxmlformats.org/drawingml/2006/main">
           <a:graphicData uri="http://schemas.openxmlformats.org/drawingml/2006/chart">
@@ -3655,45 +3594,7 @@
       </p:sp>
       <p:sp>
         <p:nvSpPr>
-          <p:cNvPr id="3" name="Text 0"/>
-          <p:cNvSpPr/>
-          <p:nvPr>
-            <p:ph idx="101" type="body" hasCustomPrompt="1"/>
-          </p:nvPr>
-        </p:nvSpPr>
-        <p:spPr>
-          <a:xfrm>
-            <a:off x="548640" y="1005840"/>
-            <a:ext cx="11094415" cy="411480"/>
-          </a:xfrm>
-          <a:prstGeom prst="rect">
-            <a:avLst/>
-          </a:prstGeom>
-          <a:noFill/>
-          <a:ln/>
-        </p:spPr>
-        <p:txBody>
-          <a:bodyPr wrap="square" lIns="0" tIns="0" rIns="0" bIns="0" rtlCol="0" anchor="ctr"/>
-          <a:lstStyle/>
-          <a:p>
-            <a:pPr algn="l" indent="0" marL="0">
-              <a:buNone/>
-            </a:pPr>
-            <a:r>
-              <a:rPr lang="en-US" sz="1500" dirty="0">
-                <a:solidFill>
-                  <a:schemeClr val="tx2"/>
-                </a:solidFill>
-              </a:rPr>
-              <a:t>데이터셋과 모델 구성</a:t>
-            </a:r>
-            <a:endParaRPr lang="en-US" sz="1500" dirty="0"/>
-          </a:p>
-        </p:txBody>
-      </p:sp>
-      <p:sp>
-        <p:nvSpPr>
-          <p:cNvPr id="4" name="dataset-card"/>
+          <p:cNvPr id="3" name="dataset-card"/>
           <p:cNvSpPr/>
           <p:nvPr/>
         </p:nvSpPr>
@@ -3715,7 +3616,7 @@
       </p:sp>
       <p:sp>
         <p:nvSpPr>
-          <p:cNvPr id="5" name="ds-h"/>
+          <p:cNvPr id="4" name="ds-h"/>
           <p:cNvSpPr txBox="1"/>
           <p:nvPr/>
         </p:nvSpPr>
@@ -3751,7 +3652,7 @@
       </p:sp>
       <p:sp>
         <p:nvSpPr>
-          <p:cNvPr id="6" name="ds-b"/>
+          <p:cNvPr id="5" name="ds-b"/>
           <p:cNvSpPr txBox="1"/>
           <p:nvPr/>
         </p:nvSpPr>
@@ -3819,7 +3720,7 @@
                   <a:schemeClr val="tx1"/>
                 </a:solidFill>
               </a:rPr>
-              <a:t>목적: 모델별 성능 차이와 INT8 경량화 효과 확인</a:t>
+              <a:t>목적: 모델별 성능 비교 · INT8 효과</a:t>
             </a:r>
             <a:endParaRPr lang="en-US" sz="1400" dirty="0"/>
           </a:p>
@@ -3827,7 +3728,7 @@
       </p:sp>
       <p:sp>
         <p:nvSpPr>
-          <p:cNvPr id="7" name="limit-h"/>
+          <p:cNvPr id="6" name="limit-h"/>
           <p:cNvSpPr txBox="1"/>
           <p:nvPr/>
         </p:nvSpPr>
@@ -3863,7 +3764,7 @@
       </p:sp>
       <p:pic>
         <p:nvPicPr>
-          <p:cNvPr id="8" name="bg-0" descr="C:\Users\user\_se4nchoi\batteryvision\docs\submission\build\img\bg_green.jpg">    </p:cNvPr>
+          <p:cNvPr id="7" name="bg-0" descr="C:\Users\user\_se4nchoi\batteryvision\docs\submission\build\img\bg_green.jpg">    </p:cNvPr>
           <p:cNvPicPr>
             <a:picLocks noChangeAspect="1"/>
           </p:cNvPicPr>
@@ -3887,7 +3788,7 @@
       </p:pic>
       <p:sp>
         <p:nvSpPr>
-          <p:cNvPr id="9" name="bg-l-0"/>
+          <p:cNvPr id="8" name="bg-l-0"/>
           <p:cNvSpPr txBox="1"/>
           <p:nvPr/>
         </p:nvSpPr>
@@ -3923,7 +3824,7 @@
       </p:sp>
       <p:pic>
         <p:nvPicPr>
-          <p:cNvPr id="10" name="bg-1" descr="C:\Users\user\_se4nchoi\batteryvision\docs\submission\build\img\bg_grey.jpg">    </p:cNvPr>
+          <p:cNvPr id="9" name="bg-1" descr="C:\Users\user\_se4nchoi\batteryvision\docs\submission\build\img\bg_grey.jpg">    </p:cNvPr>
           <p:cNvPicPr>
             <a:picLocks noChangeAspect="1"/>
           </p:cNvPicPr>
@@ -3947,7 +3848,7 @@
       </p:pic>
       <p:sp>
         <p:nvSpPr>
-          <p:cNvPr id="11" name="bg-l-1"/>
+          <p:cNvPr id="10" name="bg-l-1"/>
           <p:cNvSpPr txBox="1"/>
           <p:nvPr/>
         </p:nvSpPr>
@@ -3983,7 +3884,7 @@
       </p:sp>
       <p:pic>
         <p:nvPicPr>
-          <p:cNvPr id="12" name="bg-2" descr="C:\Users\user\_se4nchoi\batteryvision\docs\submission\build\img\bg_wood.jpg">    </p:cNvPr>
+          <p:cNvPr id="11" name="bg-2" descr="C:\Users\user\_se4nchoi\batteryvision\docs\submission\build\img\bg_wood.jpg">    </p:cNvPr>
           <p:cNvPicPr>
             <a:picLocks noChangeAspect="1"/>
           </p:cNvPicPr>
@@ -4007,7 +3908,7 @@
       </p:pic>
       <p:sp>
         <p:nvSpPr>
-          <p:cNvPr id="13" name="bg-l-2"/>
+          <p:cNvPr id="12" name="bg-l-2"/>
           <p:cNvSpPr txBox="1"/>
           <p:nvPr/>
         </p:nvSpPr>
@@ -4043,7 +3944,7 @@
       </p:sp>
       <p:sp>
         <p:nvSpPr>
-          <p:cNvPr id="14" name="limit-t"/>
+          <p:cNvPr id="13" name="limit-t"/>
           <p:cNvSpPr txBox="1"/>
           <p:nvPr/>
         </p:nvSpPr>
@@ -4079,7 +3980,7 @@
       </p:sp>
       <p:sp>
         <p:nvSpPr>
-          <p:cNvPr id="15" name="grid-h"/>
+          <p:cNvPr id="14" name="grid-h"/>
           <p:cNvSpPr txBox="1"/>
           <p:nvPr/>
         </p:nvSpPr>
@@ -5232,7 +5133,7 @@
       </p:graphicFrame>
       <p:sp>
         <p:nvSpPr>
-          <p:cNvPr id="17" name="legend-card"/>
+          <p:cNvPr id="16" name="legend-card"/>
           <p:cNvSpPr/>
           <p:nvPr/>
         </p:nvSpPr>
@@ -5254,7 +5155,7 @@
       </p:sp>
       <p:sp>
         <p:nvSpPr>
-          <p:cNvPr id="18" name="legend"/>
+          <p:cNvPr id="17" name="legend"/>
           <p:cNvSpPr txBox="1"/>
           <p:nvPr/>
         </p:nvSpPr>
@@ -5285,7 +5186,7 @@
                   <a:schemeClr val="tx1"/>
                 </a:solidFill>
               </a:rPr>
-              <a:t>FP16  </a:t>
+              <a:t>XAI  </a:t>
             </a:r>
             <a:pPr indent="0" marL="0">
               <a:spcAft>
@@ -5299,7 +5200,7 @@
                   <a:schemeClr val="tx2"/>
                 </a:solidFill>
               </a:rPr>
-              <a:t>기본 모델</a:t>
+              <a:t>결함 위치 heatmap 출력</a:t>
             </a:r>
             <a:endParaRPr lang="en-US" sz="1400" dirty="0"/>
           </a:p>
@@ -5316,7 +5217,7 @@
                   <a:schemeClr val="tx1"/>
                 </a:solidFill>
               </a:rPr>
-              <a:t>XAI  </a:t>
+              <a:t>INT8  </a:t>
             </a:r>
             <a:pPr indent="0" marL="0">
               <a:spcAft>
@@ -5330,46 +5231,15 @@
                   <a:schemeClr val="tx2"/>
                 </a:solidFill>
               </a:rPr>
-              <a:t>결함 위치 heatmap 출력 (설명 가능)</a:t>
+              <a:t>양자화 경량화</a:t>
             </a:r>
             <a:endParaRPr lang="en-US" sz="1400" dirty="0"/>
           </a:p>
-          <a:p>
-            <a:pPr indent="0" marL="0">
-              <a:spcAft>
-                <a:spcPts val="600"/>
-              </a:spcAft>
-              <a:buNone/>
-            </a:pPr>
-            <a:r>
-              <a:rPr lang="en-US" sz="1400" b="1" dirty="0">
-                <a:solidFill>
-                  <a:schemeClr val="tx1"/>
-                </a:solidFill>
-              </a:rPr>
-              <a:t>INT8  </a:t>
-            </a:r>
-            <a:pPr indent="0" marL="0">
-              <a:spcAft>
-                <a:spcPts val="600"/>
-              </a:spcAft>
-              <a:buNone/>
-            </a:pPr>
-            <a:r>
-              <a:rPr lang="en-US" sz="1400" dirty="0">
-                <a:solidFill>
-                  <a:schemeClr val="tx2"/>
-                </a:solidFill>
-              </a:rPr>
-              <a:t>양자화로 경량화</a:t>
-            </a:r>
-            <a:endParaRPr lang="en-US" sz="1400" dirty="0"/>
-          </a:p>
         </p:txBody>
       </p:sp>
       <p:sp>
         <p:nvSpPr>
-          <p:cNvPr id="19" name="credit"/>
+          <p:cNvPr id="18" name="credit"/>
           <p:cNvSpPr txBox="1"/>
           <p:nvPr/>
         </p:nvSpPr>
@@ -5400,6 +5270,36 @@
               <a:t>데이터: Battery Defect Inspection v8 (Roboflow Universe), CC BY 4.0</a:t>
             </a:r>
             <a:endParaRPr lang="en-US" sz="900" dirty="0"/>
+          </a:p>
+        </p:txBody>
+      </p:sp>
+      <p:sp>
+        <p:nvSpPr>
+          <p:cNvPr id="20" name="Text 0"/>
+          <p:cNvSpPr/>
+          <p:nvPr>
+            <p:ph idx="101" type="body" hasCustomPrompt="1"/>
+          </p:nvPr>
+        </p:nvSpPr>
+        <p:spPr>
+          <a:xfrm>
+            <a:off x="548640" y="1005840"/>
+            <a:ext cx="11094415" cy="411480"/>
+          </a:xfrm>
+          <a:prstGeom prst="rect">
+            <a:avLst/>
+          </a:prstGeom>
+          <a:noFill/>
+          <a:ln/>
+        </p:spPr>
+        <p:txBody>
+          <a:bodyPr wrap="square" lIns="0" tIns="0" rIns="0" bIns="0" rtlCol="0" anchor="ctr"/>
+          <a:lstStyle/>
+          <a:p>
+            <a:pPr algn="l" indent="0" marL="0">
+              <a:buNone/>
+            </a:pPr>
+            <a:endParaRPr lang="en-US" sz="1500" dirty="0"/>
           </a:p>
         </p:txBody>
       </p:sp>
@@ -5558,11 +5458,11 @@
         <p:spPr>
           <a:xfrm>
             <a:off x="548640" y="1645920"/>
-            <a:ext cx="5486400" cy="2468880"/>
+            <a:ext cx="4434840" cy="2651760"/>
           </a:xfrm>
           <a:prstGeom prst="roundRect">
             <a:avLst>
-              <a:gd name="adj" fmla="val 2963"/>
+              <a:gd name="adj" fmla="val 2759"/>
             </a:avLst>
           </a:prstGeom>
           <a:solidFill>
@@ -5580,7 +5480,7 @@
         <p:spPr>
           <a:xfrm>
             <a:off x="822960" y="1783080"/>
-            <a:ext cx="5029200" cy="320040"/>
+            <a:ext cx="3931920" cy="320040"/>
           </a:xfrm>
           <a:prstGeom prst="rect">
             <a:avLst/>
@@ -5616,7 +5516,7 @@
         <p:spPr>
           <a:xfrm>
             <a:off x="822960" y="2240280"/>
-            <a:ext cx="5029200" cy="731520"/>
+            <a:ext cx="3931920" cy="731520"/>
           </a:xfrm>
           <a:prstGeom prst="rect">
             <a:avLst/>
@@ -5652,7 +5552,7 @@
         <p:spPr>
           <a:xfrm>
             <a:off x="822960" y="3108960"/>
-            <a:ext cx="5029200" cy="868680"/>
+            <a:ext cx="3931920" cy="1005840"/>
           </a:xfrm>
           <a:prstGeom prst="rect">
             <a:avLst/>
@@ -5676,7 +5576,7 @@
                   <a:schemeClr val="tx1"/>
                 </a:solidFill>
               </a:rPr>
-              <a:t>= 학습 3,214 + 검증 306 + 테스트 153 (Roboflow v8 전체)</a:t>
+              <a:t>= 학습 3,214 + 검증 306 + 테스트 153</a:t>
             </a:r>
             <a:endParaRPr lang="en-US" sz="1400" dirty="0"/>
           </a:p>
@@ -5693,7 +5593,7 @@
                   <a:schemeClr val="tx2"/>
                 </a:solidFill>
               </a:rPr>
-              <a:t>Geti가 라벨 있는 약 2,800장을 70/20/10으로 다시 나눠 학습</a:t>
+              <a:t>Geti가 약 2,800장을 70/20/10으로 재분할</a:t>
             </a:r>
             <a:endParaRPr lang="en-US" sz="1400" dirty="0"/>
           </a:p>
@@ -5715,8 +5615,8 @@
         </p:blipFill>
         <p:spPr>
           <a:xfrm>
-            <a:off x="6263640" y="1645920"/>
-            <a:ext cx="1828800" cy="1828800"/>
+            <a:off x="5166360" y="1645920"/>
+            <a:ext cx="2377440" cy="2377440"/>
           </a:xfrm>
           <a:prstGeom prst="rect">
             <a:avLst/>
@@ -5731,8 +5631,8 @@
         </p:nvSpPr>
         <p:spPr>
           <a:xfrm>
-            <a:off x="6263640" y="3520440"/>
-            <a:ext cx="1828800" cy="274320"/>
+            <a:off x="5166360" y="4069080"/>
+            <a:ext cx="2377440" cy="274320"/>
           </a:xfrm>
           <a:prstGeom prst="rect">
             <a:avLst/>
@@ -5775,8 +5675,8 @@
         </p:blipFill>
         <p:spPr>
           <a:xfrm>
-            <a:off x="8229600" y="1645920"/>
-            <a:ext cx="1828800" cy="1828800"/>
+            <a:off x="7680960" y="1645920"/>
+            <a:ext cx="2377440" cy="2377440"/>
           </a:xfrm>
           <a:prstGeom prst="rect">
             <a:avLst/>
@@ -5791,8 +5691,8 @@
         </p:nvSpPr>
         <p:spPr>
           <a:xfrm>
-            <a:off x="8229600" y="3520440"/>
-            <a:ext cx="1828800" cy="274320"/>
+            <a:off x="7680960" y="4069080"/>
+            <a:ext cx="2377440" cy="274320"/>
           </a:xfrm>
           <a:prstGeom prst="rect">
             <a:avLst/>
@@ -5827,12 +5727,12 @@
         </p:nvSpPr>
         <p:spPr>
           <a:xfrm>
-            <a:off x="10195560" y="1645920"/>
-            <a:ext cx="1444752" cy="2148840"/>
+            <a:off x="10241280" y="1645920"/>
+            <a:ext cx="1399032" cy="2377440"/>
           </a:xfrm>
           <a:prstGeom prst="roundRect">
             <a:avLst>
-              <a:gd name="adj" fmla="val 5063"/>
+              <a:gd name="adj" fmla="val 5229"/>
             </a:avLst>
           </a:prstGeom>
           <a:solidFill>
@@ -5849,8 +5749,8 @@
         </p:nvSpPr>
         <p:spPr>
           <a:xfrm>
-            <a:off x="10287000" y="1874520"/>
-            <a:ext cx="1280160" cy="548640"/>
+            <a:off x="10287000" y="2103120"/>
+            <a:ext cx="1307592" cy="548640"/>
           </a:xfrm>
           <a:prstGeom prst="rect">
             <a:avLst/>
@@ -5885,8 +5785,8 @@
         </p:nvSpPr>
         <p:spPr>
           <a:xfrm>
-            <a:off x="10287000" y="2514600"/>
-            <a:ext cx="1280160" cy="1097280"/>
+            <a:off x="10287000" y="2743200"/>
+            <a:ext cx="1307592" cy="914400"/>
           </a:xfrm>
           <a:prstGeom prst="rect">
             <a:avLst/>
@@ -5907,7 +5807,7 @@
                   <a:schemeClr val="tx2"/>
                 </a:solidFill>
               </a:rPr>
-              <a:t>학습 사진과 거의 같은 테스트 사진</a:t>
+              <a:t>학습 사진의 복사본</a:t>
             </a:r>
             <a:endParaRPr lang="en-US" sz="1200" dirty="0"/>
           </a:p>
@@ -5921,8 +5821,8 @@
         </p:nvSpPr>
         <p:spPr>
           <a:xfrm>
-            <a:off x="6263640" y="3840480"/>
-            <a:ext cx="5394960" cy="274320"/>
+            <a:off x="7680960" y="4069080"/>
+            <a:ext cx="2377440" cy="274320"/>
           </a:xfrm>
           <a:prstGeom prst="rect">
             <a:avLst/>
@@ -5934,7 +5834,7 @@
           <a:bodyPr wrap="square" lIns="0" tIns="0" rIns="0" bIns="0" rtlCol="0" anchor="t"/>
           <a:lstStyle/>
           <a:p>
-            <a:pPr indent="0" marL="0">
+            <a:pPr algn="r" indent="0" marL="0">
               <a:buNone/>
             </a:pPr>
             <a:r>
@@ -5943,7 +5843,7 @@
                   <a:schemeClr val="tx2"/>
                 </a:solidFill>
               </a:rPr>
-              <a:t>dHash 거리 4 / 256비트: 사실상 같은 사진</a:t>
+              <a:t>dHash 거리 4 / 256</a:t>
             </a:r>
             <a:endParaRPr lang="en-US" sz="1200" dirty="0"/>
           </a:p>
@@ -6001,7 +5901,7 @@
                   <a:schemeClr val="tx1"/>
                 </a:solidFill>
               </a:rPr>
-              <a:t>그래서 1차 테스트 점수는</a:t>
+              <a:t>1차 테스트 점수는</a:t>
             </a:r>
             <a:endParaRPr lang="en-US" sz="1600" dirty="0"/>
           </a:p>
@@ -6041,7 +5941,7 @@
                   <a:schemeClr val="tx2"/>
                 </a:solidFill>
               </a:rPr>
-              <a:t>학습에 쓴 사진이 포함됐을 수 있음 (Geti 화면에서 분할 목록 확인 불가)</a:t>
+              <a:t>학습에 쓴 사진 포함 가능</a:t>
             </a:r>
             <a:endParaRPr lang="en-US" sz="1400" dirty="0"/>
           </a:p>
@@ -6059,7 +5959,7 @@
                   <a:schemeClr val="tx2"/>
                 </a:solidFill>
               </a:rPr>
-              <a:t>모델끼리 비교는 가능, 처음 보는 사진에서의 성능은 2차 세트로 확인</a:t>
+              <a:t>모델 간 비교용 · 실제 성능은 2차 세트로</a:t>
             </a:r>
             <a:endParaRPr lang="en-US" sz="1400" dirty="0"/>
           </a:p>
@@ -6256,11 +6156,11 @@
         <p:spPr>
           <a:xfrm>
             <a:off x="548640" y="1645920"/>
-            <a:ext cx="3566160" cy="2331720"/>
+            <a:ext cx="3566160" cy="2834640"/>
           </a:xfrm>
           <a:prstGeom prst="roundRect">
             <a:avLst>
-              <a:gd name="adj" fmla="val 3137"/>
+              <a:gd name="adj" fmla="val 2581"/>
             </a:avLst>
           </a:prstGeom>
           <a:solidFill>
@@ -6460,8 +6360,8 @@
         </p:nvSpPr>
         <p:spPr>
           <a:xfrm>
-            <a:off x="822960" y="2606040"/>
-            <a:ext cx="3108960" cy="731520"/>
+            <a:off x="822960" y="2697480"/>
+            <a:ext cx="3108960" cy="1005840"/>
           </a:xfrm>
           <a:prstGeom prst="rect">
             <a:avLst/>
@@ -6477,14 +6377,14 @@
               <a:buNone/>
             </a:pPr>
             <a:r>
-              <a:rPr lang="en-US" sz="4000" b="1" dirty="0">
+              <a:rPr lang="en-US" sz="5400" b="1" dirty="0">
                 <a:solidFill>
                   <a:schemeClr val="accent4"/>
                 </a:solidFill>
               </a:rPr>
               <a:t>92.9%</a:t>
             </a:r>
-            <a:endParaRPr lang="en-US" sz="4000" dirty="0"/>
+            <a:endParaRPr lang="en-US" sz="5400" dirty="0"/>
           </a:p>
         </p:txBody>
       </p:sp>
@@ -6496,7 +6396,7 @@
         </p:nvSpPr>
         <p:spPr>
           <a:xfrm>
-            <a:off x="822960" y="3429000"/>
+            <a:off x="822960" y="3886200"/>
             <a:ext cx="3108960" cy="274320"/>
           </a:xfrm>
           <a:prstGeom prst="rect">
@@ -6513,14 +6413,14 @@
               <a:buNone/>
             </a:pPr>
             <a:r>
-              <a:rPr lang="en-US" sz="1300" dirty="0">
+              <a:rPr lang="en-US" sz="1400" dirty="0">
                 <a:solidFill>
                   <a:schemeClr val="tx2"/>
                 </a:solidFill>
               </a:rPr>
               <a:t>mAP@50 · scratch AP 0.86</a:t>
             </a:r>
-            <a:endParaRPr lang="en-US" sz="1300" dirty="0"/>
+            <a:endParaRPr lang="en-US" sz="1400" dirty="0"/>
           </a:p>
         </p:txBody>
       </p:sp>
@@ -6533,11 +6433,11 @@
         <p:spPr>
           <a:xfrm>
             <a:off x="4297680" y="1645920"/>
-            <a:ext cx="3566160" cy="2331720"/>
+            <a:ext cx="3566160" cy="2834640"/>
           </a:xfrm>
           <a:prstGeom prst="roundRect">
             <a:avLst>
-              <a:gd name="adj" fmla="val 3137"/>
+              <a:gd name="adj" fmla="val 2581"/>
             </a:avLst>
           </a:prstGeom>
           <a:solidFill>
@@ -6679,8 +6579,8 @@
         </p:nvSpPr>
         <p:spPr>
           <a:xfrm>
-            <a:off x="4572000" y="2606040"/>
-            <a:ext cx="3108960" cy="731520"/>
+            <a:off x="4572000" y="2697480"/>
+            <a:ext cx="3108960" cy="1005840"/>
           </a:xfrm>
           <a:prstGeom prst="rect">
             <a:avLst/>
@@ -6696,14 +6596,14 @@
               <a:buNone/>
             </a:pPr>
             <a:r>
-              <a:rPr lang="en-US" sz="4000" b="1" dirty="0">
+              <a:rPr lang="en-US" sz="5400" b="1" dirty="0">
                 <a:solidFill>
                   <a:schemeClr val="accent5"/>
                 </a:solidFill>
               </a:rPr>
               <a:t>89.2%</a:t>
             </a:r>
-            <a:endParaRPr lang="en-US" sz="4000" dirty="0"/>
+            <a:endParaRPr lang="en-US" sz="5400" dirty="0"/>
           </a:p>
         </p:txBody>
       </p:sp>
@@ -6715,7 +6615,7 @@
         </p:nvSpPr>
         <p:spPr>
           <a:xfrm>
-            <a:off x="4572000" y="3429000"/>
+            <a:off x="4572000" y="3886200"/>
             <a:ext cx="3108960" cy="274320"/>
           </a:xfrm>
           <a:prstGeom prst="rect">
@@ -6732,14 +6632,14 @@
               <a:buNone/>
             </a:pPr>
             <a:r>
-              <a:rPr lang="en-US" sz="1300" dirty="0">
+              <a:rPr lang="en-US" sz="1400" dirty="0">
                 <a:solidFill>
                   <a:schemeClr val="tx2"/>
                 </a:solidFill>
               </a:rPr>
               <a:t>mAP@50 · scratch AP 0.78</a:t>
             </a:r>
-            <a:endParaRPr lang="en-US" sz="1300" dirty="0"/>
+            <a:endParaRPr lang="en-US" sz="1400" dirty="0"/>
           </a:p>
         </p:txBody>
       </p:sp>
@@ -6752,11 +6652,11 @@
         <p:spPr>
           <a:xfrm>
             <a:off x="8046720" y="1645920"/>
-            <a:ext cx="3566160" cy="2331720"/>
+            <a:ext cx="3566160" cy="2834640"/>
           </a:xfrm>
           <a:prstGeom prst="roundRect">
             <a:avLst>
-              <a:gd name="adj" fmla="val 3137"/>
+              <a:gd name="adj" fmla="val 2581"/>
             </a:avLst>
           </a:prstGeom>
           <a:solidFill>
@@ -6898,8 +6798,8 @@
         </p:nvSpPr>
         <p:spPr>
           <a:xfrm>
-            <a:off x="8321040" y="2606040"/>
-            <a:ext cx="3108960" cy="731520"/>
+            <a:off x="8321040" y="2697480"/>
+            <a:ext cx="3108960" cy="1005840"/>
           </a:xfrm>
           <a:prstGeom prst="rect">
             <a:avLst/>
@@ -6915,14 +6815,14 @@
               <a:buNone/>
             </a:pPr>
             <a:r>
-              <a:rPr lang="en-US" sz="4000" b="1" dirty="0">
+              <a:rPr lang="en-US" sz="5400" b="1" dirty="0">
                 <a:solidFill>
                   <a:schemeClr val="accent6"/>
                 </a:solidFill>
               </a:rPr>
               <a:t>83.2%</a:t>
             </a:r>
-            <a:endParaRPr lang="en-US" sz="4000" dirty="0"/>
+            <a:endParaRPr lang="en-US" sz="5400" dirty="0"/>
           </a:p>
         </p:txBody>
       </p:sp>
@@ -6934,7 +6834,7 @@
         </p:nvSpPr>
         <p:spPr>
           <a:xfrm>
-            <a:off x="8321040" y="3429000"/>
+            <a:off x="8321040" y="3886200"/>
             <a:ext cx="3108960" cy="274320"/>
           </a:xfrm>
           <a:prstGeom prst="rect">
@@ -6951,14 +6851,14 @@
               <a:buNone/>
             </a:pPr>
             <a:r>
-              <a:rPr lang="en-US" sz="1300" dirty="0">
+              <a:rPr lang="en-US" sz="1400" dirty="0">
                 <a:solidFill>
                   <a:schemeClr val="tx2"/>
                 </a:solidFill>
               </a:rPr>
               <a:t>mAP@50 · scratch AP 0.66</a:t>
             </a:r>
-            <a:endParaRPr lang="en-US" sz="1300" dirty="0"/>
+            <a:endParaRPr lang="en-US" sz="1400" dirty="0"/>
           </a:p>
         </p:txBody>
       </p:sp>
@@ -6970,12 +6870,12 @@
         </p:nvSpPr>
         <p:spPr>
           <a:xfrm>
-            <a:off x="548640" y="4206240"/>
-            <a:ext cx="5486400" cy="2011680"/>
+            <a:off x="548640" y="4709160"/>
+            <a:ext cx="5486400" cy="1508760"/>
           </a:xfrm>
           <a:prstGeom prst="roundRect">
             <a:avLst>
-              <a:gd name="adj" fmla="val 3636"/>
+              <a:gd name="adj" fmla="val 4848"/>
             </a:avLst>
           </a:prstGeom>
           <a:solidFill>
@@ -6992,7 +6892,7 @@
         </p:nvSpPr>
         <p:spPr>
           <a:xfrm>
-            <a:off x="822960" y="4343400"/>
+            <a:off x="822960" y="4828032"/>
             <a:ext cx="4572000" cy="320040"/>
           </a:xfrm>
           <a:prstGeom prst="rect">
@@ -7014,7 +6914,7 @@
                   <a:schemeClr val="accent1"/>
                 </a:solidFill>
               </a:rPr>
-              <a:t>결과</a:t>
+              <a:t>같은 순서</a:t>
             </a:r>
             <a:endParaRPr lang="en-US" sz="1600" dirty="0"/>
           </a:p>
@@ -7028,8 +6928,8 @@
         </p:nvSpPr>
         <p:spPr>
           <a:xfrm>
-            <a:off x="822960" y="4754880"/>
-            <a:ext cx="5029200" cy="1371600"/>
+            <a:off x="822960" y="5212080"/>
+            <a:ext cx="5029200" cy="868680"/>
           </a:xfrm>
           <a:prstGeom prst="rect">
             <a:avLst/>
@@ -7054,7 +6954,7 @@
                   <a:schemeClr val="tx1"/>
                 </a:solidFill>
               </a:rPr>
-              <a:t>파라미터가 가장 적은 ATSS가 가장 정확</a:t>
+              <a:t>Geti 점수: 86% · 81% · 81%</a:t>
             </a:r>
             <a:endParaRPr lang="en-US" sz="1400" dirty="0"/>
           </a:p>
@@ -7072,10 +6972,90 @@
                   <a:schemeClr val="tx1"/>
                 </a:solidFill>
               </a:rPr>
-              <a:t>Geti 점수도 ATSS 최고 (86% · 81% · 81%)</a:t>
+              <a:t>2차 세트 검출: ATSS 47% · YOLOX-S 3%</a:t>
             </a:r>
             <a:endParaRPr lang="en-US" sz="1400" dirty="0"/>
           </a:p>
+        </p:txBody>
+      </p:sp>
+      <p:sp>
+        <p:nvSpPr>
+          <p:cNvPr id="27" name="note-card"/>
+          <p:cNvSpPr/>
+          <p:nvPr/>
+        </p:nvSpPr>
+        <p:spPr>
+          <a:xfrm>
+            <a:off x="6263640" y="4709160"/>
+            <a:ext cx="5376672" cy="1508760"/>
+          </a:xfrm>
+          <a:prstGeom prst="roundRect">
+            <a:avLst>
+              <a:gd name="adj" fmla="val 4848"/>
+            </a:avLst>
+          </a:prstGeom>
+          <a:solidFill>
+            <a:schemeClr val="bg2"/>
+          </a:solidFill>
+          <a:ln/>
+        </p:spPr>
+      </p:sp>
+      <p:sp>
+        <p:nvSpPr>
+          <p:cNvPr id="28" name="note-h"/>
+          <p:cNvSpPr txBox="1"/>
+          <p:nvPr/>
+        </p:nvSpPr>
+        <p:spPr>
+          <a:xfrm>
+            <a:off x="6537960" y="4828032"/>
+            <a:ext cx="4572000" cy="320040"/>
+          </a:xfrm>
+          <a:prstGeom prst="rect">
+            <a:avLst/>
+          </a:prstGeom>
+          <a:noFill/>
+          <a:ln/>
+        </p:spPr>
+        <p:txBody>
+          <a:bodyPr wrap="square" lIns="0" tIns="0" rIns="0" bIns="0" rtlCol="0" anchor="t"/>
+          <a:lstStyle/>
+          <a:p>
+            <a:pPr indent="0" marL="0">
+              <a:buNone/>
+            </a:pPr>
+            <a:r>
+              <a:rPr lang="en-US" sz="1600" b="1" dirty="0">
+                <a:solidFill>
+                  <a:schemeClr val="accent3"/>
+                </a:solidFill>
+              </a:rPr>
+              <a:t>주의</a:t>
+            </a:r>
+            <a:endParaRPr lang="en-US" sz="1600" dirty="0"/>
+          </a:p>
+        </p:txBody>
+      </p:sp>
+      <p:sp>
+        <p:nvSpPr>
+          <p:cNvPr id="29" name="note-b"/>
+          <p:cNvSpPr txBox="1"/>
+          <p:nvPr/>
+        </p:nvSpPr>
+        <p:spPr>
+          <a:xfrm>
+            <a:off x="6537960" y="5212080"/>
+            <a:ext cx="4937760" cy="868680"/>
+          </a:xfrm>
+          <a:prstGeom prst="rect">
+            <a:avLst/>
+          </a:prstGeom>
+          <a:noFill/>
+          <a:ln/>
+        </p:spPr>
+        <p:txBody>
+          <a:bodyPr wrap="square" lIns="0" tIns="0" rIns="0" bIns="0" rtlCol="0" anchor="t"/>
+          <a:lstStyle/>
           <a:p>
             <a:pPr marL="342900" indent="-342900">
               <a:spcAft>
@@ -7090,90 +7070,10 @@
                   <a:schemeClr val="tx1"/>
                 </a:solidFill>
               </a:rPr>
-              <a:t>2차 세트도 ATSS 우위 (검출 47% vs 3%)</a:t>
+              <a:t>작은 = 파라미터 기준</a:t>
             </a:r>
             <a:endParaRPr lang="en-US" sz="1400" dirty="0"/>
           </a:p>
-        </p:txBody>
-      </p:sp>
-      <p:sp>
-        <p:nvSpPr>
-          <p:cNvPr id="27" name="note-card"/>
-          <p:cNvSpPr/>
-          <p:nvPr/>
-        </p:nvSpPr>
-        <p:spPr>
-          <a:xfrm>
-            <a:off x="6263640" y="4206240"/>
-            <a:ext cx="5376672" cy="2011680"/>
-          </a:xfrm>
-          <a:prstGeom prst="roundRect">
-            <a:avLst>
-              <a:gd name="adj" fmla="val 3636"/>
-            </a:avLst>
-          </a:prstGeom>
-          <a:solidFill>
-            <a:schemeClr val="bg2"/>
-          </a:solidFill>
-          <a:ln/>
-        </p:spPr>
-      </p:sp>
-      <p:sp>
-        <p:nvSpPr>
-          <p:cNvPr id="28" name="note-h"/>
-          <p:cNvSpPr txBox="1"/>
-          <p:nvPr/>
-        </p:nvSpPr>
-        <p:spPr>
-          <a:xfrm>
-            <a:off x="6537960" y="4343400"/>
-            <a:ext cx="4572000" cy="320040"/>
-          </a:xfrm>
-          <a:prstGeom prst="rect">
-            <a:avLst/>
-          </a:prstGeom>
-          <a:noFill/>
-          <a:ln/>
-        </p:spPr>
-        <p:txBody>
-          <a:bodyPr wrap="square" lIns="0" tIns="0" rIns="0" bIns="0" rtlCol="0" anchor="t"/>
-          <a:lstStyle/>
-          <a:p>
-            <a:pPr indent="0" marL="0">
-              <a:buNone/>
-            </a:pPr>
-            <a:r>
-              <a:rPr lang="en-US" sz="1600" b="1" dirty="0">
-                <a:solidFill>
-                  <a:schemeClr val="accent3"/>
-                </a:solidFill>
-              </a:rPr>
-              <a:t>주의</a:t>
-            </a:r>
-            <a:endParaRPr lang="en-US" sz="1600" dirty="0"/>
-          </a:p>
-        </p:txBody>
-      </p:sp>
-      <p:sp>
-        <p:nvSpPr>
-          <p:cNvPr id="29" name="note-b"/>
-          <p:cNvSpPr txBox="1"/>
-          <p:nvPr/>
-        </p:nvSpPr>
-        <p:spPr>
-          <a:xfrm>
-            <a:off x="6537960" y="4754880"/>
-            <a:ext cx="4937760" cy="1371600"/>
-          </a:xfrm>
-          <a:prstGeom prst="rect">
-            <a:avLst/>
-          </a:prstGeom>
-          <a:noFill/>
-          <a:ln/>
-        </p:spPr>
-        <p:txBody>
-          <a:bodyPr wrap="square" lIns="0" tIns="0" rIns="0" bIns="0" rtlCol="0" anchor="t"/>
-          <a:lstStyle/>
           <a:p>
             <a:pPr marL="342900" indent="-342900">
               <a:spcAft>
@@ -7188,43 +7088,7 @@
                   <a:schemeClr val="tx1"/>
                 </a:solidFill>
               </a:rPr>
-              <a:t>'작은 모델' = 파라미터 기준</a:t>
-            </a:r>
-            <a:endParaRPr lang="en-US" sz="1400" dirty="0"/>
-          </a:p>
-          <a:p>
-            <a:pPr marL="342900" indent="-342900">
-              <a:spcAft>
-                <a:spcPts val="600"/>
-              </a:spcAft>
-              <a:buSzPct val="100000"/>
-              <a:buChar char="•"/>
-            </a:pPr>
-            <a:r>
-              <a:rPr lang="en-US" sz="1400" dirty="0">
-                <a:solidFill>
-                  <a:schemeClr val="tx1"/>
-                </a:solidFill>
-              </a:rPr>
-              <a:t>연산량은 Tiny가 가장 적음 (6.45 GFLOPs)</a:t>
-            </a:r>
-            <a:endParaRPr lang="en-US" sz="1400" dirty="0"/>
-          </a:p>
-          <a:p>
-            <a:pPr marL="342900" indent="-342900">
-              <a:spcAft>
-                <a:spcPts val="600"/>
-              </a:spcAft>
-              <a:buSzPct val="100000"/>
-              <a:buChar char="•"/>
-            </a:pPr>
-            <a:r>
-              <a:rPr lang="en-US" sz="1400" dirty="0">
-                <a:solidFill>
-                  <a:schemeClr val="tx2"/>
-                </a:solidFill>
-              </a:rPr>
-              <a:t>1차 점수는 학습 사진 포함 가능 → 모델 간 비교용</a:t>
+              <a:t>연산량은 Tiny 최소 (6.45 GFLOPs)</a:t>
             </a:r>
             <a:endParaRPr lang="en-US" sz="1400" dirty="0"/>
           </a:p>
@@ -7484,7 +7348,7 @@
                 <a:gridCol w="1234440"/>
                 <a:gridCol w="1234440"/>
               </a:tblGrid>
-              <a:tr h="457200">
+              <a:tr h="411480">
                 <a:tc>
                   <a:txBody>
                     <a:bodyPr/>
@@ -7758,7 +7622,7 @@
                   </a:tcPr>
                 </a:tc>
               </a:tr>
-              <a:tr h="457200">
+              <a:tr h="411480">
                 <a:tc>
                   <a:txBody>
                     <a:bodyPr/>
@@ -8032,7 +7896,7 @@
                   </a:tcPr>
                 </a:tc>
               </a:tr>
-              <a:tr h="457200">
+              <a:tr h="411480">
                 <a:tc>
                   <a:txBody>
                     <a:bodyPr/>
@@ -8306,7 +8170,7 @@
                   </a:tcPr>
                 </a:tc>
               </a:tr>
-              <a:tr h="457200">
+              <a:tr h="411480">
                 <a:tc>
                   <a:txBody>
                     <a:bodyPr/>
@@ -8592,12 +8456,12 @@
         </p:nvSpPr>
         <p:spPr>
           <a:xfrm>
-            <a:off x="6263640" y="2651760"/>
-            <a:ext cx="5376672" cy="1828800"/>
+            <a:off x="548640" y="4572000"/>
+            <a:ext cx="5486400" cy="1645920"/>
           </a:xfrm>
           <a:prstGeom prst="roundRect">
             <a:avLst>
-              <a:gd name="adj" fmla="val 4000"/>
+              <a:gd name="adj" fmla="val 4444"/>
             </a:avLst>
           </a:prstGeom>
           <a:solidFill>
@@ -8614,8 +8478,8 @@
         </p:nvSpPr>
         <p:spPr>
           <a:xfrm>
-            <a:off x="6537960" y="2761488"/>
-            <a:ext cx="4846320" cy="292608"/>
+            <a:off x="822960" y="4663440"/>
+            <a:ext cx="4937760" cy="292608"/>
           </a:xfrm>
           <a:prstGeom prst="rect">
             <a:avLst/>
@@ -8650,7 +8514,7 @@
         </p:nvSpPr>
         <p:spPr>
           <a:xfrm>
-            <a:off x="6537960" y="3172968"/>
+            <a:off x="822960" y="5029200"/>
             <a:ext cx="1188720" cy="292608"/>
           </a:xfrm>
           <a:prstGeom prst="rect">
@@ -8686,7 +8550,7 @@
         </p:nvSpPr>
         <p:spPr>
           <a:xfrm>
-            <a:off x="7772400" y="3246120"/>
+            <a:off x="2103120" y="5102352"/>
             <a:ext cx="3017520" cy="164592"/>
           </a:xfrm>
           <a:prstGeom prst="rect">
@@ -8706,7 +8570,7 @@
         </p:nvSpPr>
         <p:spPr>
           <a:xfrm>
-            <a:off x="7772400" y="3246120"/>
+            <a:off x="2103120" y="5102352"/>
             <a:ext cx="2172614" cy="164592"/>
           </a:xfrm>
           <a:prstGeom prst="rect">
@@ -8726,7 +8590,7 @@
         </p:nvSpPr>
         <p:spPr>
           <a:xfrm>
-            <a:off x="10881360" y="3172968"/>
+            <a:off x="5212080" y="5029200"/>
             <a:ext cx="548640" cy="292608"/>
           </a:xfrm>
           <a:prstGeom prst="rect">
@@ -8762,7 +8626,7 @@
         </p:nvSpPr>
         <p:spPr>
           <a:xfrm>
-            <a:off x="6537960" y="3584448"/>
+            <a:off x="822960" y="5394960"/>
             <a:ext cx="1188720" cy="292608"/>
           </a:xfrm>
           <a:prstGeom prst="rect">
@@ -8798,7 +8662,7 @@
         </p:nvSpPr>
         <p:spPr>
           <a:xfrm>
-            <a:off x="7772400" y="3657600"/>
+            <a:off x="2103120" y="5468112"/>
             <a:ext cx="3017520" cy="164592"/>
           </a:xfrm>
           <a:prstGeom prst="rect">
@@ -8818,7 +8682,7 @@
         </p:nvSpPr>
         <p:spPr>
           <a:xfrm>
-            <a:off x="7772400" y="3657600"/>
+            <a:off x="2103120" y="5468112"/>
             <a:ext cx="2263140" cy="164592"/>
           </a:xfrm>
           <a:prstGeom prst="rect">
@@ -8838,7 +8702,7 @@
         </p:nvSpPr>
         <p:spPr>
           <a:xfrm>
-            <a:off x="10881360" y="3584448"/>
+            <a:off x="5212080" y="5394960"/>
             <a:ext cx="548640" cy="292608"/>
           </a:xfrm>
           <a:prstGeom prst="rect">
@@ -8874,7 +8738,7 @@
         </p:nvSpPr>
         <p:spPr>
           <a:xfrm>
-            <a:off x="6537960" y="3995928"/>
+            <a:off x="822960" y="5760720"/>
             <a:ext cx="1188720" cy="292608"/>
           </a:xfrm>
           <a:prstGeom prst="rect">
@@ -8910,7 +8774,7 @@
         </p:nvSpPr>
         <p:spPr>
           <a:xfrm>
-            <a:off x="7772400" y="4069080"/>
+            <a:off x="2103120" y="5833872"/>
             <a:ext cx="3017520" cy="164592"/>
           </a:xfrm>
           <a:prstGeom prst="rect">
@@ -8930,7 +8794,7 @@
         </p:nvSpPr>
         <p:spPr>
           <a:xfrm>
-            <a:off x="7772400" y="4069080"/>
+            <a:off x="2103120" y="5833872"/>
             <a:ext cx="995782" cy="164592"/>
           </a:xfrm>
           <a:prstGeom prst="rect">
@@ -8950,7 +8814,7 @@
         </p:nvSpPr>
         <p:spPr>
           <a:xfrm>
-            <a:off x="10881360" y="3995928"/>
+            <a:off x="5212080" y="5760720"/>
             <a:ext cx="548640" cy="292608"/>
           </a:xfrm>
           <a:prstGeom prst="rect">
@@ -8978,31 +8842,9 @@
           </a:p>
         </p:txBody>
       </p:sp>
-      <p:sp>
-        <p:nvSpPr>
-          <p:cNvPr id="21" name="heat-card"/>
-          <p:cNvSpPr/>
-          <p:nvPr/>
-        </p:nvSpPr>
-        <p:spPr>
-          <a:xfrm>
-            <a:off x="548640" y="4754880"/>
-            <a:ext cx="11094415" cy="1463040"/>
-          </a:xfrm>
-          <a:prstGeom prst="roundRect">
-            <a:avLst>
-              <a:gd name="adj" fmla="val 5000"/>
-            </a:avLst>
-          </a:prstGeom>
-          <a:solidFill>
-            <a:schemeClr val="bg2"/>
-          </a:solidFill>
-          <a:ln/>
-        </p:spPr>
-      </p:sp>
       <p:pic>
         <p:nvPicPr>
-          <p:cNvPr id="22" name="heat-0" descr="C:\Users\user\_se4nchoi\batteryvision\docs\submission\build\img\heat_atss.jpg">    </p:cNvPr>
+          <p:cNvPr id="21" name="heat-0" descr="C:\Users\user\_se4nchoi\batteryvision\docs\submission\build\img\heat_atss.jpg">    </p:cNvPr>
           <p:cNvPicPr>
             <a:picLocks noChangeAspect="1"/>
           </p:cNvPicPr>
@@ -9016,17 +8858,95 @@
         </p:blipFill>
         <p:spPr>
           <a:xfrm>
-            <a:off x="731520" y="4873752"/>
-            <a:ext cx="1225296" cy="1225296"/>
+            <a:off x="6263640" y="2606040"/>
+            <a:ext cx="2633472" cy="2633472"/>
           </a:xfrm>
           <a:prstGeom prst="rect">
             <a:avLst/>
           </a:prstGeom>
         </p:spPr>
       </p:pic>
+      <p:sp>
+        <p:nvSpPr>
+          <p:cNvPr id="22" name="heat-dot-0"/>
+          <p:cNvSpPr/>
+          <p:nvPr/>
+        </p:nvSpPr>
+        <p:spPr>
+          <a:xfrm>
+            <a:off x="6263640" y="5413248"/>
+            <a:ext cx="146304" cy="146304"/>
+          </a:xfrm>
+          <a:prstGeom prst="ellipse">
+            <a:avLst/>
+          </a:prstGeom>
+          <a:solidFill>
+            <a:schemeClr val="accent4"/>
+          </a:solidFill>
+          <a:ln/>
+        </p:spPr>
+      </p:sp>
+      <p:sp>
+        <p:nvSpPr>
+          <p:cNvPr id="23" name="heat-l-0"/>
+          <p:cNvSpPr txBox="1"/>
+          <p:nvPr/>
+        </p:nvSpPr>
+        <p:spPr>
+          <a:xfrm>
+            <a:off x="6501384" y="5340096"/>
+            <a:ext cx="2377440" cy="292608"/>
+          </a:xfrm>
+          <a:prstGeom prst="rect">
+            <a:avLst/>
+          </a:prstGeom>
+          <a:noFill/>
+          <a:ln/>
+        </p:spPr>
+        <p:txBody>
+          <a:bodyPr wrap="square" lIns="0" tIns="0" rIns="0" bIns="0" rtlCol="0" anchor="t"/>
+          <a:lstStyle/>
+          <a:p>
+            <a:pPr indent="0" marL="0">
+              <a:buNone/>
+            </a:pPr>
+            <a:r>
+              <a:rPr lang="en-US" sz="1400" b="1" dirty="0">
+                <a:solidFill>
+                  <a:schemeClr val="tx1"/>
+                </a:solidFill>
+              </a:rPr>
+              <a:t>ATSS  </a:t>
+            </a:r>
+            <a:pPr indent="0" marL="0">
+              <a:buNone/>
+            </a:pPr>
+            <a:r>
+              <a:rPr lang="en-US" sz="1400" dirty="0">
+                <a:solidFill>
+                  <a:schemeClr val="tx2"/>
+                </a:solidFill>
+              </a:rPr>
+              <a:t>결함 적중 </a:t>
+            </a:r>
+            <a:pPr indent="0" marL="0">
+              <a:buNone/>
+            </a:pPr>
+            <a:r>
+              <a:rPr lang="en-US" sz="1400" b="1" dirty="0">
+                <a:solidFill>
+                  <a:schemeClr val="accent4"/>
+                </a:solidFill>
+              </a:rPr>
+              <a:t>48%</a:t>
+            </a:r>
+            <a:endParaRPr lang="en-US" sz="1400" dirty="0"/>
+          </a:p>
+        </p:txBody>
+      </p:sp>
       <p:pic>
         <p:nvPicPr>
-          <p:cNvPr id="23" name="heat-1" descr="C:\Users\user\_se4nchoi\batteryvision\docs\submission\build\img\heat_yolox.jpg">    </p:cNvPr>
+          <p:cNvPr id="24" name="heat-1" descr="C:\Users\user\_se4nchoi\batteryvision\docs\submission\build\img\heat_yolox.jpg">    </p:cNvPr>
           <p:cNvPicPr>
             <a:picLocks noChangeAspect="1"/>
           </p:cNvPicPr>
@@ -9040,8 +8960,8 @@
         </p:blipFill>
         <p:spPr>
           <a:xfrm>
-            <a:off x="2057400" y="4873752"/>
-            <a:ext cx="1225296" cy="1225296"/>
+            <a:off x="9006840" y="2606040"/>
+            <a:ext cx="2633472" cy="2633472"/>
           </a:xfrm>
           <a:prstGeom prst="rect">
             <a:avLst/>
@@ -9050,14 +8970,34 @@
       </p:pic>
       <p:sp>
         <p:nvSpPr>
-          <p:cNvPr id="24" name="heat-cap"/>
+          <p:cNvPr id="25" name="heat-dot-1"/>
+          <p:cNvSpPr/>
+          <p:nvPr/>
+        </p:nvSpPr>
+        <p:spPr>
+          <a:xfrm>
+            <a:off x="9006840" y="5413248"/>
+            <a:ext cx="146304" cy="146304"/>
+          </a:xfrm>
+          <a:prstGeom prst="ellipse">
+            <a:avLst/>
+          </a:prstGeom>
+          <a:solidFill>
+            <a:schemeClr val="accent5"/>
+          </a:solidFill>
+          <a:ln/>
+        </p:spPr>
+      </p:sp>
+      <p:sp>
+        <p:nvSpPr>
+          <p:cNvPr id="26" name="heat-l-1"/>
           <p:cNvSpPr txBox="1"/>
           <p:nvPr/>
         </p:nvSpPr>
         <p:spPr>
           <a:xfrm>
-            <a:off x="3566160" y="4892040"/>
-            <a:ext cx="7772400" cy="1188720"/>
+            <a:off x="9244584" y="5340096"/>
+            <a:ext cx="2377440" cy="292608"/>
           </a:xfrm>
           <a:prstGeom prst="rect">
             <a:avLst/>
@@ -9066,68 +9006,79 @@
           <a:ln/>
         </p:spPr>
         <p:txBody>
-          <a:bodyPr wrap="square" lIns="0" tIns="0" rIns="0" bIns="0" rtlCol="0" anchor="ctr"/>
+          <a:bodyPr wrap="square" lIns="0" tIns="0" rIns="0" bIns="0" rtlCol="0" anchor="t"/>
           <a:lstStyle/>
           <a:p>
             <a:pPr indent="0" marL="0">
               <a:buNone/>
             </a:pPr>
             <a:r>
-              <a:rPr lang="en-US" sz="1500" dirty="0">
-                <a:solidFill>
-                  <a:schemeClr val="tx2"/>
+              <a:rPr lang="en-US" sz="1400" b="1" dirty="0">
+                <a:solidFill>
+                  <a:schemeClr val="tx1"/>
                 </a:solidFill>
               </a:rPr>
-              <a:t>heatmap이 결함을 짚은 비율: </a:t>
+              <a:t>YOLOX-S  </a:t>
             </a:r>
             <a:pPr indent="0" marL="0">
               <a:buNone/>
             </a:pPr>
             <a:r>
-              <a:rPr lang="en-US" sz="1500" b="1" dirty="0">
-                <a:solidFill>
-                  <a:schemeClr val="accent5"/>
+              <a:rPr lang="en-US" sz="1400" dirty="0">
+                <a:solidFill>
+                  <a:schemeClr val="tx2"/>
                 </a:solidFill>
               </a:rPr>
-              <a:t>YOLOX-S 98%</a:t>
+              <a:t>결함 적중 </a:t>
             </a:r>
             <a:pPr indent="0" marL="0">
               <a:buNone/>
             </a:pPr>
             <a:r>
-              <a:rPr lang="en-US" sz="1500" dirty="0">
-                <a:solidFill>
-                  <a:schemeClr val="tx2"/>
+              <a:rPr lang="en-US" sz="1400" b="1" dirty="0">
+                <a:solidFill>
+                  <a:schemeClr val="accent5"/>
                 </a:solidFill>
               </a:rPr>
-              <a:t> · </a:t>
-            </a:r>
+              <a:t>98%</a:t>
+            </a:r>
+            <a:endParaRPr lang="en-US" sz="1400" dirty="0"/>
+          </a:p>
+        </p:txBody>
+      </p:sp>
+      <p:sp>
+        <p:nvSpPr>
+          <p:cNvPr id="27" name="heat-cap"/>
+          <p:cNvSpPr txBox="1"/>
+          <p:nvPr/>
+        </p:nvSpPr>
+        <p:spPr>
+          <a:xfrm>
+            <a:off x="6263640" y="5760720"/>
+            <a:ext cx="5376672" cy="274320"/>
+          </a:xfrm>
+          <a:prstGeom prst="rect">
+            <a:avLst/>
+          </a:prstGeom>
+          <a:noFill/>
+          <a:ln/>
+        </p:spPr>
+        <p:txBody>
+          <a:bodyPr wrap="square" lIns="0" tIns="0" rIns="0" bIns="0" rtlCol="0" anchor="t"/>
+          <a:lstStyle/>
+          <a:p>
             <a:pPr indent="0" marL="0">
               <a:buNone/>
             </a:pPr>
             <a:r>
-              <a:rPr lang="en-US" sz="1500" b="1" dirty="0">
-                <a:solidFill>
-                  <a:schemeClr val="accent4"/>
+              <a:rPr lang="en-US" sz="1200" dirty="0">
+                <a:solidFill>
+                  <a:schemeClr val="tx2"/>
                 </a:solidFill>
               </a:rPr>
-              <a:t>ATSS 48%</a:t>
-            </a:r>
-            <a:endParaRPr lang="en-US" sz="1500" dirty="0"/>
-          </a:p>
-          <a:p>
-            <a:pPr indent="0" marL="0">
-              <a:buNone/>
-            </a:pPr>
-            <a:r>
-              <a:rPr lang="en-US" sz="1500" b="1" dirty="0">
-                <a:solidFill>
-                  <a:schemeClr val="tx1"/>
-                </a:solidFill>
-              </a:rPr>
-              <a:t>더 정확한 모델이 더 잘 설명하지는 않는다</a:t>
-            </a:r>
-            <a:endParaRPr lang="en-US" sz="1500" dirty="0"/>
+              <a:t>heatmap 최고점이 정답 박스 안 · 정확도 ≠ heatmap 품질</a:t>
+            </a:r>
+            <a:endParaRPr lang="en-US" sz="1200" dirty="0"/>
           </a:p>
         </p:txBody>
       </p:sp>
@@ -9271,7 +9222,7 @@
                   <a:schemeClr val="tx2"/>
                 </a:solidFill>
               </a:rPr>
-              <a:t>수업에서 다룬 양자화를 직접 적용 · 직접 설계한 벤치마크로 측정</a:t>
+              <a:t>수업에서 다룬 양자화 적용 · 직접 만든 벤치마크로 측정</a:t>
             </a:r>
             <a:endParaRPr lang="en-US" sz="1500" dirty="0"/>
           </a:p>
@@ -11228,7 +11179,7 @@
                   <a:schemeClr val="tx1"/>
                 </a:solidFill>
               </a:rPr>
-              <a:t>신뢰도가 낮아져 같은 기준에서 놓침 증가</a:t>
+              <a:t>신뢰도 하락 → 같은 기준에서 놓침 증가</a:t>
             </a:r>
             <a:endParaRPr lang="en-US" sz="1400" dirty="0"/>
           </a:p>
@@ -11246,7 +11197,7 @@
                   <a:schemeClr val="tx1"/>
                 </a:solidFill>
               </a:rPr>
-              <a:t>INT8용 판정 기준값을 다시 정해야 함</a:t>
+              <a:t>INT8용 기준값 재설정 필요</a:t>
             </a:r>
             <a:endParaRPr lang="en-US" sz="1400" dirty="0"/>
           </a:p>
@@ -11392,7 +11343,7 @@
                   <a:schemeClr val="tx2"/>
                 </a:solidFill>
               </a:rPr>
-              <a:t>같은 업로더의 다른 세트(v2) 45장 (결함 30 · 정상 15) · 학습에 전혀 안 쓴 사진 · 내 앱으로 테스트</a:t>
+              <a:t>학습 미사용 · 같은 업로더의 v2 세트 45장 (결함 30 · 정상 15)</a:t>
             </a:r>
             <a:endParaRPr lang="en-US" sz="1500" dirty="0"/>
           </a:p>
@@ -11968,7 +11919,7 @@
                   <a:schemeClr val="tx1"/>
                 </a:solidFill>
               </a:rPr>
-              <a:t>착각이 아니라 점수가 낮아 놓침 · 정상 불합격 0건</a:t>
+              <a:t>클래스 착각 0건 · 점수 미달로 놓침 · 정상 불합격 0건</a:t>
             </a:r>
             <a:endParaRPr lang="en-US" sz="1400" dirty="0"/>
           </a:p>
@@ -11986,7 +11937,7 @@
                   <a:schemeClr val="accent3"/>
                 </a:solidFill>
               </a:rPr>
-              <a:t>원인: 1차는 본 적 있는 사진 포함 + 같은 촬영 환경</a:t>
+              <a:t>1차: 학습 사진 포함 가능 + 같은 촬영 환경</a:t>
             </a:r>
             <a:endParaRPr lang="en-US" sz="1400" dirty="0"/>
           </a:p>
@@ -12891,8 +12842,8 @@
         </p:nvSpPr>
         <p:spPr>
           <a:xfrm>
-            <a:off x="6812280" y="4023360"/>
-            <a:ext cx="4828032" cy="685800"/>
+            <a:off x="6812280" y="3977640"/>
+            <a:ext cx="4828032" cy="365760"/>
           </a:xfrm>
           <a:prstGeom prst="rect">
             <a:avLst/>
@@ -12913,11 +12864,8 @@
                   <a:schemeClr val="tx1"/>
                 </a:solidFill>
               </a:rPr>
-              <a:t>놓침을 줄이면 정상 셀이 같이 걸림</a:t>
-            </a:r>
-            <a:endParaRPr lang="en-US" sz="1500" dirty="0"/>
-          </a:p>
-          <a:p>
+              <a:t>검출 ↑ = 정상 오검출 ↑  </a:t>
+            </a:r>
             <a:pPr indent="0" marL="0">
               <a:buNone/>
             </a:pPr>
@@ -12927,7 +12875,7 @@
                   <a:schemeClr val="accent1"/>
                 </a:solidFill>
               </a:rPr>
-              <a:t>→ 기준값이 아니라 재학습 문제</a:t>
+              <a:t>→ 재학습 필요</a:t>
             </a:r>
             <a:endParaRPr lang="en-US" sz="1500" dirty="0"/>
           </a:p>
@@ -12949,8 +12897,8 @@
         </p:blipFill>
         <p:spPr>
           <a:xfrm>
-            <a:off x="6812280" y="4846320"/>
-            <a:ext cx="1371600" cy="1371600"/>
+            <a:off x="6812280" y="4434840"/>
+            <a:ext cx="1828800" cy="1828800"/>
           </a:xfrm>
           <a:prstGeom prst="rect">
             <a:avLst/>
@@ -12965,8 +12913,8 @@
         </p:nvSpPr>
         <p:spPr>
           <a:xfrm>
-            <a:off x="8366760" y="5074920"/>
-            <a:ext cx="3200400" cy="822960"/>
+            <a:off x="8823960" y="4937760"/>
+            <a:ext cx="2743200" cy="822960"/>
           </a:xfrm>
           <a:prstGeom prst="rect">
             <a:avLst/>
@@ -12982,28 +12930,28 @@
               <a:buNone/>
             </a:pPr>
             <a:r>
-              <a:rPr lang="en-US" sz="1300" b="1" dirty="0">
+              <a:rPr lang="en-US" sz="1400" b="1" dirty="0">
                 <a:solidFill>
                   <a:schemeClr val="tx1"/>
                 </a:solidFill>
               </a:rPr>
               <a:t>놓친 예: scratch</a:t>
             </a:r>
-            <a:endParaRPr lang="en-US" sz="1300" dirty="0"/>
+            <a:endParaRPr lang="en-US" sz="1400" dirty="0"/>
           </a:p>
           <a:p>
             <a:pPr indent="0" marL="0">
               <a:buNone/>
             </a:pPr>
             <a:r>
-              <a:rPr lang="en-US" sz="1300" dirty="0">
+              <a:rPr lang="en-US" sz="1400" dirty="0">
                 <a:solidFill>
                   <a:schemeClr val="tx2"/>
                 </a:solidFill>
               </a:rPr>
               <a:t>ATSS 최고 점수 0.21</a:t>
             </a:r>
-            <a:endParaRPr lang="en-US" sz="1300" dirty="0"/>
+            <a:endParaRPr lang="en-US" sz="1400" dirty="0"/>
           </a:p>
         </p:txBody>
       </p:sp>
@@ -13639,7 +13587,7 @@
                           <a:ea typeface="Malgun Gothic" pitchFamily="34" charset="-122"/>
                           <a:cs typeface="Malgun Gothic" pitchFamily="34" charset="-120"/>
                         </a:rPr>
-                        <a:t>첫 숫자는 좋아 보인다</a:t>
+                        <a:t>–</a:t>
                       </a:r>
                       <a:endParaRPr lang="en-US" sz="1400" dirty="0">
                         <a:latin typeface="Malgun Gothic" charset="0"/>
@@ -13913,7 +13861,7 @@
                           <a:ea typeface="Malgun Gothic" pitchFamily="34" charset="-122"/>
                           <a:cs typeface="Malgun Gothic" pitchFamily="34" charset="-120"/>
                         </a:rPr>
-                        <a:t>점수 그대로, 평가는 정직</a:t>
+                        <a:t>중복 영향 0.4%p</a:t>
                       </a:r>
                       <a:endParaRPr lang="en-US" sz="1400" dirty="0">
                         <a:latin typeface="Malgun Gothic" charset="0"/>
@@ -14187,7 +14135,7 @@
                           <a:ea typeface="Malgun Gothic" pitchFamily="34" charset="-122"/>
                           <a:cs typeface="Malgun Gothic" pitchFamily="34" charset="-120"/>
                         </a:rPr>
-                        <a:t>1차 점수는 비교용으로만</a:t>
+                        <a:t>1차 = 비교용</a:t>
                       </a:r>
                       <a:endParaRPr lang="en-US" sz="1400" dirty="0">
                         <a:latin typeface="Malgun Gothic" charset="0"/>
@@ -14461,7 +14409,7 @@
                           <a:ea typeface="Malgun Gothic" pitchFamily="34" charset="-122"/>
                           <a:cs typeface="Malgun Gothic" pitchFamily="34" charset="-120"/>
                         </a:rPr>
-                        <a:t>큰 모델이 이기지 않는다</a:t>
+                        <a:t>ATSS 최고</a:t>
                       </a:r>
                       <a:endParaRPr lang="en-US" sz="1400" dirty="0">
                         <a:latin typeface="Malgun Gothic" charset="0"/>
@@ -14735,7 +14683,7 @@
                           <a:ea typeface="Malgun Gothic" pitchFamily="34" charset="-122"/>
                           <a:cs typeface="Malgun Gothic" pitchFamily="34" charset="-120"/>
                         </a:rPr>
-                        <a:t>빠르지만 기준값 재조정</a:t>
+                        <a:t>놓침 소폭 증가</a:t>
                       </a:r>
                       <a:endParaRPr lang="en-US" sz="1400" dirty="0">
                         <a:latin typeface="Malgun Gothic" charset="0"/>
@@ -15009,7 +14957,7 @@
                           <a:ea typeface="Malgun Gothic" pitchFamily="34" charset="-122"/>
                           <a:cs typeface="Malgun Gothic" pitchFamily="34" charset="-120"/>
                         </a:rPr>
-                        <a:t>처음 보는 사진의 실력</a:t>
+                        <a:t>환경 변화에 취약</a:t>
                       </a:r>
                       <a:endParaRPr lang="en-US" sz="1400" dirty="0">
                         <a:latin typeface="Malgun Gothic" charset="0"/>
@@ -15283,7 +15231,7 @@
                           <a:ea typeface="Malgun Gothic" pitchFamily="34" charset="-122"/>
                           <a:cs typeface="Malgun Gothic" pitchFamily="34" charset="-120"/>
                         </a:rPr>
-                        <a:t>기준값 X → 재학습 필요</a:t>
+                        <a:t>재학습 필요</a:t>
                       </a:r>
                       <a:endParaRPr lang="en-US" sz="1400" dirty="0">
                         <a:latin typeface="Malgun Gothic" charset="0"/>
@@ -15499,7 +15447,7 @@
                   <a:schemeClr val="tx2"/>
                 </a:solidFill>
               </a:rPr>
-              <a:t>업로드 전에 나누고, 중복·세션도 확인</a:t>
+              <a:t>업로드 전 분리 · 중복 확인</a:t>
             </a:r>
             <a:endParaRPr lang="en-US" sz="1200" dirty="0"/>
           </a:p>
@@ -15629,7 +15577,7 @@
                   <a:schemeClr val="tx2"/>
                 </a:solidFill>
               </a:rPr>
-              <a:t>데이터와 결함에 맞는 모델 선택</a:t>
+              <a:t>3.9M ATSS가 9M YOLOX-S보다 정확</a:t>
             </a:r>
             <a:endParaRPr lang="en-US" sz="1200" dirty="0"/>
           </a:p>
@@ -15759,7 +15707,7 @@
                   <a:schemeClr val="tx2"/>
                 </a:solidFill>
               </a:rPr>
-              <a:t>INT8은 빠르지만 판정 기준을 다시 맞춰야</a:t>
+              <a:t>INT8 = 속도 ↑, 신뢰도 ↓</a:t>
             </a:r>
             <a:endParaRPr lang="en-US" sz="1200" dirty="0"/>
           </a:p>
@@ -15889,7 +15837,7 @@
                   <a:schemeClr val="tx2"/>
                 </a:solidFill>
               </a:rPr>
-              <a:t>환경이 바뀌면 기준값이 아니라 재학습</a:t>
+              <a:t>92.9% → 새 환경 47%</a:t>
             </a:r>
             <a:endParaRPr lang="en-US" sz="1200" dirty="0"/>
           </a:p>

</xml_diff>

<commit_message>
Deck UX: Geti models screenshot vs own benchmark on slide 5; speed chart + compact table on slide 7
Co-Authored-By: Claude Opus 5.5 <noreply@anthropic.com>
</commit_message>
<xml_diff>
--- a/docs/submission/BatteryVision_발표.pptx
+++ b/docs/submission/BatteryVision_발표.pptx
@@ -116,13 +116,13 @@
   <p:extLst>
     <p:ext uri="{521415D9-36F7-43E2-AB2F-B90AF26B5E84}">
       <p14:sectionLst xmlns:p14="http://schemas.microsoft.com/office/powerpoint/2010/main">
-        <p14:section name="도입" id="{bb454593-116b-a06a-9ff6-363bac965195}">
+        <p14:section name="도입" id="{8e06e404-74bf-e672-ad4b-e408d23607d5}">
           <p14:sldIdLst>
             <p14:sldId id="256"/>
             <p14:sldId id="257"/>
           </p14:sldIdLst>
         </p14:section>
-        <p14:section name="실험" id="{c6f94ea2-1a58-32b7-37ea-201e44d4d77a}">
+        <p14:section name="실험" id="{a4425e8b-1365-fc80-ffe0-438ebf9b7772}">
           <p14:sldIdLst>
             <p14:sldId id="258"/>
             <p14:sldId id="259"/>
@@ -130,17 +130,17 @@
             <p14:sldId id="261"/>
           </p14:sldIdLst>
         </p14:section>
-        <p14:section name="최적화" id="{102d892e-0fef-e090-1c18-a23803b32489}">
+        <p14:section name="최적화" id="{4d0c4598-9562-f302-97d3-2ee62463dd91}">
           <p14:sldIdLst>
             <p14:sldId id="262"/>
           </p14:sldIdLst>
         </p14:section>
-        <p14:section name="검증" id="{41b6718e-cc93-73b0-8754-2ba65256846e}">
+        <p14:section name="검증" id="{9b56f984-495f-7db3-7f12-b6f342283212}">
           <p14:sldIdLst>
             <p14:sldId id="263"/>
           </p14:sldIdLst>
         </p14:section>
-        <p14:section name="정리" id="{1f389ea8-297a-f3fe-897f-76397c938f0c}">
+        <p14:section name="정리" id="{0ddf19f7-066e-78f8-bc03-a818d8656fde}">
           <p14:sldIdLst>
             <p14:sldId id="264"/>
             <p14:sldId id="265"/>
@@ -525,6 +525,375 @@
 </c:chartSpace>
 </file>
 
+<file path=ppt/charts/chart2.xml><?xml version="1.0" encoding="utf-8"?>
+<c:chartSpace xmlns:c="http://schemas.openxmlformats.org/drawingml/2006/chart" xmlns:a="http://schemas.openxmlformats.org/drawingml/2006/main" xmlns:r="http://schemas.openxmlformats.org/officeDocument/2006/relationships">
+  <c:date1904 val="0"/>
+  <c:roundedCorners val="1"/>
+  <c:chart>
+    <c:title>
+      <c:tx>
+        <c:rich>
+          <a:bodyPr/>
+          <a:lstStyle/>
+          <a:p>
+            <a:pPr>
+              <a:defRPr sz="1400" b="0" i="0" u="none" strike="noStrike">
+                <a:solidFill>
+                  <a:srgbClr val="EEF1F5"/>
+                </a:solidFill>
+                <a:latin typeface="+mn-lt"/>
+              </a:defRPr>
+            </a:pPr>
+            <a:r>
+              <a:rPr sz="1400" b="0" i="0" u="none" strike="noStrike">
+                <a:solidFill>
+                  <a:srgbClr val="EEF1F5"/>
+                </a:solidFill>
+                <a:latin typeface="+mn-lt"/>
+              </a:rPr>
+              <a:t>CPU ms / 사진 (낮을수록 빠름)</a:t>
+            </a:r>
+          </a:p>
+        </c:rich>
+      </c:tx>
+      <c:layout/>
+      <c:overlay val="0"/>
+    </c:title>
+    <c:autoTitleDeleted val="0"/>
+    <c:plotArea>
+      <c:layout/>
+      <c:barChart>
+        <c:barDir val="col"/>
+        <c:grouping val="clustered"/>
+        <c:varyColors val="0"/>
+        <c:ser>
+          <c:idx val="0"/>
+          <c:order val="0"/>
+          <c:tx>
+            <c:strRef>
+              <c:f>Sheet1!$B$1</c:f>
+              <c:strCache>
+                <c:ptCount val="1"/>
+                <c:pt idx="0">
+                  <c:v>FP16</c:v>
+                </c:pt>
+              </c:strCache>
+            </c:strRef>
+          </c:tx>
+          <c:spPr>
+            <a:solidFill>
+              <a:srgbClr val="6B7480"/>
+            </a:solidFill>
+            <a:effectLst/>
+          </c:spPr>
+          <c:invertIfNegative val="0"/>
+          <c:dLbls>
+            <c:numFmt formatCode="0.0" sourceLinked="0"/>
+            <c:txPr>
+              <a:bodyPr/>
+              <a:lstStyle/>
+              <a:p>
+                <a:pPr>
+                  <a:defRPr b="0" i="0" strike="noStrike" sz="1100" u="none">
+                    <a:solidFill>
+                      <a:srgbClr val="EEF1F5"/>
+                    </a:solidFill>
+                    <a:latin typeface="+mn-lt"/>
+                  </a:defRPr>
+                </a:pPr>
+              </a:p>
+            </c:txPr>
+            <c:showLegendKey val="0"/>
+            <c:showVal val="1"/>
+            <c:showCatName val="0"/>
+            <c:showSerName val="0"/>
+            <c:showPercent val="0"/>
+            <c:showBubbleSize val="0"/>
+            <c:showLeaderLines val="0"/>
+          </c:dLbls>
+          <c:cat>
+            <c:multiLvlStrRef>
+              <c:f>Sheet1!$A$2:$A$4</c:f>
+              <c:multiLvlStrCache>
+                <c:ptCount val="3"/>
+                <c:lvl>
+                  <c:pt idx="0">
+                    <c:v>ATSS</c:v>
+                  </c:pt>
+                  <c:pt idx="1">
+                    <c:v>YOLOX-S</c:v>
+                  </c:pt>
+                  <c:pt idx="2">
+                    <c:v>YOLOX-Tiny</c:v>
+                  </c:pt>
+                </c:lvl>
+              </c:multiLvlStrCache>
+            </c:multiLvlStrRef>
+          </c:cat>
+          <c:val>
+            <c:numRef>
+              <c:f>Sheet1!$B$2:$B$4</c:f>
+              <c:numCache>
+                <c:formatCode>General</c:formatCode>
+                <c:ptCount val="3"/>
+                <c:pt idx="0">
+                  <c:v>43.9</c:v>
+                </c:pt>
+                <c:pt idx="1">
+                  <c:v>48.9</c:v>
+                </c:pt>
+                <c:pt idx="2">
+                  <c:v>33.5</c:v>
+                </c:pt>
+              </c:numCache>
+            </c:numRef>
+          </c:val>
+        </c:ser>
+        <c:ser>
+          <c:idx val="1"/>
+          <c:order val="1"/>
+          <c:tx>
+            <c:strRef>
+              <c:f>Sheet1!$C$1</c:f>
+              <c:strCache>
+                <c:ptCount val="1"/>
+                <c:pt idx="0">
+                  <c:v>INT8</c:v>
+                </c:pt>
+              </c:strCache>
+            </c:strRef>
+          </c:tx>
+          <c:spPr>
+            <a:solidFill>
+              <a:srgbClr val="4FD1C5"/>
+            </a:solidFill>
+            <a:effectLst/>
+          </c:spPr>
+          <c:invertIfNegative val="0"/>
+          <c:dLbls>
+            <c:numFmt formatCode="0.0" sourceLinked="0"/>
+            <c:txPr>
+              <a:bodyPr/>
+              <a:lstStyle/>
+              <a:p>
+                <a:pPr>
+                  <a:defRPr b="0" i="0" strike="noStrike" sz="1100" u="none">
+                    <a:solidFill>
+                      <a:srgbClr val="EEF1F5"/>
+                    </a:solidFill>
+                    <a:latin typeface="+mn-lt"/>
+                  </a:defRPr>
+                </a:pPr>
+              </a:p>
+            </c:txPr>
+            <c:showLegendKey val="0"/>
+            <c:showVal val="1"/>
+            <c:showCatName val="0"/>
+            <c:showSerName val="0"/>
+            <c:showPercent val="0"/>
+            <c:showBubbleSize val="0"/>
+            <c:showLeaderLines val="0"/>
+          </c:dLbls>
+          <c:cat>
+            <c:multiLvlStrRef>
+              <c:f>Sheet1!$A$2:$A$4</c:f>
+              <c:multiLvlStrCache>
+                <c:ptCount val="3"/>
+                <c:lvl>
+                  <c:pt idx="0">
+                    <c:v>ATSS</c:v>
+                  </c:pt>
+                  <c:pt idx="1">
+                    <c:v>YOLOX-S</c:v>
+                  </c:pt>
+                  <c:pt idx="2">
+                    <c:v>YOLOX-Tiny</c:v>
+                  </c:pt>
+                </c:lvl>
+              </c:multiLvlStrCache>
+            </c:multiLvlStrRef>
+          </c:cat>
+          <c:val>
+            <c:numRef>
+              <c:f>Sheet1!$C$2:$C$4</c:f>
+              <c:numCache>
+                <c:formatCode>General</c:formatCode>
+                <c:ptCount val="3"/>
+                <c:pt idx="0">
+                  <c:v>20</c:v>
+                </c:pt>
+                <c:pt idx="1">
+                  <c:v>24.9</c:v>
+                </c:pt>
+                <c:pt idx="2">
+                  <c:v>8.3</c:v>
+                </c:pt>
+              </c:numCache>
+            </c:numRef>
+          </c:val>
+        </c:ser>
+        <c:dLbls>
+          <c:numFmt formatCode="0.0" sourceLinked="0"/>
+          <c:txPr>
+            <a:bodyPr/>
+            <a:lstStyle/>
+            <a:p>
+              <a:pPr>
+                <a:defRPr b="0" i="0" strike="noStrike" sz="1100" u="none">
+                  <a:solidFill>
+                    <a:srgbClr val="EEF1F5"/>
+                  </a:solidFill>
+                  <a:latin typeface="+mn-lt"/>
+                </a:defRPr>
+              </a:pPr>
+            </a:p>
+          </c:txPr>
+          <c:showLegendKey val="0"/>
+          <c:showVal val="1"/>
+          <c:showCatName val="0"/>
+          <c:showSerName val="0"/>
+          <c:showPercent val="0"/>
+          <c:showBubbleSize val="0"/>
+          <c:showLeaderLines val="0"/>
+        </c:dLbls>
+        <c:gapWidth val="55"/>
+        <c:overlap val="0"/>
+        <c:axId val="2094734554"/>
+        <c:axId val="2094734552"/>
+        <c:axId val="2094734556"/>
+      </c:barChart>
+      <c:catAx>
+        <c:axId val="2094734554"/>
+        <c:scaling>
+          <c:orientation val="minMax"/>
+        </c:scaling>
+        <c:delete val="0"/>
+        <c:axPos val="b"/>
+        <c:numFmt formatCode="General" sourceLinked="1"/>
+        <c:majorTickMark val="out"/>
+        <c:minorTickMark val="none"/>
+        <c:tickLblPos val="low"/>
+        <c:spPr>
+          <a:ln w="12700" cap="flat">
+            <a:noFill/>
+            <a:prstDash val="solid"/>
+            <a:round/>
+          </a:ln>
+        </c:spPr>
+        <c:txPr>
+          <a:bodyPr/>
+          <a:lstStyle/>
+          <a:p>
+            <a:pPr>
+              <a:defRPr sz="1200" b="0" i="0" u="none" strike="noStrike">
+                <a:solidFill>
+                  <a:srgbClr val="EEF1F5"/>
+                </a:solidFill>
+                <a:latin typeface="+mn-lt"/>
+              </a:defRPr>
+            </a:pPr>
+            <a:endParaRPr lang="en-US"/>
+          </a:p>
+        </c:txPr>
+        <c:crossAx val="2094734552"/>
+        <c:crosses val="autoZero"/>
+        <c:auto val="1"/>
+        <c:lblAlgn val="ctr"/>
+        <c:noMultiLvlLbl val="1"/>
+      </c:catAx>
+      <c:valAx>
+        <c:axId val="2094734552"/>
+        <c:scaling>
+          <c:orientation val="minMax"/>
+          <c:min val="0"/>
+        </c:scaling>
+        <c:delete val="0"/>
+        <c:axPos val="l"/>
+        <c:majorGridlines>
+          <c:spPr>
+            <a:ln w="6350" cap="flat">
+              <a:solidFill>
+                <a:srgbClr val="3A3F48"/>
+              </a:solidFill>
+              <a:prstDash val="solid"/>
+              <a:round/>
+            </a:ln>
+          </c:spPr>
+        </c:majorGridlines>
+        <c:numFmt formatCode="0" sourceLinked="0"/>
+        <c:majorTickMark val="out"/>
+        <c:minorTickMark val="none"/>
+        <c:tickLblPos val="nextTo"/>
+        <c:spPr>
+          <a:ln w="12700" cap="flat">
+            <a:noFill/>
+            <a:prstDash val="solid"/>
+            <a:round/>
+          </a:ln>
+        </c:spPr>
+        <c:txPr>
+          <a:bodyPr/>
+          <a:lstStyle/>
+          <a:p>
+            <a:pPr>
+              <a:defRPr sz="1100" b="0" i="0" u="none" strike="noStrike">
+                <a:solidFill>
+                  <a:srgbClr val="9AA4B2"/>
+                </a:solidFill>
+                <a:latin typeface="+mn-lt"/>
+              </a:defRPr>
+            </a:pPr>
+            <a:endParaRPr lang="en-US"/>
+          </a:p>
+        </c:txPr>
+        <c:crossAx val="2094734554"/>
+        <c:crosses val="autoZero"/>
+        <c:crossBetween val="between"/>
+      </c:valAx>
+      <c:spPr>
+        <a:noFill/>
+        <a:ln>
+          <a:noFill/>
+        </a:ln>
+        <a:effectLst/>
+      </c:spPr>
+    </c:plotArea>
+    <c:legend>
+      <c:legendPos val="t"/>
+      <c:overlay val="0"/>
+      <c:txPr>
+        <a:bodyPr/>
+        <a:lstStyle/>
+        <a:p>
+          <a:pPr>
+            <a:defRPr sz="1200">
+              <a:solidFill>
+                <a:srgbClr val="EEF1F5"/>
+              </a:solidFill>
+              <a:latin typeface="+mn-lt"/>
+              <a:cs typeface="+mn-lt"/>
+            </a:defRPr>
+          </a:pPr>
+          <a:endParaRPr lang="en-US"/>
+        </a:p>
+      </c:txPr>
+    </c:legend>
+    <c:plotVisOnly val="1"/>
+    <c:dispBlanksAs val="span"/>
+  </c:chart>
+  <c:spPr>
+    <a:noFill/>
+    <a:ln>
+      <a:noFill/>
+    </a:ln>
+    <a:effectLst/>
+  </c:spPr>
+  <c:externalData r:id="rId1">
+    <c:autoUpdate val="0"/>
+  </c:externalData>
+</c:chartSpace>
+</file>
+
 <file path=ppt/notesMasters/notesMaster1.xml><?xml version="1.0" encoding="utf-8"?>
 <p:notesMaster xmlns:a="http://schemas.openxmlformats.org/drawingml/2006/main" xmlns:r="http://schemas.openxmlformats.org/officeDocument/2006/relationships" xmlns:p="http://schemas.openxmlformats.org/presentationml/2006/main">
   <p:cSld>
@@ -1360,7 +1729,7 @@
           <a:p>
             <a:r>
               <a:rPr lang="en-US" dirty="0"/>
-              <a:t>세 모델을 기본 FP16으로 비교했습니다. 파라미터가 가장 적은 ATSS가 92.9%로 가장 정확했고, Geti 점수도 같은 순서입니다. 처음 보는 2차 세트에서도 ATSS가 YOLOX-S보다 훨씬 많이 잡았습니다. 다만 '작다'는 파라미터 기준이고, 연산량은 Tiny가 가장 적습니다. 그리고 1차 점수는 학습 사진이 섞였을 수 있어서, 모델끼리 비교하는 용도로만 봅니다.</a:t>
+              <a:t>왼쪽은 Geti 화면입니다. 세 모델 모두 같은 2,800장으로 학습했고, Geti 점수는 ATSS 86%, 나머지 81%입니다. 오른쪽은 직접 만든 벤치마크로 잰 값인데 순서가 같습니다. 파라미터가 가장 적은 ATSS가 가장 정확했고, 학습에 안 쓴 2차 세트에서도 ATSS가 YOLOX-S보다 훨씬 많이 잡았습니다. 다만 '작다'는 파라미터 기준이고, 연산량은 Tiny가 가장 적습니다.</a:t>
             </a:r>
             <a:endParaRPr lang="en-US" dirty="0"/>
           </a:p>
@@ -6141,64 +6510,46 @@
                   <a:schemeClr val="tx2"/>
                 </a:solidFill>
               </a:rPr>
-              <a:t>FP16 기준 · 1차 테스트 131장</a:t>
+              <a:t>FP16 기준 · Geti 화면 vs 직접 측정</a:t>
             </a:r>
             <a:endParaRPr lang="en-US" sz="1500" dirty="0"/>
           </a:p>
         </p:txBody>
       </p:sp>
-      <p:sp>
-        <p:nvSpPr>
-          <p:cNvPr id="4" name="model-0"/>
-          <p:cNvSpPr/>
+      <p:pic>
+        <p:nvPicPr>
+          <p:cNvPr id="4" name="geti-models" descr="C:\Users\user\_se4nchoi\batteryvision\docs\submission\build\img\geti_models.png">    </p:cNvPr>
+          <p:cNvPicPr>
+            <a:picLocks noChangeAspect="1"/>
+          </p:cNvPicPr>
           <p:nvPr/>
-        </p:nvSpPr>
-        <p:spPr>
-          <a:xfrm>
-            <a:off x="548640" y="1645920"/>
-            <a:ext cx="3566160" cy="2834640"/>
-          </a:xfrm>
-          <a:prstGeom prst="roundRect">
-            <a:avLst>
-              <a:gd name="adj" fmla="val 2581"/>
-            </a:avLst>
-          </a:prstGeom>
-          <a:solidFill>
-            <a:schemeClr val="bg2"/>
-          </a:solidFill>
-          <a:ln/>
-        </p:spPr>
-      </p:sp>
-      <p:sp>
-        <p:nvSpPr>
-          <p:cNvPr id="5" name="model-dot-0"/>
-          <p:cNvSpPr/>
-          <p:nvPr/>
-        </p:nvSpPr>
-        <p:spPr>
-          <a:xfrm>
-            <a:off x="822960" y="1865376"/>
-            <a:ext cx="146304" cy="146304"/>
-          </a:xfrm>
-          <a:prstGeom prst="ellipse">
-            <a:avLst/>
-          </a:prstGeom>
-          <a:solidFill>
-            <a:schemeClr val="accent4"/>
-          </a:solidFill>
-          <a:ln/>
-        </p:spPr>
-      </p:sp>
-      <p:sp>
-        <p:nvSpPr>
-          <p:cNvPr id="6" name="model-n-0"/>
+        </p:nvPicPr>
+        <p:blipFill>
+          <a:blip r:embed="rId1"/>
+          <a:stretch>
+            <a:fillRect/>
+          </a:stretch>
+        </p:blipFill>
+        <p:spPr>
+          <a:xfrm>
+            <a:off x="548640" y="1600200"/>
+            <a:ext cx="4282112" cy="4617720"/>
+          </a:xfrm>
+          <a:prstGeom prst="rect">
+            <a:avLst/>
+          </a:prstGeom>
+        </p:spPr>
+      </p:pic>
+      <p:sp>
+        <p:nvSpPr>
+          <p:cNvPr id="5" name="own-h"/>
           <p:cNvSpPr txBox="1"/>
           <p:nvPr/>
         </p:nvSpPr>
         <p:spPr>
           <a:xfrm>
-            <a:off x="1060704" y="1783080"/>
-            <a:ext cx="2194560" cy="320040"/>
+            <a:off x="5150792" y="1600200"/>
+            <a:ext cx="6492263" cy="320040"/>
           </a:xfrm>
           <a:prstGeom prst="rect">
             <a:avLst/>
@@ -6219,26 +6570,356 @@
                   <a:schemeClr val="tx1"/>
                 </a:solidFill>
               </a:rPr>
+              <a:t>직접 측정 · 1차 테스트 131장</a:t>
+            </a:r>
+            <a:endParaRPr lang="en-US" sz="1600" dirty="0"/>
+          </a:p>
+        </p:txBody>
+      </p:sp>
+      <p:sp>
+        <p:nvSpPr>
+          <p:cNvPr id="6" name="own-col-0"/>
+          <p:cNvSpPr txBox="1"/>
+          <p:nvPr/>
+        </p:nvSpPr>
+        <p:spPr>
+          <a:xfrm>
+            <a:off x="7665392" y="2011680"/>
+            <a:ext cx="1600200" cy="274320"/>
+          </a:xfrm>
+          <a:prstGeom prst="rect">
+            <a:avLst/>
+          </a:prstGeom>
+          <a:noFill/>
+          <a:ln/>
+        </p:spPr>
+        <p:txBody>
+          <a:bodyPr wrap="square" lIns="0" tIns="0" rIns="0" bIns="0" rtlCol="0" anchor="t"/>
+          <a:lstStyle/>
+          <a:p>
+            <a:pPr algn="r" indent="0" marL="0">
+              <a:buNone/>
+            </a:pPr>
+            <a:r>
+              <a:rPr lang="en-US" sz="1200" dirty="0">
+                <a:solidFill>
+                  <a:schemeClr val="tx2"/>
+                </a:solidFill>
+              </a:rPr>
+              <a:t>mAP@50</a:t>
+            </a:r>
+            <a:endParaRPr lang="en-US" sz="1200" dirty="0"/>
+          </a:p>
+        </p:txBody>
+      </p:sp>
+      <p:sp>
+        <p:nvSpPr>
+          <p:cNvPr id="7" name="own-col-1"/>
+          <p:cNvSpPr txBox="1"/>
+          <p:nvPr/>
+        </p:nvSpPr>
+        <p:spPr>
+          <a:xfrm>
+            <a:off x="9311312" y="2011680"/>
+            <a:ext cx="1097280" cy="274320"/>
+          </a:xfrm>
+          <a:prstGeom prst="rect">
+            <a:avLst/>
+          </a:prstGeom>
+          <a:noFill/>
+          <a:ln/>
+        </p:spPr>
+        <p:txBody>
+          <a:bodyPr wrap="square" lIns="0" tIns="0" rIns="0" bIns="0" rtlCol="0" anchor="t"/>
+          <a:lstStyle/>
+          <a:p>
+            <a:pPr algn="r" indent="0" marL="0">
+              <a:buNone/>
+            </a:pPr>
+            <a:r>
+              <a:rPr lang="en-US" sz="1200" dirty="0">
+                <a:solidFill>
+                  <a:schemeClr val="tx2"/>
+                </a:solidFill>
+              </a:rPr>
+              <a:t>scratch AP</a:t>
+            </a:r>
+            <a:endParaRPr lang="en-US" sz="1200" dirty="0"/>
+          </a:p>
+        </p:txBody>
+      </p:sp>
+      <p:sp>
+        <p:nvSpPr>
+          <p:cNvPr id="8" name="own-col-2"/>
+          <p:cNvSpPr txBox="1"/>
+          <p:nvPr/>
+        </p:nvSpPr>
+        <p:spPr>
+          <a:xfrm>
+            <a:off x="10179992" y="2011680"/>
+            <a:ext cx="1280160" cy="274320"/>
+          </a:xfrm>
+          <a:prstGeom prst="rect">
+            <a:avLst/>
+          </a:prstGeom>
+          <a:noFill/>
+          <a:ln/>
+        </p:spPr>
+        <p:txBody>
+          <a:bodyPr wrap="square" lIns="0" tIns="0" rIns="0" bIns="0" rtlCol="0" anchor="t"/>
+          <a:lstStyle/>
+          <a:p>
+            <a:pPr algn="r" indent="0" marL="0">
+              <a:buNone/>
+            </a:pPr>
+            <a:r>
+              <a:rPr lang="en-US" sz="1200" dirty="0">
+                <a:solidFill>
+                  <a:schemeClr val="tx2"/>
+                </a:solidFill>
+              </a:rPr>
+              <a:t>2차 세트 검출</a:t>
+            </a:r>
+            <a:endParaRPr lang="en-US" sz="1200" dirty="0"/>
+          </a:p>
+        </p:txBody>
+      </p:sp>
+      <p:sp>
+        <p:nvSpPr>
+          <p:cNvPr id="9" name="own-row-0"/>
+          <p:cNvSpPr/>
+          <p:nvPr/>
+        </p:nvSpPr>
+        <p:spPr>
+          <a:xfrm>
+            <a:off x="5150792" y="2377440"/>
+            <a:ext cx="6492263" cy="1051560"/>
+          </a:xfrm>
+          <a:prstGeom prst="roundRect">
+            <a:avLst>
+              <a:gd name="adj" fmla="val 6957"/>
+            </a:avLst>
+          </a:prstGeom>
+          <a:solidFill>
+            <a:schemeClr val="bg2"/>
+          </a:solidFill>
+          <a:ln/>
+        </p:spPr>
+      </p:sp>
+      <p:sp>
+        <p:nvSpPr>
+          <p:cNvPr id="10" name="own-dot-0"/>
+          <p:cNvSpPr/>
+          <p:nvPr/>
+        </p:nvSpPr>
+        <p:spPr>
+          <a:xfrm>
+            <a:off x="5379392" y="2606040"/>
+            <a:ext cx="146304" cy="146304"/>
+          </a:xfrm>
+          <a:prstGeom prst="ellipse">
+            <a:avLst/>
+          </a:prstGeom>
+          <a:solidFill>
+            <a:schemeClr val="accent4"/>
+          </a:solidFill>
+          <a:ln/>
+        </p:spPr>
+      </p:sp>
+      <p:sp>
+        <p:nvSpPr>
+          <p:cNvPr id="11" name="own-n-0"/>
+          <p:cNvSpPr txBox="1"/>
+          <p:nvPr/>
+        </p:nvSpPr>
+        <p:spPr>
+          <a:xfrm>
+            <a:off x="5607992" y="2514600"/>
+            <a:ext cx="2103120" cy="320040"/>
+          </a:xfrm>
+          <a:prstGeom prst="rect">
+            <a:avLst/>
+          </a:prstGeom>
+          <a:noFill/>
+          <a:ln/>
+        </p:spPr>
+        <p:txBody>
+          <a:bodyPr wrap="square" lIns="0" tIns="0" rIns="0" bIns="0" rtlCol="0" anchor="t"/>
+          <a:lstStyle/>
+          <a:p>
+            <a:pPr indent="0" marL="0">
+              <a:buNone/>
+            </a:pPr>
+            <a:r>
+              <a:rPr lang="en-US" sz="1500" b="1" dirty="0">
+                <a:solidFill>
+                  <a:schemeClr val="tx1"/>
+                </a:solidFill>
+              </a:rPr>
               <a:t>ATSS-MobileNetV2</a:t>
             </a:r>
-            <a:endParaRPr lang="en-US" sz="1600" dirty="0"/>
+            <a:endParaRPr lang="en-US" sz="1500" dirty="0"/>
           </a:p>
         </p:txBody>
       </p:sp>
       <p:sp>
         <p:nvSpPr>
-          <p:cNvPr id="7" name="best-badge"/>
+          <p:cNvPr id="12" name="own-s-0"/>
+          <p:cNvSpPr txBox="1"/>
+          <p:nvPr/>
+        </p:nvSpPr>
+        <p:spPr>
+          <a:xfrm>
+            <a:off x="5607992" y="2926080"/>
+            <a:ext cx="2103120" cy="274320"/>
+          </a:xfrm>
+          <a:prstGeom prst="rect">
+            <a:avLst/>
+          </a:prstGeom>
+          <a:noFill/>
+          <a:ln/>
+        </p:spPr>
+        <p:txBody>
+          <a:bodyPr wrap="square" lIns="0" tIns="0" rIns="0" bIns="0" rtlCol="0" anchor="t"/>
+          <a:lstStyle/>
+          <a:p>
+            <a:pPr indent="0" marL="0">
+              <a:buNone/>
+            </a:pPr>
+            <a:r>
+              <a:rPr lang="en-US" sz="1200" dirty="0">
+                <a:solidFill>
+                  <a:schemeClr val="tx2"/>
+                </a:solidFill>
+              </a:rPr>
+              <a:t>3.9M · 20.6 GFLOPs</a:t>
+            </a:r>
+            <a:endParaRPr lang="en-US" sz="1200" dirty="0"/>
+          </a:p>
+        </p:txBody>
+      </p:sp>
+      <p:sp>
+        <p:nvSpPr>
+          <p:cNvPr id="13" name="own-m-0"/>
+          <p:cNvSpPr txBox="1"/>
+          <p:nvPr/>
+        </p:nvSpPr>
+        <p:spPr>
+          <a:xfrm>
+            <a:off x="7665392" y="2487168"/>
+            <a:ext cx="1600200" cy="822960"/>
+          </a:xfrm>
+          <a:prstGeom prst="rect">
+            <a:avLst/>
+          </a:prstGeom>
+          <a:noFill/>
+          <a:ln/>
+        </p:spPr>
+        <p:txBody>
+          <a:bodyPr wrap="square" lIns="0" tIns="0" rIns="0" bIns="0" rtlCol="0" anchor="ctr"/>
+          <a:lstStyle/>
+          <a:p>
+            <a:pPr algn="r" indent="0" marL="0">
+              <a:buNone/>
+            </a:pPr>
+            <a:r>
+              <a:rPr lang="en-US" sz="3400" b="1" dirty="0">
+                <a:solidFill>
+                  <a:schemeClr val="accent4"/>
+                </a:solidFill>
+              </a:rPr>
+              <a:t>92.9%</a:t>
+            </a:r>
+            <a:endParaRPr lang="en-US" sz="3400" dirty="0"/>
+          </a:p>
+        </p:txBody>
+      </p:sp>
+      <p:sp>
+        <p:nvSpPr>
+          <p:cNvPr id="14" name="own-a-0"/>
+          <p:cNvSpPr txBox="1"/>
+          <p:nvPr/>
+        </p:nvSpPr>
+        <p:spPr>
+          <a:xfrm>
+            <a:off x="9311312" y="2487168"/>
+            <a:ext cx="1097280" cy="822960"/>
+          </a:xfrm>
+          <a:prstGeom prst="rect">
+            <a:avLst/>
+          </a:prstGeom>
+          <a:noFill/>
+          <a:ln/>
+        </p:spPr>
+        <p:txBody>
+          <a:bodyPr wrap="square" lIns="0" tIns="0" rIns="0" bIns="0" rtlCol="0" anchor="ctr"/>
+          <a:lstStyle/>
+          <a:p>
+            <a:pPr algn="r" indent="0" marL="0">
+              <a:buNone/>
+            </a:pPr>
+            <a:r>
+              <a:rPr lang="en-US" sz="1800" dirty="0">
+                <a:solidFill>
+                  <a:schemeClr val="tx1"/>
+                </a:solidFill>
+              </a:rPr>
+              <a:t>0.86</a:t>
+            </a:r>
+            <a:endParaRPr lang="en-US" sz="1800" dirty="0"/>
+          </a:p>
+        </p:txBody>
+      </p:sp>
+      <p:sp>
+        <p:nvSpPr>
+          <p:cNvPr id="15" name="own-h2-0"/>
+          <p:cNvSpPr txBox="1"/>
+          <p:nvPr/>
+        </p:nvSpPr>
+        <p:spPr>
+          <a:xfrm>
+            <a:off x="10454312" y="2487168"/>
+            <a:ext cx="1005840" cy="822960"/>
+          </a:xfrm>
+          <a:prstGeom prst="rect">
+            <a:avLst/>
+          </a:prstGeom>
+          <a:noFill/>
+          <a:ln/>
+        </p:spPr>
+        <p:txBody>
+          <a:bodyPr wrap="square" lIns="0" tIns="0" rIns="0" bIns="0" rtlCol="0" anchor="ctr"/>
+          <a:lstStyle/>
+          <a:p>
+            <a:pPr algn="r" indent="0" marL="0">
+              <a:buNone/>
+            </a:pPr>
+            <a:r>
+              <a:rPr lang="en-US" sz="1800" b="1" dirty="0">
+                <a:solidFill>
+                  <a:schemeClr val="accent2"/>
+                </a:solidFill>
+              </a:rPr>
+              <a:t>47%</a:t>
+            </a:r>
+            <a:endParaRPr lang="en-US" sz="1800" dirty="0"/>
+          </a:p>
+        </p:txBody>
+      </p:sp>
+      <p:sp>
+        <p:nvSpPr>
+          <p:cNvPr id="16" name="best-badge"/>
           <p:cNvSpPr/>
           <p:nvPr/>
         </p:nvSpPr>
         <p:spPr>
           <a:xfrm>
-            <a:off x="3246120" y="1801368"/>
-            <a:ext cx="640080" cy="274320"/>
+            <a:off x="7071032" y="2944368"/>
+            <a:ext cx="502920" cy="237744"/>
           </a:xfrm>
           <a:prstGeom prst="roundRect">
             <a:avLst>
-              <a:gd name="adj" fmla="val 16667"/>
+              <a:gd name="adj" fmla="val 15385"/>
             </a:avLst>
           </a:prstGeom>
           <a:solidFill>
@@ -6249,14 +6930,14 @@
       </p:sp>
       <p:sp>
         <p:nvSpPr>
-          <p:cNvPr id="8" name="best-t"/>
+          <p:cNvPr id="17" name="best-t"/>
           <p:cNvSpPr txBox="1"/>
           <p:nvPr/>
         </p:nvSpPr>
         <p:spPr>
           <a:xfrm>
-            <a:off x="3246120" y="1801368"/>
-            <a:ext cx="640080" cy="274320"/>
+            <a:off x="7071032" y="2944368"/>
+            <a:ext cx="502920" cy="237744"/>
           </a:xfrm>
           <a:prstGeom prst="rect">
             <a:avLst/>
@@ -6272,27 +6953,69 @@
               <a:buNone/>
             </a:pPr>
             <a:r>
-              <a:rPr lang="en-US" sz="1100" b="1" dirty="0">
+              <a:rPr lang="en-US" sz="1000" b="1" dirty="0">
                 <a:solidFill>
                   <a:schemeClr val="bg1"/>
                 </a:solidFill>
               </a:rPr>
               <a:t>최고</a:t>
             </a:r>
-            <a:endParaRPr lang="en-US" sz="1100" dirty="0"/>
+            <a:endParaRPr lang="en-US" sz="1000" dirty="0"/>
           </a:p>
         </p:txBody>
       </p:sp>
       <p:sp>
         <p:nvSpPr>
-          <p:cNvPr id="9" name="model-s-0"/>
+          <p:cNvPr id="18" name="own-row-1"/>
+          <p:cNvSpPr/>
+          <p:nvPr/>
+        </p:nvSpPr>
+        <p:spPr>
+          <a:xfrm>
+            <a:off x="5150792" y="3566160"/>
+            <a:ext cx="6492263" cy="1051560"/>
+          </a:xfrm>
+          <a:prstGeom prst="roundRect">
+            <a:avLst>
+              <a:gd name="adj" fmla="val 6957"/>
+            </a:avLst>
+          </a:prstGeom>
+          <a:solidFill>
+            <a:schemeClr val="bg2"/>
+          </a:solidFill>
+          <a:ln/>
+        </p:spPr>
+      </p:sp>
+      <p:sp>
+        <p:nvSpPr>
+          <p:cNvPr id="19" name="own-dot-1"/>
+          <p:cNvSpPr/>
+          <p:nvPr/>
+        </p:nvSpPr>
+        <p:spPr>
+          <a:xfrm>
+            <a:off x="5379392" y="3794760"/>
+            <a:ext cx="146304" cy="146304"/>
+          </a:xfrm>
+          <a:prstGeom prst="ellipse">
+            <a:avLst/>
+          </a:prstGeom>
+          <a:solidFill>
+            <a:schemeClr val="accent5"/>
+          </a:solidFill>
+          <a:ln/>
+        </p:spPr>
+      </p:sp>
+      <p:sp>
+        <p:nvSpPr>
+          <p:cNvPr id="20" name="own-n-1"/>
           <p:cNvSpPr txBox="1"/>
           <p:nvPr/>
         </p:nvSpPr>
         <p:spPr>
           <a:xfrm>
-            <a:off x="822960" y="2194560"/>
-            <a:ext cx="3154680" cy="274320"/>
+            <a:off x="5607992" y="3703320"/>
+            <a:ext cx="2103120" cy="320040"/>
           </a:xfrm>
           <a:prstGeom prst="rect">
             <a:avLst/>
@@ -6308,210 +7031,27 @@
               <a:buNone/>
             </a:pPr>
             <a:r>
-              <a:rPr lang="en-US" sz="1300" dirty="0">
-                <a:solidFill>
-                  <a:schemeClr val="tx2"/>
-                </a:solidFill>
-              </a:rPr>
-              <a:t>파라미터 </a:t>
-            </a:r>
-            <a:pPr indent="0" marL="0">
-              <a:buNone/>
-            </a:pPr>
-            <a:r>
-              <a:rPr lang="en-US" sz="1300" b="1" dirty="0">
-                <a:solidFill>
-                  <a:schemeClr val="tx1"/>
-                </a:solidFill>
-              </a:rPr>
-              <a:t>3.9M</a:t>
-            </a:r>
-            <a:pPr indent="0" marL="0">
-              <a:buNone/>
-            </a:pPr>
-            <a:r>
-              <a:rPr lang="en-US" sz="1300" dirty="0">
-                <a:solidFill>
-                  <a:schemeClr val="tx2"/>
-                </a:solidFill>
-              </a:rPr>
-              <a:t>   연산량 </a:t>
-            </a:r>
-            <a:pPr indent="0" marL="0">
-              <a:buNone/>
-            </a:pPr>
-            <a:r>
-              <a:rPr lang="en-US" sz="1300" b="1" dirty="0">
-                <a:solidFill>
-                  <a:schemeClr val="tx1"/>
-                </a:solidFill>
-              </a:rPr>
-              <a:t>20.6 GFLOPs</a:t>
-            </a:r>
-            <a:endParaRPr lang="en-US" sz="1300" dirty="0"/>
-          </a:p>
-        </p:txBody>
-      </p:sp>
-      <p:sp>
-        <p:nvSpPr>
-          <p:cNvPr id="10" name="model-m-0"/>
-          <p:cNvSpPr txBox="1"/>
-          <p:nvPr/>
-        </p:nvSpPr>
-        <p:spPr>
-          <a:xfrm>
-            <a:off x="822960" y="2697480"/>
-            <a:ext cx="3108960" cy="1005840"/>
-          </a:xfrm>
-          <a:prstGeom prst="rect">
-            <a:avLst/>
-          </a:prstGeom>
-          <a:noFill/>
-          <a:ln/>
-        </p:spPr>
-        <p:txBody>
-          <a:bodyPr wrap="square" lIns="0" tIns="0" rIns="0" bIns="0" rtlCol="0" anchor="t"/>
-          <a:lstStyle/>
-          <a:p>
-            <a:pPr indent="0" marL="0">
-              <a:buNone/>
-            </a:pPr>
-            <a:r>
-              <a:rPr lang="en-US" sz="5400" b="1" dirty="0">
-                <a:solidFill>
-                  <a:schemeClr val="accent4"/>
-                </a:solidFill>
-              </a:rPr>
-              <a:t>92.9%</a:t>
-            </a:r>
-            <a:endParaRPr lang="en-US" sz="5400" dirty="0"/>
-          </a:p>
-        </p:txBody>
-      </p:sp>
-      <p:sp>
-        <p:nvSpPr>
-          <p:cNvPr id="11" name="model-a-0"/>
-          <p:cNvSpPr txBox="1"/>
-          <p:nvPr/>
-        </p:nvSpPr>
-        <p:spPr>
-          <a:xfrm>
-            <a:off x="822960" y="3886200"/>
-            <a:ext cx="3108960" cy="274320"/>
-          </a:xfrm>
-          <a:prstGeom prst="rect">
-            <a:avLst/>
-          </a:prstGeom>
-          <a:noFill/>
-          <a:ln/>
-        </p:spPr>
-        <p:txBody>
-          <a:bodyPr wrap="square" lIns="0" tIns="0" rIns="0" bIns="0" rtlCol="0" anchor="t"/>
-          <a:lstStyle/>
-          <a:p>
-            <a:pPr indent="0" marL="0">
-              <a:buNone/>
-            </a:pPr>
-            <a:r>
-              <a:rPr lang="en-US" sz="1400" dirty="0">
-                <a:solidFill>
-                  <a:schemeClr val="tx2"/>
-                </a:solidFill>
-              </a:rPr>
-              <a:t>mAP@50 · scratch AP 0.86</a:t>
-            </a:r>
-            <a:endParaRPr lang="en-US" sz="1400" dirty="0"/>
-          </a:p>
-        </p:txBody>
-      </p:sp>
-      <p:sp>
-        <p:nvSpPr>
-          <p:cNvPr id="12" name="model-1"/>
-          <p:cNvSpPr/>
-          <p:nvPr/>
-        </p:nvSpPr>
-        <p:spPr>
-          <a:xfrm>
-            <a:off x="4297680" y="1645920"/>
-            <a:ext cx="3566160" cy="2834640"/>
-          </a:xfrm>
-          <a:prstGeom prst="roundRect">
-            <a:avLst>
-              <a:gd name="adj" fmla="val 2581"/>
-            </a:avLst>
-          </a:prstGeom>
-          <a:solidFill>
-            <a:schemeClr val="bg2"/>
-          </a:solidFill>
-          <a:ln/>
-        </p:spPr>
-      </p:sp>
-      <p:sp>
-        <p:nvSpPr>
-          <p:cNvPr id="13" name="model-dot-1"/>
-          <p:cNvSpPr/>
-          <p:nvPr/>
-        </p:nvSpPr>
-        <p:spPr>
-          <a:xfrm>
-            <a:off x="4572000" y="1865376"/>
-            <a:ext cx="146304" cy="146304"/>
-          </a:xfrm>
-          <a:prstGeom prst="ellipse">
-            <a:avLst/>
-          </a:prstGeom>
-          <a:solidFill>
-            <a:schemeClr val="accent5"/>
-          </a:solidFill>
-          <a:ln/>
-        </p:spPr>
-      </p:sp>
-      <p:sp>
-        <p:nvSpPr>
-          <p:cNvPr id="14" name="model-n-1"/>
-          <p:cNvSpPr txBox="1"/>
-          <p:nvPr/>
-        </p:nvSpPr>
-        <p:spPr>
-          <a:xfrm>
-            <a:off x="4809744" y="1783080"/>
-            <a:ext cx="2194560" cy="320040"/>
-          </a:xfrm>
-          <a:prstGeom prst="rect">
-            <a:avLst/>
-          </a:prstGeom>
-          <a:noFill/>
-          <a:ln/>
-        </p:spPr>
-        <p:txBody>
-          <a:bodyPr wrap="square" lIns="0" tIns="0" rIns="0" bIns="0" rtlCol="0" anchor="t"/>
-          <a:lstStyle/>
-          <a:p>
-            <a:pPr indent="0" marL="0">
-              <a:buNone/>
-            </a:pPr>
-            <a:r>
-              <a:rPr lang="en-US" sz="1600" b="1" dirty="0">
+              <a:rPr lang="en-US" sz="1500" b="1" dirty="0">
                 <a:solidFill>
                   <a:schemeClr val="tx1"/>
                 </a:solidFill>
               </a:rPr>
               <a:t>YOLOX-S</a:t>
             </a:r>
-            <a:endParaRPr lang="en-US" sz="1600" dirty="0"/>
+            <a:endParaRPr lang="en-US" sz="1500" dirty="0"/>
           </a:p>
         </p:txBody>
       </p:sp>
       <p:sp>
         <p:nvSpPr>
-          <p:cNvPr id="15" name="model-s-1"/>
+          <p:cNvPr id="21" name="own-s-1"/>
           <p:cNvSpPr txBox="1"/>
           <p:nvPr/>
         </p:nvSpPr>
         <p:spPr>
           <a:xfrm>
-            <a:off x="4572000" y="2194560"/>
-            <a:ext cx="3154680" cy="274320"/>
+            <a:off x="5607992" y="4114800"/>
+            <a:ext cx="2103120" cy="274320"/>
           </a:xfrm>
           <a:prstGeom prst="rect">
             <a:avLst/>
@@ -6527,96 +7067,177 @@
               <a:buNone/>
             </a:pPr>
             <a:r>
-              <a:rPr lang="en-US" sz="1300" dirty="0">
+              <a:rPr lang="en-US" sz="1200" dirty="0">
                 <a:solidFill>
                   <a:schemeClr val="tx2"/>
                 </a:solidFill>
               </a:rPr>
-              <a:t>파라미터 </a:t>
+              <a:t>9M · 26.8 GFLOPs</a:t>
             </a:r>
-            <a:pPr indent="0" marL="0">
+            <a:endParaRPr lang="en-US" sz="1200" dirty="0"/>
+          </a:p>
+        </p:txBody>
+      </p:sp>
+      <p:sp>
+        <p:nvSpPr>
+          <p:cNvPr id="22" name="own-m-1"/>
+          <p:cNvSpPr txBox="1"/>
+          <p:nvPr/>
+        </p:nvSpPr>
+        <p:spPr>
+          <a:xfrm>
+            <a:off x="7665392" y="3675888"/>
+            <a:ext cx="1600200" cy="822960"/>
+          </a:xfrm>
+          <a:prstGeom prst="rect">
+            <a:avLst/>
+          </a:prstGeom>
+          <a:noFill/>
+          <a:ln/>
+        </p:spPr>
+        <p:txBody>
+          <a:bodyPr wrap="square" lIns="0" tIns="0" rIns="0" bIns="0" rtlCol="0" anchor="ctr"/>
+          <a:lstStyle/>
+          <a:p>
+            <a:pPr algn="r" indent="0" marL="0">
               <a:buNone/>
             </a:pPr>
             <a:r>
-              <a:rPr lang="en-US" sz="1300" b="1" dirty="0">
-                <a:solidFill>
-                  <a:schemeClr val="tx1"/>
-                </a:solidFill>
-              </a:rPr>
-              <a:t>9M</a:t>
-            </a:r>
-            <a:pPr indent="0" marL="0">
-              <a:buNone/>
-            </a:pPr>
-            <a:r>
-              <a:rPr lang="en-US" sz="1300" dirty="0">
-                <a:solidFill>
-                  <a:schemeClr val="tx2"/>
-                </a:solidFill>
-              </a:rPr>
-              <a:t>   연산량 </a:t>
-            </a:r>
-            <a:pPr indent="0" marL="0">
-              <a:buNone/>
-            </a:pPr>
-            <a:r>
-              <a:rPr lang="en-US" sz="1300" b="1" dirty="0">
-                <a:solidFill>
-                  <a:schemeClr val="tx1"/>
-                </a:solidFill>
-              </a:rPr>
-              <a:t>26.8 GFLOPs</a:t>
-            </a:r>
-            <a:endParaRPr lang="en-US" sz="1300" dirty="0"/>
-          </a:p>
-        </p:txBody>
-      </p:sp>
-      <p:sp>
-        <p:nvSpPr>
-          <p:cNvPr id="16" name="model-m-1"/>
-          <p:cNvSpPr txBox="1"/>
-          <p:nvPr/>
-        </p:nvSpPr>
-        <p:spPr>
-          <a:xfrm>
-            <a:off x="4572000" y="2697480"/>
-            <a:ext cx="3108960" cy="1005840"/>
-          </a:xfrm>
-          <a:prstGeom prst="rect">
-            <a:avLst/>
-          </a:prstGeom>
-          <a:noFill/>
-          <a:ln/>
-        </p:spPr>
-        <p:txBody>
-          <a:bodyPr wrap="square" lIns="0" tIns="0" rIns="0" bIns="0" rtlCol="0" anchor="t"/>
-          <a:lstStyle/>
-          <a:p>
-            <a:pPr indent="0" marL="0">
-              <a:buNone/>
-            </a:pPr>
-            <a:r>
-              <a:rPr lang="en-US" sz="5400" b="1" dirty="0">
+              <a:rPr lang="en-US" sz="3400" b="1" dirty="0">
                 <a:solidFill>
                   <a:schemeClr val="accent5"/>
                 </a:solidFill>
               </a:rPr>
               <a:t>89.2%</a:t>
             </a:r>
-            <a:endParaRPr lang="en-US" sz="5400" dirty="0"/>
+            <a:endParaRPr lang="en-US" sz="3400" dirty="0"/>
           </a:p>
         </p:txBody>
       </p:sp>
       <p:sp>
         <p:nvSpPr>
-          <p:cNvPr id="17" name="model-a-1"/>
+          <p:cNvPr id="23" name="own-a-1"/>
           <p:cNvSpPr txBox="1"/>
           <p:nvPr/>
         </p:nvSpPr>
         <p:spPr>
           <a:xfrm>
-            <a:off x="4572000" y="3886200"/>
-            <a:ext cx="3108960" cy="274320"/>
+            <a:off x="9311312" y="3675888"/>
+            <a:ext cx="1097280" cy="822960"/>
+          </a:xfrm>
+          <a:prstGeom prst="rect">
+            <a:avLst/>
+          </a:prstGeom>
+          <a:noFill/>
+          <a:ln/>
+        </p:spPr>
+        <p:txBody>
+          <a:bodyPr wrap="square" lIns="0" tIns="0" rIns="0" bIns="0" rtlCol="0" anchor="ctr"/>
+          <a:lstStyle/>
+          <a:p>
+            <a:pPr algn="r" indent="0" marL="0">
+              <a:buNone/>
+            </a:pPr>
+            <a:r>
+              <a:rPr lang="en-US" sz="1800" dirty="0">
+                <a:solidFill>
+                  <a:schemeClr val="tx1"/>
+                </a:solidFill>
+              </a:rPr>
+              <a:t>0.78</a:t>
+            </a:r>
+            <a:endParaRPr lang="en-US" sz="1800" dirty="0"/>
+          </a:p>
+        </p:txBody>
+      </p:sp>
+      <p:sp>
+        <p:nvSpPr>
+          <p:cNvPr id="24" name="own-h2-1"/>
+          <p:cNvSpPr txBox="1"/>
+          <p:nvPr/>
+        </p:nvSpPr>
+        <p:spPr>
+          <a:xfrm>
+            <a:off x="10454312" y="3675888"/>
+            <a:ext cx="1005840" cy="822960"/>
+          </a:xfrm>
+          <a:prstGeom prst="rect">
+            <a:avLst/>
+          </a:prstGeom>
+          <a:noFill/>
+          <a:ln/>
+        </p:spPr>
+        <p:txBody>
+          <a:bodyPr wrap="square" lIns="0" tIns="0" rIns="0" bIns="0" rtlCol="0" anchor="ctr"/>
+          <a:lstStyle/>
+          <a:p>
+            <a:pPr algn="r" indent="0" marL="0">
+              <a:buNone/>
+            </a:pPr>
+            <a:r>
+              <a:rPr lang="en-US" sz="1800" b="1" dirty="0">
+                <a:solidFill>
+                  <a:schemeClr val="accent2"/>
+                </a:solidFill>
+              </a:rPr>
+              <a:t>3%</a:t>
+            </a:r>
+            <a:endParaRPr lang="en-US" sz="1800" dirty="0"/>
+          </a:p>
+        </p:txBody>
+      </p:sp>
+      <p:sp>
+        <p:nvSpPr>
+          <p:cNvPr id="25" name="own-row-2"/>
+          <p:cNvSpPr/>
+          <p:nvPr/>
+        </p:nvSpPr>
+        <p:spPr>
+          <a:xfrm>
+            <a:off x="5150792" y="4754880"/>
+            <a:ext cx="6492263" cy="1051560"/>
+          </a:xfrm>
+          <a:prstGeom prst="roundRect">
+            <a:avLst>
+              <a:gd name="adj" fmla="val 6957"/>
+            </a:avLst>
+          </a:prstGeom>
+          <a:solidFill>
+            <a:schemeClr val="bg2"/>
+          </a:solidFill>
+          <a:ln/>
+        </p:spPr>
+      </p:sp>
+      <p:sp>
+        <p:nvSpPr>
+          <p:cNvPr id="26" name="own-dot-2"/>
+          <p:cNvSpPr/>
+          <p:nvPr/>
+        </p:nvSpPr>
+        <p:spPr>
+          <a:xfrm>
+            <a:off x="5379392" y="4983480"/>
+            <a:ext cx="146304" cy="146304"/>
+          </a:xfrm>
+          <a:prstGeom prst="ellipse">
+            <a:avLst/>
+          </a:prstGeom>
+          <a:solidFill>
+            <a:schemeClr val="accent6"/>
+          </a:solidFill>
+          <a:ln/>
+        </p:spPr>
+      </p:sp>
+      <p:sp>
+        <p:nvSpPr>
+          <p:cNvPr id="27" name="own-n-2"/>
+          <p:cNvSpPr txBox="1"/>
+          <p:nvPr/>
+        </p:nvSpPr>
+        <p:spPr>
+          <a:xfrm>
+            <a:off x="5607992" y="4892040"/>
+            <a:ext cx="2103120" cy="320040"/>
           </a:xfrm>
           <a:prstGeom prst="rect">
             <a:avLst/>
@@ -6632,105 +7253,27 @@
               <a:buNone/>
             </a:pPr>
             <a:r>
-              <a:rPr lang="en-US" sz="1400" dirty="0">
-                <a:solidFill>
-                  <a:schemeClr val="tx2"/>
-                </a:solidFill>
-              </a:rPr>
-              <a:t>mAP@50 · scratch AP 0.78</a:t>
-            </a:r>
-            <a:endParaRPr lang="en-US" sz="1400" dirty="0"/>
-          </a:p>
-        </p:txBody>
-      </p:sp>
-      <p:sp>
-        <p:nvSpPr>
-          <p:cNvPr id="18" name="model-2"/>
-          <p:cNvSpPr/>
-          <p:nvPr/>
-        </p:nvSpPr>
-        <p:spPr>
-          <a:xfrm>
-            <a:off x="8046720" y="1645920"/>
-            <a:ext cx="3566160" cy="2834640"/>
-          </a:xfrm>
-          <a:prstGeom prst="roundRect">
-            <a:avLst>
-              <a:gd name="adj" fmla="val 2581"/>
-            </a:avLst>
-          </a:prstGeom>
-          <a:solidFill>
-            <a:schemeClr val="bg2"/>
-          </a:solidFill>
-          <a:ln/>
-        </p:spPr>
-      </p:sp>
-      <p:sp>
-        <p:nvSpPr>
-          <p:cNvPr id="19" name="model-dot-2"/>
-          <p:cNvSpPr/>
-          <p:nvPr/>
-        </p:nvSpPr>
-        <p:spPr>
-          <a:xfrm>
-            <a:off x="8321040" y="1865376"/>
-            <a:ext cx="146304" cy="146304"/>
-          </a:xfrm>
-          <a:prstGeom prst="ellipse">
-            <a:avLst/>
-          </a:prstGeom>
-          <a:solidFill>
-            <a:schemeClr val="accent6"/>
-          </a:solidFill>
-          <a:ln/>
-        </p:spPr>
-      </p:sp>
-      <p:sp>
-        <p:nvSpPr>
-          <p:cNvPr id="20" name="model-n-2"/>
-          <p:cNvSpPr txBox="1"/>
-          <p:nvPr/>
-        </p:nvSpPr>
-        <p:spPr>
-          <a:xfrm>
-            <a:off x="8558784" y="1783080"/>
-            <a:ext cx="2194560" cy="320040"/>
-          </a:xfrm>
-          <a:prstGeom prst="rect">
-            <a:avLst/>
-          </a:prstGeom>
-          <a:noFill/>
-          <a:ln/>
-        </p:spPr>
-        <p:txBody>
-          <a:bodyPr wrap="square" lIns="0" tIns="0" rIns="0" bIns="0" rtlCol="0" anchor="t"/>
-          <a:lstStyle/>
-          <a:p>
-            <a:pPr indent="0" marL="0">
-              <a:buNone/>
-            </a:pPr>
-            <a:r>
-              <a:rPr lang="en-US" sz="1600" b="1" dirty="0">
+              <a:rPr lang="en-US" sz="1500" b="1" dirty="0">
                 <a:solidFill>
                   <a:schemeClr val="tx1"/>
                 </a:solidFill>
               </a:rPr>
               <a:t>YOLOX-Tiny</a:t>
             </a:r>
-            <a:endParaRPr lang="en-US" sz="1600" dirty="0"/>
+            <a:endParaRPr lang="en-US" sz="1500" dirty="0"/>
           </a:p>
         </p:txBody>
       </p:sp>
       <p:sp>
         <p:nvSpPr>
-          <p:cNvPr id="21" name="model-s-2"/>
+          <p:cNvPr id="28" name="own-s-2"/>
           <p:cNvSpPr txBox="1"/>
           <p:nvPr/>
         </p:nvSpPr>
         <p:spPr>
           <a:xfrm>
-            <a:off x="8321040" y="2194560"/>
-            <a:ext cx="3154680" cy="274320"/>
+            <a:off x="5607992" y="5303520"/>
+            <a:ext cx="2103120" cy="274320"/>
           </a:xfrm>
           <a:prstGeom prst="rect">
             <a:avLst/>
@@ -6746,96 +7289,135 @@
               <a:buNone/>
             </a:pPr>
             <a:r>
-              <a:rPr lang="en-US" sz="1300" dirty="0">
+              <a:rPr lang="en-US" sz="1200" dirty="0">
                 <a:solidFill>
                   <a:schemeClr val="tx2"/>
                 </a:solidFill>
               </a:rPr>
-              <a:t>파라미터 </a:t>
+              <a:t>5.06M · 6.45 GFLOPs</a:t>
             </a:r>
-            <a:pPr indent="0" marL="0">
+            <a:endParaRPr lang="en-US" sz="1200" dirty="0"/>
+          </a:p>
+        </p:txBody>
+      </p:sp>
+      <p:sp>
+        <p:nvSpPr>
+          <p:cNvPr id="29" name="own-m-2"/>
+          <p:cNvSpPr txBox="1"/>
+          <p:nvPr/>
+        </p:nvSpPr>
+        <p:spPr>
+          <a:xfrm>
+            <a:off x="7665392" y="4864608"/>
+            <a:ext cx="1600200" cy="822960"/>
+          </a:xfrm>
+          <a:prstGeom prst="rect">
+            <a:avLst/>
+          </a:prstGeom>
+          <a:noFill/>
+          <a:ln/>
+        </p:spPr>
+        <p:txBody>
+          <a:bodyPr wrap="square" lIns="0" tIns="0" rIns="0" bIns="0" rtlCol="0" anchor="ctr"/>
+          <a:lstStyle/>
+          <a:p>
+            <a:pPr algn="r" indent="0" marL="0">
               <a:buNone/>
             </a:pPr>
             <a:r>
-              <a:rPr lang="en-US" sz="1300" b="1" dirty="0">
-                <a:solidFill>
-                  <a:schemeClr val="tx1"/>
-                </a:solidFill>
-              </a:rPr>
-              <a:t>5.06M</a:t>
-            </a:r>
-            <a:pPr indent="0" marL="0">
-              <a:buNone/>
-            </a:pPr>
-            <a:r>
-              <a:rPr lang="en-US" sz="1300" dirty="0">
-                <a:solidFill>
-                  <a:schemeClr val="tx2"/>
-                </a:solidFill>
-              </a:rPr>
-              <a:t>   연산량 </a:t>
-            </a:r>
-            <a:pPr indent="0" marL="0">
-              <a:buNone/>
-            </a:pPr>
-            <a:r>
-              <a:rPr lang="en-US" sz="1300" b="1" dirty="0">
-                <a:solidFill>
-                  <a:schemeClr val="tx1"/>
-                </a:solidFill>
-              </a:rPr>
-              <a:t>6.45 GFLOPs</a:t>
-            </a:r>
-            <a:endParaRPr lang="en-US" sz="1300" dirty="0"/>
-          </a:p>
-        </p:txBody>
-      </p:sp>
-      <p:sp>
-        <p:nvSpPr>
-          <p:cNvPr id="22" name="model-m-2"/>
-          <p:cNvSpPr txBox="1"/>
-          <p:nvPr/>
-        </p:nvSpPr>
-        <p:spPr>
-          <a:xfrm>
-            <a:off x="8321040" y="2697480"/>
-            <a:ext cx="3108960" cy="1005840"/>
-          </a:xfrm>
-          <a:prstGeom prst="rect">
-            <a:avLst/>
-          </a:prstGeom>
-          <a:noFill/>
-          <a:ln/>
-        </p:spPr>
-        <p:txBody>
-          <a:bodyPr wrap="square" lIns="0" tIns="0" rIns="0" bIns="0" rtlCol="0" anchor="t"/>
-          <a:lstStyle/>
-          <a:p>
-            <a:pPr indent="0" marL="0">
-              <a:buNone/>
-            </a:pPr>
-            <a:r>
-              <a:rPr lang="en-US" sz="5400" b="1" dirty="0">
+              <a:rPr lang="en-US" sz="3400" b="1" dirty="0">
                 <a:solidFill>
                   <a:schemeClr val="accent6"/>
                 </a:solidFill>
               </a:rPr>
               <a:t>83.2%</a:t>
             </a:r>
-            <a:endParaRPr lang="en-US" sz="5400" dirty="0"/>
+            <a:endParaRPr lang="en-US" sz="3400" dirty="0"/>
           </a:p>
         </p:txBody>
       </p:sp>
       <p:sp>
         <p:nvSpPr>
-          <p:cNvPr id="23" name="model-a-2"/>
+          <p:cNvPr id="30" name="own-a-2"/>
           <p:cNvSpPr txBox="1"/>
           <p:nvPr/>
         </p:nvSpPr>
         <p:spPr>
           <a:xfrm>
-            <a:off x="8321040" y="3886200"/>
-            <a:ext cx="3108960" cy="274320"/>
+            <a:off x="9311312" y="4864608"/>
+            <a:ext cx="1097280" cy="822960"/>
+          </a:xfrm>
+          <a:prstGeom prst="rect">
+            <a:avLst/>
+          </a:prstGeom>
+          <a:noFill/>
+          <a:ln/>
+        </p:spPr>
+        <p:txBody>
+          <a:bodyPr wrap="square" lIns="0" tIns="0" rIns="0" bIns="0" rtlCol="0" anchor="ctr"/>
+          <a:lstStyle/>
+          <a:p>
+            <a:pPr algn="r" indent="0" marL="0">
+              <a:buNone/>
+            </a:pPr>
+            <a:r>
+              <a:rPr lang="en-US" sz="1800" dirty="0">
+                <a:solidFill>
+                  <a:schemeClr val="tx1"/>
+                </a:solidFill>
+              </a:rPr>
+              <a:t>0.66</a:t>
+            </a:r>
+            <a:endParaRPr lang="en-US" sz="1800" dirty="0"/>
+          </a:p>
+        </p:txBody>
+      </p:sp>
+      <p:sp>
+        <p:nvSpPr>
+          <p:cNvPr id="31" name="own-h2-2"/>
+          <p:cNvSpPr txBox="1"/>
+          <p:nvPr/>
+        </p:nvSpPr>
+        <p:spPr>
+          <a:xfrm>
+            <a:off x="10454312" y="4864608"/>
+            <a:ext cx="1005840" cy="822960"/>
+          </a:xfrm>
+          <a:prstGeom prst="rect">
+            <a:avLst/>
+          </a:prstGeom>
+          <a:noFill/>
+          <a:ln/>
+        </p:spPr>
+        <p:txBody>
+          <a:bodyPr wrap="square" lIns="0" tIns="0" rIns="0" bIns="0" rtlCol="0" anchor="ctr"/>
+          <a:lstStyle/>
+          <a:p>
+            <a:pPr algn="r" indent="0" marL="0">
+              <a:buNone/>
+            </a:pPr>
+            <a:r>
+              <a:rPr lang="en-US" sz="1800" b="1" dirty="0">
+                <a:solidFill>
+                  <a:schemeClr val="accent2"/>
+                </a:solidFill>
+              </a:rPr>
+              <a:t>47%</a:t>
+            </a:r>
+            <a:endParaRPr lang="en-US" sz="1800" dirty="0"/>
+          </a:p>
+        </p:txBody>
+      </p:sp>
+      <p:sp>
+        <p:nvSpPr>
+          <p:cNvPr id="32" name="own-note"/>
+          <p:cNvSpPr txBox="1"/>
+          <p:nvPr/>
+        </p:nvSpPr>
+        <p:spPr>
+          <a:xfrm>
+            <a:off x="5150792" y="5943600"/>
+            <a:ext cx="6492263" cy="274320"/>
           </a:xfrm>
           <a:prstGeom prst="rect">
             <a:avLst/>
@@ -6851,246 +7433,14 @@
               <a:buNone/>
             </a:pPr>
             <a:r>
-              <a:rPr lang="en-US" sz="1400" dirty="0">
+              <a:rPr lang="en-US" sz="1200" dirty="0">
                 <a:solidFill>
                   <a:schemeClr val="tx2"/>
                 </a:solidFill>
               </a:rPr>
-              <a:t>mAP@50 · scratch AP 0.66</a:t>
+              <a:t>Geti 점수와 같은 순서 · 작은 = 파라미터 기준 (연산량은 Tiny 최소)</a:t>
             </a:r>
-            <a:endParaRPr lang="en-US" sz="1400" dirty="0"/>
-          </a:p>
-        </p:txBody>
-      </p:sp>
-      <p:sp>
-        <p:nvSpPr>
-          <p:cNvPr id="24" name="why-card"/>
-          <p:cNvSpPr/>
-          <p:nvPr/>
-        </p:nvSpPr>
-        <p:spPr>
-          <a:xfrm>
-            <a:off x="548640" y="4709160"/>
-            <a:ext cx="5486400" cy="1508760"/>
-          </a:xfrm>
-          <a:prstGeom prst="roundRect">
-            <a:avLst>
-              <a:gd name="adj" fmla="val 4848"/>
-            </a:avLst>
-          </a:prstGeom>
-          <a:solidFill>
-            <a:schemeClr val="bg2"/>
-          </a:solidFill>
-          <a:ln/>
-        </p:spPr>
-      </p:sp>
-      <p:sp>
-        <p:nvSpPr>
-          <p:cNvPr id="25" name="why-h"/>
-          <p:cNvSpPr txBox="1"/>
-          <p:nvPr/>
-        </p:nvSpPr>
-        <p:spPr>
-          <a:xfrm>
-            <a:off x="822960" y="4828032"/>
-            <a:ext cx="4572000" cy="320040"/>
-          </a:xfrm>
-          <a:prstGeom prst="rect">
-            <a:avLst/>
-          </a:prstGeom>
-          <a:noFill/>
-          <a:ln/>
-        </p:spPr>
-        <p:txBody>
-          <a:bodyPr wrap="square" lIns="0" tIns="0" rIns="0" bIns="0" rtlCol="0" anchor="t"/>
-          <a:lstStyle/>
-          <a:p>
-            <a:pPr indent="0" marL="0">
-              <a:buNone/>
-            </a:pPr>
-            <a:r>
-              <a:rPr lang="en-US" sz="1600" b="1" dirty="0">
-                <a:solidFill>
-                  <a:schemeClr val="accent1"/>
-                </a:solidFill>
-              </a:rPr>
-              <a:t>같은 순서</a:t>
-            </a:r>
-            <a:endParaRPr lang="en-US" sz="1600" dirty="0"/>
-          </a:p>
-        </p:txBody>
-      </p:sp>
-      <p:sp>
-        <p:nvSpPr>
-          <p:cNvPr id="26" name="why-b"/>
-          <p:cNvSpPr txBox="1"/>
-          <p:nvPr/>
-        </p:nvSpPr>
-        <p:spPr>
-          <a:xfrm>
-            <a:off x="822960" y="5212080"/>
-            <a:ext cx="5029200" cy="868680"/>
-          </a:xfrm>
-          <a:prstGeom prst="rect">
-            <a:avLst/>
-          </a:prstGeom>
-          <a:noFill/>
-          <a:ln/>
-        </p:spPr>
-        <p:txBody>
-          <a:bodyPr wrap="square" lIns="0" tIns="0" rIns="0" bIns="0" rtlCol="0" anchor="t"/>
-          <a:lstStyle/>
-          <a:p>
-            <a:pPr marL="342900" indent="-342900">
-              <a:spcAft>
-                <a:spcPts val="600"/>
-              </a:spcAft>
-              <a:buSzPct val="100000"/>
-              <a:buChar char="•"/>
-            </a:pPr>
-            <a:r>
-              <a:rPr lang="en-US" sz="1400" dirty="0">
-                <a:solidFill>
-                  <a:schemeClr val="tx1"/>
-                </a:solidFill>
-              </a:rPr>
-              <a:t>Geti 점수: 86% · 81% · 81%</a:t>
-            </a:r>
-            <a:endParaRPr lang="en-US" sz="1400" dirty="0"/>
-          </a:p>
-          <a:p>
-            <a:pPr marL="342900" indent="-342900">
-              <a:spcAft>
-                <a:spcPts val="600"/>
-              </a:spcAft>
-              <a:buSzPct val="100000"/>
-              <a:buChar char="•"/>
-            </a:pPr>
-            <a:r>
-              <a:rPr lang="en-US" sz="1400" dirty="0">
-                <a:solidFill>
-                  <a:schemeClr val="tx1"/>
-                </a:solidFill>
-              </a:rPr>
-              <a:t>2차 세트 검출: ATSS 47% · YOLOX-S 3%</a:t>
-            </a:r>
-            <a:endParaRPr lang="en-US" sz="1400" dirty="0"/>
-          </a:p>
-        </p:txBody>
-      </p:sp>
-      <p:sp>
-        <p:nvSpPr>
-          <p:cNvPr id="27" name="note-card"/>
-          <p:cNvSpPr/>
-          <p:nvPr/>
-        </p:nvSpPr>
-        <p:spPr>
-          <a:xfrm>
-            <a:off x="6263640" y="4709160"/>
-            <a:ext cx="5376672" cy="1508760"/>
-          </a:xfrm>
-          <a:prstGeom prst="roundRect">
-            <a:avLst>
-              <a:gd name="adj" fmla="val 4848"/>
-            </a:avLst>
-          </a:prstGeom>
-          <a:solidFill>
-            <a:schemeClr val="bg2"/>
-          </a:solidFill>
-          <a:ln/>
-        </p:spPr>
-      </p:sp>
-      <p:sp>
-        <p:nvSpPr>
-          <p:cNvPr id="28" name="note-h"/>
-          <p:cNvSpPr txBox="1"/>
-          <p:nvPr/>
-        </p:nvSpPr>
-        <p:spPr>
-          <a:xfrm>
-            <a:off x="6537960" y="4828032"/>
-            <a:ext cx="4572000" cy="320040"/>
-          </a:xfrm>
-          <a:prstGeom prst="rect">
-            <a:avLst/>
-          </a:prstGeom>
-          <a:noFill/>
-          <a:ln/>
-        </p:spPr>
-        <p:txBody>
-          <a:bodyPr wrap="square" lIns="0" tIns="0" rIns="0" bIns="0" rtlCol="0" anchor="t"/>
-          <a:lstStyle/>
-          <a:p>
-            <a:pPr indent="0" marL="0">
-              <a:buNone/>
-            </a:pPr>
-            <a:r>
-              <a:rPr lang="en-US" sz="1600" b="1" dirty="0">
-                <a:solidFill>
-                  <a:schemeClr val="accent3"/>
-                </a:solidFill>
-              </a:rPr>
-              <a:t>주의</a:t>
-            </a:r>
-            <a:endParaRPr lang="en-US" sz="1600" dirty="0"/>
-          </a:p>
-        </p:txBody>
-      </p:sp>
-      <p:sp>
-        <p:nvSpPr>
-          <p:cNvPr id="29" name="note-b"/>
-          <p:cNvSpPr txBox="1"/>
-          <p:nvPr/>
-        </p:nvSpPr>
-        <p:spPr>
-          <a:xfrm>
-            <a:off x="6537960" y="5212080"/>
-            <a:ext cx="4937760" cy="868680"/>
-          </a:xfrm>
-          <a:prstGeom prst="rect">
-            <a:avLst/>
-          </a:prstGeom>
-          <a:noFill/>
-          <a:ln/>
-        </p:spPr>
-        <p:txBody>
-          <a:bodyPr wrap="square" lIns="0" tIns="0" rIns="0" bIns="0" rtlCol="0" anchor="t"/>
-          <a:lstStyle/>
-          <a:p>
-            <a:pPr marL="342900" indent="-342900">
-              <a:spcAft>
-                <a:spcPts val="600"/>
-              </a:spcAft>
-              <a:buSzPct val="100000"/>
-              <a:buChar char="•"/>
-            </a:pPr>
-            <a:r>
-              <a:rPr lang="en-US" sz="1400" dirty="0">
-                <a:solidFill>
-                  <a:schemeClr val="tx1"/>
-                </a:solidFill>
-              </a:rPr>
-              <a:t>작은 = 파라미터 기준</a:t>
-            </a:r>
-            <a:endParaRPr lang="en-US" sz="1400" dirty="0"/>
-          </a:p>
-          <a:p>
-            <a:pPr marL="342900" indent="-342900">
-              <a:spcAft>
-                <a:spcPts val="600"/>
-              </a:spcAft>
-              <a:buSzPct val="100000"/>
-              <a:buChar char="•"/>
-            </a:pPr>
-            <a:r>
-              <a:rPr lang="en-US" sz="1400" dirty="0">
-                <a:solidFill>
-                  <a:schemeClr val="tx1"/>
-                </a:solidFill>
-              </a:rPr>
-              <a:t>연산량은 Tiny 최소 (6.45 GFLOPs)</a:t>
-            </a:r>
-            <a:endParaRPr lang="en-US" sz="1400" dirty="0"/>
+            <a:endParaRPr lang="en-US" sz="1200" dirty="0"/>
           </a:p>
         </p:txBody>
       </p:sp>
@@ -9230,6 +9580,22 @@
       </p:sp>
       <p:graphicFrame>
         <p:nvGraphicFramePr>
+          <p:cNvPr id="4" name="speed-chart" descr=""/>
+          <p:cNvGraphicFramePr/>
+          <p:nvPr/>
+        </p:nvGraphicFramePr>
+        <p:xfrm>
+          <a:off x="548640" y="1554480"/>
+          <a:ext cx="5760720" cy="3108960"/>
+        </p:xfrm>
+        <a:graphic xmlns:a="http://schemas.openxmlformats.org/drawingml/2006/main">
+          <a:graphicData uri="http://schemas.openxmlformats.org/drawingml/2006/chart">
+            <c:chart xmlns:c="http://schemas.openxmlformats.org/drawingml/2006/chart" r:id="rId1"/>
+          </a:graphicData>
+        </a:graphic>
+      </p:graphicFrame>
+      <p:graphicFrame>
+        <p:nvGraphicFramePr>
           <p:cNvPr id="8" name="int8-table"/>
           <p:cNvGraphicFramePr>
             <a:graphicFrameLocks noGrp="1"/>
@@ -9243,22 +9609,21 @@
           </p:nvPr>
         </p:nvGraphicFramePr>
         <p:xfrm>
-          <a:off x="548640" y="1645920"/>
-          <a:ext cx="11094415" cy="914400"/>
+          <a:off x="6537960" y="1828800"/>
+          <a:ext cx="5102352" cy="914400"/>
         </p:xfrm>
         <a:graphic>
           <a:graphicData uri="http://schemas.openxmlformats.org/drawingml/2006/table">
             <a:tbl>
               <a:tblPr/>
               <a:tblGrid>
-                <a:gridCol w="2194560"/>
-                <a:gridCol w="2103120"/>
-                <a:gridCol w="1005840"/>
-                <a:gridCol w="1645920"/>
-                <a:gridCol w="1920240"/>
-                <a:gridCol w="2221992"/>
+                <a:gridCol w="1188720"/>
+                <a:gridCol w="731520"/>
+                <a:gridCol w="1051560"/>
+                <a:gridCol w="1307592"/>
+                <a:gridCol w="822960"/>
               </a:tblGrid>
-              <a:tr h="530352">
+              <a:tr h="566928">
                 <a:tc>
                   <a:txBody>
                     <a:bodyPr/>
@@ -9268,7 +9633,7 @@
                         <a:buNone/>
                       </a:pPr>
                       <a:r>
-                        <a:rPr lang="en-US" sz="1500" b="1" dirty="0">
+                        <a:rPr lang="en-US" sz="1300" b="1" dirty="0">
                           <a:solidFill>
                             <a:schemeClr val="tx2"/>
                           </a:solidFill>
@@ -9278,7 +9643,7 @@
                         </a:rPr>
                         <a:t>모델</a:t>
                       </a:r>
-                      <a:endParaRPr lang="en-US" sz="1500" dirty="0">
+                      <a:endParaRPr lang="en-US" sz="1300" dirty="0">
                         <a:latin typeface="Malgun Gothic" charset="0"/>
                         <a:ea typeface="Malgun Gothic" charset="0"/>
                         <a:cs typeface="Malgun Gothic" charset="0"/>
@@ -9336,7 +9701,7 @@
                         <a:buNone/>
                       </a:pPr>
                       <a:r>
-                        <a:rPr lang="en-US" sz="1500" b="1" dirty="0">
+                        <a:rPr lang="en-US" sz="1300" b="1" dirty="0">
                           <a:solidFill>
                             <a:schemeClr val="tx2"/>
                           </a:solidFill>
@@ -9344,9 +9709,9 @@
                           <a:ea typeface="Malgun Gothic" pitchFamily="34" charset="-122"/>
                           <a:cs typeface="Malgun Gothic" pitchFamily="34" charset="-120"/>
                         </a:rPr>
-                        <a:t>CPU ms</a:t>
+                        <a:t>속도</a:t>
                       </a:r>
-                      <a:endParaRPr lang="en-US" sz="1500" dirty="0">
+                      <a:endParaRPr lang="en-US" sz="1300" dirty="0">
                         <a:latin typeface="Malgun Gothic" charset="0"/>
                         <a:ea typeface="Malgun Gothic" charset="0"/>
                         <a:cs typeface="Malgun Gothic" charset="0"/>
@@ -9404,7 +9769,7 @@
                         <a:buNone/>
                       </a:pPr>
                       <a:r>
-                        <a:rPr lang="en-US" sz="1500" b="1" dirty="0">
+                        <a:rPr lang="en-US" sz="1300" b="1" dirty="0">
                           <a:solidFill>
                             <a:schemeClr val="tx2"/>
                           </a:solidFill>
@@ -9412,9 +9777,9 @@
                           <a:ea typeface="Malgun Gothic" pitchFamily="34" charset="-122"/>
                           <a:cs typeface="Malgun Gothic" pitchFamily="34" charset="-120"/>
                         </a:rPr>
-                        <a:t>속도</a:t>
+                        <a:t>크기 MB</a:t>
                       </a:r>
-                      <a:endParaRPr lang="en-US" sz="1500" dirty="0">
+                      <a:endParaRPr lang="en-US" sz="1300" dirty="0">
                         <a:latin typeface="Malgun Gothic" charset="0"/>
                         <a:ea typeface="Malgun Gothic" charset="0"/>
                         <a:cs typeface="Malgun Gothic" charset="0"/>
@@ -9472,7 +9837,7 @@
                         <a:buNone/>
                       </a:pPr>
                       <a:r>
-                        <a:rPr lang="en-US" sz="1500" b="1" dirty="0">
+                        <a:rPr lang="en-US" sz="1300" b="1" dirty="0">
                           <a:solidFill>
                             <a:schemeClr val="tx2"/>
                           </a:solidFill>
@@ -9480,9 +9845,9 @@
                           <a:ea typeface="Malgun Gothic" pitchFamily="34" charset="-122"/>
                           <a:cs typeface="Malgun Gothic" pitchFamily="34" charset="-120"/>
                         </a:rPr>
-                        <a:t>크기 MB</a:t>
+                        <a:t>mAP@50</a:t>
                       </a:r>
-                      <a:endParaRPr lang="en-US" sz="1500" dirty="0">
+                      <a:endParaRPr lang="en-US" sz="1300" dirty="0">
                         <a:latin typeface="Malgun Gothic" charset="0"/>
                         <a:ea typeface="Malgun Gothic" charset="0"/>
                         <a:cs typeface="Malgun Gothic" charset="0"/>
@@ -9540,7 +9905,7 @@
                         <a:buNone/>
                       </a:pPr>
                       <a:r>
-                        <a:rPr lang="en-US" sz="1500" b="1" dirty="0">
+                        <a:rPr lang="en-US" sz="1300" b="1" dirty="0">
                           <a:solidFill>
                             <a:schemeClr val="tx2"/>
                           </a:solidFill>
@@ -9548,9 +9913,9 @@
                           <a:ea typeface="Malgun Gothic" pitchFamily="34" charset="-122"/>
                           <a:cs typeface="Malgun Gothic" pitchFamily="34" charset="-120"/>
                         </a:rPr>
-                        <a:t>mAP@50</a:t>
+                        <a:t>놓친 셀</a:t>
                       </a:r>
-                      <a:endParaRPr lang="en-US" sz="1500" dirty="0">
+                      <a:endParaRPr lang="en-US" sz="1300" dirty="0">
                         <a:latin typeface="Malgun Gothic" charset="0"/>
                         <a:ea typeface="Malgun Gothic" charset="0"/>
                         <a:cs typeface="Malgun Gothic" charset="0"/>
@@ -9599,76 +9964,8 @@
                     </a:solidFill>
                   </a:tcPr>
                 </a:tc>
-                <a:tc>
-                  <a:txBody>
-                    <a:bodyPr/>
-                    <a:lstStyle/>
-                    <a:p>
-                      <a:pPr algn="ctr" indent="0" marL="0">
-                        <a:buNone/>
-                      </a:pPr>
-                      <a:r>
-                        <a:rPr lang="en-US" sz="1500" b="1" dirty="0">
-                          <a:solidFill>
-                            <a:schemeClr val="tx2"/>
-                          </a:solidFill>
-                          <a:latin typeface="Malgun Gothic" pitchFamily="34" charset="0"/>
-                          <a:ea typeface="Malgun Gothic" pitchFamily="34" charset="-122"/>
-                          <a:cs typeface="Malgun Gothic" pitchFamily="34" charset="-120"/>
-                        </a:rPr>
-                        <a:t>놓친 결함 셀 (/98)</a:t>
-                      </a:r>
-                      <a:endParaRPr lang="en-US" sz="1500" dirty="0">
-                        <a:latin typeface="Malgun Gothic" charset="0"/>
-                        <a:ea typeface="Malgun Gothic" charset="0"/>
-                        <a:cs typeface="Malgun Gothic" charset="0"/>
-                      </a:endParaRPr>
-                    </a:p>
-                  </a:txBody>
-                  <a:tcPr marL="91440" marR="91440" marT="45720" marB="45720" anchor="ctr">
-                    <a:lnL w="9525" cap="flat" cmpd="sng" algn="ctr">
-                      <a:solidFill>
-                        <a:srgbClr val="3A3F48"/>
-                      </a:solidFill>
-                      <a:prstDash val="solid"/>
-                      <a:round/>
-                      <a:headEnd type="none" w="med" len="med"/>
-                      <a:tailEnd type="none" w="med" len="med"/>
-                    </a:lnL>
-                    <a:lnR w="9525" cap="flat" cmpd="sng" algn="ctr">
-                      <a:solidFill>
-                        <a:srgbClr val="3A3F48"/>
-                      </a:solidFill>
-                      <a:prstDash val="solid"/>
-                      <a:round/>
-                      <a:headEnd type="none" w="med" len="med"/>
-                      <a:tailEnd type="none" w="med" len="med"/>
-                    </a:lnR>
-                    <a:lnT w="9525" cap="flat" cmpd="sng" algn="ctr">
-                      <a:solidFill>
-                        <a:srgbClr val="3A3F48"/>
-                      </a:solidFill>
-                      <a:prstDash val="solid"/>
-                      <a:round/>
-                      <a:headEnd type="none" w="med" len="med"/>
-                      <a:tailEnd type="none" w="med" len="med"/>
-                    </a:lnT>
-                    <a:lnB w="9525" cap="flat" cmpd="sng" algn="ctr">
-                      <a:solidFill>
-                        <a:srgbClr val="3A3F48"/>
-                      </a:solidFill>
-                      <a:prstDash val="solid"/>
-                      <a:round/>
-                      <a:headEnd type="none" w="med" len="med"/>
-                      <a:tailEnd type="none" w="med" len="med"/>
-                    </a:lnB>
-                    <a:solidFill>
-                      <a:srgbClr val="16191E"/>
-                    </a:solidFill>
-                  </a:tcPr>
-                </a:tc>
               </a:tr>
-              <a:tr h="530352">
+              <a:tr h="566928">
                 <a:tc>
                   <a:txBody>
                     <a:bodyPr/>
@@ -9678,7 +9975,7 @@
                         <a:buNone/>
                       </a:pPr>
                       <a:r>
-                        <a:rPr lang="en-US" sz="1500" b="1" dirty="0">
+                        <a:rPr lang="en-US" sz="1300" b="1" dirty="0">
                           <a:solidFill>
                             <a:schemeClr val="accent4"/>
                           </a:solidFill>
@@ -9686,9 +9983,9 @@
                           <a:ea typeface="Malgun Gothic" pitchFamily="34" charset="-122"/>
                           <a:cs typeface="Malgun Gothic" pitchFamily="34" charset="-120"/>
                         </a:rPr>
-                        <a:t>ATSS-MobileNetV2</a:t>
+                        <a:t>ATSS</a:t>
                       </a:r>
-                      <a:endParaRPr lang="en-US" sz="1500" dirty="0">
+                      <a:endParaRPr lang="en-US" sz="1300" dirty="0">
                         <a:latin typeface="Malgun Gothic" charset="0"/>
                         <a:ea typeface="Malgun Gothic" charset="0"/>
                         <a:cs typeface="Malgun Gothic" charset="0"/>
@@ -9746,17 +10043,17 @@
                         <a:buNone/>
                       </a:pPr>
                       <a:r>
-                        <a:rPr lang="en-US" sz="1500" dirty="0">
+                        <a:rPr lang="en-US" sz="1300" b="1" dirty="0">
                           <a:solidFill>
-                            <a:schemeClr val="tx1"/>
+                            <a:schemeClr val="accent1"/>
                           </a:solidFill>
                           <a:latin typeface="Malgun Gothic" pitchFamily="34" charset="0"/>
                           <a:ea typeface="Malgun Gothic" pitchFamily="34" charset="-122"/>
                           <a:cs typeface="Malgun Gothic" pitchFamily="34" charset="-120"/>
                         </a:rPr>
-                        <a:t>43.9 → 20.0</a:t>
+                        <a:t>2.2×</a:t>
                       </a:r>
-                      <a:endParaRPr lang="en-US" sz="1500" dirty="0">
+                      <a:endParaRPr lang="en-US" sz="1300" dirty="0">
                         <a:latin typeface="Malgun Gothic" charset="0"/>
                         <a:ea typeface="Malgun Gothic" charset="0"/>
                         <a:cs typeface="Malgun Gothic" charset="0"/>
@@ -9814,17 +10111,17 @@
                         <a:buNone/>
                       </a:pPr>
                       <a:r>
-                        <a:rPr lang="en-US" sz="1500" b="1" dirty="0">
+                        <a:rPr lang="en-US" sz="1300" dirty="0">
                           <a:solidFill>
-                            <a:schemeClr val="accent1"/>
+                            <a:schemeClr val="tx1"/>
                           </a:solidFill>
                           <a:latin typeface="Malgun Gothic" pitchFamily="34" charset="0"/>
                           <a:ea typeface="Malgun Gothic" pitchFamily="34" charset="-122"/>
                           <a:cs typeface="Malgun Gothic" pitchFamily="34" charset="-120"/>
                         </a:rPr>
-                        <a:t>2.2×</a:t>
+                        <a:t>5.7 → 3.9</a:t>
                       </a:r>
-                      <a:endParaRPr lang="en-US" sz="1500" dirty="0">
+                      <a:endParaRPr lang="en-US" sz="1300" dirty="0">
                         <a:latin typeface="Malgun Gothic" charset="0"/>
                         <a:ea typeface="Malgun Gothic" charset="0"/>
                         <a:cs typeface="Malgun Gothic" charset="0"/>
@@ -9882,7 +10179,7 @@
                         <a:buNone/>
                       </a:pPr>
                       <a:r>
-                        <a:rPr lang="en-US" sz="1500" dirty="0">
+                        <a:rPr lang="en-US" sz="1300" dirty="0">
                           <a:solidFill>
                             <a:schemeClr val="tx1"/>
                           </a:solidFill>
@@ -9890,9 +10187,9 @@
                           <a:ea typeface="Malgun Gothic" pitchFamily="34" charset="-122"/>
                           <a:cs typeface="Malgun Gothic" pitchFamily="34" charset="-120"/>
                         </a:rPr>
-                        <a:t>5.7 → 3.9</a:t>
+                        <a:t>0.929 → 0.929</a:t>
                       </a:r>
-                      <a:endParaRPr lang="en-US" sz="1500" dirty="0">
+                      <a:endParaRPr lang="en-US" sz="1300" dirty="0">
                         <a:latin typeface="Malgun Gothic" charset="0"/>
                         <a:ea typeface="Malgun Gothic" charset="0"/>
                         <a:cs typeface="Malgun Gothic" charset="0"/>
@@ -9950,17 +10247,87 @@
                         <a:buNone/>
                       </a:pPr>
                       <a:r>
-                        <a:rPr lang="en-US" sz="1500" dirty="0">
+                        <a:rPr lang="en-US" sz="1300" dirty="0">
                           <a:solidFill>
-                            <a:schemeClr val="tx1"/>
+                            <a:schemeClr val="accent2"/>
                           </a:solidFill>
                           <a:latin typeface="Malgun Gothic" pitchFamily="34" charset="0"/>
                           <a:ea typeface="Malgun Gothic" pitchFamily="34" charset="-122"/>
                           <a:cs typeface="Malgun Gothic" pitchFamily="34" charset="-120"/>
                         </a:rPr>
-                        <a:t>0.929 → 0.929</a:t>
+                        <a:t>0 → 1</a:t>
                       </a:r>
-                      <a:endParaRPr lang="en-US" sz="1500" dirty="0">
+                      <a:endParaRPr lang="en-US" sz="1300" dirty="0">
+                        <a:latin typeface="Malgun Gothic" charset="0"/>
+                        <a:ea typeface="Malgun Gothic" charset="0"/>
+                        <a:cs typeface="Malgun Gothic" charset="0"/>
+                      </a:endParaRPr>
+                    </a:p>
+                  </a:txBody>
+                  <a:tcPr marL="91440" marR="91440" marT="45720" marB="45720" anchor="ctr">
+                    <a:lnL w="9525" cap="flat" cmpd="sng" algn="ctr">
+                      <a:solidFill>
+                        <a:srgbClr val="3A3F48"/>
+                      </a:solidFill>
+                      <a:prstDash val="solid"/>
+                      <a:round/>
+                      <a:headEnd type="none" w="med" len="med"/>
+                      <a:tailEnd type="none" w="med" len="med"/>
+                    </a:lnL>
+                    <a:lnR w="9525" cap="flat" cmpd="sng" algn="ctr">
+                      <a:solidFill>
+                        <a:srgbClr val="3A3F48"/>
+                      </a:solidFill>
+                      <a:prstDash val="solid"/>
+                      <a:round/>
+                      <a:headEnd type="none" w="med" len="med"/>
+                      <a:tailEnd type="none" w="med" len="med"/>
+                    </a:lnR>
+                    <a:lnT w="9525" cap="flat" cmpd="sng" algn="ctr">
+                      <a:solidFill>
+                        <a:srgbClr val="3A3F48"/>
+                      </a:solidFill>
+                      <a:prstDash val="solid"/>
+                      <a:round/>
+                      <a:headEnd type="none" w="med" len="med"/>
+                      <a:tailEnd type="none" w="med" len="med"/>
+                    </a:lnT>
+                    <a:lnB w="9525" cap="flat" cmpd="sng" algn="ctr">
+                      <a:solidFill>
+                        <a:srgbClr val="3A3F48"/>
+                      </a:solidFill>
+                      <a:prstDash val="solid"/>
+                      <a:round/>
+                      <a:headEnd type="none" w="med" len="med"/>
+                      <a:tailEnd type="none" w="med" len="med"/>
+                    </a:lnB>
+                    <a:solidFill>
+                      <a:srgbClr val="23272F"/>
+                    </a:solidFill>
+                  </a:tcPr>
+                </a:tc>
+              </a:tr>
+              <a:tr h="566928">
+                <a:tc>
+                  <a:txBody>
+                    <a:bodyPr/>
+                    <a:lstStyle/>
+                    <a:p>
+                      <a:pPr algn="l" indent="0" marL="0">
+                        <a:buNone/>
+                      </a:pPr>
+                      <a:r>
+                        <a:rPr lang="en-US" sz="1300" b="1" dirty="0">
+                          <a:solidFill>
+                            <a:schemeClr val="accent5"/>
+                          </a:solidFill>
+                          <a:latin typeface="Malgun Gothic" pitchFamily="34" charset="0"/>
+                          <a:ea typeface="Malgun Gothic" pitchFamily="34" charset="-122"/>
+                          <a:cs typeface="Malgun Gothic" pitchFamily="34" charset="-120"/>
+                        </a:rPr>
+                        <a:t>YOLOX-S</a:t>
+                      </a:r>
+                      <a:endParaRPr lang="en-US" sz="1300" dirty="0">
                         <a:latin typeface="Malgun Gothic" charset="0"/>
                         <a:ea typeface="Malgun Gothic" charset="0"/>
                         <a:cs typeface="Malgun Gothic" charset="0"/>
@@ -10018,87 +10385,17 @@
                         <a:buNone/>
                       </a:pPr>
                       <a:r>
-                        <a:rPr lang="en-US" sz="1500" dirty="0">
+                        <a:rPr lang="en-US" sz="1300" b="1" dirty="0">
                           <a:solidFill>
-                            <a:schemeClr val="accent2"/>
+                            <a:schemeClr val="accent1"/>
                           </a:solidFill>
                           <a:latin typeface="Malgun Gothic" pitchFamily="34" charset="0"/>
                           <a:ea typeface="Malgun Gothic" pitchFamily="34" charset="-122"/>
                           <a:cs typeface="Malgun Gothic" pitchFamily="34" charset="-120"/>
                         </a:rPr>
-                        <a:t>0 → 1</a:t>
+                        <a:t>2.0×</a:t>
                       </a:r>
-                      <a:endParaRPr lang="en-US" sz="1500" dirty="0">
-                        <a:latin typeface="Malgun Gothic" charset="0"/>
-                        <a:ea typeface="Malgun Gothic" charset="0"/>
-                        <a:cs typeface="Malgun Gothic" charset="0"/>
-                      </a:endParaRPr>
-                    </a:p>
-                  </a:txBody>
-                  <a:tcPr marL="91440" marR="91440" marT="45720" marB="45720" anchor="ctr">
-                    <a:lnL w="9525" cap="flat" cmpd="sng" algn="ctr">
-                      <a:solidFill>
-                        <a:srgbClr val="3A3F48"/>
-                      </a:solidFill>
-                      <a:prstDash val="solid"/>
-                      <a:round/>
-                      <a:headEnd type="none" w="med" len="med"/>
-                      <a:tailEnd type="none" w="med" len="med"/>
-                    </a:lnL>
-                    <a:lnR w="9525" cap="flat" cmpd="sng" algn="ctr">
-                      <a:solidFill>
-                        <a:srgbClr val="3A3F48"/>
-                      </a:solidFill>
-                      <a:prstDash val="solid"/>
-                      <a:round/>
-                      <a:headEnd type="none" w="med" len="med"/>
-                      <a:tailEnd type="none" w="med" len="med"/>
-                    </a:lnR>
-                    <a:lnT w="9525" cap="flat" cmpd="sng" algn="ctr">
-                      <a:solidFill>
-                        <a:srgbClr val="3A3F48"/>
-                      </a:solidFill>
-                      <a:prstDash val="solid"/>
-                      <a:round/>
-                      <a:headEnd type="none" w="med" len="med"/>
-                      <a:tailEnd type="none" w="med" len="med"/>
-                    </a:lnT>
-                    <a:lnB w="9525" cap="flat" cmpd="sng" algn="ctr">
-                      <a:solidFill>
-                        <a:srgbClr val="3A3F48"/>
-                      </a:solidFill>
-                      <a:prstDash val="solid"/>
-                      <a:round/>
-                      <a:headEnd type="none" w="med" len="med"/>
-                      <a:tailEnd type="none" w="med" len="med"/>
-                    </a:lnB>
-                    <a:solidFill>
-                      <a:srgbClr val="23272F"/>
-                    </a:solidFill>
-                  </a:tcPr>
-                </a:tc>
-              </a:tr>
-              <a:tr h="530352">
-                <a:tc>
-                  <a:txBody>
-                    <a:bodyPr/>
-                    <a:lstStyle/>
-                    <a:p>
-                      <a:pPr algn="l" indent="0" marL="0">
-                        <a:buNone/>
-                      </a:pPr>
-                      <a:r>
-                        <a:rPr lang="en-US" sz="1500" b="1" dirty="0">
-                          <a:solidFill>
-                            <a:schemeClr val="accent5"/>
-                          </a:solidFill>
-                          <a:latin typeface="Malgun Gothic" pitchFamily="34" charset="0"/>
-                          <a:ea typeface="Malgun Gothic" pitchFamily="34" charset="-122"/>
-                          <a:cs typeface="Malgun Gothic" pitchFamily="34" charset="-120"/>
-                        </a:rPr>
-                        <a:t>YOLOX-S</a:t>
-                      </a:r>
-                      <a:endParaRPr lang="en-US" sz="1500" dirty="0">
+                      <a:endParaRPr lang="en-US" sz="1300" dirty="0">
                         <a:latin typeface="Malgun Gothic" charset="0"/>
                         <a:ea typeface="Malgun Gothic" charset="0"/>
                         <a:cs typeface="Malgun Gothic" charset="0"/>
@@ -10156,7 +10453,7 @@
                         <a:buNone/>
                       </a:pPr>
                       <a:r>
-                        <a:rPr lang="en-US" sz="1500" dirty="0">
+                        <a:rPr lang="en-US" sz="1300" dirty="0">
                           <a:solidFill>
                             <a:schemeClr val="tx1"/>
                           </a:solidFill>
@@ -10164,9 +10461,9 @@
                           <a:ea typeface="Malgun Gothic" pitchFamily="34" charset="-122"/>
                           <a:cs typeface="Malgun Gothic" pitchFamily="34" charset="-120"/>
                         </a:rPr>
-                        <a:t>48.9 → 24.9</a:t>
+                        <a:t>18.4 → 9.8</a:t>
                       </a:r>
-                      <a:endParaRPr lang="en-US" sz="1500" dirty="0">
+                      <a:endParaRPr lang="en-US" sz="1300" dirty="0">
                         <a:latin typeface="Malgun Gothic" charset="0"/>
                         <a:ea typeface="Malgun Gothic" charset="0"/>
                         <a:cs typeface="Malgun Gothic" charset="0"/>
@@ -10224,17 +10521,17 @@
                         <a:buNone/>
                       </a:pPr>
                       <a:r>
-                        <a:rPr lang="en-US" sz="1500" b="1" dirty="0">
+                        <a:rPr lang="en-US" sz="1300" dirty="0">
                           <a:solidFill>
-                            <a:schemeClr val="accent1"/>
+                            <a:schemeClr val="tx1"/>
                           </a:solidFill>
                           <a:latin typeface="Malgun Gothic" pitchFamily="34" charset="0"/>
                           <a:ea typeface="Malgun Gothic" pitchFamily="34" charset="-122"/>
                           <a:cs typeface="Malgun Gothic" pitchFamily="34" charset="-120"/>
                         </a:rPr>
-                        <a:t>2.0×</a:t>
+                        <a:t>0.892 → 0.902</a:t>
                       </a:r>
-                      <a:endParaRPr lang="en-US" sz="1500" dirty="0">
+                      <a:endParaRPr lang="en-US" sz="1300" dirty="0">
                         <a:latin typeface="Malgun Gothic" charset="0"/>
                         <a:ea typeface="Malgun Gothic" charset="0"/>
                         <a:cs typeface="Malgun Gothic" charset="0"/>
@@ -10292,17 +10589,87 @@
                         <a:buNone/>
                       </a:pPr>
                       <a:r>
-                        <a:rPr lang="en-US" sz="1500" dirty="0">
+                        <a:rPr lang="en-US" sz="1300" dirty="0">
                           <a:solidFill>
-                            <a:schemeClr val="tx1"/>
+                            <a:schemeClr val="accent2"/>
                           </a:solidFill>
                           <a:latin typeface="Malgun Gothic" pitchFamily="34" charset="0"/>
                           <a:ea typeface="Malgun Gothic" pitchFamily="34" charset="-122"/>
                           <a:cs typeface="Malgun Gothic" pitchFamily="34" charset="-120"/>
                         </a:rPr>
-                        <a:t>18.4 → 9.8</a:t>
+                        <a:t>6 → 8</a:t>
                       </a:r>
-                      <a:endParaRPr lang="en-US" sz="1500" dirty="0">
+                      <a:endParaRPr lang="en-US" sz="1300" dirty="0">
+                        <a:latin typeface="Malgun Gothic" charset="0"/>
+                        <a:ea typeface="Malgun Gothic" charset="0"/>
+                        <a:cs typeface="Malgun Gothic" charset="0"/>
+                      </a:endParaRPr>
+                    </a:p>
+                  </a:txBody>
+                  <a:tcPr marL="91440" marR="91440" marT="45720" marB="45720" anchor="ctr">
+                    <a:lnL w="9525" cap="flat" cmpd="sng" algn="ctr">
+                      <a:solidFill>
+                        <a:srgbClr val="3A3F48"/>
+                      </a:solidFill>
+                      <a:prstDash val="solid"/>
+                      <a:round/>
+                      <a:headEnd type="none" w="med" len="med"/>
+                      <a:tailEnd type="none" w="med" len="med"/>
+                    </a:lnL>
+                    <a:lnR w="9525" cap="flat" cmpd="sng" algn="ctr">
+                      <a:solidFill>
+                        <a:srgbClr val="3A3F48"/>
+                      </a:solidFill>
+                      <a:prstDash val="solid"/>
+                      <a:round/>
+                      <a:headEnd type="none" w="med" len="med"/>
+                      <a:tailEnd type="none" w="med" len="med"/>
+                    </a:lnR>
+                    <a:lnT w="9525" cap="flat" cmpd="sng" algn="ctr">
+                      <a:solidFill>
+                        <a:srgbClr val="3A3F48"/>
+                      </a:solidFill>
+                      <a:prstDash val="solid"/>
+                      <a:round/>
+                      <a:headEnd type="none" w="med" len="med"/>
+                      <a:tailEnd type="none" w="med" len="med"/>
+                    </a:lnT>
+                    <a:lnB w="9525" cap="flat" cmpd="sng" algn="ctr">
+                      <a:solidFill>
+                        <a:srgbClr val="3A3F48"/>
+                      </a:solidFill>
+                      <a:prstDash val="solid"/>
+                      <a:round/>
+                      <a:headEnd type="none" w="med" len="med"/>
+                      <a:tailEnd type="none" w="med" len="med"/>
+                    </a:lnB>
+                    <a:solidFill>
+                      <a:srgbClr val="23272F"/>
+                    </a:solidFill>
+                  </a:tcPr>
+                </a:tc>
+              </a:tr>
+              <a:tr h="566928">
+                <a:tc>
+                  <a:txBody>
+                    <a:bodyPr/>
+                    <a:lstStyle/>
+                    <a:p>
+                      <a:pPr algn="l" indent="0" marL="0">
+                        <a:buNone/>
+                      </a:pPr>
+                      <a:r>
+                        <a:rPr lang="en-US" sz="1300" b="1" dirty="0">
+                          <a:solidFill>
+                            <a:schemeClr val="accent6"/>
+                          </a:solidFill>
+                          <a:latin typeface="Malgun Gothic" pitchFamily="34" charset="0"/>
+                          <a:ea typeface="Malgun Gothic" pitchFamily="34" charset="-122"/>
+                          <a:cs typeface="Malgun Gothic" pitchFamily="34" charset="-120"/>
+                        </a:rPr>
+                        <a:t>YOLOX-Tiny</a:t>
+                      </a:r>
+                      <a:endParaRPr lang="en-US" sz="1300" dirty="0">
                         <a:latin typeface="Malgun Gothic" charset="0"/>
                         <a:ea typeface="Malgun Gothic" charset="0"/>
                         <a:cs typeface="Malgun Gothic" charset="0"/>
@@ -10360,17 +10727,17 @@
                         <a:buNone/>
                       </a:pPr>
                       <a:r>
-                        <a:rPr lang="en-US" sz="1500" dirty="0">
+                        <a:rPr lang="en-US" sz="1300" b="1" dirty="0">
                           <a:solidFill>
-                            <a:schemeClr val="tx1"/>
+                            <a:schemeClr val="accent1"/>
                           </a:solidFill>
                           <a:latin typeface="Malgun Gothic" pitchFamily="34" charset="0"/>
                           <a:ea typeface="Malgun Gothic" pitchFamily="34" charset="-122"/>
                           <a:cs typeface="Malgun Gothic" pitchFamily="34" charset="-120"/>
                         </a:rPr>
-                        <a:t>0.892 → 0.902</a:t>
+                        <a:t>4.0×</a:t>
                       </a:r>
-                      <a:endParaRPr lang="en-US" sz="1500" dirty="0">
+                      <a:endParaRPr lang="en-US" sz="1300" dirty="0">
                         <a:latin typeface="Malgun Gothic" charset="0"/>
                         <a:ea typeface="Malgun Gothic" charset="0"/>
                         <a:cs typeface="Malgun Gothic" charset="0"/>
@@ -10428,87 +10795,17 @@
                         <a:buNone/>
                       </a:pPr>
                       <a:r>
-                        <a:rPr lang="en-US" sz="1500" dirty="0">
+                        <a:rPr lang="en-US" sz="1300" dirty="0">
                           <a:solidFill>
-                            <a:schemeClr val="accent2"/>
+                            <a:schemeClr val="tx1"/>
                           </a:solidFill>
                           <a:latin typeface="Malgun Gothic" pitchFamily="34" charset="0"/>
                           <a:ea typeface="Malgun Gothic" pitchFamily="34" charset="-122"/>
                           <a:cs typeface="Malgun Gothic" pitchFamily="34" charset="-120"/>
                         </a:rPr>
-                        <a:t>6 → 8</a:t>
+                        <a:t>10.6 → 5.8</a:t>
                       </a:r>
-                      <a:endParaRPr lang="en-US" sz="1500" dirty="0">
-                        <a:latin typeface="Malgun Gothic" charset="0"/>
-                        <a:ea typeface="Malgun Gothic" charset="0"/>
-                        <a:cs typeface="Malgun Gothic" charset="0"/>
-                      </a:endParaRPr>
-                    </a:p>
-                  </a:txBody>
-                  <a:tcPr marL="91440" marR="91440" marT="45720" marB="45720" anchor="ctr">
-                    <a:lnL w="9525" cap="flat" cmpd="sng" algn="ctr">
-                      <a:solidFill>
-                        <a:srgbClr val="3A3F48"/>
-                      </a:solidFill>
-                      <a:prstDash val="solid"/>
-                      <a:round/>
-                      <a:headEnd type="none" w="med" len="med"/>
-                      <a:tailEnd type="none" w="med" len="med"/>
-                    </a:lnL>
-                    <a:lnR w="9525" cap="flat" cmpd="sng" algn="ctr">
-                      <a:solidFill>
-                        <a:srgbClr val="3A3F48"/>
-                      </a:solidFill>
-                      <a:prstDash val="solid"/>
-                      <a:round/>
-                      <a:headEnd type="none" w="med" len="med"/>
-                      <a:tailEnd type="none" w="med" len="med"/>
-                    </a:lnR>
-                    <a:lnT w="9525" cap="flat" cmpd="sng" algn="ctr">
-                      <a:solidFill>
-                        <a:srgbClr val="3A3F48"/>
-                      </a:solidFill>
-                      <a:prstDash val="solid"/>
-                      <a:round/>
-                      <a:headEnd type="none" w="med" len="med"/>
-                      <a:tailEnd type="none" w="med" len="med"/>
-                    </a:lnT>
-                    <a:lnB w="9525" cap="flat" cmpd="sng" algn="ctr">
-                      <a:solidFill>
-                        <a:srgbClr val="3A3F48"/>
-                      </a:solidFill>
-                      <a:prstDash val="solid"/>
-                      <a:round/>
-                      <a:headEnd type="none" w="med" len="med"/>
-                      <a:tailEnd type="none" w="med" len="med"/>
-                    </a:lnB>
-                    <a:solidFill>
-                      <a:srgbClr val="23272F"/>
-                    </a:solidFill>
-                  </a:tcPr>
-                </a:tc>
-              </a:tr>
-              <a:tr h="530352">
-                <a:tc>
-                  <a:txBody>
-                    <a:bodyPr/>
-                    <a:lstStyle/>
-                    <a:p>
-                      <a:pPr algn="l" indent="0" marL="0">
-                        <a:buNone/>
-                      </a:pPr>
-                      <a:r>
-                        <a:rPr lang="en-US" sz="1500" b="1" dirty="0">
-                          <a:solidFill>
-                            <a:schemeClr val="accent6"/>
-                          </a:solidFill>
-                          <a:latin typeface="Malgun Gothic" pitchFamily="34" charset="0"/>
-                          <a:ea typeface="Malgun Gothic" pitchFamily="34" charset="-122"/>
-                          <a:cs typeface="Malgun Gothic" pitchFamily="34" charset="-120"/>
-                        </a:rPr>
-                        <a:t>YOLOX-Tiny</a:t>
-                      </a:r>
-                      <a:endParaRPr lang="en-US" sz="1500" dirty="0">
+                      <a:endParaRPr lang="en-US" sz="1300" dirty="0">
                         <a:latin typeface="Malgun Gothic" charset="0"/>
                         <a:ea typeface="Malgun Gothic" charset="0"/>
                         <a:cs typeface="Malgun Gothic" charset="0"/>
@@ -10566,7 +10863,7 @@
                         <a:buNone/>
                       </a:pPr>
                       <a:r>
-                        <a:rPr lang="en-US" sz="1500" dirty="0">
+                        <a:rPr lang="en-US" sz="1300" dirty="0">
                           <a:solidFill>
                             <a:schemeClr val="tx1"/>
                           </a:solidFill>
@@ -10574,9 +10871,9 @@
                           <a:ea typeface="Malgun Gothic" pitchFamily="34" charset="-122"/>
                           <a:cs typeface="Malgun Gothic" pitchFamily="34" charset="-120"/>
                         </a:rPr>
-                        <a:t>33.5 → 8.3</a:t>
+                        <a:t>0.832 → 0.829</a:t>
                       </a:r>
-                      <a:endParaRPr lang="en-US" sz="1500" dirty="0">
+                      <a:endParaRPr lang="en-US" sz="1300" dirty="0">
                         <a:latin typeface="Malgun Gothic" charset="0"/>
                         <a:ea typeface="Malgun Gothic" charset="0"/>
                         <a:cs typeface="Malgun Gothic" charset="0"/>
@@ -10634,211 +10931,7 @@
                         <a:buNone/>
                       </a:pPr>
                       <a:r>
-                        <a:rPr lang="en-US" sz="1500" b="1" dirty="0">
-                          <a:solidFill>
-                            <a:schemeClr val="accent1"/>
-                          </a:solidFill>
-                          <a:latin typeface="Malgun Gothic" pitchFamily="34" charset="0"/>
-                          <a:ea typeface="Malgun Gothic" pitchFamily="34" charset="-122"/>
-                          <a:cs typeface="Malgun Gothic" pitchFamily="34" charset="-120"/>
-                        </a:rPr>
-                        <a:t>4.0×</a:t>
-                      </a:r>
-                      <a:endParaRPr lang="en-US" sz="1500" dirty="0">
-                        <a:latin typeface="Malgun Gothic" charset="0"/>
-                        <a:ea typeface="Malgun Gothic" charset="0"/>
-                        <a:cs typeface="Malgun Gothic" charset="0"/>
-                      </a:endParaRPr>
-                    </a:p>
-                  </a:txBody>
-                  <a:tcPr marL="91440" marR="91440" marT="45720" marB="45720" anchor="ctr">
-                    <a:lnL w="9525" cap="flat" cmpd="sng" algn="ctr">
-                      <a:solidFill>
-                        <a:srgbClr val="3A3F48"/>
-                      </a:solidFill>
-                      <a:prstDash val="solid"/>
-                      <a:round/>
-                      <a:headEnd type="none" w="med" len="med"/>
-                      <a:tailEnd type="none" w="med" len="med"/>
-                    </a:lnL>
-                    <a:lnR w="9525" cap="flat" cmpd="sng" algn="ctr">
-                      <a:solidFill>
-                        <a:srgbClr val="3A3F48"/>
-                      </a:solidFill>
-                      <a:prstDash val="solid"/>
-                      <a:round/>
-                      <a:headEnd type="none" w="med" len="med"/>
-                      <a:tailEnd type="none" w="med" len="med"/>
-                    </a:lnR>
-                    <a:lnT w="9525" cap="flat" cmpd="sng" algn="ctr">
-                      <a:solidFill>
-                        <a:srgbClr val="3A3F48"/>
-                      </a:solidFill>
-                      <a:prstDash val="solid"/>
-                      <a:round/>
-                      <a:headEnd type="none" w="med" len="med"/>
-                      <a:tailEnd type="none" w="med" len="med"/>
-                    </a:lnT>
-                    <a:lnB w="9525" cap="flat" cmpd="sng" algn="ctr">
-                      <a:solidFill>
-                        <a:srgbClr val="3A3F48"/>
-                      </a:solidFill>
-                      <a:prstDash val="solid"/>
-                      <a:round/>
-                      <a:headEnd type="none" w="med" len="med"/>
-                      <a:tailEnd type="none" w="med" len="med"/>
-                    </a:lnB>
-                    <a:solidFill>
-                      <a:srgbClr val="23272F"/>
-                    </a:solidFill>
-                  </a:tcPr>
-                </a:tc>
-                <a:tc>
-                  <a:txBody>
-                    <a:bodyPr/>
-                    <a:lstStyle/>
-                    <a:p>
-                      <a:pPr algn="ctr" indent="0" marL="0">
-                        <a:buNone/>
-                      </a:pPr>
-                      <a:r>
-                        <a:rPr lang="en-US" sz="1500" dirty="0">
-                          <a:solidFill>
-                            <a:schemeClr val="tx1"/>
-                          </a:solidFill>
-                          <a:latin typeface="Malgun Gothic" pitchFamily="34" charset="0"/>
-                          <a:ea typeface="Malgun Gothic" pitchFamily="34" charset="-122"/>
-                          <a:cs typeface="Malgun Gothic" pitchFamily="34" charset="-120"/>
-                        </a:rPr>
-                        <a:t>10.6 → 5.8</a:t>
-                      </a:r>
-                      <a:endParaRPr lang="en-US" sz="1500" dirty="0">
-                        <a:latin typeface="Malgun Gothic" charset="0"/>
-                        <a:ea typeface="Malgun Gothic" charset="0"/>
-                        <a:cs typeface="Malgun Gothic" charset="0"/>
-                      </a:endParaRPr>
-                    </a:p>
-                  </a:txBody>
-                  <a:tcPr marL="91440" marR="91440" marT="45720" marB="45720" anchor="ctr">
-                    <a:lnL w="9525" cap="flat" cmpd="sng" algn="ctr">
-                      <a:solidFill>
-                        <a:srgbClr val="3A3F48"/>
-                      </a:solidFill>
-                      <a:prstDash val="solid"/>
-                      <a:round/>
-                      <a:headEnd type="none" w="med" len="med"/>
-                      <a:tailEnd type="none" w="med" len="med"/>
-                    </a:lnL>
-                    <a:lnR w="9525" cap="flat" cmpd="sng" algn="ctr">
-                      <a:solidFill>
-                        <a:srgbClr val="3A3F48"/>
-                      </a:solidFill>
-                      <a:prstDash val="solid"/>
-                      <a:round/>
-                      <a:headEnd type="none" w="med" len="med"/>
-                      <a:tailEnd type="none" w="med" len="med"/>
-                    </a:lnR>
-                    <a:lnT w="9525" cap="flat" cmpd="sng" algn="ctr">
-                      <a:solidFill>
-                        <a:srgbClr val="3A3F48"/>
-                      </a:solidFill>
-                      <a:prstDash val="solid"/>
-                      <a:round/>
-                      <a:headEnd type="none" w="med" len="med"/>
-                      <a:tailEnd type="none" w="med" len="med"/>
-                    </a:lnT>
-                    <a:lnB w="9525" cap="flat" cmpd="sng" algn="ctr">
-                      <a:solidFill>
-                        <a:srgbClr val="3A3F48"/>
-                      </a:solidFill>
-                      <a:prstDash val="solid"/>
-                      <a:round/>
-                      <a:headEnd type="none" w="med" len="med"/>
-                      <a:tailEnd type="none" w="med" len="med"/>
-                    </a:lnB>
-                    <a:solidFill>
-                      <a:srgbClr val="23272F"/>
-                    </a:solidFill>
-                  </a:tcPr>
-                </a:tc>
-                <a:tc>
-                  <a:txBody>
-                    <a:bodyPr/>
-                    <a:lstStyle/>
-                    <a:p>
-                      <a:pPr algn="ctr" indent="0" marL="0">
-                        <a:buNone/>
-                      </a:pPr>
-                      <a:r>
-                        <a:rPr lang="en-US" sz="1500" dirty="0">
-                          <a:solidFill>
-                            <a:schemeClr val="tx1"/>
-                          </a:solidFill>
-                          <a:latin typeface="Malgun Gothic" pitchFamily="34" charset="0"/>
-                          <a:ea typeface="Malgun Gothic" pitchFamily="34" charset="-122"/>
-                          <a:cs typeface="Malgun Gothic" pitchFamily="34" charset="-120"/>
-                        </a:rPr>
-                        <a:t>0.832 → 0.829</a:t>
-                      </a:r>
-                      <a:endParaRPr lang="en-US" sz="1500" dirty="0">
-                        <a:latin typeface="Malgun Gothic" charset="0"/>
-                        <a:ea typeface="Malgun Gothic" charset="0"/>
-                        <a:cs typeface="Malgun Gothic" charset="0"/>
-                      </a:endParaRPr>
-                    </a:p>
-                  </a:txBody>
-                  <a:tcPr marL="91440" marR="91440" marT="45720" marB="45720" anchor="ctr">
-                    <a:lnL w="9525" cap="flat" cmpd="sng" algn="ctr">
-                      <a:solidFill>
-                        <a:srgbClr val="3A3F48"/>
-                      </a:solidFill>
-                      <a:prstDash val="solid"/>
-                      <a:round/>
-                      <a:headEnd type="none" w="med" len="med"/>
-                      <a:tailEnd type="none" w="med" len="med"/>
-                    </a:lnL>
-                    <a:lnR w="9525" cap="flat" cmpd="sng" algn="ctr">
-                      <a:solidFill>
-                        <a:srgbClr val="3A3F48"/>
-                      </a:solidFill>
-                      <a:prstDash val="solid"/>
-                      <a:round/>
-                      <a:headEnd type="none" w="med" len="med"/>
-                      <a:tailEnd type="none" w="med" len="med"/>
-                    </a:lnR>
-                    <a:lnT w="9525" cap="flat" cmpd="sng" algn="ctr">
-                      <a:solidFill>
-                        <a:srgbClr val="3A3F48"/>
-                      </a:solidFill>
-                      <a:prstDash val="solid"/>
-                      <a:round/>
-                      <a:headEnd type="none" w="med" len="med"/>
-                      <a:tailEnd type="none" w="med" len="med"/>
-                    </a:lnT>
-                    <a:lnB w="9525" cap="flat" cmpd="sng" algn="ctr">
-                      <a:solidFill>
-                        <a:srgbClr val="3A3F48"/>
-                      </a:solidFill>
-                      <a:prstDash val="solid"/>
-                      <a:round/>
-                      <a:headEnd type="none" w="med" len="med"/>
-                      <a:tailEnd type="none" w="med" len="med"/>
-                    </a:lnB>
-                    <a:solidFill>
-                      <a:srgbClr val="23272F"/>
-                    </a:solidFill>
-                  </a:tcPr>
-                </a:tc>
-                <a:tc>
-                  <a:txBody>
-                    <a:bodyPr/>
-                    <a:lstStyle/>
-                    <a:p>
-                      <a:pPr algn="ctr" indent="0" marL="0">
-                        <a:buNone/>
-                      </a:pPr>
-                      <a:r>
-                        <a:rPr lang="en-US" sz="1500" dirty="0">
+                        <a:rPr lang="en-US" sz="1300" dirty="0">
                           <a:solidFill>
                             <a:schemeClr val="tx1"/>
                           </a:solidFill>
@@ -10848,7 +10941,7 @@
                         </a:rPr>
                         <a:t>1 → 0</a:t>
                       </a:r>
-                      <a:endParaRPr lang="en-US" sz="1500" dirty="0">
+                      <a:endParaRPr lang="en-US" sz="1300" dirty="0">
                         <a:latin typeface="Malgun Gothic" charset="0"/>
                         <a:ea typeface="Malgun Gothic" charset="0"/>
                         <a:cs typeface="Malgun Gothic" charset="0"/>
@@ -10904,18 +10997,54 @@
       </p:graphicFrame>
       <p:sp>
         <p:nvSpPr>
-          <p:cNvPr id="5" name="method-card"/>
+          <p:cNvPr id="6" name="int8-note"/>
+          <p:cNvSpPr txBox="1"/>
+          <p:nvPr/>
+        </p:nvSpPr>
+        <p:spPr>
+          <a:xfrm>
+            <a:off x="6537960" y="4160520"/>
+            <a:ext cx="5102352" cy="274320"/>
+          </a:xfrm>
+          <a:prstGeom prst="rect">
+            <a:avLst/>
+          </a:prstGeom>
+          <a:noFill/>
+          <a:ln/>
+        </p:spPr>
+        <p:txBody>
+          <a:bodyPr wrap="square" lIns="0" tIns="0" rIns="0" bIns="0" rtlCol="0" anchor="t"/>
+          <a:lstStyle/>
+          <a:p>
+            <a:pPr indent="0" marL="0">
+              <a:buNone/>
+            </a:pPr>
+            <a:r>
+              <a:rPr lang="en-US" sz="1100" dirty="0">
+                <a:solidFill>
+                  <a:schemeClr val="tx2"/>
+                </a:solidFill>
+              </a:rPr>
+              <a:t>값: FP16 → INT8 · 놓친 셀 = 결함 98장 중 검토 기준 0.30 미만</a:t>
+            </a:r>
+            <a:endParaRPr lang="en-US" sz="1100" dirty="0"/>
+          </a:p>
+        </p:txBody>
+      </p:sp>
+      <p:sp>
+        <p:nvSpPr>
+          <p:cNvPr id="7" name="method-card"/>
           <p:cNvSpPr/>
           <p:nvPr/>
         </p:nvSpPr>
         <p:spPr>
           <a:xfrm>
-            <a:off x="548640" y="3931920"/>
-            <a:ext cx="11094415" cy="566928"/>
+            <a:off x="548640" y="4800600"/>
+            <a:ext cx="11094415" cy="502920"/>
           </a:xfrm>
           <a:prstGeom prst="roundRect">
             <a:avLst>
-              <a:gd name="adj" fmla="val 12903"/>
+              <a:gd name="adj" fmla="val 14545"/>
             </a:avLst>
           </a:prstGeom>
           <a:solidFill>
@@ -10926,14 +11055,14 @@
       </p:sp>
       <p:sp>
         <p:nvSpPr>
-          <p:cNvPr id="6" name="method"/>
+          <p:cNvPr id="8" name="method"/>
           <p:cNvSpPr txBox="1"/>
           <p:nvPr/>
         </p:nvSpPr>
         <p:spPr>
           <a:xfrm>
-            <a:off x="822960" y="3959352"/>
-            <a:ext cx="10545775" cy="512064"/>
+            <a:off x="822960" y="4800600"/>
+            <a:ext cx="10545775" cy="502920"/>
           </a:xfrm>
           <a:prstGeom prst="rect">
             <a:avLst/>
@@ -10973,18 +11102,18 @@
       </p:sp>
       <p:sp>
         <p:nvSpPr>
-          <p:cNvPr id="7" name="pro-card"/>
+          <p:cNvPr id="9" name="pro-card"/>
           <p:cNvSpPr/>
           <p:nvPr/>
         </p:nvSpPr>
         <p:spPr>
           <a:xfrm>
-            <a:off x="548640" y="4709160"/>
-            <a:ext cx="5440680" cy="1508760"/>
+            <a:off x="548640" y="5486400"/>
+            <a:ext cx="5440680" cy="731520"/>
           </a:xfrm>
           <a:prstGeom prst="roundRect">
             <a:avLst>
-              <a:gd name="adj" fmla="val 4848"/>
+              <a:gd name="adj" fmla="val 10000"/>
             </a:avLst>
           </a:prstGeom>
           <a:solidFill>
@@ -10995,14 +11124,14 @@
       </p:sp>
       <p:sp>
         <p:nvSpPr>
-          <p:cNvPr id="8" name="pro-h"/>
+          <p:cNvPr id="10" name="pro"/>
           <p:cNvSpPr txBox="1"/>
           <p:nvPr/>
         </p:nvSpPr>
         <p:spPr>
           <a:xfrm>
-            <a:off x="822960" y="4828032"/>
-            <a:ext cx="2743200" cy="320040"/>
+            <a:off x="822960" y="5486400"/>
+            <a:ext cx="5029200" cy="731520"/>
           </a:xfrm>
           <a:prstGeom prst="rect">
             <a:avLst/>
@@ -11011,195 +11140,101 @@
           <a:ln/>
         </p:spPr>
         <p:txBody>
-          <a:bodyPr wrap="square" lIns="0" tIns="0" rIns="0" bIns="0" rtlCol="0" anchor="t"/>
+          <a:bodyPr wrap="square" lIns="0" tIns="0" rIns="0" bIns="0" rtlCol="0" anchor="ctr"/>
           <a:lstStyle/>
           <a:p>
             <a:pPr indent="0" marL="0">
               <a:buNone/>
             </a:pPr>
             <a:r>
-              <a:rPr lang="en-US" sz="1600" b="1" dirty="0">
+              <a:rPr lang="en-US" sz="1500" b="1" dirty="0">
                 <a:solidFill>
                   <a:schemeClr val="accent6"/>
                 </a:solidFill>
               </a:rPr>
-              <a:t>장점</a:t>
+              <a:t>장점  </a:t>
             </a:r>
-            <a:endParaRPr lang="en-US" sz="1600" dirty="0"/>
-          </a:p>
-        </p:txBody>
-      </p:sp>
-      <p:sp>
-        <p:nvSpPr>
-          <p:cNvPr id="9" name="pro-b"/>
-          <p:cNvSpPr txBox="1"/>
-          <p:nvPr/>
-        </p:nvSpPr>
-        <p:spPr>
-          <a:xfrm>
-            <a:off x="822960" y="5212080"/>
-            <a:ext cx="4937760" cy="868680"/>
-          </a:xfrm>
-          <a:prstGeom prst="rect">
-            <a:avLst/>
-          </a:prstGeom>
-          <a:noFill/>
-          <a:ln/>
-        </p:spPr>
-        <p:txBody>
-          <a:bodyPr wrap="square" lIns="0" tIns="0" rIns="0" bIns="0" rtlCol="0" anchor="t"/>
-          <a:lstStyle/>
-          <a:p>
-            <a:pPr marL="342900" indent="-342900">
-              <a:spcAft>
-                <a:spcPts val="600"/>
-              </a:spcAft>
-              <a:buSzPct val="100000"/>
-              <a:buChar char="•"/>
+            <a:pPr indent="0" marL="0">
+              <a:buNone/>
             </a:pPr>
             <a:r>
-              <a:rPr lang="en-US" sz="1400" dirty="0">
+              <a:rPr lang="en-US" sz="1500" dirty="0">
                 <a:solidFill>
                   <a:schemeClr val="tx1"/>
                 </a:solidFill>
               </a:rPr>
-              <a:t>CPU 2–4배 빠름 · 크기 약 절반</a:t>
+              <a:t>2–4배 빠름 · 크기 절반 · mAP 유지</a:t>
             </a:r>
-            <a:endParaRPr lang="en-US" sz="1400" dirty="0"/>
-          </a:p>
-          <a:p>
-            <a:pPr marL="342900" indent="-342900">
-              <a:spcAft>
-                <a:spcPts val="600"/>
-              </a:spcAft>
-              <a:buSzPct val="100000"/>
-              <a:buChar char="•"/>
+            <a:endParaRPr lang="en-US" sz="1500" dirty="0"/>
+          </a:p>
+        </p:txBody>
+      </p:sp>
+      <p:sp>
+        <p:nvSpPr>
+          <p:cNvPr id="11" name="con-card"/>
+          <p:cNvSpPr/>
+          <p:nvPr/>
+        </p:nvSpPr>
+        <p:spPr>
+          <a:xfrm>
+            <a:off x="6199632" y="5486400"/>
+            <a:ext cx="5440680" cy="731520"/>
+          </a:xfrm>
+          <a:prstGeom prst="roundRect">
+            <a:avLst>
+              <a:gd name="adj" fmla="val 10000"/>
+            </a:avLst>
+          </a:prstGeom>
+          <a:solidFill>
+            <a:schemeClr val="bg2"/>
+          </a:solidFill>
+          <a:ln/>
+        </p:spPr>
+      </p:sp>
+      <p:sp>
+        <p:nvSpPr>
+          <p:cNvPr id="12" name="con"/>
+          <p:cNvSpPr txBox="1"/>
+          <p:nvPr/>
+        </p:nvSpPr>
+        <p:spPr>
+          <a:xfrm>
+            <a:off x="6473952" y="5486400"/>
+            <a:ext cx="5029200" cy="731520"/>
+          </a:xfrm>
+          <a:prstGeom prst="rect">
+            <a:avLst/>
+          </a:prstGeom>
+          <a:noFill/>
+          <a:ln/>
+        </p:spPr>
+        <p:txBody>
+          <a:bodyPr wrap="square" lIns="0" tIns="0" rIns="0" bIns="0" rtlCol="0" anchor="ctr"/>
+          <a:lstStyle/>
+          <a:p>
+            <a:pPr indent="0" marL="0">
+              <a:buNone/>
             </a:pPr>
             <a:r>
-              <a:rPr lang="en-US" sz="1400" dirty="0">
+              <a:rPr lang="en-US" sz="1500" b="1" dirty="0">
+                <a:solidFill>
+                  <a:schemeClr val="accent2"/>
+                </a:solidFill>
+              </a:rPr>
+              <a:t>단점  </a:t>
+            </a:r>
+            <a:pPr indent="0" marL="0">
+              <a:buNone/>
+            </a:pPr>
+            <a:r>
+              <a:rPr lang="en-US" sz="1500" dirty="0">
                 <a:solidFill>
                   <a:schemeClr val="tx1"/>
                 </a:solidFill>
               </a:rPr>
-              <a:t>mAP@50은 거의 그대로</a:t>
+              <a:t>신뢰도 ↓ → 놓침 ↑ · 기준값 재설정 필요</a:t>
             </a:r>
-            <a:endParaRPr lang="en-US" sz="1400" dirty="0"/>
-          </a:p>
-        </p:txBody>
-      </p:sp>
-      <p:sp>
-        <p:nvSpPr>
-          <p:cNvPr id="10" name="con-card"/>
-          <p:cNvSpPr/>
-          <p:nvPr/>
-        </p:nvSpPr>
-        <p:spPr>
-          <a:xfrm>
-            <a:off x="6199632" y="4709160"/>
-            <a:ext cx="5440680" cy="1508760"/>
-          </a:xfrm>
-          <a:prstGeom prst="roundRect">
-            <a:avLst>
-              <a:gd name="adj" fmla="val 4848"/>
-            </a:avLst>
-          </a:prstGeom>
-          <a:solidFill>
-            <a:schemeClr val="bg2"/>
-          </a:solidFill>
-          <a:ln/>
-        </p:spPr>
-      </p:sp>
-      <p:sp>
-        <p:nvSpPr>
-          <p:cNvPr id="11" name="con-h"/>
-          <p:cNvSpPr txBox="1"/>
-          <p:nvPr/>
-        </p:nvSpPr>
-        <p:spPr>
-          <a:xfrm>
-            <a:off x="6473952" y="4828032"/>
-            <a:ext cx="2743200" cy="320040"/>
-          </a:xfrm>
-          <a:prstGeom prst="rect">
-            <a:avLst/>
-          </a:prstGeom>
-          <a:noFill/>
-          <a:ln/>
-        </p:spPr>
-        <p:txBody>
-          <a:bodyPr wrap="square" lIns="0" tIns="0" rIns="0" bIns="0" rtlCol="0" anchor="t"/>
-          <a:lstStyle/>
-          <a:p>
-            <a:pPr indent="0" marL="0">
-              <a:buNone/>
-            </a:pPr>
-            <a:r>
-              <a:rPr lang="en-US" sz="1600" b="1" dirty="0">
-                <a:solidFill>
-                  <a:schemeClr val="accent2"/>
-                </a:solidFill>
-              </a:rPr>
-              <a:t>단점</a:t>
-            </a:r>
-            <a:endParaRPr lang="en-US" sz="1600" dirty="0"/>
-          </a:p>
-        </p:txBody>
-      </p:sp>
-      <p:sp>
-        <p:nvSpPr>
-          <p:cNvPr id="12" name="con-b"/>
-          <p:cNvSpPr txBox="1"/>
-          <p:nvPr/>
-        </p:nvSpPr>
-        <p:spPr>
-          <a:xfrm>
-            <a:off x="6473952" y="5212080"/>
-            <a:ext cx="4937760" cy="868680"/>
-          </a:xfrm>
-          <a:prstGeom prst="rect">
-            <a:avLst/>
-          </a:prstGeom>
-          <a:noFill/>
-          <a:ln/>
-        </p:spPr>
-        <p:txBody>
-          <a:bodyPr wrap="square" lIns="0" tIns="0" rIns="0" bIns="0" rtlCol="0" anchor="t"/>
-          <a:lstStyle/>
-          <a:p>
-            <a:pPr marL="342900" indent="-342900">
-              <a:spcAft>
-                <a:spcPts val="600"/>
-              </a:spcAft>
-              <a:buSzPct val="100000"/>
-              <a:buChar char="•"/>
-            </a:pPr>
-            <a:r>
-              <a:rPr lang="en-US" sz="1400" dirty="0">
-                <a:solidFill>
-                  <a:schemeClr val="tx1"/>
-                </a:solidFill>
-              </a:rPr>
-              <a:t>신뢰도 하락 → 같은 기준에서 놓침 증가</a:t>
-            </a:r>
-            <a:endParaRPr lang="en-US" sz="1400" dirty="0"/>
-          </a:p>
-          <a:p>
-            <a:pPr marL="342900" indent="-342900">
-              <a:spcAft>
-                <a:spcPts val="600"/>
-              </a:spcAft>
-              <a:buSzPct val="100000"/>
-              <a:buChar char="•"/>
-            </a:pPr>
-            <a:r>
-              <a:rPr lang="en-US" sz="1400" b="1" dirty="0">
-                <a:solidFill>
-                  <a:schemeClr val="tx1"/>
-                </a:solidFill>
-              </a:rPr>
-              <a:t>INT8용 기준값 재설정 필요</a:t>
-            </a:r>
-            <a:endParaRPr lang="en-US" sz="1400" dirty="0"/>
+            <a:endParaRPr lang="en-US" sz="1500" dirty="0"/>
           </a:p>
         </p:txBody>
       </p:sp>

</xml_diff>

<commit_message>
Add Geti-score caveat (slide 5) and per-model threshold insight (slide 8); badge text 'best'
Co-Authored-By: Claude Opus 5.5 <noreply@anthropic.com>
</commit_message>
<xml_diff>
--- a/docs/submission/BatteryVision_발표.pptx
+++ b/docs/submission/BatteryVision_발표.pptx
@@ -116,13 +116,13 @@
   <p:extLst>
     <p:ext uri="{521415D9-36F7-43E2-AB2F-B90AF26B5E84}">
       <p14:sectionLst xmlns:p14="http://schemas.microsoft.com/office/powerpoint/2010/main">
-        <p14:section name="도입" id="{8e06e404-74bf-e672-ad4b-e408d23607d5}">
+        <p14:section name="도입" id="{dfc59b71-a3ae-029e-6699-5dd83144d8bf}">
           <p14:sldIdLst>
             <p14:sldId id="256"/>
             <p14:sldId id="257"/>
           </p14:sldIdLst>
         </p14:section>
-        <p14:section name="실험" id="{a4425e8b-1365-fc80-ffe0-438ebf9b7772}">
+        <p14:section name="실험" id="{bde8193f-717a-5375-ea80-5f49ac4d68fb}">
           <p14:sldIdLst>
             <p14:sldId id="258"/>
             <p14:sldId id="259"/>
@@ -130,17 +130,17 @@
             <p14:sldId id="261"/>
           </p14:sldIdLst>
         </p14:section>
-        <p14:section name="최적화" id="{4d0c4598-9562-f302-97d3-2ee62463dd91}">
+        <p14:section name="최적화" id="{47949f94-4b1c-365b-4ae1-541cdba602b2}">
           <p14:sldIdLst>
             <p14:sldId id="262"/>
           </p14:sldIdLst>
         </p14:section>
-        <p14:section name="검증" id="{9b56f984-495f-7db3-7f12-b6f342283212}">
+        <p14:section name="검증" id="{1b9ad431-83c8-c39e-f745-2f243faf8572}">
           <p14:sldIdLst>
             <p14:sldId id="263"/>
           </p14:sldIdLst>
         </p14:section>
-        <p14:section name="정리" id="{0ddf19f7-066e-78f8-bc03-a818d8656fde}">
+        <p14:section name="정리" id="{b9d06c33-3bf9-1a1c-f4c7-e4ab02b1a570}">
           <p14:sldIdLst>
             <p14:sldId id="264"/>
             <p14:sldId id="265"/>
@@ -1729,7 +1729,7 @@
           <a:p>
             <a:r>
               <a:rPr lang="en-US" dirty="0"/>
-              <a:t>왼쪽은 Geti 화면입니다. 세 모델 모두 같은 2,800장으로 학습했고, Geti 점수는 ATSS 86%, 나머지 81%입니다. 오른쪽은 직접 만든 벤치마크로 잰 값인데 순서가 같습니다. 파라미터가 가장 적은 ATSS가 가장 정확했고, 학습에 안 쓴 2차 세트에서도 ATSS가 YOLOX-S보다 훨씬 많이 잡았습니다. 다만 '작다'는 파라미터 기준이고, 연산량은 Tiny가 가장 적습니다.</a:t>
+              <a:t>왼쪽은 Geti 화면입니다. 세 모델 모두 같은 2,800장으로 학습했고, Geti 점수는 ATSS 86%, 나머지 81%입니다. 다만 Roboflow가 원본마다 증강 사본 3장을 만들어 두었고 Geti가 이를 무작위로 나눴기 때문에, 같은 원본의 사본이 Geti 학습과 테스트에 함께 들어갔을 가능성이 높아 Geti 점수도 낙관적입니다. 오른쪽은 직접 만든 벤치마크로 잰 값인데 순서가 같습니다. 파라미터가 가장 적은 ATSS가 가장 정확했고, 학습에 안 쓴 2차 세트에서도 ATSS가 YOLOX-S보다 훨씬 많이 잡았습니다. 다만 '작다'는 파라미터 기준이고, 연산량은 Tiny가 가장 적습니다.</a:t>
             </a:r>
             <a:endParaRPr lang="en-US" dirty="0"/>
           </a:p>
@@ -1993,7 +1993,7 @@
           <a:p>
             <a:r>
               <a:rPr lang="en-US" dirty="0"/>
-              <a:t>같은 업로더가 올린 다른 세트에서, 학습에 한 번도 쓰지 않은 45장으로 제 앱에서 다시 테스트했습니다. 1차 테스트에서 결함 셀을 거의 다 잡던 모델이 ATSS 47%, YOLOX-S 3%까지 떨어집니다. 결함을 착각한 게 아니라 점수가 낮아서 통과시킨 것이고, 정상 셀을 불합격시킨 경우는 없었습니다. 1차 테스트에는 학습 때 본 사진이 섞여 있었고 촬영 환경도 같았기 때문입니다. 그럼 기준값을 낮추면 될까요? 0.15까지 낮추면 결함은 97% 잡지만 정상 셀도 87%가 걸립니다. 두 점수 분포가 겹치기 때문에 기준값으로는 해결되지 않고, 새 환경의 사진으로 재학습해야 합니다.</a:t>
+              <a:t>같은 업로더가 올린 다른 세트에서, 학습에 한 번도 쓰지 않은 45장으로 제 앱에서 다시 테스트했습니다. 1차 테스트에서 결함 셀을 거의 다 잡던 모델이 ATSS 47%, YOLOX-S 3%까지 떨어집니다. 결함을 착각한 게 아니라 점수가 낮아서 통과시킨 것이고, 정상 셀을 불합격시킨 경우는 없었습니다. 기준값을 바꿔 보면, ATSS는 0.15까지 낮추면 결함 97%를 잡지만 정상 셀도 87%가 걸립니다. YOLOX-S는 다릅니다. 2차 세트 mAP@50이 0.93으로 결함을 정상보다 높게 순위 매기는 건 정확한데, 점수 자체가 낮습니다. 0.05로 낮추면 정상 오검출 없이 57%를 잡습니다. 즉 기준값은 모델마다 따로 정해야 하고, 그래도 부족하기 때문에 새 환경 사진으로 재학습이 필요합니다.</a:t>
             </a:r>
             <a:endParaRPr lang="en-US" dirty="0"/>
           </a:p>
@@ -6533,7 +6533,7 @@
         <p:spPr>
           <a:xfrm>
             <a:off x="548640" y="1600200"/>
-            <a:ext cx="4282112" cy="4617720"/>
+            <a:ext cx="3730949" cy="4023360"/>
           </a:xfrm>
           <a:prstGeom prst="rect">
             <a:avLst/>
@@ -6542,14 +6542,64 @@
       </p:pic>
       <p:sp>
         <p:nvSpPr>
-          <p:cNvPr id="5" name="own-h"/>
+          <p:cNvPr id="5" name="geti-caveat"/>
           <p:cNvSpPr txBox="1"/>
           <p:nvPr/>
         </p:nvSpPr>
         <p:spPr>
           <a:xfrm>
-            <a:off x="5150792" y="1600200"/>
-            <a:ext cx="6492263" cy="320040"/>
+            <a:off x="548640" y="5687568"/>
+            <a:ext cx="3730949" cy="548640"/>
+          </a:xfrm>
+          <a:prstGeom prst="rect">
+            <a:avLst/>
+          </a:prstGeom>
+          <a:noFill/>
+          <a:ln/>
+        </p:spPr>
+        <p:txBody>
+          <a:bodyPr wrap="square" lIns="0" tIns="0" rIns="0" bIns="0" rtlCol="0" anchor="t"/>
+          <a:lstStyle/>
+          <a:p>
+            <a:pPr indent="0" marL="0">
+              <a:buNone/>
+            </a:pPr>
+            <a:r>
+              <a:rPr lang="en-US" sz="1100" b="1" dirty="0">
+                <a:solidFill>
+                  <a:schemeClr val="accent3"/>
+                </a:solidFill>
+              </a:rPr>
+              <a:t>Geti 점수도 낙관적  </a:t>
+            </a:r>
+            <a:endParaRPr lang="en-US" sz="1100" dirty="0"/>
+          </a:p>
+          <a:p>
+            <a:pPr indent="0" marL="0">
+              <a:buNone/>
+            </a:pPr>
+            <a:r>
+              <a:rPr lang="en-US" sz="1100" dirty="0">
+                <a:solidFill>
+                  <a:schemeClr val="tx2"/>
+                </a:solidFill>
+              </a:rPr>
+              <a:t>같은 원본의 ×3 증강 사본이 Geti 학습·테스트에 함께 분할됐을 가능성</a:t>
+            </a:r>
+            <a:endParaRPr lang="en-US" sz="1100" dirty="0"/>
+          </a:p>
+        </p:txBody>
+      </p:sp>
+      <p:sp>
+        <p:nvSpPr>
+          <p:cNvPr id="6" name="own-h"/>
+          <p:cNvSpPr txBox="1"/>
+          <p:nvPr/>
+        </p:nvSpPr>
+        <p:spPr>
+          <a:xfrm>
+            <a:off x="4599629" y="1600200"/>
+            <a:ext cx="7043426" cy="320040"/>
           </a:xfrm>
           <a:prstGeom prst="rect">
             <a:avLst/>
@@ -6578,13 +6628,13 @@
       </p:sp>
       <p:sp>
         <p:nvSpPr>
-          <p:cNvPr id="6" name="own-col-0"/>
+          <p:cNvPr id="7" name="own-col-0"/>
           <p:cNvSpPr txBox="1"/>
           <p:nvPr/>
         </p:nvSpPr>
         <p:spPr>
           <a:xfrm>
-            <a:off x="7665392" y="2011680"/>
+            <a:off x="7114229" y="2011680"/>
             <a:ext cx="1600200" cy="274320"/>
           </a:xfrm>
           <a:prstGeom prst="rect">
@@ -6614,13 +6664,13 @@
       </p:sp>
       <p:sp>
         <p:nvSpPr>
-          <p:cNvPr id="7" name="own-col-1"/>
+          <p:cNvPr id="8" name="own-col-1"/>
           <p:cNvSpPr txBox="1"/>
           <p:nvPr/>
         </p:nvSpPr>
         <p:spPr>
           <a:xfrm>
-            <a:off x="9311312" y="2011680"/>
+            <a:off x="8760149" y="2011680"/>
             <a:ext cx="1097280" cy="274320"/>
           </a:xfrm>
           <a:prstGeom prst="rect">
@@ -6650,13 +6700,13 @@
       </p:sp>
       <p:sp>
         <p:nvSpPr>
-          <p:cNvPr id="8" name="own-col-2"/>
+          <p:cNvPr id="9" name="own-col-2"/>
           <p:cNvSpPr txBox="1"/>
           <p:nvPr/>
         </p:nvSpPr>
         <p:spPr>
           <a:xfrm>
-            <a:off x="10179992" y="2011680"/>
+            <a:off x="9628829" y="2011680"/>
             <a:ext cx="1280160" cy="274320"/>
           </a:xfrm>
           <a:prstGeom prst="rect">
@@ -6686,14 +6736,14 @@
       </p:sp>
       <p:sp>
         <p:nvSpPr>
-          <p:cNvPr id="9" name="own-row-0"/>
+          <p:cNvPr id="10" name="own-row-0"/>
           <p:cNvSpPr/>
           <p:nvPr/>
         </p:nvSpPr>
         <p:spPr>
           <a:xfrm>
-            <a:off x="5150792" y="2377440"/>
-            <a:ext cx="6492263" cy="1051560"/>
+            <a:off x="4599629" y="2377440"/>
+            <a:ext cx="7043426" cy="1051560"/>
           </a:xfrm>
           <a:prstGeom prst="roundRect">
             <a:avLst>
@@ -6708,13 +6758,13 @@
       </p:sp>
       <p:sp>
         <p:nvSpPr>
-          <p:cNvPr id="10" name="own-dot-0"/>
+          <p:cNvPr id="11" name="own-dot-0"/>
           <p:cNvSpPr/>
           <p:nvPr/>
         </p:nvSpPr>
         <p:spPr>
           <a:xfrm>
-            <a:off x="5379392" y="2606040"/>
+            <a:off x="4828229" y="2606040"/>
             <a:ext cx="146304" cy="146304"/>
           </a:xfrm>
           <a:prstGeom prst="ellipse">
@@ -6728,13 +6778,13 @@
       </p:sp>
       <p:sp>
         <p:nvSpPr>
-          <p:cNvPr id="11" name="own-n-0"/>
+          <p:cNvPr id="12" name="own-n-0"/>
           <p:cNvSpPr txBox="1"/>
           <p:nvPr/>
         </p:nvSpPr>
         <p:spPr>
           <a:xfrm>
-            <a:off x="5607992" y="2514600"/>
+            <a:off x="5056829" y="2514600"/>
             <a:ext cx="2103120" cy="320040"/>
           </a:xfrm>
           <a:prstGeom prst="rect">
@@ -6764,13 +6814,13 @@
       </p:sp>
       <p:sp>
         <p:nvSpPr>
-          <p:cNvPr id="12" name="own-s-0"/>
+          <p:cNvPr id="13" name="own-s-0"/>
           <p:cNvSpPr txBox="1"/>
           <p:nvPr/>
         </p:nvSpPr>
         <p:spPr>
           <a:xfrm>
-            <a:off x="5607992" y="2926080"/>
+            <a:off x="5056829" y="2926080"/>
             <a:ext cx="2103120" cy="274320"/>
           </a:xfrm>
           <a:prstGeom prst="rect">
@@ -6800,13 +6850,13 @@
       </p:sp>
       <p:sp>
         <p:nvSpPr>
-          <p:cNvPr id="13" name="own-m-0"/>
+          <p:cNvPr id="14" name="own-m-0"/>
           <p:cNvSpPr txBox="1"/>
           <p:nvPr/>
         </p:nvSpPr>
         <p:spPr>
           <a:xfrm>
-            <a:off x="7665392" y="2487168"/>
+            <a:off x="7114229" y="2487168"/>
             <a:ext cx="1600200" cy="822960"/>
           </a:xfrm>
           <a:prstGeom prst="rect">
@@ -6836,13 +6886,13 @@
       </p:sp>
       <p:sp>
         <p:nvSpPr>
-          <p:cNvPr id="14" name="own-a-0"/>
+          <p:cNvPr id="15" name="own-a-0"/>
           <p:cNvSpPr txBox="1"/>
           <p:nvPr/>
         </p:nvSpPr>
         <p:spPr>
           <a:xfrm>
-            <a:off x="9311312" y="2487168"/>
+            <a:off x="8760149" y="2487168"/>
             <a:ext cx="1097280" cy="822960"/>
           </a:xfrm>
           <a:prstGeom prst="rect">
@@ -6872,13 +6922,13 @@
       </p:sp>
       <p:sp>
         <p:nvSpPr>
-          <p:cNvPr id="15" name="own-h2-0"/>
+          <p:cNvPr id="16" name="own-h2-0"/>
           <p:cNvSpPr txBox="1"/>
           <p:nvPr/>
         </p:nvSpPr>
         <p:spPr>
           <a:xfrm>
-            <a:off x="10454312" y="2487168"/>
+            <a:off x="9903149" y="2487168"/>
             <a:ext cx="1005840" cy="822960"/>
           </a:xfrm>
           <a:prstGeom prst="rect">
@@ -6908,13 +6958,13 @@
       </p:sp>
       <p:sp>
         <p:nvSpPr>
-          <p:cNvPr id="16" name="best-badge"/>
+          <p:cNvPr id="17" name="best-badge"/>
           <p:cNvSpPr/>
           <p:nvPr/>
         </p:nvSpPr>
         <p:spPr>
           <a:xfrm>
-            <a:off x="7071032" y="2944368"/>
+            <a:off x="6519869" y="2944368"/>
             <a:ext cx="502920" cy="237744"/>
           </a:xfrm>
           <a:prstGeom prst="roundRect">
@@ -6930,13 +6980,13 @@
       </p:sp>
       <p:sp>
         <p:nvSpPr>
-          <p:cNvPr id="17" name="best-t"/>
+          <p:cNvPr id="18" name="best-t"/>
           <p:cNvSpPr txBox="1"/>
           <p:nvPr/>
         </p:nvSpPr>
         <p:spPr>
           <a:xfrm>
-            <a:off x="7071032" y="2944368"/>
+            <a:off x="6519869" y="2944368"/>
             <a:ext cx="502920" cy="237744"/>
           </a:xfrm>
           <a:prstGeom prst="rect">
@@ -6958,7 +7008,7 @@
                   <a:schemeClr val="bg1"/>
                 </a:solidFill>
               </a:rPr>
-              <a:t>최고</a:t>
+              <a:t>best</a:t>
             </a:r>
             <a:endParaRPr lang="en-US" sz="1000" dirty="0"/>
           </a:p>
@@ -6966,14 +7016,14 @@
       </p:sp>
       <p:sp>
         <p:nvSpPr>
-          <p:cNvPr id="18" name="own-row-1"/>
+          <p:cNvPr id="19" name="own-row-1"/>
           <p:cNvSpPr/>
           <p:nvPr/>
         </p:nvSpPr>
         <p:spPr>
           <a:xfrm>
-            <a:off x="5150792" y="3566160"/>
-            <a:ext cx="6492263" cy="1051560"/>
+            <a:off x="4599629" y="3566160"/>
+            <a:ext cx="7043426" cy="1051560"/>
           </a:xfrm>
           <a:prstGeom prst="roundRect">
             <a:avLst>
@@ -6988,13 +7038,13 @@
       </p:sp>
       <p:sp>
         <p:nvSpPr>
-          <p:cNvPr id="19" name="own-dot-1"/>
+          <p:cNvPr id="20" name="own-dot-1"/>
           <p:cNvSpPr/>
           <p:nvPr/>
         </p:nvSpPr>
         <p:spPr>
           <a:xfrm>
-            <a:off x="5379392" y="3794760"/>
+            <a:off x="4828229" y="3794760"/>
             <a:ext cx="146304" cy="146304"/>
           </a:xfrm>
           <a:prstGeom prst="ellipse">
@@ -7008,13 +7058,13 @@
       </p:sp>
       <p:sp>
         <p:nvSpPr>
-          <p:cNvPr id="20" name="own-n-1"/>
+          <p:cNvPr id="21" name="own-n-1"/>
           <p:cNvSpPr txBox="1"/>
           <p:nvPr/>
         </p:nvSpPr>
         <p:spPr>
           <a:xfrm>
-            <a:off x="5607992" y="3703320"/>
+            <a:off x="5056829" y="3703320"/>
             <a:ext cx="2103120" cy="320040"/>
           </a:xfrm>
           <a:prstGeom prst="rect">
@@ -7044,13 +7094,13 @@
       </p:sp>
       <p:sp>
         <p:nvSpPr>
-          <p:cNvPr id="21" name="own-s-1"/>
+          <p:cNvPr id="22" name="own-s-1"/>
           <p:cNvSpPr txBox="1"/>
           <p:nvPr/>
         </p:nvSpPr>
         <p:spPr>
           <a:xfrm>
-            <a:off x="5607992" y="4114800"/>
+            <a:off x="5056829" y="4114800"/>
             <a:ext cx="2103120" cy="274320"/>
           </a:xfrm>
           <a:prstGeom prst="rect">
@@ -7080,13 +7130,13 @@
       </p:sp>
       <p:sp>
         <p:nvSpPr>
-          <p:cNvPr id="22" name="own-m-1"/>
+          <p:cNvPr id="23" name="own-m-1"/>
           <p:cNvSpPr txBox="1"/>
           <p:nvPr/>
         </p:nvSpPr>
         <p:spPr>
           <a:xfrm>
-            <a:off x="7665392" y="3675888"/>
+            <a:off x="7114229" y="3675888"/>
             <a:ext cx="1600200" cy="822960"/>
           </a:xfrm>
           <a:prstGeom prst="rect">
@@ -7116,13 +7166,13 @@
       </p:sp>
       <p:sp>
         <p:nvSpPr>
-          <p:cNvPr id="23" name="own-a-1"/>
+          <p:cNvPr id="24" name="own-a-1"/>
           <p:cNvSpPr txBox="1"/>
           <p:nvPr/>
         </p:nvSpPr>
         <p:spPr>
           <a:xfrm>
-            <a:off x="9311312" y="3675888"/>
+            <a:off x="8760149" y="3675888"/>
             <a:ext cx="1097280" cy="822960"/>
           </a:xfrm>
           <a:prstGeom prst="rect">
@@ -7152,13 +7202,13 @@
       </p:sp>
       <p:sp>
         <p:nvSpPr>
-          <p:cNvPr id="24" name="own-h2-1"/>
+          <p:cNvPr id="25" name="own-h2-1"/>
           <p:cNvSpPr txBox="1"/>
           <p:nvPr/>
         </p:nvSpPr>
         <p:spPr>
           <a:xfrm>
-            <a:off x="10454312" y="3675888"/>
+            <a:off x="9903149" y="3675888"/>
             <a:ext cx="1005840" cy="822960"/>
           </a:xfrm>
           <a:prstGeom prst="rect">
@@ -7188,14 +7238,14 @@
       </p:sp>
       <p:sp>
         <p:nvSpPr>
-          <p:cNvPr id="25" name="own-row-2"/>
+          <p:cNvPr id="26" name="own-row-2"/>
           <p:cNvSpPr/>
           <p:nvPr/>
         </p:nvSpPr>
         <p:spPr>
           <a:xfrm>
-            <a:off x="5150792" y="4754880"/>
-            <a:ext cx="6492263" cy="1051560"/>
+            <a:off x="4599629" y="4754880"/>
+            <a:ext cx="7043426" cy="1051560"/>
           </a:xfrm>
           <a:prstGeom prst="roundRect">
             <a:avLst>
@@ -7210,13 +7260,13 @@
       </p:sp>
       <p:sp>
         <p:nvSpPr>
-          <p:cNvPr id="26" name="own-dot-2"/>
+          <p:cNvPr id="27" name="own-dot-2"/>
           <p:cNvSpPr/>
           <p:nvPr/>
         </p:nvSpPr>
         <p:spPr>
           <a:xfrm>
-            <a:off x="5379392" y="4983480"/>
+            <a:off x="4828229" y="4983480"/>
             <a:ext cx="146304" cy="146304"/>
           </a:xfrm>
           <a:prstGeom prst="ellipse">
@@ -7230,13 +7280,13 @@
       </p:sp>
       <p:sp>
         <p:nvSpPr>
-          <p:cNvPr id="27" name="own-n-2"/>
+          <p:cNvPr id="28" name="own-n-2"/>
           <p:cNvSpPr txBox="1"/>
           <p:nvPr/>
         </p:nvSpPr>
         <p:spPr>
           <a:xfrm>
-            <a:off x="5607992" y="4892040"/>
+            <a:off x="5056829" y="4892040"/>
             <a:ext cx="2103120" cy="320040"/>
           </a:xfrm>
           <a:prstGeom prst="rect">
@@ -7266,13 +7316,13 @@
       </p:sp>
       <p:sp>
         <p:nvSpPr>
-          <p:cNvPr id="28" name="own-s-2"/>
+          <p:cNvPr id="29" name="own-s-2"/>
           <p:cNvSpPr txBox="1"/>
           <p:nvPr/>
         </p:nvSpPr>
         <p:spPr>
           <a:xfrm>
-            <a:off x="5607992" y="5303520"/>
+            <a:off x="5056829" y="5303520"/>
             <a:ext cx="2103120" cy="274320"/>
           </a:xfrm>
           <a:prstGeom prst="rect">
@@ -7302,13 +7352,13 @@
       </p:sp>
       <p:sp>
         <p:nvSpPr>
-          <p:cNvPr id="29" name="own-m-2"/>
+          <p:cNvPr id="30" name="own-m-2"/>
           <p:cNvSpPr txBox="1"/>
           <p:nvPr/>
         </p:nvSpPr>
         <p:spPr>
           <a:xfrm>
-            <a:off x="7665392" y="4864608"/>
+            <a:off x="7114229" y="4864608"/>
             <a:ext cx="1600200" cy="822960"/>
           </a:xfrm>
           <a:prstGeom prst="rect">
@@ -7338,13 +7388,13 @@
       </p:sp>
       <p:sp>
         <p:nvSpPr>
-          <p:cNvPr id="30" name="own-a-2"/>
+          <p:cNvPr id="31" name="own-a-2"/>
           <p:cNvSpPr txBox="1"/>
           <p:nvPr/>
         </p:nvSpPr>
         <p:spPr>
           <a:xfrm>
-            <a:off x="9311312" y="4864608"/>
+            <a:off x="8760149" y="4864608"/>
             <a:ext cx="1097280" cy="822960"/>
           </a:xfrm>
           <a:prstGeom prst="rect">
@@ -7374,13 +7424,13 @@
       </p:sp>
       <p:sp>
         <p:nvSpPr>
-          <p:cNvPr id="31" name="own-h2-2"/>
+          <p:cNvPr id="32" name="own-h2-2"/>
           <p:cNvSpPr txBox="1"/>
           <p:nvPr/>
         </p:nvSpPr>
         <p:spPr>
           <a:xfrm>
-            <a:off x="10454312" y="4864608"/>
+            <a:off x="9903149" y="4864608"/>
             <a:ext cx="1005840" cy="822960"/>
           </a:xfrm>
           <a:prstGeom prst="rect">
@@ -7410,14 +7460,14 @@
       </p:sp>
       <p:sp>
         <p:nvSpPr>
-          <p:cNvPr id="32" name="own-note"/>
+          <p:cNvPr id="33" name="own-note"/>
           <p:cNvSpPr txBox="1"/>
           <p:nvPr/>
         </p:nvSpPr>
         <p:spPr>
           <a:xfrm>
-            <a:off x="5150792" y="5943600"/>
-            <a:ext cx="6492263" cy="274320"/>
+            <a:off x="4599629" y="5943600"/>
+            <a:ext cx="7043426" cy="274320"/>
           </a:xfrm>
           <a:prstGeom prst="rect">
             <a:avLst/>
@@ -11393,11 +11443,11 @@
         <p:spPr>
           <a:xfrm>
             <a:off x="548640" y="1645920"/>
-            <a:ext cx="6035040" cy="3017520"/>
+            <a:ext cx="6035040" cy="2514600"/>
           </a:xfrm>
           <a:prstGeom prst="roundRect">
             <a:avLst>
-              <a:gd name="adj" fmla="val 2424"/>
+              <a:gd name="adj" fmla="val 2909"/>
             </a:avLst>
           </a:prstGeom>
           <a:solidFill>
@@ -11414,7 +11464,7 @@
         </p:nvSpPr>
         <p:spPr>
           <a:xfrm>
-            <a:off x="822960" y="1783080"/>
+            <a:off x="822960" y="1755648"/>
             <a:ext cx="5486400" cy="320040"/>
           </a:xfrm>
           <a:prstGeom prst="rect">
@@ -11450,7 +11500,7 @@
         </p:nvSpPr>
         <p:spPr>
           <a:xfrm>
-            <a:off x="2926080" y="2194560"/>
+            <a:off x="2926080" y="2103120"/>
             <a:ext cx="1463040" cy="274320"/>
           </a:xfrm>
           <a:prstGeom prst="rect">
@@ -11486,7 +11536,7 @@
         </p:nvSpPr>
         <p:spPr>
           <a:xfrm>
-            <a:off x="4754880" y="2194560"/>
+            <a:off x="4754880" y="2103120"/>
             <a:ext cx="1463040" cy="274320"/>
           </a:xfrm>
           <a:prstGeom prst="rect">
@@ -11522,7 +11572,7 @@
         </p:nvSpPr>
         <p:spPr>
           <a:xfrm>
-            <a:off x="822960" y="2715768"/>
+            <a:off x="822960" y="2596896"/>
             <a:ext cx="146304" cy="146304"/>
           </a:xfrm>
           <a:prstGeom prst="ellipse">
@@ -11542,7 +11592,7 @@
         </p:nvSpPr>
         <p:spPr>
           <a:xfrm>
-            <a:off x="1060704" y="2542032"/>
+            <a:off x="1060704" y="2423160"/>
             <a:ext cx="1828800" cy="502920"/>
           </a:xfrm>
           <a:prstGeom prst="rect">
@@ -11578,7 +11628,7 @@
         </p:nvSpPr>
         <p:spPr>
           <a:xfrm>
-            <a:off x="2926080" y="2542032"/>
+            <a:off x="2926080" y="2423160"/>
             <a:ext cx="1463040" cy="502920"/>
           </a:xfrm>
           <a:prstGeom prst="rect">
@@ -11614,7 +11664,7 @@
         </p:nvSpPr>
         <p:spPr>
           <a:xfrm>
-            <a:off x="4754880" y="2542032"/>
+            <a:off x="4754880" y="2423160"/>
             <a:ext cx="1463040" cy="502920"/>
           </a:xfrm>
           <a:prstGeom prst="rect">
@@ -11650,7 +11700,7 @@
         </p:nvSpPr>
         <p:spPr>
           <a:xfrm>
-            <a:off x="822960" y="3374136"/>
+            <a:off x="822960" y="3145536"/>
             <a:ext cx="146304" cy="146304"/>
           </a:xfrm>
           <a:prstGeom prst="ellipse">
@@ -11670,7 +11720,7 @@
         </p:nvSpPr>
         <p:spPr>
           <a:xfrm>
-            <a:off x="1060704" y="3200400"/>
+            <a:off x="1060704" y="2971800"/>
             <a:ext cx="1828800" cy="502920"/>
           </a:xfrm>
           <a:prstGeom prst="rect">
@@ -11706,7 +11756,7 @@
         </p:nvSpPr>
         <p:spPr>
           <a:xfrm>
-            <a:off x="2926080" y="3200400"/>
+            <a:off x="2926080" y="2971800"/>
             <a:ext cx="1463040" cy="502920"/>
           </a:xfrm>
           <a:prstGeom prst="rect">
@@ -11742,7 +11792,7 @@
         </p:nvSpPr>
         <p:spPr>
           <a:xfrm>
-            <a:off x="4754880" y="3200400"/>
+            <a:off x="4754880" y="2971800"/>
             <a:ext cx="1463040" cy="502920"/>
           </a:xfrm>
           <a:prstGeom prst="rect">
@@ -11778,7 +11828,7 @@
         </p:nvSpPr>
         <p:spPr>
           <a:xfrm>
-            <a:off x="822960" y="4032504"/>
+            <a:off x="822960" y="3694176"/>
             <a:ext cx="146304" cy="146304"/>
           </a:xfrm>
           <a:prstGeom prst="ellipse">
@@ -11798,7 +11848,7 @@
         </p:nvSpPr>
         <p:spPr>
           <a:xfrm>
-            <a:off x="1060704" y="3858768"/>
+            <a:off x="1060704" y="3520440"/>
             <a:ext cx="1828800" cy="502920"/>
           </a:xfrm>
           <a:prstGeom prst="rect">
@@ -11834,7 +11884,7 @@
         </p:nvSpPr>
         <p:spPr>
           <a:xfrm>
-            <a:off x="2926080" y="3858768"/>
+            <a:off x="2926080" y="3520440"/>
             <a:ext cx="1463040" cy="502920"/>
           </a:xfrm>
           <a:prstGeom prst="rect">
@@ -11870,7 +11920,7 @@
         </p:nvSpPr>
         <p:spPr>
           <a:xfrm>
-            <a:off x="4754880" y="3858768"/>
+            <a:off x="4754880" y="3520440"/>
             <a:ext cx="1463040" cy="502920"/>
           </a:xfrm>
           <a:prstGeom prst="rect">
@@ -11898,38 +11948,40 @@
           </a:p>
         </p:txBody>
       </p:sp>
-      <p:sp>
-        <p:nvSpPr>
-          <p:cNvPr id="20" name="finding-card"/>
-          <p:cNvSpPr/>
+      <p:pic>
+        <p:nvPicPr>
+          <p:cNvPr id="20" name="miss-img" descr="C:\Users\user\_se4nchoi\batteryvision\docs\submission\build\img\holdout_miss.jpg">    </p:cNvPr>
+          <p:cNvPicPr>
+            <a:picLocks noChangeAspect="1"/>
+          </p:cNvPicPr>
           <p:nvPr/>
-        </p:nvSpPr>
-        <p:spPr>
-          <a:xfrm>
-            <a:off x="548640" y="4846320"/>
-            <a:ext cx="6035040" cy="1371600"/>
-          </a:xfrm>
-          <a:prstGeom prst="roundRect">
-            <a:avLst>
-              <a:gd name="adj" fmla="val 5333"/>
-            </a:avLst>
-          </a:prstGeom>
-          <a:solidFill>
-            <a:schemeClr val="bg2"/>
-          </a:solidFill>
-          <a:ln/>
-        </p:spPr>
-      </p:sp>
-      <p:sp>
-        <p:nvSpPr>
-          <p:cNvPr id="21" name="finding-b"/>
+        </p:nvPicPr>
+        <p:blipFill>
+          <a:blip r:embed="rId1"/>
+          <a:stretch>
+            <a:fillRect/>
+          </a:stretch>
+        </p:blipFill>
+        <p:spPr>
+          <a:xfrm>
+            <a:off x="548640" y="4343400"/>
+            <a:ext cx="1874520" cy="1874520"/>
+          </a:xfrm>
+          <a:prstGeom prst="rect">
+            <a:avLst/>
+          </a:prstGeom>
+        </p:spPr>
+      </p:pic>
+      <p:sp>
+        <p:nvSpPr>
+          <p:cNvPr id="21" name="miss-cap"/>
           <p:cNvSpPr txBox="1"/>
           <p:nvPr/>
         </p:nvSpPr>
         <p:spPr>
           <a:xfrm>
-            <a:off x="822960" y="4956048"/>
-            <a:ext cx="5577840" cy="1143000"/>
+            <a:off x="2651760" y="4389120"/>
+            <a:ext cx="3931920" cy="1783080"/>
           </a:xfrm>
           <a:prstGeom prst="rect">
             <a:avLst/>
@@ -11938,12 +11990,29 @@
           <a:ln/>
         </p:spPr>
         <p:txBody>
-          <a:bodyPr wrap="square" lIns="0" tIns="0" rIns="0" bIns="0" rtlCol="0" anchor="t"/>
+          <a:bodyPr wrap="square" lIns="0" tIns="0" rIns="0" bIns="0" rtlCol="0" anchor="ctr"/>
           <a:lstStyle/>
+          <a:p>
+            <a:pPr indent="0" marL="0">
+              <a:spcAft>
+                <a:spcPts val="600"/>
+              </a:spcAft>
+              <a:buNone/>
+            </a:pPr>
+            <a:r>
+              <a:rPr lang="en-US" sz="1400" b="1" dirty="0">
+                <a:solidFill>
+                  <a:schemeClr val="tx1"/>
+                </a:solidFill>
+              </a:rPr>
+              <a:t>놓친 예: scratch · ATSS 최고 점수 0.21</a:t>
+            </a:r>
+            <a:endParaRPr lang="en-US" sz="1400" dirty="0"/>
+          </a:p>
           <a:p>
             <a:pPr marL="342900" indent="-342900">
               <a:spcAft>
-                <a:spcPts val="400"/>
+                <a:spcPts val="600"/>
               </a:spcAft>
               <a:buSzPct val="100000"/>
               <a:buChar char="•"/>
@@ -11954,14 +12023,14 @@
                   <a:schemeClr val="tx1"/>
                 </a:solidFill>
               </a:rPr>
-              <a:t>클래스 착각 0건 · 점수 미달로 놓침 · 정상 불합격 0건</a:t>
+              <a:t>클래스 착각 0건 · 정상 불합격 0건</a:t>
             </a:r>
             <a:endParaRPr lang="en-US" sz="1400" dirty="0"/>
           </a:p>
           <a:p>
             <a:pPr marL="342900" indent="-342900">
               <a:spcAft>
-                <a:spcPts val="400"/>
+                <a:spcPts val="600"/>
               </a:spcAft>
               <a:buSzPct val="100000"/>
               <a:buChar char="•"/>
@@ -12008,7 +12077,7 @@
                   <a:schemeClr val="tx1"/>
                 </a:solidFill>
               </a:rPr>
-              <a:t>기준값을 낮추면? (ATSS · 2차 세트)</a:t>
+              <a:t>기준값을 바꾸면? (2차 세트)</a:t>
             </a:r>
             <a:endParaRPr lang="en-US" sz="1600" dirty="0"/>
           </a:p>
@@ -12029,7 +12098,7 @@
           </p:nvPr>
         </p:nvGraphicFramePr>
         <p:xfrm>
-          <a:off x="6812280" y="2103120"/>
+          <a:off x="6812280" y="2057400"/>
           <a:ext cx="4828032" cy="914400"/>
         </p:xfrm>
         <a:graphic>
@@ -12037,11 +12106,80 @@
             <a:tbl>
               <a:tblPr/>
               <a:tblGrid>
-                <a:gridCol w="1609344"/>
-                <a:gridCol w="1609344"/>
-                <a:gridCol w="1609344"/>
+                <a:gridCol w="1280160"/>
+                <a:gridCol w="1188720"/>
+                <a:gridCol w="1133856"/>
+                <a:gridCol w="1225296"/>
               </a:tblGrid>
-              <a:tr h="457200">
+              <a:tr h="402336">
+                <a:tc>
+                  <a:txBody>
+                    <a:bodyPr/>
+                    <a:lstStyle/>
+                    <a:p>
+                      <a:pPr algn="l" indent="0" marL="0">
+                        <a:buNone/>
+                      </a:pPr>
+                      <a:r>
+                        <a:rPr lang="en-US" sz="1400" b="1" dirty="0">
+                          <a:solidFill>
+                            <a:schemeClr val="tx2"/>
+                          </a:solidFill>
+                          <a:latin typeface="Malgun Gothic" pitchFamily="34" charset="0"/>
+                          <a:ea typeface="Malgun Gothic" pitchFamily="34" charset="-122"/>
+                          <a:cs typeface="Malgun Gothic" pitchFamily="34" charset="-120"/>
+                        </a:rPr>
+                        <a:t>모델</a:t>
+                      </a:r>
+                      <a:endParaRPr lang="en-US" sz="1400" dirty="0">
+                        <a:latin typeface="Malgun Gothic" charset="0"/>
+                        <a:ea typeface="Malgun Gothic" charset="0"/>
+                        <a:cs typeface="Malgun Gothic" charset="0"/>
+                      </a:endParaRPr>
+                    </a:p>
+                  </a:txBody>
+                  <a:tcPr marL="91440" marR="91440" marT="45720" marB="45720" anchor="ctr">
+                    <a:lnL w="9525" cap="flat" cmpd="sng" algn="ctr">
+                      <a:solidFill>
+                        <a:srgbClr val="3A3F48"/>
+                      </a:solidFill>
+                      <a:prstDash val="solid"/>
+                      <a:round/>
+                      <a:headEnd type="none" w="med" len="med"/>
+                      <a:tailEnd type="none" w="med" len="med"/>
+                    </a:lnL>
+                    <a:lnR w="9525" cap="flat" cmpd="sng" algn="ctr">
+                      <a:solidFill>
+                        <a:srgbClr val="3A3F48"/>
+                      </a:solidFill>
+                      <a:prstDash val="solid"/>
+                      <a:round/>
+                      <a:headEnd type="none" w="med" len="med"/>
+                      <a:tailEnd type="none" w="med" len="med"/>
+                    </a:lnR>
+                    <a:lnT w="9525" cap="flat" cmpd="sng" algn="ctr">
+                      <a:solidFill>
+                        <a:srgbClr val="3A3F48"/>
+                      </a:solidFill>
+                      <a:prstDash val="solid"/>
+                      <a:round/>
+                      <a:headEnd type="none" w="med" len="med"/>
+                      <a:tailEnd type="none" w="med" len="med"/>
+                    </a:lnT>
+                    <a:lnB w="9525" cap="flat" cmpd="sng" algn="ctr">
+                      <a:solidFill>
+                        <a:srgbClr val="3A3F48"/>
+                      </a:solidFill>
+                      <a:prstDash val="solid"/>
+                      <a:round/>
+                      <a:headEnd type="none" w="med" len="med"/>
+                      <a:tailEnd type="none" w="med" len="med"/>
+                    </a:lnB>
+                    <a:solidFill>
+                      <a:srgbClr val="16191E"/>
+                    </a:solidFill>
+                  </a:tcPr>
+                </a:tc>
                 <a:tc>
                   <a:txBody>
                     <a:bodyPr/>
@@ -12247,7 +12385,75 @@
                   </a:tcPr>
                 </a:tc>
               </a:tr>
-              <a:tr h="457200">
+              <a:tr h="402336">
+                <a:tc>
+                  <a:txBody>
+                    <a:bodyPr/>
+                    <a:lstStyle/>
+                    <a:p>
+                      <a:pPr algn="l" indent="0" marL="0">
+                        <a:buNone/>
+                      </a:pPr>
+                      <a:r>
+                        <a:rPr lang="en-US" sz="1400" b="1" dirty="0">
+                          <a:solidFill>
+                            <a:schemeClr val="accent4"/>
+                          </a:solidFill>
+                          <a:latin typeface="Malgun Gothic" pitchFamily="34" charset="0"/>
+                          <a:ea typeface="Malgun Gothic" pitchFamily="34" charset="-122"/>
+                          <a:cs typeface="Malgun Gothic" pitchFamily="34" charset="-120"/>
+                        </a:rPr>
+                        <a:t>ATSS</a:t>
+                      </a:r>
+                      <a:endParaRPr lang="en-US" sz="1400" dirty="0">
+                        <a:latin typeface="Malgun Gothic" charset="0"/>
+                        <a:ea typeface="Malgun Gothic" charset="0"/>
+                        <a:cs typeface="Malgun Gothic" charset="0"/>
+                      </a:endParaRPr>
+                    </a:p>
+                  </a:txBody>
+                  <a:tcPr marL="91440" marR="91440" marT="45720" marB="45720" anchor="ctr">
+                    <a:lnL w="9525" cap="flat" cmpd="sng" algn="ctr">
+                      <a:solidFill>
+                        <a:srgbClr val="3A3F48"/>
+                      </a:solidFill>
+                      <a:prstDash val="solid"/>
+                      <a:round/>
+                      <a:headEnd type="none" w="med" len="med"/>
+                      <a:tailEnd type="none" w="med" len="med"/>
+                    </a:lnL>
+                    <a:lnR w="9525" cap="flat" cmpd="sng" algn="ctr">
+                      <a:solidFill>
+                        <a:srgbClr val="3A3F48"/>
+                      </a:solidFill>
+                      <a:prstDash val="solid"/>
+                      <a:round/>
+                      <a:headEnd type="none" w="med" len="med"/>
+                      <a:tailEnd type="none" w="med" len="med"/>
+                    </a:lnR>
+                    <a:lnT w="9525" cap="flat" cmpd="sng" algn="ctr">
+                      <a:solidFill>
+                        <a:srgbClr val="3A3F48"/>
+                      </a:solidFill>
+                      <a:prstDash val="solid"/>
+                      <a:round/>
+                      <a:headEnd type="none" w="med" len="med"/>
+                      <a:tailEnd type="none" w="med" len="med"/>
+                    </a:lnT>
+                    <a:lnB w="9525" cap="flat" cmpd="sng" algn="ctr">
+                      <a:solidFill>
+                        <a:srgbClr val="3A3F48"/>
+                      </a:solidFill>
+                      <a:prstDash val="solid"/>
+                      <a:round/>
+                      <a:headEnd type="none" w="med" len="med"/>
+                      <a:tailEnd type="none" w="med" len="med"/>
+                    </a:lnB>
+                    <a:solidFill>
+                      <a:srgbClr val="23272F"/>
+                    </a:solidFill>
+                  </a:tcPr>
+                </a:tc>
                 <a:tc>
                   <a:txBody>
                     <a:bodyPr/>
@@ -12453,7 +12659,75 @@
                   </a:tcPr>
                 </a:tc>
               </a:tr>
-              <a:tr h="457200">
+              <a:tr h="402336">
+                <a:tc>
+                  <a:txBody>
+                    <a:bodyPr/>
+                    <a:lstStyle/>
+                    <a:p>
+                      <a:pPr algn="l" indent="0" marL="0">
+                        <a:buNone/>
+                      </a:pPr>
+                      <a:r>
+                        <a:rPr lang="en-US" sz="1400" b="1" dirty="0">
+                          <a:solidFill>
+                            <a:schemeClr val="accent4"/>
+                          </a:solidFill>
+                          <a:latin typeface="Malgun Gothic" pitchFamily="34" charset="0"/>
+                          <a:ea typeface="Malgun Gothic" pitchFamily="34" charset="-122"/>
+                          <a:cs typeface="Malgun Gothic" pitchFamily="34" charset="-120"/>
+                        </a:rPr>
+                        <a:t>ATSS</a:t>
+                      </a:r>
+                      <a:endParaRPr lang="en-US" sz="1400" dirty="0">
+                        <a:latin typeface="Malgun Gothic" charset="0"/>
+                        <a:ea typeface="Malgun Gothic" charset="0"/>
+                        <a:cs typeface="Malgun Gothic" charset="0"/>
+                      </a:endParaRPr>
+                    </a:p>
+                  </a:txBody>
+                  <a:tcPr marL="91440" marR="91440" marT="45720" marB="45720" anchor="ctr">
+                    <a:lnL w="9525" cap="flat" cmpd="sng" algn="ctr">
+                      <a:solidFill>
+                        <a:srgbClr val="3A3F48"/>
+                      </a:solidFill>
+                      <a:prstDash val="solid"/>
+                      <a:round/>
+                      <a:headEnd type="none" w="med" len="med"/>
+                      <a:tailEnd type="none" w="med" len="med"/>
+                    </a:lnL>
+                    <a:lnR w="9525" cap="flat" cmpd="sng" algn="ctr">
+                      <a:solidFill>
+                        <a:srgbClr val="3A3F48"/>
+                      </a:solidFill>
+                      <a:prstDash val="solid"/>
+                      <a:round/>
+                      <a:headEnd type="none" w="med" len="med"/>
+                      <a:tailEnd type="none" w="med" len="med"/>
+                    </a:lnR>
+                    <a:lnT w="9525" cap="flat" cmpd="sng" algn="ctr">
+                      <a:solidFill>
+                        <a:srgbClr val="3A3F48"/>
+                      </a:solidFill>
+                      <a:prstDash val="solid"/>
+                      <a:round/>
+                      <a:headEnd type="none" w="med" len="med"/>
+                      <a:tailEnd type="none" w="med" len="med"/>
+                    </a:lnT>
+                    <a:lnB w="9525" cap="flat" cmpd="sng" algn="ctr">
+                      <a:solidFill>
+                        <a:srgbClr val="3A3F48"/>
+                      </a:solidFill>
+                      <a:prstDash val="solid"/>
+                      <a:round/>
+                      <a:headEnd type="none" w="med" len="med"/>
+                      <a:tailEnd type="none" w="med" len="med"/>
+                    </a:lnB>
+                    <a:solidFill>
+                      <a:srgbClr val="23272F"/>
+                    </a:solidFill>
+                  </a:tcPr>
+                </a:tc>
                 <a:tc>
                   <a:txBody>
                     <a:bodyPr/>
@@ -12659,7 +12933,75 @@
                   </a:tcPr>
                 </a:tc>
               </a:tr>
-              <a:tr h="457200">
+              <a:tr h="402336">
+                <a:tc>
+                  <a:txBody>
+                    <a:bodyPr/>
+                    <a:lstStyle/>
+                    <a:p>
+                      <a:pPr algn="l" indent="0" marL="0">
+                        <a:buNone/>
+                      </a:pPr>
+                      <a:r>
+                        <a:rPr lang="en-US" sz="1400" b="1" dirty="0">
+                          <a:solidFill>
+                            <a:schemeClr val="accent4"/>
+                          </a:solidFill>
+                          <a:latin typeface="Malgun Gothic" pitchFamily="34" charset="0"/>
+                          <a:ea typeface="Malgun Gothic" pitchFamily="34" charset="-122"/>
+                          <a:cs typeface="Malgun Gothic" pitchFamily="34" charset="-120"/>
+                        </a:rPr>
+                        <a:t>ATSS</a:t>
+                      </a:r>
+                      <a:endParaRPr lang="en-US" sz="1400" dirty="0">
+                        <a:latin typeface="Malgun Gothic" charset="0"/>
+                        <a:ea typeface="Malgun Gothic" charset="0"/>
+                        <a:cs typeface="Malgun Gothic" charset="0"/>
+                      </a:endParaRPr>
+                    </a:p>
+                  </a:txBody>
+                  <a:tcPr marL="91440" marR="91440" marT="45720" marB="45720" anchor="ctr">
+                    <a:lnL w="9525" cap="flat" cmpd="sng" algn="ctr">
+                      <a:solidFill>
+                        <a:srgbClr val="3A3F48"/>
+                      </a:solidFill>
+                      <a:prstDash val="solid"/>
+                      <a:round/>
+                      <a:headEnd type="none" w="med" len="med"/>
+                      <a:tailEnd type="none" w="med" len="med"/>
+                    </a:lnL>
+                    <a:lnR w="9525" cap="flat" cmpd="sng" algn="ctr">
+                      <a:solidFill>
+                        <a:srgbClr val="3A3F48"/>
+                      </a:solidFill>
+                      <a:prstDash val="solid"/>
+                      <a:round/>
+                      <a:headEnd type="none" w="med" len="med"/>
+                      <a:tailEnd type="none" w="med" len="med"/>
+                    </a:lnR>
+                    <a:lnT w="9525" cap="flat" cmpd="sng" algn="ctr">
+                      <a:solidFill>
+                        <a:srgbClr val="3A3F48"/>
+                      </a:solidFill>
+                      <a:prstDash val="solid"/>
+                      <a:round/>
+                      <a:headEnd type="none" w="med" len="med"/>
+                      <a:tailEnd type="none" w="med" len="med"/>
+                    </a:lnT>
+                    <a:lnB w="9525" cap="flat" cmpd="sng" algn="ctr">
+                      <a:solidFill>
+                        <a:srgbClr val="3A3F48"/>
+                      </a:solidFill>
+                      <a:prstDash val="solid"/>
+                      <a:round/>
+                      <a:headEnd type="none" w="med" len="med"/>
+                      <a:tailEnd type="none" w="med" len="med"/>
+                    </a:lnB>
+                    <a:solidFill>
+                      <a:srgbClr val="23272F"/>
+                    </a:solidFill>
+                  </a:tcPr>
+                </a:tc>
                 <a:tc>
                   <a:txBody>
                     <a:bodyPr/>
@@ -12865,6 +13207,554 @@
                   </a:tcPr>
                 </a:tc>
               </a:tr>
+              <a:tr h="402336">
+                <a:tc>
+                  <a:txBody>
+                    <a:bodyPr/>
+                    <a:lstStyle/>
+                    <a:p>
+                      <a:pPr algn="l" indent="0" marL="0">
+                        <a:buNone/>
+                      </a:pPr>
+                      <a:r>
+                        <a:rPr lang="en-US" sz="1400" b="1" dirty="0">
+                          <a:solidFill>
+                            <a:schemeClr val="accent5"/>
+                          </a:solidFill>
+                          <a:latin typeface="Malgun Gothic" pitchFamily="34" charset="0"/>
+                          <a:ea typeface="Malgun Gothic" pitchFamily="34" charset="-122"/>
+                          <a:cs typeface="Malgun Gothic" pitchFamily="34" charset="-120"/>
+                        </a:rPr>
+                        <a:t>YOLOX-S</a:t>
+                      </a:r>
+                      <a:endParaRPr lang="en-US" sz="1400" dirty="0">
+                        <a:latin typeface="Malgun Gothic" charset="0"/>
+                        <a:ea typeface="Malgun Gothic" charset="0"/>
+                        <a:cs typeface="Malgun Gothic" charset="0"/>
+                      </a:endParaRPr>
+                    </a:p>
+                  </a:txBody>
+                  <a:tcPr marL="91440" marR="91440" marT="45720" marB="45720" anchor="ctr">
+                    <a:lnL w="9525" cap="flat" cmpd="sng" algn="ctr">
+                      <a:solidFill>
+                        <a:srgbClr val="3A3F48"/>
+                      </a:solidFill>
+                      <a:prstDash val="solid"/>
+                      <a:round/>
+                      <a:headEnd type="none" w="med" len="med"/>
+                      <a:tailEnd type="none" w="med" len="med"/>
+                    </a:lnL>
+                    <a:lnR w="9525" cap="flat" cmpd="sng" algn="ctr">
+                      <a:solidFill>
+                        <a:srgbClr val="3A3F48"/>
+                      </a:solidFill>
+                      <a:prstDash val="solid"/>
+                      <a:round/>
+                      <a:headEnd type="none" w="med" len="med"/>
+                      <a:tailEnd type="none" w="med" len="med"/>
+                    </a:lnR>
+                    <a:lnT w="9525" cap="flat" cmpd="sng" algn="ctr">
+                      <a:solidFill>
+                        <a:srgbClr val="3A3F48"/>
+                      </a:solidFill>
+                      <a:prstDash val="solid"/>
+                      <a:round/>
+                      <a:headEnd type="none" w="med" len="med"/>
+                      <a:tailEnd type="none" w="med" len="med"/>
+                    </a:lnT>
+                    <a:lnB w="9525" cap="flat" cmpd="sng" algn="ctr">
+                      <a:solidFill>
+                        <a:srgbClr val="3A3F48"/>
+                      </a:solidFill>
+                      <a:prstDash val="solid"/>
+                      <a:round/>
+                      <a:headEnd type="none" w="med" len="med"/>
+                      <a:tailEnd type="none" w="med" len="med"/>
+                    </a:lnB>
+                    <a:solidFill>
+                      <a:srgbClr val="23272F"/>
+                    </a:solidFill>
+                  </a:tcPr>
+                </a:tc>
+                <a:tc>
+                  <a:txBody>
+                    <a:bodyPr/>
+                    <a:lstStyle/>
+                    <a:p>
+                      <a:pPr algn="ctr" indent="0" marL="0">
+                        <a:buNone/>
+                      </a:pPr>
+                      <a:r>
+                        <a:rPr lang="en-US" sz="1400" dirty="0">
+                          <a:solidFill>
+                            <a:schemeClr val="tx1"/>
+                          </a:solidFill>
+                          <a:latin typeface="Malgun Gothic" pitchFamily="34" charset="0"/>
+                          <a:ea typeface="Malgun Gothic" pitchFamily="34" charset="-122"/>
+                          <a:cs typeface="Malgun Gothic" pitchFamily="34" charset="-120"/>
+                        </a:rPr>
+                        <a:t>0.30 (현재)</a:t>
+                      </a:r>
+                      <a:endParaRPr lang="en-US" sz="1400" dirty="0">
+                        <a:latin typeface="Malgun Gothic" charset="0"/>
+                        <a:ea typeface="Malgun Gothic" charset="0"/>
+                        <a:cs typeface="Malgun Gothic" charset="0"/>
+                      </a:endParaRPr>
+                    </a:p>
+                  </a:txBody>
+                  <a:tcPr marL="91440" marR="91440" marT="45720" marB="45720" anchor="ctr">
+                    <a:lnL w="9525" cap="flat" cmpd="sng" algn="ctr">
+                      <a:solidFill>
+                        <a:srgbClr val="3A3F48"/>
+                      </a:solidFill>
+                      <a:prstDash val="solid"/>
+                      <a:round/>
+                      <a:headEnd type="none" w="med" len="med"/>
+                      <a:tailEnd type="none" w="med" len="med"/>
+                    </a:lnL>
+                    <a:lnR w="9525" cap="flat" cmpd="sng" algn="ctr">
+                      <a:solidFill>
+                        <a:srgbClr val="3A3F48"/>
+                      </a:solidFill>
+                      <a:prstDash val="solid"/>
+                      <a:round/>
+                      <a:headEnd type="none" w="med" len="med"/>
+                      <a:tailEnd type="none" w="med" len="med"/>
+                    </a:lnR>
+                    <a:lnT w="9525" cap="flat" cmpd="sng" algn="ctr">
+                      <a:solidFill>
+                        <a:srgbClr val="3A3F48"/>
+                      </a:solidFill>
+                      <a:prstDash val="solid"/>
+                      <a:round/>
+                      <a:headEnd type="none" w="med" len="med"/>
+                      <a:tailEnd type="none" w="med" len="med"/>
+                    </a:lnT>
+                    <a:lnB w="9525" cap="flat" cmpd="sng" algn="ctr">
+                      <a:solidFill>
+                        <a:srgbClr val="3A3F48"/>
+                      </a:solidFill>
+                      <a:prstDash val="solid"/>
+                      <a:round/>
+                      <a:headEnd type="none" w="med" len="med"/>
+                      <a:tailEnd type="none" w="med" len="med"/>
+                    </a:lnB>
+                    <a:solidFill>
+                      <a:srgbClr val="23272F"/>
+                    </a:solidFill>
+                  </a:tcPr>
+                </a:tc>
+                <a:tc>
+                  <a:txBody>
+                    <a:bodyPr/>
+                    <a:lstStyle/>
+                    <a:p>
+                      <a:pPr algn="ctr" indent="0" marL="0">
+                        <a:buNone/>
+                      </a:pPr>
+                      <a:r>
+                        <a:rPr lang="en-US" sz="1400" b="1" dirty="0">
+                          <a:solidFill>
+                            <a:schemeClr val="accent2"/>
+                          </a:solidFill>
+                          <a:latin typeface="Malgun Gothic" pitchFamily="34" charset="0"/>
+                          <a:ea typeface="Malgun Gothic" pitchFamily="34" charset="-122"/>
+                          <a:cs typeface="Malgun Gothic" pitchFamily="34" charset="-120"/>
+                        </a:rPr>
+                        <a:t>3%</a:t>
+                      </a:r>
+                      <a:endParaRPr lang="en-US" sz="1400" dirty="0">
+                        <a:latin typeface="Malgun Gothic" charset="0"/>
+                        <a:ea typeface="Malgun Gothic" charset="0"/>
+                        <a:cs typeface="Malgun Gothic" charset="0"/>
+                      </a:endParaRPr>
+                    </a:p>
+                  </a:txBody>
+                  <a:tcPr marL="91440" marR="91440" marT="45720" marB="45720" anchor="ctr">
+                    <a:lnL w="9525" cap="flat" cmpd="sng" algn="ctr">
+                      <a:solidFill>
+                        <a:srgbClr val="3A3F48"/>
+                      </a:solidFill>
+                      <a:prstDash val="solid"/>
+                      <a:round/>
+                      <a:headEnd type="none" w="med" len="med"/>
+                      <a:tailEnd type="none" w="med" len="med"/>
+                    </a:lnL>
+                    <a:lnR w="9525" cap="flat" cmpd="sng" algn="ctr">
+                      <a:solidFill>
+                        <a:srgbClr val="3A3F48"/>
+                      </a:solidFill>
+                      <a:prstDash val="solid"/>
+                      <a:round/>
+                      <a:headEnd type="none" w="med" len="med"/>
+                      <a:tailEnd type="none" w="med" len="med"/>
+                    </a:lnR>
+                    <a:lnT w="9525" cap="flat" cmpd="sng" algn="ctr">
+                      <a:solidFill>
+                        <a:srgbClr val="3A3F48"/>
+                      </a:solidFill>
+                      <a:prstDash val="solid"/>
+                      <a:round/>
+                      <a:headEnd type="none" w="med" len="med"/>
+                      <a:tailEnd type="none" w="med" len="med"/>
+                    </a:lnT>
+                    <a:lnB w="9525" cap="flat" cmpd="sng" algn="ctr">
+                      <a:solidFill>
+                        <a:srgbClr val="3A3F48"/>
+                      </a:solidFill>
+                      <a:prstDash val="solid"/>
+                      <a:round/>
+                      <a:headEnd type="none" w="med" len="med"/>
+                      <a:tailEnd type="none" w="med" len="med"/>
+                    </a:lnB>
+                    <a:solidFill>
+                      <a:srgbClr val="23272F"/>
+                    </a:solidFill>
+                  </a:tcPr>
+                </a:tc>
+                <a:tc>
+                  <a:txBody>
+                    <a:bodyPr/>
+                    <a:lstStyle/>
+                    <a:p>
+                      <a:pPr algn="ctr" indent="0" marL="0">
+                        <a:buNone/>
+                      </a:pPr>
+                      <a:r>
+                        <a:rPr lang="en-US" sz="1400" dirty="0">
+                          <a:solidFill>
+                            <a:schemeClr val="tx1"/>
+                          </a:solidFill>
+                          <a:latin typeface="Malgun Gothic" pitchFamily="34" charset="0"/>
+                          <a:ea typeface="Malgun Gothic" pitchFamily="34" charset="-122"/>
+                          <a:cs typeface="Malgun Gothic" pitchFamily="34" charset="-120"/>
+                        </a:rPr>
+                        <a:t>0%</a:t>
+                      </a:r>
+                      <a:endParaRPr lang="en-US" sz="1400" dirty="0">
+                        <a:latin typeface="Malgun Gothic" charset="0"/>
+                        <a:ea typeface="Malgun Gothic" charset="0"/>
+                        <a:cs typeface="Malgun Gothic" charset="0"/>
+                      </a:endParaRPr>
+                    </a:p>
+                  </a:txBody>
+                  <a:tcPr marL="91440" marR="91440" marT="45720" marB="45720" anchor="ctr">
+                    <a:lnL w="9525" cap="flat" cmpd="sng" algn="ctr">
+                      <a:solidFill>
+                        <a:srgbClr val="3A3F48"/>
+                      </a:solidFill>
+                      <a:prstDash val="solid"/>
+                      <a:round/>
+                      <a:headEnd type="none" w="med" len="med"/>
+                      <a:tailEnd type="none" w="med" len="med"/>
+                    </a:lnL>
+                    <a:lnR w="9525" cap="flat" cmpd="sng" algn="ctr">
+                      <a:solidFill>
+                        <a:srgbClr val="3A3F48"/>
+                      </a:solidFill>
+                      <a:prstDash val="solid"/>
+                      <a:round/>
+                      <a:headEnd type="none" w="med" len="med"/>
+                      <a:tailEnd type="none" w="med" len="med"/>
+                    </a:lnR>
+                    <a:lnT w="9525" cap="flat" cmpd="sng" algn="ctr">
+                      <a:solidFill>
+                        <a:srgbClr val="3A3F48"/>
+                      </a:solidFill>
+                      <a:prstDash val="solid"/>
+                      <a:round/>
+                      <a:headEnd type="none" w="med" len="med"/>
+                      <a:tailEnd type="none" w="med" len="med"/>
+                    </a:lnT>
+                    <a:lnB w="9525" cap="flat" cmpd="sng" algn="ctr">
+                      <a:solidFill>
+                        <a:srgbClr val="3A3F48"/>
+                      </a:solidFill>
+                      <a:prstDash val="solid"/>
+                      <a:round/>
+                      <a:headEnd type="none" w="med" len="med"/>
+                      <a:tailEnd type="none" w="med" len="med"/>
+                    </a:lnB>
+                    <a:solidFill>
+                      <a:srgbClr val="23272F"/>
+                    </a:solidFill>
+                  </a:tcPr>
+                </a:tc>
+              </a:tr>
+              <a:tr h="402336">
+                <a:tc>
+                  <a:txBody>
+                    <a:bodyPr/>
+                    <a:lstStyle/>
+                    <a:p>
+                      <a:pPr algn="l" indent="0" marL="0">
+                        <a:buNone/>
+                      </a:pPr>
+                      <a:r>
+                        <a:rPr lang="en-US" sz="1400" b="1" dirty="0">
+                          <a:solidFill>
+                            <a:schemeClr val="accent5"/>
+                          </a:solidFill>
+                          <a:latin typeface="Malgun Gothic" pitchFamily="34" charset="0"/>
+                          <a:ea typeface="Malgun Gothic" pitchFamily="34" charset="-122"/>
+                          <a:cs typeface="Malgun Gothic" pitchFamily="34" charset="-120"/>
+                        </a:rPr>
+                        <a:t>YOLOX-S</a:t>
+                      </a:r>
+                      <a:endParaRPr lang="en-US" sz="1400" dirty="0">
+                        <a:latin typeface="Malgun Gothic" charset="0"/>
+                        <a:ea typeface="Malgun Gothic" charset="0"/>
+                        <a:cs typeface="Malgun Gothic" charset="0"/>
+                      </a:endParaRPr>
+                    </a:p>
+                  </a:txBody>
+                  <a:tcPr marL="91440" marR="91440" marT="45720" marB="45720" anchor="ctr">
+                    <a:lnL w="9525" cap="flat" cmpd="sng" algn="ctr">
+                      <a:solidFill>
+                        <a:srgbClr val="3A3F48"/>
+                      </a:solidFill>
+                      <a:prstDash val="solid"/>
+                      <a:round/>
+                      <a:headEnd type="none" w="med" len="med"/>
+                      <a:tailEnd type="none" w="med" len="med"/>
+                    </a:lnL>
+                    <a:lnR w="9525" cap="flat" cmpd="sng" algn="ctr">
+                      <a:solidFill>
+                        <a:srgbClr val="3A3F48"/>
+                      </a:solidFill>
+                      <a:prstDash val="solid"/>
+                      <a:round/>
+                      <a:headEnd type="none" w="med" len="med"/>
+                      <a:tailEnd type="none" w="med" len="med"/>
+                    </a:lnR>
+                    <a:lnT w="9525" cap="flat" cmpd="sng" algn="ctr">
+                      <a:solidFill>
+                        <a:srgbClr val="3A3F48"/>
+                      </a:solidFill>
+                      <a:prstDash val="solid"/>
+                      <a:round/>
+                      <a:headEnd type="none" w="med" len="med"/>
+                      <a:tailEnd type="none" w="med" len="med"/>
+                    </a:lnT>
+                    <a:lnB w="9525" cap="flat" cmpd="sng" algn="ctr">
+                      <a:solidFill>
+                        <a:srgbClr val="3A3F48"/>
+                      </a:solidFill>
+                      <a:prstDash val="solid"/>
+                      <a:round/>
+                      <a:headEnd type="none" w="med" len="med"/>
+                      <a:tailEnd type="none" w="med" len="med"/>
+                    </a:lnB>
+                    <a:solidFill>
+                      <a:srgbClr val="23272F"/>
+                    </a:solidFill>
+                  </a:tcPr>
+                </a:tc>
+                <a:tc>
+                  <a:txBody>
+                    <a:bodyPr/>
+                    <a:lstStyle/>
+                    <a:p>
+                      <a:pPr algn="ctr" indent="0" marL="0">
+                        <a:buNone/>
+                      </a:pPr>
+                      <a:r>
+                        <a:rPr lang="en-US" sz="1400" dirty="0">
+                          <a:solidFill>
+                            <a:schemeClr val="tx1"/>
+                          </a:solidFill>
+                          <a:latin typeface="Malgun Gothic" pitchFamily="34" charset="0"/>
+                          <a:ea typeface="Malgun Gothic" pitchFamily="34" charset="-122"/>
+                          <a:cs typeface="Malgun Gothic" pitchFamily="34" charset="-120"/>
+                        </a:rPr>
+                        <a:t>0.05</a:t>
+                      </a:r>
+                      <a:endParaRPr lang="en-US" sz="1400" dirty="0">
+                        <a:latin typeface="Malgun Gothic" charset="0"/>
+                        <a:ea typeface="Malgun Gothic" charset="0"/>
+                        <a:cs typeface="Malgun Gothic" charset="0"/>
+                      </a:endParaRPr>
+                    </a:p>
+                  </a:txBody>
+                  <a:tcPr marL="91440" marR="91440" marT="45720" marB="45720" anchor="ctr">
+                    <a:lnL w="9525" cap="flat" cmpd="sng" algn="ctr">
+                      <a:solidFill>
+                        <a:srgbClr val="3A3F48"/>
+                      </a:solidFill>
+                      <a:prstDash val="solid"/>
+                      <a:round/>
+                      <a:headEnd type="none" w="med" len="med"/>
+                      <a:tailEnd type="none" w="med" len="med"/>
+                    </a:lnL>
+                    <a:lnR w="9525" cap="flat" cmpd="sng" algn="ctr">
+                      <a:solidFill>
+                        <a:srgbClr val="3A3F48"/>
+                      </a:solidFill>
+                      <a:prstDash val="solid"/>
+                      <a:round/>
+                      <a:headEnd type="none" w="med" len="med"/>
+                      <a:tailEnd type="none" w="med" len="med"/>
+                    </a:lnR>
+                    <a:lnT w="9525" cap="flat" cmpd="sng" algn="ctr">
+                      <a:solidFill>
+                        <a:srgbClr val="3A3F48"/>
+                      </a:solidFill>
+                      <a:prstDash val="solid"/>
+                      <a:round/>
+                      <a:headEnd type="none" w="med" len="med"/>
+                      <a:tailEnd type="none" w="med" len="med"/>
+                    </a:lnT>
+                    <a:lnB w="9525" cap="flat" cmpd="sng" algn="ctr">
+                      <a:solidFill>
+                        <a:srgbClr val="3A3F48"/>
+                      </a:solidFill>
+                      <a:prstDash val="solid"/>
+                      <a:round/>
+                      <a:headEnd type="none" w="med" len="med"/>
+                      <a:tailEnd type="none" w="med" len="med"/>
+                    </a:lnB>
+                    <a:solidFill>
+                      <a:srgbClr val="23272F"/>
+                    </a:solidFill>
+                  </a:tcPr>
+                </a:tc>
+                <a:tc>
+                  <a:txBody>
+                    <a:bodyPr/>
+                    <a:lstStyle/>
+                    <a:p>
+                      <a:pPr algn="ctr" indent="0" marL="0">
+                        <a:buNone/>
+                      </a:pPr>
+                      <a:r>
+                        <a:rPr lang="en-US" sz="1400" b="1" dirty="0">
+                          <a:solidFill>
+                            <a:schemeClr val="tx1"/>
+                          </a:solidFill>
+                          <a:latin typeface="Malgun Gothic" pitchFamily="34" charset="0"/>
+                          <a:ea typeface="Malgun Gothic" pitchFamily="34" charset="-122"/>
+                          <a:cs typeface="Malgun Gothic" pitchFamily="34" charset="-120"/>
+                        </a:rPr>
+                        <a:t>57%</a:t>
+                      </a:r>
+                      <a:endParaRPr lang="en-US" sz="1400" dirty="0">
+                        <a:latin typeface="Malgun Gothic" charset="0"/>
+                        <a:ea typeface="Malgun Gothic" charset="0"/>
+                        <a:cs typeface="Malgun Gothic" charset="0"/>
+                      </a:endParaRPr>
+                    </a:p>
+                  </a:txBody>
+                  <a:tcPr marL="91440" marR="91440" marT="45720" marB="45720" anchor="ctr">
+                    <a:lnL w="9525" cap="flat" cmpd="sng" algn="ctr">
+                      <a:solidFill>
+                        <a:srgbClr val="3A3F48"/>
+                      </a:solidFill>
+                      <a:prstDash val="solid"/>
+                      <a:round/>
+                      <a:headEnd type="none" w="med" len="med"/>
+                      <a:tailEnd type="none" w="med" len="med"/>
+                    </a:lnL>
+                    <a:lnR w="9525" cap="flat" cmpd="sng" algn="ctr">
+                      <a:solidFill>
+                        <a:srgbClr val="3A3F48"/>
+                      </a:solidFill>
+                      <a:prstDash val="solid"/>
+                      <a:round/>
+                      <a:headEnd type="none" w="med" len="med"/>
+                      <a:tailEnd type="none" w="med" len="med"/>
+                    </a:lnR>
+                    <a:lnT w="9525" cap="flat" cmpd="sng" algn="ctr">
+                      <a:solidFill>
+                        <a:srgbClr val="3A3F48"/>
+                      </a:solidFill>
+                      <a:prstDash val="solid"/>
+                      <a:round/>
+                      <a:headEnd type="none" w="med" len="med"/>
+                      <a:tailEnd type="none" w="med" len="med"/>
+                    </a:lnT>
+                    <a:lnB w="9525" cap="flat" cmpd="sng" algn="ctr">
+                      <a:solidFill>
+                        <a:srgbClr val="3A3F48"/>
+                      </a:solidFill>
+                      <a:prstDash val="solid"/>
+                      <a:round/>
+                      <a:headEnd type="none" w="med" len="med"/>
+                      <a:tailEnd type="none" w="med" len="med"/>
+                    </a:lnB>
+                    <a:solidFill>
+                      <a:srgbClr val="23272F"/>
+                    </a:solidFill>
+                  </a:tcPr>
+                </a:tc>
+                <a:tc>
+                  <a:txBody>
+                    <a:bodyPr/>
+                    <a:lstStyle/>
+                    <a:p>
+                      <a:pPr algn="ctr" indent="0" marL="0">
+                        <a:buNone/>
+                      </a:pPr>
+                      <a:r>
+                        <a:rPr lang="en-US" sz="1400" b="1" dirty="0">
+                          <a:solidFill>
+                            <a:schemeClr val="accent1"/>
+                          </a:solidFill>
+                          <a:latin typeface="Malgun Gothic" pitchFamily="34" charset="0"/>
+                          <a:ea typeface="Malgun Gothic" pitchFamily="34" charset="-122"/>
+                          <a:cs typeface="Malgun Gothic" pitchFamily="34" charset="-120"/>
+                        </a:rPr>
+                        <a:t>0%</a:t>
+                      </a:r>
+                      <a:endParaRPr lang="en-US" sz="1400" dirty="0">
+                        <a:latin typeface="Malgun Gothic" charset="0"/>
+                        <a:ea typeface="Malgun Gothic" charset="0"/>
+                        <a:cs typeface="Malgun Gothic" charset="0"/>
+                      </a:endParaRPr>
+                    </a:p>
+                  </a:txBody>
+                  <a:tcPr marL="91440" marR="91440" marT="45720" marB="45720" anchor="ctr">
+                    <a:lnL w="9525" cap="flat" cmpd="sng" algn="ctr">
+                      <a:solidFill>
+                        <a:srgbClr val="3A3F48"/>
+                      </a:solidFill>
+                      <a:prstDash val="solid"/>
+                      <a:round/>
+                      <a:headEnd type="none" w="med" len="med"/>
+                      <a:tailEnd type="none" w="med" len="med"/>
+                    </a:lnL>
+                    <a:lnR w="9525" cap="flat" cmpd="sng" algn="ctr">
+                      <a:solidFill>
+                        <a:srgbClr val="3A3F48"/>
+                      </a:solidFill>
+                      <a:prstDash val="solid"/>
+                      <a:round/>
+                      <a:headEnd type="none" w="med" len="med"/>
+                      <a:tailEnd type="none" w="med" len="med"/>
+                    </a:lnR>
+                    <a:lnT w="9525" cap="flat" cmpd="sng" algn="ctr">
+                      <a:solidFill>
+                        <a:srgbClr val="3A3F48"/>
+                      </a:solidFill>
+                      <a:prstDash val="solid"/>
+                      <a:round/>
+                      <a:headEnd type="none" w="med" len="med"/>
+                      <a:tailEnd type="none" w="med" len="med"/>
+                    </a:lnT>
+                    <a:lnB w="9525" cap="flat" cmpd="sng" algn="ctr">
+                      <a:solidFill>
+                        <a:srgbClr val="3A3F48"/>
+                      </a:solidFill>
+                      <a:prstDash val="solid"/>
+                      <a:round/>
+                      <a:headEnd type="none" w="med" len="med"/>
+                      <a:tailEnd type="none" w="med" len="med"/>
+                    </a:lnB>
+                    <a:solidFill>
+                      <a:srgbClr val="23272F"/>
+                    </a:solidFill>
+                  </a:tcPr>
+                </a:tc>
+              </a:tr>
             </a:tbl>
           </a:graphicData>
         </a:graphic>
@@ -12877,8 +13767,8 @@
         </p:nvSpPr>
         <p:spPr>
           <a:xfrm>
-            <a:off x="6812280" y="3977640"/>
-            <a:ext cx="4828032" cy="365760"/>
+            <a:off x="6812280" y="4663440"/>
+            <a:ext cx="4828032" cy="1463040"/>
           </a:xfrm>
           <a:prstGeom prst="rect">
             <a:avLst/>
@@ -12891,100 +13781,80 @@
           <a:lstStyle/>
           <a:p>
             <a:pPr indent="0" marL="0">
-              <a:buNone/>
-            </a:pPr>
-            <a:r>
-              <a:rPr lang="en-US" sz="1500" b="1" dirty="0">
-                <a:solidFill>
-                  <a:schemeClr val="tx1"/>
-                </a:solidFill>
-              </a:rPr>
-              <a:t>검출 ↑ = 정상 오검출 ↑  </a:t>
-            </a:r>
-            <a:pPr indent="0" marL="0">
-              <a:buNone/>
-            </a:pPr>
-            <a:r>
-              <a:rPr lang="en-US" sz="1500" b="1" dirty="0">
-                <a:solidFill>
-                  <a:schemeClr val="accent1"/>
-                </a:solidFill>
-              </a:rPr>
-              <a:t>→ 재학습 필요</a:t>
-            </a:r>
-            <a:endParaRPr lang="en-US" sz="1500" dirty="0"/>
-          </a:p>
-        </p:txBody>
-      </p:sp>
-      <p:pic>
-        <p:nvPicPr>
-          <p:cNvPr id="25" name="miss-img" descr="C:\Users\user\_se4nchoi\batteryvision\docs\submission\build\img\holdout_miss.jpg">    </p:cNvPr>
-          <p:cNvPicPr>
-            <a:picLocks noChangeAspect="1"/>
-          </p:cNvPicPr>
-          <p:nvPr/>
-        </p:nvPicPr>
-        <p:blipFill>
-          <a:blip r:embed="rId1"/>
-          <a:stretch>
-            <a:fillRect/>
-          </a:stretch>
-        </p:blipFill>
-        <p:spPr>
-          <a:xfrm>
-            <a:off x="6812280" y="4434840"/>
-            <a:ext cx="1828800" cy="1828800"/>
-          </a:xfrm>
-          <a:prstGeom prst="rect">
-            <a:avLst/>
-          </a:prstGeom>
-        </p:spPr>
-      </p:pic>
-      <p:sp>
-        <p:nvSpPr>
-          <p:cNvPr id="26" name="miss-cap"/>
-          <p:cNvSpPr txBox="1"/>
-          <p:nvPr/>
-        </p:nvSpPr>
-        <p:spPr>
-          <a:xfrm>
-            <a:off x="8823960" y="4937760"/>
-            <a:ext cx="2743200" cy="822960"/>
-          </a:xfrm>
-          <a:prstGeom prst="rect">
-            <a:avLst/>
-          </a:prstGeom>
-          <a:noFill/>
-          <a:ln/>
-        </p:spPr>
-        <p:txBody>
-          <a:bodyPr wrap="square" lIns="0" tIns="0" rIns="0" bIns="0" rtlCol="0" anchor="ctr"/>
-          <a:lstStyle/>
-          <a:p>
-            <a:pPr indent="0" marL="0">
+              <a:spcAft>
+                <a:spcPts val="600"/>
+              </a:spcAft>
               <a:buNone/>
             </a:pPr>
             <a:r>
               <a:rPr lang="en-US" sz="1400" b="1" dirty="0">
                 <a:solidFill>
-                  <a:schemeClr val="tx1"/>
+                  <a:schemeClr val="accent4"/>
                 </a:solidFill>
               </a:rPr>
-              <a:t>놓친 예: scratch</a:t>
+              <a:t>ATSS  </a:t>
             </a:r>
-            <a:endParaRPr lang="en-US" sz="1400" dirty="0"/>
-          </a:p>
-          <a:p>
             <a:pPr indent="0" marL="0">
+              <a:spcAft>
+                <a:spcPts val="600"/>
+              </a:spcAft>
               <a:buNone/>
             </a:pPr>
             <a:r>
               <a:rPr lang="en-US" sz="1400" dirty="0">
                 <a:solidFill>
-                  <a:schemeClr val="tx2"/>
+                  <a:schemeClr val="tx1"/>
                 </a:solidFill>
               </a:rPr>
-              <a:t>ATSS 최고 점수 0.21</a:t>
+              <a:t>검출 ↑ = 정상 오검출 ↑</a:t>
+            </a:r>
+            <a:endParaRPr lang="en-US" sz="1400" dirty="0"/>
+          </a:p>
+          <a:p>
+            <a:pPr indent="0" marL="0">
+              <a:spcAft>
+                <a:spcPts val="600"/>
+              </a:spcAft>
+              <a:buNone/>
+            </a:pPr>
+            <a:r>
+              <a:rPr lang="en-US" sz="1400" b="1" dirty="0">
+                <a:solidFill>
+                  <a:schemeClr val="accent5"/>
+                </a:solidFill>
+              </a:rPr>
+              <a:t>YOLOX-S  </a:t>
+            </a:r>
+            <a:pPr indent="0" marL="0">
+              <a:spcAft>
+                <a:spcPts val="600"/>
+              </a:spcAft>
+              <a:buNone/>
+            </a:pPr>
+            <a:r>
+              <a:rPr lang="en-US" sz="1400" dirty="0">
+                <a:solidFill>
+                  <a:schemeClr val="tx1"/>
+                </a:solidFill>
+              </a:rPr>
+              <a:t>순위는 정확 (mAP@50 0.93), 점수만 낮음</a:t>
+            </a:r>
+            <a:endParaRPr lang="en-US" sz="1400" dirty="0"/>
+          </a:p>
+          <a:p>
+            <a:pPr indent="0" marL="0">
+              <a:spcAft>
+                <a:spcPts val="600"/>
+              </a:spcAft>
+              <a:buNone/>
+            </a:pPr>
+            <a:r>
+              <a:rPr lang="en-US" sz="1400" b="1" dirty="0">
+                <a:solidFill>
+                  <a:schemeClr val="accent1"/>
+                </a:solidFill>
+              </a:rPr>
+              <a:t>→ 기준값은 모델별로 · 그래도 부족 → 재학습</a:t>
             </a:r>
             <a:endParaRPr lang="en-US" sz="1400" dirty="0"/>
           </a:p>

</xml_diff>

<commit_message>
Add 'why' lines to finding slides and speaker notes; box sizes in pixels; small-crack finding on slide 8
Co-Authored-By: Claude Opus 5.5 <noreply@anthropic.com>
</commit_message>
<xml_diff>
--- a/docs/submission/BatteryVision_발표.pptx
+++ b/docs/submission/BatteryVision_발표.pptx
@@ -116,13 +116,13 @@
   <p:extLst>
     <p:ext uri="{521415D9-36F7-43E2-AB2F-B90AF26B5E84}">
       <p14:sectionLst xmlns:p14="http://schemas.microsoft.com/office/powerpoint/2010/main">
-        <p14:section name="도입" id="{dfc59b71-a3ae-029e-6699-5dd83144d8bf}">
+        <p14:section name="도입" id="{df899e8e-f73a-1535-f14f-ba43cb566f3d}">
           <p14:sldIdLst>
             <p14:sldId id="256"/>
             <p14:sldId id="257"/>
           </p14:sldIdLst>
         </p14:section>
-        <p14:section name="실험" id="{bde8193f-717a-5375-ea80-5f49ac4d68fb}">
+        <p14:section name="실험" id="{7ac2d25a-7667-554b-9494-1f93ff41f383}">
           <p14:sldIdLst>
             <p14:sldId id="258"/>
             <p14:sldId id="259"/>
@@ -130,17 +130,17 @@
             <p14:sldId id="261"/>
           </p14:sldIdLst>
         </p14:section>
-        <p14:section name="최적화" id="{47949f94-4b1c-365b-4ae1-541cdba602b2}">
+        <p14:section name="최적화" id="{b18c5141-5c3c-cc91-bf53-4902d7da81f7}">
           <p14:sldIdLst>
             <p14:sldId id="262"/>
           </p14:sldIdLst>
         </p14:section>
-        <p14:section name="검증" id="{1b9ad431-83c8-c39e-f745-2f243faf8572}">
+        <p14:section name="검증" id="{b8148790-546b-f277-bf02-966a7e0de876}">
           <p14:sldIdLst>
             <p14:sldId id="263"/>
           </p14:sldIdLst>
         </p14:section>
-        <p14:section name="정리" id="{b9d06c33-3bf9-1a1c-f4c7-e4ab02b1a570}">
+        <p14:section name="정리" id="{ef2245b8-c325-61bf-ddb8-b6b90c7f71c7}">
           <p14:sldIdLst>
             <p14:sldId id="264"/>
             <p14:sldId id="265"/>
@@ -1465,7 +1465,7 @@
           <a:p>
             <a:r>
               <a:rPr lang="en-US" dirty="0"/>
-              <a:t>crack은 세 모델 모두 AP 1.0이지만, scratch는 0.66에서 0.86입니다. 박스 크기는 둘 다 이미지의 0.4% 안팎으로 비슷합니다. 차이는 대비입니다. crack은 어둡고 뚜렷하고, scratch는 반사나 나무결과 비슷한 흐릿한 선입니다. 이후 나오는 오류도 대부분 scratch입니다.</a:t>
+              <a:t>crack은 세 모델 모두 AP 1.0이지만, scratch는 0.66에서 0.86입니다. 박스 크기는 640픽셀 사진에서 둘 다 약 44×38픽셀로 같습니다. 차이는 대비입니다. crack은 어둡고 뚜렷하고, scratch는 반사나 나무결과 비슷한 흐릿한 선입니다. 이후 나오는 오류도 대부분 scratch입니다. 실제로 배경을 결함으로 잘못 본 16건 중 13건이 scratch였습니다. 모델이 배경의 결이나 반사를 scratch로 착각한다는 뜻입니다.</a:t>
             </a:r>
             <a:endParaRPr lang="en-US" dirty="0"/>
           </a:p>
@@ -1729,7 +1729,7 @@
           <a:p>
             <a:r>
               <a:rPr lang="en-US" dirty="0"/>
-              <a:t>왼쪽은 Geti 화면입니다. 세 모델 모두 같은 2,800장으로 학습했고, Geti 점수는 ATSS 86%, 나머지 81%입니다. 다만 Roboflow가 원본마다 증강 사본 3장을 만들어 두었고 Geti가 이를 무작위로 나눴기 때문에, 같은 원본의 사본이 Geti 학습과 테스트에 함께 들어갔을 가능성이 높아 Geti 점수도 낙관적입니다. 오른쪽은 직접 만든 벤치마크로 잰 값인데 순서가 같습니다. 파라미터가 가장 적은 ATSS가 가장 정확했고, 학습에 안 쓴 2차 세트에서도 ATSS가 YOLOX-S보다 훨씬 많이 잡았습니다. 다만 '작다'는 파라미터 기준이고, 연산량은 Tiny가 가장 적습니다.</a:t>
+              <a:t>왼쪽은 Geti 화면입니다. 세 모델 모두 같은 2,800장으로 학습했고, Geti 점수는 ATSS 86%, 나머지 81%입니다. 다만 Roboflow가 원본마다 증강 사본 3장을 만들어 두었고 Geti가 이를 무작위로 나눴기 때문에, 같은 원본의 사본이 Geti 학습과 테스트에 함께 들어갔을 가능성이 높아 Geti 점수도 낙관적입니다. 오른쪽은 직접 만든 벤치마크로 잰 값인데 순서가 같습니다. 파라미터가 가장 적은 ATSS가 가장 정확했고, 학습에 안 쓴 2차 세트에서도 ATSS가 YOLOX-S보다 훨씬 많이 잡았습니다. 다만 '작다'는 파라미터 기준이고, 연산량은 Tiny가 가장 적습니다. 왜 ATSS가 이겼는지는 가설 단계입니다. ATSS는 992×800으로 학습해 결함을 1.5배 크게 보고, 데이터가 2,800장으로 적어 작은 모델이 덜 과적합했을 수 있습니다. 모델마다 한 번씩만 학습해서 확정할 수는 없습니다.</a:t>
             </a:r>
             <a:endParaRPr lang="en-US" dirty="0"/>
           </a:p>
@@ -1817,7 +1817,7 @@
           <a:p>
             <a:r>
               <a:rPr lang="en-US" dirty="0"/>
-              <a:t>결론부터 말하면, crack과 scratch를 서로 헷갈린 경우는 한 번도 없고, 오류는 전부 놓친 scratch나 배경 오검출입니다. 특히 나무 탁상 배경에서 재현율이 33%로 가장 약합니다. heatmap은 YOLOX-S가 98%의 사진에서 결함을 짚지만 ATSS는 48%로, 정확도와 설명력은 별개였습니다.</a:t>
+              <a:t>결론부터 말하면, crack과 scratch를 서로 헷갈린 경우는 한 번도 없고, 오류는 전부 놓친 scratch나 배경 오검출입니다. 특히 나무 탁상 배경에서 재현율이 33%로 가장 약합니다. 나무결이 scratch처럼 가는 선 모양이라 놓치기도 하고 잘못 보기도 합니다. heatmap은 YOLOX-S가 98%의 사진에서 결함을 짚지만 ATSS는 48%로, 정확도와 설명력은 별개였습니다.</a:t>
             </a:r>
             <a:endParaRPr lang="en-US" dirty="0"/>
           </a:p>
@@ -1905,7 +1905,7 @@
           <a:p>
             <a:r>
               <a:rPr lang="en-US" dirty="0"/>
-              <a:t>수업에서 다룬 모델 최적화를 직접 써보고 싶어서, Geti에서 INT8 모델을 받아 직접 만든 벤치마크로 측정했습니다. 같은 131장을 한 장씩, 같은 CPU에서, 전처리와 후처리를 포함해 잰 값입니다. INT8은 2배에서 4배 빠르고 크기는 절반 정도이며, mAP는 그대로입니다. 대신 신뢰도 점수가 조금 낮아져 같은 기준에서는 놓치는 결함이 늘어납니다. INT8을 쓰려면 기준값을 다시 정해야 합니다.</a:t>
+              <a:t>수업에서 다룬 모델 최적화를 직접 써보고 싶어서, Geti에서 INT8 모델을 받아 직접 만든 벤치마크로 측정했습니다. 같은 131장을 한 장씩, 같은 CPU에서, 전처리와 후처리를 포함해 잰 값입니다. INT8은 2배에서 4배 빠르고 크기는 절반 정도이며, mAP는 그대로입니다. 대신 신뢰도 점수가 조금 낮아져 같은 기준에서는 놓치는 결함이 늘어납니다. INT8을 쓰려면 기준값을 다시 정해야 합니다. 빨라지는 이유는 CPU의 8비트 연산 명령을 쓰고 옮길 데이터가 절반이기 때문이고, 놓침이 느는 이유는 양자화로 점수가 조금 내려가 0.30 근처 결함이 기준 아래로 떨어지기 때문입니다.</a:t>
             </a:r>
             <a:endParaRPr lang="en-US" dirty="0"/>
           </a:p>
@@ -1993,7 +1993,7 @@
           <a:p>
             <a:r>
               <a:rPr lang="en-US" dirty="0"/>
-              <a:t>같은 업로더가 올린 다른 세트에서, 학습에 한 번도 쓰지 않은 45장으로 제 앱에서 다시 테스트했습니다. 1차 테스트에서 결함 셀을 거의 다 잡던 모델이 ATSS 47%, YOLOX-S 3%까지 떨어집니다. 결함을 착각한 게 아니라 점수가 낮아서 통과시킨 것이고, 정상 셀을 불합격시킨 경우는 없었습니다. 기준값을 바꿔 보면, ATSS는 0.15까지 낮추면 결함 97%를 잡지만 정상 셀도 87%가 걸립니다. YOLOX-S는 다릅니다. 2차 세트 mAP@50이 0.93으로 결함을 정상보다 높게 순위 매기는 건 정확한데, 점수 자체가 낮습니다. 0.05로 낮추면 정상 오검출 없이 57%를 잡습니다. 즉 기준값은 모델마다 따로 정해야 하고, 그래도 부족하기 때문에 새 환경 사진으로 재학습이 필요합니다.</a:t>
+              <a:t>같은 업로더가 올린 다른 세트에서, 학습에 한 번도 쓰지 않은 45장으로 제 앱에서 다시 테스트했습니다. 1차 테스트에서 결함 셀을 거의 다 잡던 모델이 ATSS 47%, YOLOX-S 3%까지 떨어집니다. 결함을 착각한 게 아니라 점수가 낮아서 통과시킨 것이고, 정상 셀을 불합격시킨 경우는 없었습니다. 가장 큰 원인은 crack입니다. 2차 세트의 crack은 약 30×26픽셀로 1차의 절반 면적이고, ATSS는 15개 중 1개만 잡았습니다. 학습 때 본 크기의 crack만 쉬웠던 겁니다. 기준값을 바꿔 보면, ATSS는 0.15까지 낮추면 결함 97%를 잡지만 정상 셀도 87%가 걸립니다. YOLOX-S는 다릅니다. 2차 세트 mAP@50이 0.93으로 결함을 정상보다 높게 순위 매기는 건 정확한데, 점수 자체가 낮습니다. YOLOX 점수는 물체일 확률과 클래스 확률을 곱한 값이라 원래 낮게 나오고, 처음 보는 사진에서는 더 낮아집니다. 0.05로 낮추면 정상 오검출 없이 57%를 잡습니다. 즉 기준값은 모델마다 따로 정해야 하고, 그래도 부족하기 때문에 새 환경 사진으로 재학습이 필요합니다.</a:t>
             </a:r>
             <a:endParaRPr lang="en-US" dirty="0"/>
           </a:p>
@@ -3798,7 +3798,7 @@
         </p:nvSpPr>
         <p:spPr>
           <a:xfrm>
-            <a:off x="548640" y="5486400"/>
+            <a:off x="548640" y="5349240"/>
             <a:ext cx="6309360" cy="365760"/>
           </a:xfrm>
           <a:prstGeom prst="rect">
@@ -3820,7 +3820,7 @@
                   <a:schemeClr val="tx2"/>
                 </a:solidFill>
               </a:rPr>
-              <a:t>박스 크기 중앙값  </a:t>
+              <a:t>박스 크기 (640px 사진, 중앙값)  </a:t>
             </a:r>
             <a:pPr indent="0" marL="0">
               <a:buNone/>
@@ -3831,15 +3831,62 @@
                   <a:schemeClr val="tx1"/>
                 </a:solidFill>
               </a:rPr>
-              <a:t>crack 0.39% · scratch 0.44%</a:t>
+              <a:t>crack 44×38px · scratch 43×38px</a:t>
             </a:r>
             <a:endParaRPr lang="en-US" sz="1600" dirty="0"/>
           </a:p>
         </p:txBody>
       </p:sp>
+      <p:sp>
+        <p:nvSpPr>
+          <p:cNvPr id="13" name="why-2"/>
+          <p:cNvSpPr txBox="1"/>
+          <p:nvPr/>
+        </p:nvSpPr>
+        <p:spPr>
+          <a:xfrm>
+            <a:off x="548640" y="5760720"/>
+            <a:ext cx="6309360" cy="365760"/>
+          </a:xfrm>
+          <a:prstGeom prst="rect">
+            <a:avLst/>
+          </a:prstGeom>
+          <a:noFill/>
+          <a:ln/>
+        </p:spPr>
+        <p:txBody>
+          <a:bodyPr wrap="square" lIns="0" tIns="0" rIns="0" bIns="0" rtlCol="0" anchor="t"/>
+          <a:lstStyle/>
+          <a:p>
+            <a:pPr indent="0" marL="0">
+              <a:buNone/>
+            </a:pPr>
+            <a:r>
+              <a:rPr lang="en-US" sz="1400" b="1" dirty="0">
+                <a:solidFill>
+                  <a:schemeClr val="accent1"/>
+                </a:solidFill>
+              </a:rPr>
+              <a:t>왜?  </a:t>
+            </a:r>
+            <a:pPr indent="0" marL="0">
+              <a:buNone/>
+            </a:pPr>
+            <a:r>
+              <a:rPr lang="en-US" sz="1400" dirty="0">
+                <a:solidFill>
+                  <a:schemeClr val="tx1"/>
+                </a:solidFill>
+              </a:rPr>
+              <a:t>scratch = 반사·나무결 같은 가는 선 → 오검출 16건 중 13건</a:t>
+            </a:r>
+            <a:endParaRPr lang="en-US" sz="1400" dirty="0"/>
+          </a:p>
+        </p:txBody>
+      </p:sp>
       <p:graphicFrame>
         <p:nvGraphicFramePr>
-          <p:cNvPr id="13" name="ap-chart" descr=""/>
+          <p:cNvPr id="14" name="ap-chart" descr=""/>
           <p:cNvGraphicFramePr/>
           <p:nvPr/>
         </p:nvGraphicFramePr>
@@ -6310,7 +6357,7 @@
                   <a:schemeClr val="tx2"/>
                 </a:solidFill>
               </a:rPr>
-              <a:t>학습에 쓴 사진 포함 가능</a:t>
+              <a:t>학습에 쓴 사진 포함 가능 → 일반화가 아니라 암기를 측정</a:t>
             </a:r>
             <a:endParaRPr lang="en-US" sz="1400" dirty="0"/>
           </a:p>
@@ -7466,8 +7513,8 @@
         </p:nvSpPr>
         <p:spPr>
           <a:xfrm>
-            <a:off x="4599629" y="5943600"/>
-            <a:ext cx="7043426" cy="274320"/>
+            <a:off x="4599629" y="5669280"/>
+            <a:ext cx="7043426" cy="566928"/>
           </a:xfrm>
           <a:prstGeom prst="rect">
             <a:avLst/>
@@ -7489,6 +7536,31 @@
                 </a:solidFill>
               </a:rPr>
               <a:t>Geti 점수와 같은 순서 · 작은 = 파라미터 기준 (연산량은 Tiny 최소)</a:t>
+            </a:r>
+            <a:endParaRPr lang="en-US" sz="1200" dirty="0"/>
+          </a:p>
+          <a:p>
+            <a:pPr indent="0" marL="0">
+              <a:buNone/>
+            </a:pPr>
+            <a:r>
+              <a:rPr lang="en-US" sz="1200" b="1" dirty="0">
+                <a:solidFill>
+                  <a:schemeClr val="accent1"/>
+                </a:solidFill>
+              </a:rPr>
+              <a:t>왜?  </a:t>
+            </a:r>
+            <a:pPr indent="0" marL="0">
+              <a:buNone/>
+            </a:pPr>
+            <a:r>
+              <a:rPr lang="en-US" sz="1200" dirty="0">
+                <a:solidFill>
+                  <a:schemeClr val="tx2"/>
+                </a:solidFill>
+              </a:rPr>
+              <a:t>가설: ATSS 입력 992×800 (YOLOX 640×640) · 적은 데이터엔 작은 모델 · 학습 1회라 미검증</a:t>
             </a:r>
             <a:endParaRPr lang="en-US" sz="1200" dirty="0"/>
           </a:p>
@@ -9454,7 +9526,7 @@
         </p:nvSpPr>
         <p:spPr>
           <a:xfrm>
-            <a:off x="6263640" y="5760720"/>
+            <a:off x="6263640" y="5715000"/>
             <a:ext cx="5376672" cy="274320"/>
           </a:xfrm>
           <a:prstGeom prst="rect">
@@ -9479,6 +9551,53 @@
               <a:t>heatmap 최고점이 정답 박스 안 · 정확도 ≠ heatmap 품질</a:t>
             </a:r>
             <a:endParaRPr lang="en-US" sz="1200" dirty="0"/>
+          </a:p>
+        </p:txBody>
+      </p:sp>
+      <p:sp>
+        <p:nvSpPr>
+          <p:cNvPr id="28" name="why-6"/>
+          <p:cNvSpPr txBox="1"/>
+          <p:nvPr/>
+        </p:nvSpPr>
+        <p:spPr>
+          <a:xfrm>
+            <a:off x="6263640" y="5961888"/>
+            <a:ext cx="5376672" cy="292608"/>
+          </a:xfrm>
+          <a:prstGeom prst="rect">
+            <a:avLst/>
+          </a:prstGeom>
+          <a:noFill/>
+          <a:ln/>
+        </p:spPr>
+        <p:txBody>
+          <a:bodyPr wrap="square" lIns="0" tIns="0" rIns="0" bIns="0" rtlCol="0" anchor="t"/>
+          <a:lstStyle/>
+          <a:p>
+            <a:pPr indent="0" marL="0">
+              <a:buNone/>
+            </a:pPr>
+            <a:r>
+              <a:rPr lang="en-US" sz="1400" b="1" dirty="0">
+                <a:solidFill>
+                  <a:schemeClr val="accent1"/>
+                </a:solidFill>
+              </a:rPr>
+              <a:t>왜?  </a:t>
+            </a:r>
+            <a:pPr indent="0" marL="0">
+              <a:buNone/>
+            </a:pPr>
+            <a:r>
+              <a:rPr lang="en-US" sz="1400" dirty="0">
+                <a:solidFill>
+                  <a:schemeClr val="tx1"/>
+                </a:solidFill>
+              </a:rPr>
+              <a:t>나무결 = scratch와 같은 가는 선 패턴</a:t>
+            </a:r>
+            <a:endParaRPr lang="en-US" sz="1400" dirty="0"/>
           </a:p>
         </p:txBody>
       </p:sp>
@@ -11083,7 +11202,54 @@
       </p:sp>
       <p:sp>
         <p:nvSpPr>
-          <p:cNvPr id="7" name="method-card"/>
+          <p:cNvPr id="7" name="why-7"/>
+          <p:cNvSpPr txBox="1"/>
+          <p:nvPr/>
+        </p:nvSpPr>
+        <p:spPr>
+          <a:xfrm>
+            <a:off x="6537960" y="4407408"/>
+            <a:ext cx="5102352" cy="292608"/>
+          </a:xfrm>
+          <a:prstGeom prst="rect">
+            <a:avLst/>
+          </a:prstGeom>
+          <a:noFill/>
+          <a:ln/>
+        </p:spPr>
+        <p:txBody>
+          <a:bodyPr wrap="square" lIns="0" tIns="0" rIns="0" bIns="0" rtlCol="0" anchor="t"/>
+          <a:lstStyle/>
+          <a:p>
+            <a:pPr indent="0" marL="0">
+              <a:buNone/>
+            </a:pPr>
+            <a:r>
+              <a:rPr lang="en-US" sz="1300" b="1" dirty="0">
+                <a:solidFill>
+                  <a:schemeClr val="accent1"/>
+                </a:solidFill>
+              </a:rPr>
+              <a:t>왜?  </a:t>
+            </a:r>
+            <a:pPr indent="0" marL="0">
+              <a:buNone/>
+            </a:pPr>
+            <a:r>
+              <a:rPr lang="en-US" sz="1300" dirty="0">
+                <a:solidFill>
+                  <a:schemeClr val="tx1"/>
+                </a:solidFill>
+              </a:rPr>
+              <a:t>int8 연산·데이터 절반 → 빠름 · 점수 소폭 ↓ → 놓침</a:t>
+            </a:r>
+            <a:endParaRPr lang="en-US" sz="1300" dirty="0"/>
+          </a:p>
+        </p:txBody>
+      </p:sp>
+      <p:sp>
+        <p:nvSpPr>
+          <p:cNvPr id="8" name="method-card"/>
           <p:cNvSpPr/>
           <p:nvPr/>
         </p:nvSpPr>
@@ -11105,7 +11271,7 @@
       </p:sp>
       <p:sp>
         <p:nvSpPr>
-          <p:cNvPr id="8" name="method"/>
+          <p:cNvPr id="9" name="method"/>
           <p:cNvSpPr txBox="1"/>
           <p:nvPr/>
         </p:nvSpPr>
@@ -11152,7 +11318,7 @@
       </p:sp>
       <p:sp>
         <p:nvSpPr>
-          <p:cNvPr id="9" name="pro-card"/>
+          <p:cNvPr id="10" name="pro-card"/>
           <p:cNvSpPr/>
           <p:nvPr/>
         </p:nvSpPr>
@@ -11174,7 +11340,7 @@
       </p:sp>
       <p:sp>
         <p:nvSpPr>
-          <p:cNvPr id="10" name="pro"/>
+          <p:cNvPr id="11" name="pro"/>
           <p:cNvSpPr txBox="1"/>
           <p:nvPr/>
         </p:nvSpPr>
@@ -11221,7 +11387,7 @@
       </p:sp>
       <p:sp>
         <p:nvSpPr>
-          <p:cNvPr id="11" name="con-card"/>
+          <p:cNvPr id="12" name="con-card"/>
           <p:cNvSpPr/>
           <p:nvPr/>
         </p:nvSpPr>
@@ -11243,7 +11409,7 @@
       </p:sp>
       <p:sp>
         <p:nvSpPr>
-          <p:cNvPr id="12" name="con"/>
+          <p:cNvPr id="13" name="con"/>
           <p:cNvSpPr txBox="1"/>
           <p:nvPr/>
         </p:nvSpPr>
@@ -12018,12 +12184,12 @@
               <a:buChar char="•"/>
             </a:pPr>
             <a:r>
-              <a:rPr lang="en-US" sz="1400" dirty="0">
-                <a:solidFill>
-                  <a:schemeClr val="tx1"/>
+              <a:rPr lang="en-US" sz="1400" b="1" dirty="0">
+                <a:solidFill>
+                  <a:schemeClr val="accent2"/>
                 </a:solidFill>
               </a:rPr>
-              <a:t>클래스 착각 0건 · 정상 불합격 0건</a:t>
+              <a:t>2차 crack 30×26px로 작아짐 → 검출 1/15</a:t>
             </a:r>
             <a:endParaRPr lang="en-US" sz="1400" dirty="0"/>
           </a:p>
@@ -12036,7 +12202,25 @@
               <a:buChar char="•"/>
             </a:pPr>
             <a:r>
-              <a:rPr lang="en-US" sz="1400" b="1" dirty="0">
+              <a:rPr lang="en-US" sz="1400" dirty="0">
+                <a:solidFill>
+                  <a:schemeClr val="tx1"/>
+                </a:solidFill>
+              </a:rPr>
+              <a:t>클래스 착각 0건 · 정상 불합격 0건</a:t>
+            </a:r>
+            <a:endParaRPr lang="en-US" sz="1400" dirty="0"/>
+          </a:p>
+          <a:p>
+            <a:pPr marL="342900" indent="-342900">
+              <a:spcAft>
+                <a:spcPts val="600"/>
+              </a:spcAft>
+              <a:buSzPct val="100000"/>
+              <a:buChar char="•"/>
+            </a:pPr>
+            <a:r>
+              <a:rPr lang="en-US" sz="1400" dirty="0">
                 <a:solidFill>
                   <a:schemeClr val="accent3"/>
                 </a:solidFill>
@@ -12111,7 +12295,7 @@
                 <a:gridCol w="1133856"/>
                 <a:gridCol w="1225296"/>
               </a:tblGrid>
-              <a:tr h="402336">
+              <a:tr h="374904">
                 <a:tc>
                   <a:txBody>
                     <a:bodyPr/>
@@ -12385,7 +12569,7 @@
                   </a:tcPr>
                 </a:tc>
               </a:tr>
-              <a:tr h="402336">
+              <a:tr h="374904">
                 <a:tc>
                   <a:txBody>
                     <a:bodyPr/>
@@ -12659,7 +12843,7 @@
                   </a:tcPr>
                 </a:tc>
               </a:tr>
-              <a:tr h="402336">
+              <a:tr h="374904">
                 <a:tc>
                   <a:txBody>
                     <a:bodyPr/>
@@ -12933,7 +13117,7 @@
                   </a:tcPr>
                 </a:tc>
               </a:tr>
-              <a:tr h="402336">
+              <a:tr h="374904">
                 <a:tc>
                   <a:txBody>
                     <a:bodyPr/>
@@ -13207,7 +13391,7 @@
                   </a:tcPr>
                 </a:tc>
               </a:tr>
-              <a:tr h="402336">
+              <a:tr h="374904">
                 <a:tc>
                   <a:txBody>
                     <a:bodyPr/>
@@ -13481,7 +13665,7 @@
                   </a:tcPr>
                 </a:tc>
               </a:tr>
-              <a:tr h="402336">
+              <a:tr h="374904">
                 <a:tc>
                   <a:txBody>
                     <a:bodyPr/>
@@ -13767,8 +13951,8 @@
         </p:nvSpPr>
         <p:spPr>
           <a:xfrm>
-            <a:off x="6812280" y="4663440"/>
-            <a:ext cx="4828032" cy="1463040"/>
+            <a:off x="6812280" y="4434840"/>
+            <a:ext cx="4828032" cy="1783080"/>
           </a:xfrm>
           <a:prstGeom prst="rect">
             <a:avLst/>
@@ -13806,7 +13990,7 @@
                   <a:schemeClr val="tx1"/>
                 </a:solidFill>
               </a:rPr>
-              <a:t>검출 ↑ = 정상 오검출 ↑</a:t>
+              <a:t>검출 ↑ = 정상 오검출 ↑ (점수 분포 겹침)</a:t>
             </a:r>
             <a:endParaRPr lang="en-US" sz="1400" dirty="0"/>
           </a:p>
@@ -13838,6 +14022,37 @@
                 </a:solidFill>
               </a:rPr>
               <a:t>순위는 정확 (mAP@50 0.93), 점수만 낮음</a:t>
+            </a:r>
+            <a:endParaRPr lang="en-US" sz="1400" dirty="0"/>
+          </a:p>
+          <a:p>
+            <a:pPr indent="0" marL="0">
+              <a:spcAft>
+                <a:spcPts val="600"/>
+              </a:spcAft>
+              <a:buNone/>
+            </a:pPr>
+            <a:r>
+              <a:rPr lang="en-US" sz="1400" b="1" dirty="0">
+                <a:solidFill>
+                  <a:schemeClr val="accent1"/>
+                </a:solidFill>
+              </a:rPr>
+              <a:t>왜?  </a:t>
+            </a:r>
+            <a:pPr indent="0" marL="0">
+              <a:spcAft>
+                <a:spcPts val="600"/>
+              </a:spcAft>
+              <a:buNone/>
+            </a:pPr>
+            <a:r>
+              <a:rPr lang="en-US" sz="1400" dirty="0">
+                <a:solidFill>
+                  <a:schemeClr val="tx2"/>
+                </a:solidFill>
+              </a:rPr>
+              <a:t>YOLOX 점수 = 두 확률의 곱 (objectness × class)</a:t>
             </a:r>
             <a:endParaRPr lang="en-US" sz="1400" dirty="0"/>
           </a:p>

</xml_diff>

<commit_message>
Deck: carry user's edits into build.js, reword WHY slide, add presenter name and 감사합니다/Q&A slide; name on summary
Co-Authored-By: Claude Opus 5.5 <noreply@anthropic.com>
</commit_message>
<xml_diff>
--- a/docs/submission/BatteryVision_발표.pptx
+++ b/docs/submission/BatteryVision_발표.pptx
@@ -16,9 +16,10 @@
     <p:sldId id="264" r:id="rId10"/>
     <p:sldId id="265" r:id="rId11"/>
     <p:sldId id="266" r:id="rId12"/>
+    <p:sldId id="267" r:id="rId13"/>
   </p:sldIdLst>
   <p:notesMasterIdLst>
-    <p:notesMasterId r:id="rId13"/>
+    <p:notesMasterId r:id="rId14"/>
   </p:notesMasterIdLst>
   <p:sldSz cx="12192000" cy="6858000"/>
   <p:notesSz cx="6858000" cy="12192000"/>
@@ -117,13 +118,13 @@
   <p:extLst>
     <p:ext uri="{521415D9-36F7-43E2-AB2F-B90AF26B5E84}">
       <p14:sectionLst xmlns:p14="http://schemas.microsoft.com/office/powerpoint/2010/main">
-        <p14:section name="도입" id="{98717ff3-c11c-ab26-22eb-50142ed9e67d}">
+        <p14:section name="도입" id="{076eb02f-5afc-1a65-3561-743820df2dff}">
           <p14:sldIdLst>
             <p14:sldId id="256"/>
             <p14:sldId id="257"/>
           </p14:sldIdLst>
         </p14:section>
-        <p14:section name="실험" id="{637e45b7-6636-1466-480d-48dd11d05963}">
+        <p14:section name="실험" id="{e3e54d36-3792-4920-e93d-52064877aaaf}">
           <p14:sldIdLst>
             <p14:sldId id="258"/>
             <p14:sldId id="259"/>
@@ -131,21 +132,22 @@
             <p14:sldId id="261"/>
           </p14:sldIdLst>
         </p14:section>
-        <p14:section name="최적화" id="{11f94f5a-a960-ee64-8b60-98aac936bc4e}">
+        <p14:section name="최적화" id="{f45113e3-66e8-e4ff-842e-17102335b750}">
           <p14:sldIdLst>
             <p14:sldId id="262"/>
           </p14:sldIdLst>
         </p14:section>
-        <p14:section name="검증" id="{69d40958-8096-e577-2cf8-e044e2c3ae9e}">
+        <p14:section name="검증" id="{2753db95-4b25-223f-3db5-9e2a1731c483}">
           <p14:sldIdLst>
             <p14:sldId id="263"/>
           </p14:sldIdLst>
         </p14:section>
-        <p14:section name="정리" id="{7a16fc6c-fbe3-84f9-31d6-18cb52fa2046}">
+        <p14:section name="정리" id="{33f28c43-0a38-24a8-d40a-ae94db6bd67e}">
           <p14:sldIdLst>
             <p14:sldId id="264"/>
             <p14:sldId id="265"/>
             <p14:sldId id="266"/>
+            <p14:sldId id="267"/>
           </p14:sldIdLst>
         </p14:section>
       </p14:sectionLst>
@@ -1509,6 +1511,94 @@
 </p:notes>
 </file>
 
+<file path=ppt/notesSlides/notesSlide12.xml><?xml version="1.0" encoding="utf-8"?>
+<p:notes xmlns:a="http://schemas.openxmlformats.org/drawingml/2006/main" xmlns:r="http://schemas.openxmlformats.org/officeDocument/2006/relationships" xmlns:p="http://schemas.openxmlformats.org/presentationml/2006/main">
+  <p:cSld>
+    <p:spTree>
+      <p:nvGrpSpPr>
+        <p:cNvPr id="1" name=""/>
+        <p:cNvGrpSpPr/>
+        <p:nvPr/>
+      </p:nvGrpSpPr>
+      <p:grpSpPr>
+        <a:xfrm>
+          <a:off x="0" y="0"/>
+          <a:ext cx="0" cy="0"/>
+          <a:chOff x="0" y="0"/>
+          <a:chExt cx="0" cy="0"/>
+        </a:xfrm>
+      </p:grpSpPr>
+      <p:sp>
+        <p:nvSpPr>
+          <p:cNvPr id="2" name="Slide Image Placeholder 1"/>
+          <p:cNvSpPr>
+            <a:spLocks noGrp="1" noRot="1" noChangeAspect="1"/>
+          </p:cNvSpPr>
+          <p:nvPr>
+            <p:ph type="sldImg"/>
+          </p:nvPr>
+        </p:nvSpPr>
+        <p:spPr/>
+      </p:sp>
+      <p:sp>
+        <p:nvSpPr>
+          <p:cNvPr id="3" name="Notes Placeholder 2"/>
+          <p:cNvSpPr>
+            <a:spLocks noGrp="1"/>
+          </p:cNvSpPr>
+          <p:nvPr>
+            <p:ph type="body" idx="1"/>
+          </p:nvPr>
+        </p:nvSpPr>
+        <p:spPr/>
+        <p:txBody>
+          <a:bodyPr/>
+          <a:lstStyle/>
+          <a:p>
+            <a:r>
+              <a:rPr lang="en-US" dirty="0"/>
+              <a:t>들어주셔서 감사합니다. 질문 받겠습니다.</a:t>
+            </a:r>
+            <a:endParaRPr lang="en-US" dirty="0"/>
+          </a:p>
+        </p:txBody>
+      </p:sp>
+      <p:sp>
+        <p:nvSpPr>
+          <p:cNvPr id="4" name="Slide Number Placeholder 3"/>
+          <p:cNvSpPr>
+            <a:spLocks noGrp="1"/>
+          </p:cNvSpPr>
+          <p:nvPr>
+            <p:ph type="sldNum" sz="quarter" idx="10"/>
+          </p:nvPr>
+        </p:nvSpPr>
+        <p:spPr/>
+        <p:txBody>
+          <a:bodyPr/>
+          <a:lstStyle/>
+          <a:p>
+            <a:fld id="{F7021451-1387-4CA6-816F-3879F97B5CBC}" type="slidenum">
+              <a:rPr lang="en-US"/>
+              <a:t>12</a:t>
+            </a:fld>
+            <a:endParaRPr lang="en-US"/>
+          </a:p>
+        </p:txBody>
+      </p:sp>
+    </p:spTree>
+    <p:extLst>
+      <p:ext uri="{BB962C8B-B14F-4D97-AF65-F5344CB8AC3E}">
+        <p14:creationId xmlns:p14="http://schemas.microsoft.com/office/powerpoint/2010/main" val="1024086991"/>
+      </p:ext>
+    </p:extLst>
+  </p:cSld>
+  <p:clrMapOvr>
+    <a:masterClrMapping/>
+  </p:clrMapOvr>
+</p:notes>
+</file>
+
 <file path=ppt/notesSlides/notesSlide2.xml><?xml version="1.0" encoding="utf-8"?>
 <p:notes xmlns:a="http://schemas.openxmlformats.org/drawingml/2006/main" xmlns:r="http://schemas.openxmlformats.org/officeDocument/2006/relationships" xmlns:p="http://schemas.openxmlformats.org/presentationml/2006/main">
   <p:cSld>
@@ -2171,7 +2261,7 @@
           <a:p>
             <a:r>
               <a:rPr lang="en-US" dirty="0"/>
-              <a:t>앞에서 본 결과들의 원인을 한 장에 모았습니다. 오른쪽 근거 칸은 얼마나 확실한지입니다. 측정은 데이터로 직접 확인한 것, 추정은 데이터와 맞지만 따로 검증하지 않은 것, 가설은 아직 검증하지 않은 것입니다. 가장 확실한 원인은 세 가지입니다. scratch는 반사나 나무결과 비슷한 가는 선이라 어렵고, 1차 93%는 테스트 사진까지 학습 데이터에 섞여 과대평가됐고, 2차 세트에서 떨어진 건 crack이 절반 크기로 작아졌기 때문입니다. ATSS가 왜 가장 좋은지는 아직 가설입니다.</a:t>
+              <a:t>앞에서 본 결과들의 원인을 한 장에 모았습니다. 오른쪽 근거 칸은 얼마나 확실한지입니다. 확인은 데이터로 직접 확인한 것, 추정은 데이터와 맞지만 따로 검증하지 않은 것, 가설은 아직 검증하지 못한 것입니다. 가장 확실한 원인은 세 가지입니다. scratch는 반사나 나무결과 비슷한 가는 선이라 어렵고, 93%는 테스트 사진까지 학습에 들어가 부풀려진 수치이고, 2차 세트에서 떨어진 건 crack이 절반 크기로 작아졌기 때문입니다. ATSS가 왜 가장 좋은지는 아직 가설입니다.</a:t>
             </a:r>
             <a:endParaRPr lang="en-US" dirty="0"/>
           </a:p>
@@ -3011,9 +3101,45 @@
           </a:p>
         </p:txBody>
       </p:sp>
+      <p:sp>
+        <p:nvSpPr>
+          <p:cNvPr id="5" name="presenter"/>
+          <p:cNvSpPr txBox="1"/>
+          <p:nvPr/>
+        </p:nvSpPr>
+        <p:spPr>
+          <a:xfrm>
+            <a:off x="548640" y="5349240"/>
+            <a:ext cx="4206240" cy="365760"/>
+          </a:xfrm>
+          <a:prstGeom prst="rect">
+            <a:avLst/>
+          </a:prstGeom>
+          <a:noFill/>
+          <a:ln/>
+        </p:spPr>
+        <p:txBody>
+          <a:bodyPr wrap="square" lIns="0" tIns="0" rIns="0" bIns="0" rtlCol="0" anchor="t"/>
+          <a:lstStyle/>
+          <a:p>
+            <a:pPr indent="0" marL="0">
+              <a:buNone/>
+            </a:pPr>
+            <a:r>
+              <a:rPr lang="en-US" sz="1600" b="1" dirty="0">
+                <a:solidFill>
+                  <a:schemeClr val="tx1"/>
+                </a:solidFill>
+              </a:rPr>
+              <a:t>최예현</a:t>
+            </a:r>
+            <a:endParaRPr lang="en-US" sz="1600" dirty="0"/>
+          </a:p>
+        </p:txBody>
+      </p:sp>
       <p:pic>
         <p:nvPicPr>
-          <p:cNvPr id="5" name="cover-crack" descr="C:\Users\user\_se4nchoi\batteryvision\docs\submission\build\img\cover_crack.jpg">    </p:cNvPr>
+          <p:cNvPr id="6" name="cover-crack" descr="C:\Users\user\_se4nchoi\batteryvision\docs\submission\build\img\cover_crack.jpg">    </p:cNvPr>
           <p:cNvPicPr>
             <a:picLocks noChangeAspect="1"/>
           </p:cNvPicPr>
@@ -3037,7 +3163,7 @@
       </p:pic>
       <p:sp>
         <p:nvSpPr>
-          <p:cNvPr id="6" name="cover-dot-crack"/>
+          <p:cNvPr id="7" name="cover-dot-crack"/>
           <p:cNvSpPr/>
           <p:nvPr/>
         </p:nvSpPr>
@@ -3057,7 +3183,7 @@
       </p:sp>
       <p:sp>
         <p:nvSpPr>
-          <p:cNvPr id="7" name="cover-label-crack"/>
+          <p:cNvPr id="8" name="cover-label-crack"/>
           <p:cNvSpPr txBox="1"/>
           <p:nvPr/>
         </p:nvSpPr>
@@ -3093,7 +3219,7 @@
       </p:sp>
       <p:pic>
         <p:nvPicPr>
-          <p:cNvPr id="8" name="cover-scratch" descr="C:\Users\user\_se4nchoi\batteryvision\docs\submission\build\img\cover_scratch.jpg">    </p:cNvPr>
+          <p:cNvPr id="9" name="cover-scratch" descr="C:\Users\user\_se4nchoi\batteryvision\docs\submission\build\img\cover_scratch.jpg">    </p:cNvPr>
           <p:cNvPicPr>
             <a:picLocks noChangeAspect="1"/>
           </p:cNvPicPr>
@@ -3117,7 +3243,7 @@
       </p:pic>
       <p:sp>
         <p:nvSpPr>
-          <p:cNvPr id="9" name="cover-dot-scratch"/>
+          <p:cNvPr id="10" name="cover-dot-scratch"/>
           <p:cNvSpPr/>
           <p:nvPr/>
         </p:nvSpPr>
@@ -3137,7 +3263,7 @@
       </p:sp>
       <p:sp>
         <p:nvSpPr>
-          <p:cNvPr id="10" name="cover-label-scratch"/>
+          <p:cNvPr id="11" name="cover-label-scratch"/>
           <p:cNvSpPr txBox="1"/>
           <p:nvPr/>
         </p:nvSpPr>
@@ -3173,7 +3299,7 @@
       </p:sp>
       <p:pic>
         <p:nvPicPr>
-          <p:cNvPr id="11" name="cover-정상" descr="C:\Users\user\_se4nchoi\batteryvision\docs\submission\build\img\cover_good.jpg">    </p:cNvPr>
+          <p:cNvPr id="12" name="cover-정상" descr="C:\Users\user\_se4nchoi\batteryvision\docs\submission\build\img\cover_good.jpg">    </p:cNvPr>
           <p:cNvPicPr>
             <a:picLocks noChangeAspect="1"/>
           </p:cNvPicPr>
@@ -3197,7 +3323,7 @@
       </p:pic>
       <p:sp>
         <p:nvSpPr>
-          <p:cNvPr id="12" name="cover-dot-정상"/>
+          <p:cNvPr id="13" name="cover-dot-정상"/>
           <p:cNvSpPr/>
           <p:nvPr/>
         </p:nvSpPr>
@@ -3217,7 +3343,7 @@
       </p:sp>
       <p:sp>
         <p:nvSpPr>
-          <p:cNvPr id="13" name="cover-label-정상"/>
+          <p:cNvPr id="14" name="cover-label-정상"/>
           <p:cNvSpPr txBox="1"/>
           <p:nvPr/>
         </p:nvSpPr>
@@ -6337,6 +6463,23 @@
           <a:bodyPr wrap="square" lIns="0" tIns="0" rIns="0" bIns="0" rtlCol="0" anchor="t"/>
           <a:lstStyle/>
           <a:p>
+            <a:pPr indent="0" marL="0">
+              <a:spcAft>
+                <a:spcPts val="1000"/>
+              </a:spcAft>
+              <a:buNone/>
+            </a:pPr>
+            <a:r>
+              <a:rPr lang="en-US" sz="2000" b="1" dirty="0">
+                <a:solidFill>
+                  <a:schemeClr val="tx1"/>
+                </a:solidFill>
+              </a:rPr>
+              <a:t>SIMULATED</a:t>
+            </a:r>
+            <a:endParaRPr lang="en-US" sz="1400" dirty="0"/>
+          </a:p>
+          <a:p>
             <a:pPr marL="342900" indent="-342900">
               <a:spcAft>
                 <a:spcPts val="1000"/>
@@ -6386,25 +6529,7 @@
                   <a:schemeClr val="tx1"/>
                 </a:solidFill>
               </a:rPr>
-              <a:t>로트별 추적</a:t>
-            </a:r>
-            <a:endParaRPr lang="en-US" sz="1400" dirty="0"/>
-          </a:p>
-          <a:p>
-            <a:pPr marL="342900" indent="-342900">
-              <a:spcAft>
-                <a:spcPts val="1000"/>
-              </a:spcAft>
-              <a:buSzPct val="100000"/>
-              <a:buChar char="•"/>
-            </a:pPr>
-            <a:r>
-              <a:rPr lang="en-US" sz="1400" dirty="0">
-                <a:solidFill>
-                  <a:schemeClr val="tx2"/>
-                </a:solidFill>
-              </a:rPr>
-              <a:t>실제 장비 미연결</a:t>
+              <a:t>LOT별 추적</a:t>
             </a:r>
             <a:endParaRPr lang="en-US" sz="1400" dirty="0"/>
           </a:p>
@@ -6452,6 +6577,411 @@
               <a:t>11</a:t>
             </a:fld>
             <a:endParaRPr lang="en-US"/>
+          </a:p>
+        </p:txBody>
+      </p:sp>
+    </p:spTree>
+  </p:cSld>
+  <p:clrMapOvr>
+    <a:masterClrMapping/>
+  </p:clrMapOvr>
+</p:sld>
+</file>
+
+<file path=ppt/slides/slide12.xml><?xml version="1.0" encoding="utf-8"?>
+<p:sld xmlns:a="http://schemas.openxmlformats.org/drawingml/2006/main" xmlns:r="http://schemas.openxmlformats.org/officeDocument/2006/relationships" xmlns:p="http://schemas.openxmlformats.org/presentationml/2006/main">
+  <p:cSld name="Slide 12">
+    <p:spTree>
+      <p:nvGrpSpPr>
+        <p:cNvPr id="1" name=""/>
+        <p:cNvGrpSpPr/>
+        <p:nvPr/>
+      </p:nvGrpSpPr>
+      <p:grpSpPr>
+        <a:xfrm>
+          <a:off x="0" y="0"/>
+          <a:ext cx="0" cy="0"/>
+          <a:chOff x="0" y="0"/>
+          <a:chExt cx="0" cy="0"/>
+        </a:xfrm>
+      </p:grpSpPr>
+      <p:sp>
+        <p:nvSpPr>
+          <p:cNvPr id="2" name="Text 0"/>
+          <p:cNvSpPr/>
+          <p:nvPr>
+            <p:ph idx="100" type="title" hasCustomPrompt="1"/>
+          </p:nvPr>
+        </p:nvSpPr>
+        <p:spPr>
+          <a:xfrm>
+            <a:off x="548640" y="2606040"/>
+            <a:ext cx="4389120" cy="1645920"/>
+          </a:xfrm>
+          <a:prstGeom prst="rect">
+            <a:avLst/>
+          </a:prstGeom>
+          <a:noFill/>
+          <a:ln/>
+        </p:spPr>
+        <p:txBody>
+          <a:bodyPr wrap="square" lIns="0" tIns="0" rIns="0" bIns="0" rtlCol="0" anchor="t"/>
+          <a:lstStyle/>
+          <a:p>
+            <a:pPr algn="l" indent="0" marL="0">
+              <a:buNone/>
+            </a:pPr>
+            <a:r>
+              <a:rPr lang="en-US" sz="4000" b="1" dirty="0">
+                <a:solidFill>
+                  <a:schemeClr val="tx1"/>
+                </a:solidFill>
+              </a:rPr>
+              <a:t>감사합니다</a:t>
+            </a:r>
+            <a:endParaRPr lang="en-US" sz="4000" dirty="0"/>
+          </a:p>
+        </p:txBody>
+      </p:sp>
+      <p:sp>
+        <p:nvSpPr>
+          <p:cNvPr id="3" name="qa"/>
+          <p:cNvSpPr txBox="1"/>
+          <p:nvPr/>
+        </p:nvSpPr>
+        <p:spPr>
+          <a:xfrm>
+            <a:off x="548640" y="3429000"/>
+            <a:ext cx="4206240" cy="640080"/>
+          </a:xfrm>
+          <a:prstGeom prst="rect">
+            <a:avLst/>
+          </a:prstGeom>
+          <a:noFill/>
+          <a:ln/>
+        </p:spPr>
+        <p:txBody>
+          <a:bodyPr wrap="square" lIns="0" tIns="0" rIns="0" bIns="0" rtlCol="0" anchor="t"/>
+          <a:lstStyle/>
+          <a:p>
+            <a:pPr indent="0" marL="0">
+              <a:buNone/>
+            </a:pPr>
+            <a:r>
+              <a:rPr lang="en-US" sz="3200" b="1" dirty="0">
+                <a:solidFill>
+                  <a:schemeClr val="accent1"/>
+                </a:solidFill>
+              </a:rPr>
+              <a:t>Q&amp;A</a:t>
+            </a:r>
+            <a:endParaRPr lang="en-US" sz="3200" dirty="0"/>
+          </a:p>
+        </p:txBody>
+      </p:sp>
+      <p:sp>
+        <p:nvSpPr>
+          <p:cNvPr id="4" name="presenter"/>
+          <p:cNvSpPr txBox="1"/>
+          <p:nvPr/>
+        </p:nvSpPr>
+        <p:spPr>
+          <a:xfrm>
+            <a:off x="548640" y="4343400"/>
+            <a:ext cx="4206240" cy="365760"/>
+          </a:xfrm>
+          <a:prstGeom prst="rect">
+            <a:avLst/>
+          </a:prstGeom>
+          <a:noFill/>
+          <a:ln/>
+        </p:spPr>
+        <p:txBody>
+          <a:bodyPr wrap="square" lIns="0" tIns="0" rIns="0" bIns="0" rtlCol="0" anchor="t"/>
+          <a:lstStyle/>
+          <a:p>
+            <a:pPr indent="0" marL="0">
+              <a:buNone/>
+            </a:pPr>
+            <a:r>
+              <a:rPr lang="en-US" sz="1600" b="1" dirty="0">
+                <a:solidFill>
+                  <a:schemeClr val="tx1"/>
+                </a:solidFill>
+              </a:rPr>
+              <a:t>최예현</a:t>
+            </a:r>
+            <a:endParaRPr lang="en-US" sz="1600" dirty="0"/>
+          </a:p>
+        </p:txBody>
+      </p:sp>
+      <p:pic>
+        <p:nvPicPr>
+          <p:cNvPr id="5" name="end-crack" descr="C:\Users\user\_se4nchoi\batteryvision\docs\submission\build\img\cover_crack.jpg">    </p:cNvPr>
+          <p:cNvPicPr>
+            <a:picLocks noChangeAspect="1"/>
+          </p:cNvPicPr>
+          <p:nvPr/>
+        </p:nvPicPr>
+        <p:blipFill>
+          <a:blip r:embed="rId1"/>
+          <a:stretch>
+            <a:fillRect/>
+          </a:stretch>
+        </p:blipFill>
+        <p:spPr>
+          <a:xfrm>
+            <a:off x="5074920" y="2377440"/>
+            <a:ext cx="2103120" cy="2103120"/>
+          </a:xfrm>
+          <a:prstGeom prst="rect">
+            <a:avLst/>
+          </a:prstGeom>
+        </p:spPr>
+      </p:pic>
+      <p:sp>
+        <p:nvSpPr>
+          <p:cNvPr id="6" name="end-dot-crack"/>
+          <p:cNvSpPr/>
+          <p:nvPr/>
+        </p:nvSpPr>
+        <p:spPr>
+          <a:xfrm>
+            <a:off x="5074920" y="4663440"/>
+            <a:ext cx="146304" cy="146304"/>
+          </a:xfrm>
+          <a:prstGeom prst="ellipse">
+            <a:avLst/>
+          </a:prstGeom>
+          <a:solidFill>
+            <a:schemeClr val="accent2"/>
+          </a:solidFill>
+          <a:ln/>
+        </p:spPr>
+      </p:sp>
+      <p:sp>
+        <p:nvSpPr>
+          <p:cNvPr id="7" name="end-label-crack"/>
+          <p:cNvSpPr txBox="1"/>
+          <p:nvPr/>
+        </p:nvSpPr>
+        <p:spPr>
+          <a:xfrm>
+            <a:off x="5312664" y="4590288"/>
+            <a:ext cx="1828800" cy="292608"/>
+          </a:xfrm>
+          <a:prstGeom prst="rect">
+            <a:avLst/>
+          </a:prstGeom>
+          <a:noFill/>
+          <a:ln/>
+        </p:spPr>
+        <p:txBody>
+          <a:bodyPr wrap="square" lIns="0" tIns="0" rIns="0" bIns="0" rtlCol="0" anchor="t"/>
+          <a:lstStyle/>
+          <a:p>
+            <a:pPr indent="0" marL="0">
+              <a:buNone/>
+            </a:pPr>
+            <a:r>
+              <a:rPr lang="en-US" sz="1400" b="1" dirty="0">
+                <a:solidFill>
+                  <a:schemeClr val="tx1"/>
+                </a:solidFill>
+              </a:rPr>
+              <a:t>crack</a:t>
+            </a:r>
+            <a:endParaRPr lang="en-US" sz="1400" dirty="0"/>
+          </a:p>
+        </p:txBody>
+      </p:sp>
+      <p:pic>
+        <p:nvPicPr>
+          <p:cNvPr id="8" name="end-scratch" descr="C:\Users\user\_se4nchoi\batteryvision\docs\submission\build\img\cover_scratch.jpg">    </p:cNvPr>
+          <p:cNvPicPr>
+            <a:picLocks noChangeAspect="1"/>
+          </p:cNvPicPr>
+          <p:nvPr/>
+        </p:nvPicPr>
+        <p:blipFill>
+          <a:blip r:embed="rId2"/>
+          <a:stretch>
+            <a:fillRect/>
+          </a:stretch>
+        </p:blipFill>
+        <p:spPr>
+          <a:xfrm>
+            <a:off x="7360920" y="2377440"/>
+            <a:ext cx="2103120" cy="2103120"/>
+          </a:xfrm>
+          <a:prstGeom prst="rect">
+            <a:avLst/>
+          </a:prstGeom>
+        </p:spPr>
+      </p:pic>
+      <p:sp>
+        <p:nvSpPr>
+          <p:cNvPr id="9" name="end-dot-scratch"/>
+          <p:cNvSpPr/>
+          <p:nvPr/>
+        </p:nvSpPr>
+        <p:spPr>
+          <a:xfrm>
+            <a:off x="7360920" y="4663440"/>
+            <a:ext cx="146304" cy="146304"/>
+          </a:xfrm>
+          <a:prstGeom prst="ellipse">
+            <a:avLst/>
+          </a:prstGeom>
+          <a:solidFill>
+            <a:schemeClr val="accent3"/>
+          </a:solidFill>
+          <a:ln/>
+        </p:spPr>
+      </p:sp>
+      <p:sp>
+        <p:nvSpPr>
+          <p:cNvPr id="10" name="end-label-scratch"/>
+          <p:cNvSpPr txBox="1"/>
+          <p:nvPr/>
+        </p:nvSpPr>
+        <p:spPr>
+          <a:xfrm>
+            <a:off x="7598664" y="4590288"/>
+            <a:ext cx="1828800" cy="292608"/>
+          </a:xfrm>
+          <a:prstGeom prst="rect">
+            <a:avLst/>
+          </a:prstGeom>
+          <a:noFill/>
+          <a:ln/>
+        </p:spPr>
+        <p:txBody>
+          <a:bodyPr wrap="square" lIns="0" tIns="0" rIns="0" bIns="0" rtlCol="0" anchor="t"/>
+          <a:lstStyle/>
+          <a:p>
+            <a:pPr indent="0" marL="0">
+              <a:buNone/>
+            </a:pPr>
+            <a:r>
+              <a:rPr lang="en-US" sz="1400" b="1" dirty="0">
+                <a:solidFill>
+                  <a:schemeClr val="tx1"/>
+                </a:solidFill>
+              </a:rPr>
+              <a:t>scratch</a:t>
+            </a:r>
+            <a:endParaRPr lang="en-US" sz="1400" dirty="0"/>
+          </a:p>
+        </p:txBody>
+      </p:sp>
+      <p:pic>
+        <p:nvPicPr>
+          <p:cNvPr id="11" name="end-정상" descr="C:\Users\user\_se4nchoi\batteryvision\docs\submission\build\img\cover_good.jpg">    </p:cNvPr>
+          <p:cNvPicPr>
+            <a:picLocks noChangeAspect="1"/>
+          </p:cNvPicPr>
+          <p:nvPr/>
+        </p:nvPicPr>
+        <p:blipFill>
+          <a:blip r:embed="rId3"/>
+          <a:stretch>
+            <a:fillRect/>
+          </a:stretch>
+        </p:blipFill>
+        <p:spPr>
+          <a:xfrm>
+            <a:off x="9646920" y="2377440"/>
+            <a:ext cx="2103120" cy="2103120"/>
+          </a:xfrm>
+          <a:prstGeom prst="rect">
+            <a:avLst/>
+          </a:prstGeom>
+        </p:spPr>
+      </p:pic>
+      <p:sp>
+        <p:nvSpPr>
+          <p:cNvPr id="12" name="end-dot-정상"/>
+          <p:cNvSpPr/>
+          <p:nvPr/>
+        </p:nvSpPr>
+        <p:spPr>
+          <a:xfrm>
+            <a:off x="9646920" y="4663440"/>
+            <a:ext cx="146304" cy="146304"/>
+          </a:xfrm>
+          <a:prstGeom prst="ellipse">
+            <a:avLst/>
+          </a:prstGeom>
+          <a:solidFill>
+            <a:schemeClr val="accent6"/>
+          </a:solidFill>
+          <a:ln/>
+        </p:spPr>
+      </p:sp>
+      <p:sp>
+        <p:nvSpPr>
+          <p:cNvPr id="13" name="end-label-정상"/>
+          <p:cNvSpPr txBox="1"/>
+          <p:nvPr/>
+        </p:nvSpPr>
+        <p:spPr>
+          <a:xfrm>
+            <a:off x="9884664" y="4590288"/>
+            <a:ext cx="1828800" cy="292608"/>
+          </a:xfrm>
+          <a:prstGeom prst="rect">
+            <a:avLst/>
+          </a:prstGeom>
+          <a:noFill/>
+          <a:ln/>
+        </p:spPr>
+        <p:txBody>
+          <a:bodyPr wrap="square" lIns="0" tIns="0" rIns="0" bIns="0" rtlCol="0" anchor="t"/>
+          <a:lstStyle/>
+          <a:p>
+            <a:pPr indent="0" marL="0">
+              <a:buNone/>
+            </a:pPr>
+            <a:r>
+              <a:rPr lang="en-US" sz="1400" b="1" dirty="0">
+                <a:solidFill>
+                  <a:schemeClr val="tx1"/>
+                </a:solidFill>
+              </a:rPr>
+              <a:t>정상</a:t>
+            </a:r>
+            <a:endParaRPr lang="en-US" sz="1400" dirty="0"/>
+          </a:p>
+        </p:txBody>
+      </p:sp>
+      <p:sp>
+        <p:nvSpPr>
+          <p:cNvPr id="15" name="Text 0"/>
+          <p:cNvSpPr/>
+          <p:nvPr>
+            <p:ph idx="101" type="body" hasCustomPrompt="1"/>
+          </p:nvPr>
+        </p:nvSpPr>
+        <p:spPr>
+          <a:xfrm>
+            <a:off x="548640" y="4343400"/>
+            <a:ext cx="4297680" cy="822960"/>
+          </a:xfrm>
+          <a:prstGeom prst="rect">
+            <a:avLst/>
+          </a:prstGeom>
+          <a:noFill/>
+          <a:ln/>
+        </p:spPr>
+        <p:txBody>
+          <a:bodyPr wrap="square" lIns="0" tIns="0" rIns="0" bIns="0" rtlCol="0" anchor="t"/>
+          <a:lstStyle/>
+          <a:p>
+            <a:pPr algn="l" indent="0" marL="0">
+              <a:buNone/>
+            </a:pPr>
+            <a:endParaRPr lang="en-US" sz="1600" dirty="0"/>
           </a:p>
         </p:txBody>
       </p:sp>
@@ -8782,7 +9312,7 @@
                   <a:schemeClr val="tx1"/>
                 </a:solidFill>
               </a:rPr>
-              <a:t>높은 결과에 숨은 함정</a:t>
+              <a:t>높은 수치, 숨은 함정</a:t>
             </a:r>
             <a:endParaRPr lang="en-US" sz="3200" dirty="0"/>
           </a:p>
@@ -8820,7 +9350,7 @@
                   <a:schemeClr val="tx2"/>
                 </a:solidFill>
               </a:rPr>
-              <a:t>1차 테스트 93%, 그런데 테스트 사진이 학습 데이터에 섞여 있었다</a:t>
+              <a:t>1차 테스트 93%, but 테스트 사진이 학습 데이터에 섞여 있었다</a:t>
             </a:r>
             <a:endParaRPr lang="en-US" sz="1500" dirty="0"/>
           </a:p>
@@ -16880,7 +17410,41 @@
                   <a:schemeClr val="accent1"/>
                 </a:solidFill>
               </a:rPr>
-              <a:t>→ 기준값은 모델별로 · 그래도 부족 → 재학습</a:t>
+              <a:t>→ 모델별로 다른 기준값 적용</a:t>
+            </a:r>
+            <a:endParaRPr lang="en-US" sz="1400" dirty="0"/>
+          </a:p>
+          <a:p>
+            <a:pPr indent="0" marL="0">
+              <a:spcAft>
+                <a:spcPts val="600"/>
+              </a:spcAft>
+              <a:buNone/>
+            </a:pPr>
+            <a:r>
+              <a:rPr lang="en-US" sz="1400" b="1" dirty="0">
+                <a:solidFill>
+                  <a:schemeClr val="accent1"/>
+                </a:solidFill>
+              </a:rPr>
+              <a:t>→ 결과치 불충분</a:t>
+            </a:r>
+            <a:endParaRPr lang="en-US" sz="1400" dirty="0"/>
+          </a:p>
+          <a:p>
+            <a:pPr indent="0" marL="0">
+              <a:spcAft>
+                <a:spcPts val="600"/>
+              </a:spcAft>
+              <a:buNone/>
+            </a:pPr>
+            <a:r>
+              <a:rPr lang="en-US" sz="1400" b="1" dirty="0">
+                <a:solidFill>
+                  <a:schemeClr val="accent1"/>
+                </a:solidFill>
+              </a:rPr>
+              <a:t>→ 재학습</a:t>
             </a:r>
             <a:endParaRPr lang="en-US" sz="1400" dirty="0"/>
           </a:p>
@@ -16988,47 +17552,9 @@
                   <a:schemeClr val="tx1"/>
                 </a:solidFill>
               </a:rPr>
-              <a:t>원인</a:t>
+              <a:t>WHY ?</a:t>
             </a:r>
             <a:endParaRPr lang="en-US" sz="3200" dirty="0"/>
-          </a:p>
-        </p:txBody>
-      </p:sp>
-      <p:sp>
-        <p:nvSpPr>
-          <p:cNvPr id="3" name="Text 0"/>
-          <p:cNvSpPr/>
-          <p:nvPr>
-            <p:ph idx="101" type="body" hasCustomPrompt="1"/>
-          </p:nvPr>
-        </p:nvSpPr>
-        <p:spPr>
-          <a:xfrm>
-            <a:off x="548640" y="1005840"/>
-            <a:ext cx="11094415" cy="411480"/>
-          </a:xfrm>
-          <a:prstGeom prst="rect">
-            <a:avLst/>
-          </a:prstGeom>
-          <a:noFill/>
-          <a:ln/>
-        </p:spPr>
-        <p:txBody>
-          <a:bodyPr wrap="square" lIns="0" tIns="0" rIns="0" bIns="0" rtlCol="0" anchor="ctr"/>
-          <a:lstStyle/>
-          <a:p>
-            <a:pPr algn="l" indent="0" marL="0">
-              <a:buNone/>
-            </a:pPr>
-            <a:r>
-              <a:rPr lang="en-US" sz="1500" dirty="0">
-                <a:solidFill>
-                  <a:schemeClr val="tx2"/>
-                </a:solidFill>
-              </a:rPr>
-              <a:t>슬라이드 2–8의 결과는 왜 나왔나</a:t>
-            </a:r>
-            <a:endParaRPr lang="en-US" sz="1500" dirty="0"/>
           </a:p>
         </p:txBody>
       </p:sp>
@@ -17047,7 +17573,7 @@
           </p:nvPr>
         </p:nvGraphicFramePr>
         <p:xfrm>
-          <a:off x="548640" y="1600200"/>
+          <a:off x="548640" y="1325880"/>
           <a:ext cx="11094415" cy="914400"/>
         </p:xfrm>
         <a:graphic>
@@ -17056,19 +17582,30 @@
               <a:tblPr/>
               <a:tblGrid>
                 <a:gridCol w="502920"/>
-                <a:gridCol w="2514600"/>
-                <a:gridCol w="7205472"/>
+                <a:gridCol w="2606040"/>
+                <a:gridCol w="7114032"/>
                 <a:gridCol w="868680"/>
               </a:tblGrid>
-              <a:tr h="429768">
+              <a:tr h="457200">
                 <a:tc>
                   <a:txBody>
                     <a:bodyPr/>
                     <a:lstStyle/>
                     <a:p>
-                      <a:pPr indent="0" marL="0">
+                      <a:pPr algn="ctr" indent="0" marL="0">
                         <a:buNone/>
                       </a:pPr>
+                      <a:r>
+                        <a:rPr lang="en-US" sz="1400" b="1" dirty="0">
+                          <a:solidFill>
+                            <a:schemeClr val="tx2"/>
+                          </a:solidFill>
+                          <a:latin typeface="Malgun Gothic" pitchFamily="34" charset="0"/>
+                          <a:ea typeface="Malgun Gothic" pitchFamily="34" charset="-122"/>
+                          <a:cs typeface="Malgun Gothic" pitchFamily="34" charset="-120"/>
+                        </a:rPr>
+                        <a:t>장</a:t>
+                      </a:r>
                       <a:endParaRPr lang="en-US" sz="1400" dirty="0">
                         <a:latin typeface="Malgun Gothic" charset="0"/>
                         <a:ea typeface="Malgun Gothic" charset="0"/>
@@ -17323,7 +17860,7 @@
                   </a:tcPr>
                 </a:tc>
               </a:tr>
-              <a:tr h="429768">
+              <a:tr h="457200">
                 <a:tc>
                   <a:txBody>
                     <a:bodyPr/>
@@ -17409,7 +17946,7 @@
                           <a:ea typeface="Malgun Gothic" pitchFamily="34" charset="-122"/>
                           <a:cs typeface="Malgun Gothic" pitchFamily="34" charset="-120"/>
                         </a:rPr>
-                        <a:t>scratch가 어렵다</a:t>
+                        <a:t>Scratch 식별 어려움</a:t>
                       </a:r>
                       <a:endParaRPr lang="en-US" sz="1400" dirty="0">
                         <a:latin typeface="Malgun Gothic" charset="0"/>
@@ -17477,7 +18014,7 @@
                           <a:ea typeface="Malgun Gothic" pitchFamily="34" charset="-122"/>
                           <a:cs typeface="Malgun Gothic" pitchFamily="34" charset="-120"/>
                         </a:rPr>
-                        <a:t>반사·나무결 같은 가는 선 (배경 오검출 16건 중 13건이 scratch)</a:t>
+                        <a:t>반사·나무결과 비슷한 가는 선. 배경 오검출 16건 중 13건이 scratch</a:t>
                       </a:r>
                       <a:endParaRPr lang="en-US" sz="1400" dirty="0">
                         <a:latin typeface="Malgun Gothic" charset="0"/>
@@ -17545,7 +18082,7 @@
                           <a:ea typeface="Malgun Gothic" pitchFamily="34" charset="-122"/>
                           <a:cs typeface="Malgun Gothic" pitchFamily="34" charset="-120"/>
                         </a:rPr>
-                        <a:t>측정</a:t>
+                        <a:t>확인</a:t>
                       </a:r>
                       <a:endParaRPr lang="en-US" sz="1400" dirty="0">
                         <a:latin typeface="Malgun Gothic" charset="0"/>
@@ -17597,7 +18134,7 @@
                   </a:tcPr>
                 </a:tc>
               </a:tr>
-              <a:tr h="429768">
+              <a:tr h="457200">
                 <a:tc>
                   <a:txBody>
                     <a:bodyPr/>
@@ -17683,7 +18220,7 @@
                           <a:ea typeface="Malgun Gothic" pitchFamily="34" charset="-122"/>
                           <a:cs typeface="Malgun Gothic" pitchFamily="34" charset="-120"/>
                         </a:rPr>
-                        <a:t>1차 93%는 과대평가</a:t>
+                        <a:t>과대평가 수치 (93%)</a:t>
                       </a:r>
                       <a:endParaRPr lang="en-US" sz="1400" dirty="0">
                         <a:latin typeface="Malgun Gothic" charset="0"/>
@@ -17751,7 +18288,7 @@
                           <a:ea typeface="Malgun Gothic" pitchFamily="34" charset="-122"/>
                           <a:cs typeface="Malgun Gothic" pitchFamily="34" charset="-120"/>
                         </a:rPr>
-                        <a:t>테스트까지 업로드 · 복사본 22장 · 같은 촬영 세션 → 암기를 측정</a:t>
+                        <a:t>테스트 사진도 학습에 포함. 복사본 22장, 같은 촬영 세션</a:t>
                       </a:r>
                       <a:endParaRPr lang="en-US" sz="1400" dirty="0">
                         <a:latin typeface="Malgun Gothic" charset="0"/>
@@ -17819,7 +18356,7 @@
                           <a:ea typeface="Malgun Gothic" pitchFamily="34" charset="-122"/>
                           <a:cs typeface="Malgun Gothic" pitchFamily="34" charset="-120"/>
                         </a:rPr>
-                        <a:t>측정</a:t>
+                        <a:t>확인</a:t>
                       </a:r>
                       <a:endParaRPr lang="en-US" sz="1400" dirty="0">
                         <a:latin typeface="Malgun Gothic" charset="0"/>
@@ -17871,7 +18408,7 @@
                   </a:tcPr>
                 </a:tc>
               </a:tr>
-              <a:tr h="429768">
+              <a:tr h="457200">
                 <a:tc>
                   <a:txBody>
                     <a:bodyPr/>
@@ -17957,7 +18494,7 @@
                           <a:ea typeface="Malgun Gothic" pitchFamily="34" charset="-122"/>
                           <a:cs typeface="Malgun Gothic" pitchFamily="34" charset="-120"/>
                         </a:rPr>
-                        <a:t>Geti 점수도 낙관적</a:t>
+                        <a:t>낙관적인 Geti score</a:t>
                       </a:r>
                       <a:endParaRPr lang="en-US" sz="1400" dirty="0">
                         <a:latin typeface="Malgun Gothic" charset="0"/>
@@ -18025,7 +18562,7 @@
                           <a:ea typeface="Malgun Gothic" pitchFamily="34" charset="-122"/>
                           <a:cs typeface="Malgun Gothic" pitchFamily="34" charset="-120"/>
                         </a:rPr>
-                        <a:t>같은 원본의 ×3 증강 사본이 Geti 학습·테스트에 함께 분할</a:t>
+                        <a:t>원본 1장당 증강본 3장이 Geti 학습·테스트에 나뉘어 들어갔을 가능성</a:t>
                       </a:r>
                       <a:endParaRPr lang="en-US" sz="1400" dirty="0">
                         <a:latin typeface="Malgun Gothic" charset="0"/>
@@ -18145,7 +18682,7 @@
                   </a:tcPr>
                 </a:tc>
               </a:tr>
-              <a:tr h="429768">
+              <a:tr h="457200">
                 <a:tc>
                   <a:txBody>
                     <a:bodyPr/>
@@ -18231,7 +18768,7 @@
                           <a:ea typeface="Malgun Gothic" pitchFamily="34" charset="-122"/>
                           <a:cs typeface="Malgun Gothic" pitchFamily="34" charset="-120"/>
                         </a:rPr>
-                        <a:t>작은 ATSS가 최고</a:t>
+                        <a:t>ATSS 최고평가</a:t>
                       </a:r>
                       <a:endParaRPr lang="en-US" sz="1400" dirty="0">
                         <a:latin typeface="Malgun Gothic" charset="0"/>
@@ -18299,7 +18836,7 @@
                           <a:ea typeface="Malgun Gothic" pitchFamily="34" charset="-122"/>
                           <a:cs typeface="Malgun Gothic" pitchFamily="34" charset="-120"/>
                         </a:rPr>
-                        <a:t>입력 992×800 vs 640×640 · 적은 데이터엔 작은 모델 (학습 1회)</a:t>
+                        <a:t>입력 해상도 차이 (992×800 vs 640×640), 적은 데이터엔 작은 모델. 학습 1회라 미확인</a:t>
                       </a:r>
                       <a:endParaRPr lang="en-US" sz="1400" dirty="0">
                         <a:latin typeface="Malgun Gothic" charset="0"/>
@@ -18419,7 +18956,7 @@
                   </a:tcPr>
                 </a:tc>
               </a:tr>
-              <a:tr h="429768">
+              <a:tr h="457200">
                 <a:tc>
                   <a:txBody>
                     <a:bodyPr/>
@@ -18505,7 +19042,7 @@
                           <a:ea typeface="Malgun Gothic" pitchFamily="34" charset="-122"/>
                           <a:cs typeface="Malgun Gothic" pitchFamily="34" charset="-120"/>
                         </a:rPr>
-                        <a:t>나무 배경 33%</a:t>
+                        <a:t>나무 배경 취약 (33%)</a:t>
                       </a:r>
                       <a:endParaRPr lang="en-US" sz="1400" dirty="0">
                         <a:latin typeface="Malgun Gothic" charset="0"/>
@@ -18573,7 +19110,7 @@
                           <a:ea typeface="Malgun Gothic" pitchFamily="34" charset="-122"/>
                           <a:cs typeface="Malgun Gothic" pitchFamily="34" charset="-120"/>
                         </a:rPr>
-                        <a:t>나무결 = scratch와 같은 가는 선 패턴</a:t>
+                        <a:t>나무결도 scratch처럼 가는 선</a:t>
                       </a:r>
                       <a:endParaRPr lang="en-US" sz="1400" dirty="0">
                         <a:latin typeface="Malgun Gothic" charset="0"/>
@@ -18693,7 +19230,7 @@
                   </a:tcPr>
                 </a:tc>
               </a:tr>
-              <a:tr h="429768">
+              <a:tr h="457200">
                 <a:tc>
                   <a:txBody>
                     <a:bodyPr/>
@@ -18847,7 +19384,7 @@
                           <a:ea typeface="Malgun Gothic" pitchFamily="34" charset="-122"/>
                           <a:cs typeface="Malgun Gothic" pitchFamily="34" charset="-120"/>
                         </a:rPr>
-                        <a:t>양자화로 점수 소폭 하락 → 0.30 근처 결함이 기준 아래로</a:t>
+                        <a:t>양자화 후 점수 소폭 하락, 0.30 근처 결함이 기준 미달</a:t>
                       </a:r>
                       <a:endParaRPr lang="en-US" sz="1400" dirty="0">
                         <a:latin typeface="Malgun Gothic" charset="0"/>
@@ -18967,7 +19504,7 @@
                   </a:tcPr>
                 </a:tc>
               </a:tr>
-              <a:tr h="429768">
+              <a:tr h="457200">
                 <a:tc>
                   <a:txBody>
                     <a:bodyPr/>
@@ -19053,7 +19590,7 @@
                           <a:ea typeface="Malgun Gothic" pitchFamily="34" charset="-122"/>
                           <a:cs typeface="Malgun Gothic" pitchFamily="34" charset="-120"/>
                         </a:rPr>
-                        <a:t>2차 세트 47%</a:t>
+                        <a:t>2차 세트 검출 47%</a:t>
                       </a:r>
                       <a:endParaRPr lang="en-US" sz="1400" dirty="0">
                         <a:latin typeface="Malgun Gothic" charset="0"/>
@@ -19121,7 +19658,7 @@
                           <a:ea typeface="Malgun Gothic" pitchFamily="34" charset="-122"/>
                           <a:cs typeface="Malgun Gothic" pitchFamily="34" charset="-120"/>
                         </a:rPr>
-                        <a:t>crack이 30×26px로 작아짐 (검출 1/15) + 새 촬영 환경</a:t>
+                        <a:t>crack이 30×26px로 작아짐 (15개 중 1개 검출), 촬영 환경도 바뀜</a:t>
                       </a:r>
                       <a:endParaRPr lang="en-US" sz="1400" dirty="0">
                         <a:latin typeface="Malgun Gothic" charset="0"/>
@@ -19189,7 +19726,7 @@
                           <a:ea typeface="Malgun Gothic" pitchFamily="34" charset="-122"/>
                           <a:cs typeface="Malgun Gothic" pitchFamily="34" charset="-120"/>
                         </a:rPr>
-                        <a:t>측정</a:t>
+                        <a:t>확인</a:t>
                       </a:r>
                       <a:endParaRPr lang="en-US" sz="1400" dirty="0">
                         <a:latin typeface="Malgun Gothic" charset="0"/>
@@ -19241,7 +19778,7 @@
                   </a:tcPr>
                 </a:tc>
               </a:tr>
-              <a:tr h="429768">
+              <a:tr h="457200">
                 <a:tc>
                   <a:txBody>
                     <a:bodyPr/>
@@ -19327,7 +19864,7 @@
                           <a:ea typeface="Malgun Gothic" pitchFamily="34" charset="-122"/>
                           <a:cs typeface="Malgun Gothic" pitchFamily="34" charset="-120"/>
                         </a:rPr>
-                        <a:t>YOLOX-S 점수가 낮음</a:t>
+                        <a:t>YOLOX-S 낮은 점수</a:t>
                       </a:r>
                       <a:endParaRPr lang="en-US" sz="1400" dirty="0">
                         <a:latin typeface="Malgun Gothic" charset="0"/>
@@ -19395,7 +19932,7 @@
                           <a:ea typeface="Malgun Gothic" pitchFamily="34" charset="-122"/>
                           <a:cs typeface="Malgun Gothic" pitchFamily="34" charset="-120"/>
                         </a:rPr>
-                        <a:t>점수 = objectness × class 확률의 곱</a:t>
+                        <a:t>점수 = 물체일 확률 × 클래스 확률. 두 확률의 곱이라 낮게 나옴</a:t>
                       </a:r>
                       <a:endParaRPr lang="en-US" sz="1400" dirty="0">
                         <a:latin typeface="Malgun Gothic" charset="0"/>
@@ -19515,7 +20052,7 @@
                   </a:tcPr>
                 </a:tc>
               </a:tr>
-              <a:tr h="429768">
+              <a:tr h="457200">
                 <a:tc>
                   <a:txBody>
                     <a:bodyPr/>
@@ -19601,7 +20138,7 @@
                           <a:ea typeface="Malgun Gothic" pitchFamily="34" charset="-122"/>
                           <a:cs typeface="Malgun Gothic" pitchFamily="34" charset="-120"/>
                         </a:rPr>
-                        <a:t>기준값으로 해결 안 됨</a:t>
+                        <a:t>기준값 조정으로 해결 불가</a:t>
                       </a:r>
                       <a:endParaRPr lang="en-US" sz="1400" dirty="0">
                         <a:latin typeface="Malgun Gothic" charset="0"/>
@@ -19669,7 +20206,7 @@
                           <a:ea typeface="Malgun Gothic" pitchFamily="34" charset="-122"/>
                           <a:cs typeface="Malgun Gothic" pitchFamily="34" charset="-120"/>
                         </a:rPr>
-                        <a:t>새 환경에서 결함·정상 점수 분포가 겹침</a:t>
+                        <a:t>새 환경에서 결함과 정상의 점수 구간이 겹침</a:t>
                       </a:r>
                       <a:endParaRPr lang="en-US" sz="1400" dirty="0">
                         <a:latin typeface="Malgun Gothic" charset="0"/>
@@ -19737,7 +20274,7 @@
                           <a:ea typeface="Malgun Gothic" pitchFamily="34" charset="-122"/>
                           <a:cs typeface="Malgun Gothic" pitchFamily="34" charset="-120"/>
                         </a:rPr>
-                        <a:t>측정</a:t>
+                        <a:t>확인</a:t>
                       </a:r>
                       <a:endParaRPr lang="en-US" sz="1400" dirty="0">
                         <a:latin typeface="Malgun Gothic" charset="0"/>
@@ -19795,13 +20332,13 @@
       </p:graphicFrame>
       <p:sp>
         <p:nvSpPr>
-          <p:cNvPr id="5" name="causes-legend"/>
+          <p:cNvPr id="4" name="causes-legend"/>
           <p:cNvSpPr txBox="1"/>
           <p:nvPr/>
         </p:nvSpPr>
         <p:spPr>
           <a:xfrm>
-            <a:off x="548640" y="5989320"/>
+            <a:off x="548640" y="6053328"/>
             <a:ext cx="11094415" cy="274320"/>
           </a:xfrm>
           <a:prstGeom prst="rect">
@@ -19823,7 +20360,7 @@
                   <a:schemeClr val="accent6"/>
                 </a:solidFill>
               </a:rPr>
-              <a:t>측정 </a:t>
+              <a:t>확인 </a:t>
             </a:r>
             <a:pPr indent="0" marL="0">
               <a:buNone/>
@@ -19834,7 +20371,7 @@
                   <a:schemeClr val="tx2"/>
                 </a:solidFill>
               </a:rPr>
-              <a:t>데이터로 확인   </a:t>
+              <a:t>데이터로 직접 확인   </a:t>
             </a:r>
             <a:pPr indent="0" marL="0">
               <a:buNone/>
@@ -19856,7 +20393,7 @@
                   <a:schemeClr val="tx2"/>
                 </a:solidFill>
               </a:rPr>
-              <a:t>데이터와 일치, 따로 검증 안 함   </a:t>
+              <a:t>데이터와 맞지만 별도 검증 없음   </a:t>
             </a:r>
             <a:pPr indent="0" marL="0">
               <a:buNone/>
@@ -19878,9 +20415,39 @@
                   <a:schemeClr val="tx2"/>
                 </a:solidFill>
               </a:rPr>
-              <a:t>미검증</a:t>
+              <a:t>아직 검증 못 함</a:t>
             </a:r>
             <a:endParaRPr lang="en-US" sz="1200" dirty="0"/>
+          </a:p>
+        </p:txBody>
+      </p:sp>
+      <p:sp>
+        <p:nvSpPr>
+          <p:cNvPr id="6" name="Text 0"/>
+          <p:cNvSpPr/>
+          <p:nvPr>
+            <p:ph idx="101" type="body" hasCustomPrompt="1"/>
+          </p:nvPr>
+        </p:nvSpPr>
+        <p:spPr>
+          <a:xfrm>
+            <a:off x="548640" y="1005840"/>
+            <a:ext cx="11094415" cy="411480"/>
+          </a:xfrm>
+          <a:prstGeom prst="rect">
+            <a:avLst/>
+          </a:prstGeom>
+          <a:noFill/>
+          <a:ln/>
+        </p:spPr>
+        <p:txBody>
+          <a:bodyPr wrap="square" lIns="0" tIns="0" rIns="0" bIns="0" rtlCol="0" anchor="ctr"/>
+          <a:lstStyle/>
+          <a:p>
+            <a:pPr algn="l" indent="0" marL="0">
+              <a:buNone/>
+            </a:pPr>
+            <a:endParaRPr lang="en-US" sz="1500" dirty="0"/>
           </a:p>
         </p:txBody>
       </p:sp>

</xml_diff>

<commit_message>
Slide 3: separate 데이터셋/한계 cards with color-tagged rows; subtitle-less layout for slides without a subtitle
Co-Authored-By: Claude Opus 5.5 <noreply@anthropic.com>
</commit_message>
<xml_diff>
--- a/docs/submission/BatteryVision_발표.pptx
+++ b/docs/submission/BatteryVision_발표.pptx
@@ -119,13 +119,13 @@
   <p:extLst>
     <p:ext uri="{521415D9-36F7-43E2-AB2F-B90AF26B5E84}">
       <p14:sectionLst xmlns:p14="http://schemas.microsoft.com/office/powerpoint/2010/main">
-        <p14:section name="도입" id="{ea74ea0f-f449-7e35-c3dc-f73f6ff0372a}">
+        <p14:section name="도입" id="{25ebfbdf-5b03-d097-9371-40695ae54486}">
           <p14:sldIdLst>
             <p14:sldId id="256"/>
             <p14:sldId id="257"/>
           </p14:sldIdLst>
         </p14:section>
-        <p14:section name="실험" id="{b086b4b4-1337-c1e3-3f43-50eb28ce2ba0}">
+        <p14:section name="실험" id="{3be77ada-f206-8265-e6ef-c93bff4d1fd0}">
           <p14:sldIdLst>
             <p14:sldId id="258"/>
             <p14:sldId id="259"/>
@@ -133,18 +133,18 @@
             <p14:sldId id="261"/>
           </p14:sldIdLst>
         </p14:section>
-        <p14:section name="최적화" id="{bc3883a6-c347-7cf7-794b-2ca58f0ede9a}">
+        <p14:section name="최적화" id="{5d95946b-7547-21e0-b5dc-68b79882177f}">
           <p14:sldIdLst>
             <p14:sldId id="262"/>
           </p14:sldIdLst>
         </p14:section>
-        <p14:section name="검증" id="{9c4bad10-b721-c4b6-5373-2a8ea8929e5a}">
+        <p14:section name="검증" id="{ddce3dda-44d9-622a-ae8d-a3c5161eecfa}">
           <p14:sldIdLst>
             <p14:sldId id="263"/>
             <p14:sldId id="264"/>
           </p14:sldIdLst>
         </p14:section>
-        <p14:section name="정리" id="{6411d161-5d15-4921-938c-0273821b6067}">
+        <p14:section name="정리" id="{2bcfceac-4fc0-dcb4-ca3b-51138667b3ca}">
           <p14:sldIdLst>
             <p14:sldId id="265"/>
             <p14:sldId id="266"/>
@@ -2535,6 +2535,158 @@
 
 <file path=ppt/slideLayouts/slideLayout3.xml><?xml version="1.0" encoding="utf-8"?>
 <p:sldLayout xmlns:a="http://schemas.openxmlformats.org/drawingml/2006/main" xmlns:r="http://schemas.openxmlformats.org/officeDocument/2006/relationships" xmlns:p="http://schemas.openxmlformats.org/presentationml/2006/main" preserve="1">
+  <p:cSld name="CONTENT_T">
+    <p:bg>
+      <p:bgPr>
+        <a:solidFill>
+          <a:schemeClr val="bg1"/>
+        </a:solidFill>
+      </p:bgPr>
+    </p:bg>
+    <p:spTree>
+      <p:nvGrpSpPr>
+        <p:cNvPr id="1" name=""/>
+        <p:cNvGrpSpPr/>
+        <p:nvPr/>
+      </p:nvGrpSpPr>
+      <p:grpSpPr>
+        <a:xfrm>
+          <a:off x="0" y="0"/>
+          <a:ext cx="0" cy="0"/>
+          <a:chOff x="0" y="0"/>
+          <a:chExt cx="0" cy="0"/>
+        </a:xfrm>
+      </p:grpSpPr>
+      <p:sp>
+        <p:nvSpPr>
+          <p:cNvPr id="2" name="Text 0"/>
+          <p:cNvSpPr/>
+          <p:nvPr>
+            <p:ph idx="100" type="title" hasCustomPrompt="1"/>
+          </p:nvPr>
+        </p:nvSpPr>
+        <p:spPr>
+          <a:xfrm>
+            <a:off x="548640" y="347472"/>
+            <a:ext cx="11094415" cy="685800"/>
+          </a:xfrm>
+          <a:prstGeom prst="rect">
+            <a:avLst/>
+          </a:prstGeom>
+          <a:noFill/>
+          <a:ln/>
+        </p:spPr>
+        <p:txBody>
+          <a:bodyPr wrap="square" rtlCol="0"/>
+          <a:lstStyle>
+            <a:lvl1pPr algn="l" indent="0" marL="0">
+              <a:buNone/>
+              <a:defRPr lang="en-US" sz="3200" b="1" dirty="0">
+                <a:solidFill>
+                  <a:schemeClr val="tx1"/>
+                </a:solidFill>
+              </a:defRPr>
+            </a:lvl1pPr>
+          </a:lstStyle>
+          <a:p>
+            <a:pPr algn="l" indent="0" marL="0">
+              <a:buNone/>
+            </a:pPr>
+            <a:endParaRPr lang="en-US" sz="3200" dirty="0"/>
+          </a:p>
+        </p:txBody>
+      </p:sp>
+      <p:sp>
+        <p:nvSpPr>
+          <p:cNvPr id="3" name="Text 0"/>
+          <p:cNvSpPr/>
+          <p:nvPr/>
+        </p:nvSpPr>
+        <p:spPr>
+          <a:xfrm>
+            <a:off x="548640" y="6419088"/>
+            <a:ext cx="5486400" cy="274320"/>
+          </a:xfrm>
+          <a:prstGeom prst="rect">
+            <a:avLst/>
+          </a:prstGeom>
+          <a:noFill/>
+          <a:ln/>
+        </p:spPr>
+        <p:txBody>
+          <a:bodyPr wrap="square" lIns="0" tIns="0" rIns="0" bIns="0" rtlCol="0" anchor="ctr"/>
+          <a:lstStyle/>
+          <a:p>
+            <a:pPr indent="0" marL="0">
+              <a:buNone/>
+            </a:pPr>
+            <a:r>
+              <a:rPr lang="en-US" sz="1000" dirty="0">
+                <a:solidFill>
+                  <a:schemeClr val="tx2"/>
+                </a:solidFill>
+              </a:rPr>
+              <a:t>BatteryVision · Intel Geti 실습</a:t>
+            </a:r>
+            <a:endParaRPr lang="en-US" sz="1000" dirty="0"/>
+          </a:p>
+        </p:txBody>
+      </p:sp>
+      <p:sp>
+        <p:nvSpPr>
+          <p:cNvPr id="25" name="Slide Number Placeholder 0"/>
+          <p:cNvSpPr>
+            <a:spLocks noGrp="1"/>
+          </p:cNvSpPr>
+          <p:nvPr>
+            <p:ph type="sldNum" sz="quarter" idx="4294967295"/>
+          </p:nvPr>
+        </p:nvSpPr>
+        <p:spPr>
+          <a:xfrm>
+            <a:off x="11094415" y="6419088"/>
+            <a:ext cx="548640" cy="274320"/>
+          </a:xfrm>
+          <a:prstGeom prst="rect">
+            <a:avLst/>
+          </a:prstGeom>
+          <a:extLst>
+            <a:ext uri="{C572A759-6A51-4108-AA02-DFA0A04FC94B}">
+              <ma14:wrappingTextBoxFlag xmlns:ma14="http://schemas.microsoft.com/office/mac/drawingml/2011/main" val="0"/>
+            </a:ext>
+          </a:extLst>
+        </p:spPr>
+        <p:txBody>
+          <a:bodyPr/>
+          <a:lstStyle>
+            <a:lvl1pPr>
+              <a:defRPr sz="1000">
+                <a:solidFill>
+                  <a:schemeClr val="tx2"/>
+                </a:solidFill>
+              </a:defRPr>
+            </a:lvl1pPr>
+          </a:lstStyle>
+          <a:p>
+            <a:pPr algn="r"/>
+            <a:fld id="{F7021451-1387-4CA6-816F-3879F97B5CBC}" type="slidenum">
+              <a:rPr b="0" lang="en-US"/>
+              <a:t>1003</a:t>
+            </a:fld>
+            <a:endParaRPr lang="en-US"/>
+          </a:p>
+        </p:txBody>
+      </p:sp>
+    </p:spTree>
+  </p:cSld>
+  <p:clrMapOvr>
+    <a:masterClrMapping/>
+  </p:clrMapOvr>
+</p:sldLayout>
+</file>
+
+<file path=ppt/slideLayouts/slideLayout4.xml><?xml version="1.0" encoding="utf-8"?>
+<p:sldLayout xmlns:a="http://schemas.openxmlformats.org/drawingml/2006/main" xmlns:r="http://schemas.openxmlformats.org/officeDocument/2006/relationships" xmlns:p="http://schemas.openxmlformats.org/presentationml/2006/main" preserve="1">
   <p:cSld name="CONTENT">
     <p:bg>
       <p:bgPr>
@@ -2710,7 +2862,7 @@
             <a:pPr algn="r"/>
             <a:fld id="{F7021451-1387-4CA6-816F-3879F97B5CBC}" type="slidenum">
               <a:rPr b="0" lang="en-US"/>
-              <a:t>1003</a:t>
+              <a:t>1004</a:t>
             </a:fld>
             <a:endParaRPr lang="en-US"/>
           </a:p>
@@ -2793,6 +2945,7 @@
     <p:sldLayoutId id="2147483649" r:id="rId1"/>
     <p:sldLayoutId id="2147483650" r:id="rId2"/>
     <p:sldLayoutId id="2147483651" r:id="rId3"/>
+    <p:sldLayoutId id="2147483652" r:id="rId4"/>
   </p:sldLayoutIdLst>
   <p:hf sldNum="0" hdr="0" ftr="0" dt="0"/>
   <p:txStyles>
@@ -6395,36 +6548,6 @@
       </p:sp>
       <p:sp>
         <p:nvSpPr>
-          <p:cNvPr id="6" name="Text 0"/>
-          <p:cNvSpPr/>
-          <p:nvPr>
-            <p:ph idx="101" type="body" hasCustomPrompt="1"/>
-          </p:nvPr>
-        </p:nvSpPr>
-        <p:spPr>
-          <a:xfrm>
-            <a:off x="548640" y="1005840"/>
-            <a:ext cx="11094415" cy="411480"/>
-          </a:xfrm>
-          <a:prstGeom prst="rect">
-            <a:avLst/>
-          </a:prstGeom>
-          <a:noFill/>
-          <a:ln/>
-        </p:spPr>
-        <p:txBody>
-          <a:bodyPr wrap="square" lIns="0" tIns="0" rIns="0" bIns="0" rtlCol="0" anchor="ctr"/>
-          <a:lstStyle/>
-          <a:p>
-            <a:pPr algn="l" indent="0" marL="0">
-              <a:buNone/>
-            </a:pPr>
-            <a:endParaRPr lang="en-US" sz="1500" dirty="0"/>
-          </a:p>
-        </p:txBody>
-      </p:sp>
-      <p:sp>
-        <p:nvSpPr>
           <p:cNvPr id="25" name="Slide Number Placeholder 0"/>
           <p:cNvSpPr>
             <a:spLocks noGrp="1"/>
@@ -8110,11 +8233,11 @@
         <p:spPr>
           <a:xfrm>
             <a:off x="548640" y="1645920"/>
-            <a:ext cx="5394960" cy="4572000"/>
+            <a:ext cx="5394960" cy="1965960"/>
           </a:xfrm>
           <a:prstGeom prst="roundRect">
             <a:avLst>
-              <a:gd name="adj" fmla="val 1600"/>
+              <a:gd name="adj" fmla="val 3721"/>
             </a:avLst>
           </a:prstGeom>
           <a:solidFill>
@@ -8131,7 +8254,7 @@
         </p:nvSpPr>
         <p:spPr>
           <a:xfrm>
-            <a:off x="822960" y="1783080"/>
+            <a:off x="822960" y="1755648"/>
             <a:ext cx="4572000" cy="320040"/>
           </a:xfrm>
           <a:prstGeom prst="rect">
@@ -8161,14 +8284,43 @@
       </p:sp>
       <p:sp>
         <p:nvSpPr>
-          <p:cNvPr id="5" name="ds-b"/>
+          <p:cNvPr id="5" name="ds-k-bg-0"/>
+          <p:cNvSpPr/>
+          <p:nvPr/>
+        </p:nvSpPr>
+        <p:spPr>
+          <a:xfrm>
+            <a:off x="822960" y="2212848"/>
+            <a:ext cx="658368" cy="329184"/>
+          </a:xfrm>
+          <a:prstGeom prst="roundRect">
+            <a:avLst>
+              <a:gd name="adj" fmla="val 13889"/>
+            </a:avLst>
+          </a:prstGeom>
+          <a:solidFill>
+            <a:schemeClr val="accent1">
+              <a:alpha val="22000"/>
+            </a:schemeClr>
+          </a:solidFill>
+          <a:ln w="12700">
+            <a:solidFill>
+              <a:schemeClr val="accent1"/>
+            </a:solidFill>
+            <a:prstDash val="solid"/>
+          </a:ln>
+        </p:spPr>
+      </p:sp>
+      <p:sp>
+        <p:nvSpPr>
+          <p:cNvPr id="6" name="ds-k-0"/>
           <p:cNvSpPr txBox="1"/>
           <p:nvPr/>
         </p:nvSpPr>
         <p:spPr>
           <a:xfrm>
-            <a:off x="822960" y="2194560"/>
-            <a:ext cx="4892040" cy="1325880"/>
+            <a:off x="822960" y="2212848"/>
+            <a:ext cx="658368" cy="329184"/>
           </a:xfrm>
           <a:prstGeom prst="rect">
             <a:avLst/>
@@ -8177,15 +8329,47 @@
           <a:ln/>
         </p:spPr>
         <p:txBody>
-          <a:bodyPr wrap="square" lIns="0" tIns="0" rIns="0" bIns="0" rtlCol="0" anchor="t"/>
+          <a:bodyPr wrap="square" lIns="0" tIns="0" rIns="0" bIns="0" rtlCol="0" anchor="ctr"/>
           <a:lstStyle/>
           <a:p>
-            <a:pPr marL="342900" indent="-342900">
-              <a:spcAft>
-                <a:spcPts val="600"/>
-              </a:spcAft>
-              <a:buSzPct val="100000"/>
-              <a:buChar char="•"/>
+            <a:pPr algn="ctr" indent="0" marL="0">
+              <a:buNone/>
+            </a:pPr>
+            <a:r>
+              <a:rPr lang="en-US" sz="1300" b="1" dirty="0">
+                <a:solidFill>
+                  <a:schemeClr val="accent1"/>
+                </a:solidFill>
+              </a:rPr>
+              <a:t>출처</a:t>
+            </a:r>
+            <a:endParaRPr lang="en-US" sz="1300" dirty="0"/>
+          </a:p>
+        </p:txBody>
+      </p:sp>
+      <p:sp>
+        <p:nvSpPr>
+          <p:cNvPr id="7" name="ds-v-0"/>
+          <p:cNvSpPr txBox="1"/>
+          <p:nvPr/>
+        </p:nvSpPr>
+        <p:spPr>
+          <a:xfrm>
+            <a:off x="1627632" y="2212848"/>
+            <a:ext cx="4206240" cy="329184"/>
+          </a:xfrm>
+          <a:prstGeom prst="rect">
+            <a:avLst/>
+          </a:prstGeom>
+          <a:noFill/>
+          <a:ln/>
+        </p:spPr>
+        <p:txBody>
+          <a:bodyPr wrap="square" lIns="0" tIns="0" rIns="0" bIns="0" rtlCol="0" anchor="ctr"/>
+          <a:lstStyle/>
+          <a:p>
+            <a:pPr indent="0" marL="0">
+              <a:buNone/>
             </a:pPr>
             <a:r>
               <a:rPr lang="en-US" sz="1400" dirty="0">
@@ -8197,13 +8381,96 @@
             </a:r>
             <a:endParaRPr lang="en-US" sz="1400" dirty="0"/>
           </a:p>
-          <a:p>
-            <a:pPr marL="342900" indent="-342900">
-              <a:spcAft>
-                <a:spcPts val="600"/>
-              </a:spcAft>
-              <a:buSzPct val="100000"/>
-              <a:buChar char="•"/>
+        </p:txBody>
+      </p:sp>
+      <p:sp>
+        <p:nvSpPr>
+          <p:cNvPr id="8" name="ds-k-bg-1"/>
+          <p:cNvSpPr/>
+          <p:nvPr/>
+        </p:nvSpPr>
+        <p:spPr>
+          <a:xfrm>
+            <a:off x="822960" y="2651760"/>
+            <a:ext cx="658368" cy="329184"/>
+          </a:xfrm>
+          <a:prstGeom prst="roundRect">
+            <a:avLst>
+              <a:gd name="adj" fmla="val 13889"/>
+            </a:avLst>
+          </a:prstGeom>
+          <a:solidFill>
+            <a:schemeClr val="accent3">
+              <a:alpha val="22000"/>
+            </a:schemeClr>
+          </a:solidFill>
+          <a:ln w="12700">
+            <a:solidFill>
+              <a:schemeClr val="accent3"/>
+            </a:solidFill>
+            <a:prstDash val="solid"/>
+          </a:ln>
+        </p:spPr>
+      </p:sp>
+      <p:sp>
+        <p:nvSpPr>
+          <p:cNvPr id="9" name="ds-k-1"/>
+          <p:cNvSpPr txBox="1"/>
+          <p:nvPr/>
+        </p:nvSpPr>
+        <p:spPr>
+          <a:xfrm>
+            <a:off x="822960" y="2651760"/>
+            <a:ext cx="658368" cy="329184"/>
+          </a:xfrm>
+          <a:prstGeom prst="rect">
+            <a:avLst/>
+          </a:prstGeom>
+          <a:noFill/>
+          <a:ln/>
+        </p:spPr>
+        <p:txBody>
+          <a:bodyPr wrap="square" lIns="0" tIns="0" rIns="0" bIns="0" rtlCol="0" anchor="ctr"/>
+          <a:lstStyle/>
+          <a:p>
+            <a:pPr algn="ctr" indent="0" marL="0">
+              <a:buNone/>
+            </a:pPr>
+            <a:r>
+              <a:rPr lang="en-US" sz="1300" b="1" dirty="0">
+                <a:solidFill>
+                  <a:schemeClr val="accent3"/>
+                </a:solidFill>
+              </a:rPr>
+              <a:t>구성</a:t>
+            </a:r>
+            <a:endParaRPr lang="en-US" sz="1300" dirty="0"/>
+          </a:p>
+        </p:txBody>
+      </p:sp>
+      <p:sp>
+        <p:nvSpPr>
+          <p:cNvPr id="10" name="ds-v-1"/>
+          <p:cNvSpPr txBox="1"/>
+          <p:nvPr/>
+        </p:nvSpPr>
+        <p:spPr>
+          <a:xfrm>
+            <a:off x="1627632" y="2651760"/>
+            <a:ext cx="4206240" cy="329184"/>
+          </a:xfrm>
+          <a:prstGeom prst="rect">
+            <a:avLst/>
+          </a:prstGeom>
+          <a:noFill/>
+          <a:ln/>
+        </p:spPr>
+        <p:txBody>
+          <a:bodyPr wrap="square" lIns="0" tIns="0" rIns="0" bIns="0" rtlCol="0" anchor="ctr"/>
+          <a:lstStyle/>
+          <a:p>
+            <a:pPr indent="0" marL="0">
+              <a:buNone/>
             </a:pPr>
             <a:r>
               <a:rPr lang="en-US" sz="1400" dirty="0">
@@ -8215,13 +8482,96 @@
             </a:r>
             <a:endParaRPr lang="en-US" sz="1400" dirty="0"/>
           </a:p>
-          <a:p>
-            <a:pPr marL="342900" indent="-342900">
-              <a:spcAft>
-                <a:spcPts val="600"/>
-              </a:spcAft>
-              <a:buSzPct val="100000"/>
-              <a:buChar char="•"/>
+        </p:txBody>
+      </p:sp>
+      <p:sp>
+        <p:nvSpPr>
+          <p:cNvPr id="11" name="ds-k-bg-2"/>
+          <p:cNvSpPr/>
+          <p:nvPr/>
+        </p:nvSpPr>
+        <p:spPr>
+          <a:xfrm>
+            <a:off x="822960" y="3090672"/>
+            <a:ext cx="658368" cy="329184"/>
+          </a:xfrm>
+          <a:prstGeom prst="roundRect">
+            <a:avLst>
+              <a:gd name="adj" fmla="val 13889"/>
+            </a:avLst>
+          </a:prstGeom>
+          <a:solidFill>
+            <a:schemeClr val="accent6">
+              <a:alpha val="22000"/>
+            </a:schemeClr>
+          </a:solidFill>
+          <a:ln w="12700">
+            <a:solidFill>
+              <a:schemeClr val="accent6"/>
+            </a:solidFill>
+            <a:prstDash val="solid"/>
+          </a:ln>
+        </p:spPr>
+      </p:sp>
+      <p:sp>
+        <p:nvSpPr>
+          <p:cNvPr id="12" name="ds-k-2"/>
+          <p:cNvSpPr txBox="1"/>
+          <p:nvPr/>
+        </p:nvSpPr>
+        <p:spPr>
+          <a:xfrm>
+            <a:off x="822960" y="3090672"/>
+            <a:ext cx="658368" cy="329184"/>
+          </a:xfrm>
+          <a:prstGeom prst="rect">
+            <a:avLst/>
+          </a:prstGeom>
+          <a:noFill/>
+          <a:ln/>
+        </p:spPr>
+        <p:txBody>
+          <a:bodyPr wrap="square" lIns="0" tIns="0" rIns="0" bIns="0" rtlCol="0" anchor="ctr"/>
+          <a:lstStyle/>
+          <a:p>
+            <a:pPr algn="ctr" indent="0" marL="0">
+              <a:buNone/>
+            </a:pPr>
+            <a:r>
+              <a:rPr lang="en-US" sz="1300" b="1" dirty="0">
+                <a:solidFill>
+                  <a:schemeClr val="accent6"/>
+                </a:solidFill>
+              </a:rPr>
+              <a:t>목적</a:t>
+            </a:r>
+            <a:endParaRPr lang="en-US" sz="1300" dirty="0"/>
+          </a:p>
+        </p:txBody>
+      </p:sp>
+      <p:sp>
+        <p:nvSpPr>
+          <p:cNvPr id="13" name="ds-v-2"/>
+          <p:cNvSpPr txBox="1"/>
+          <p:nvPr/>
+        </p:nvSpPr>
+        <p:spPr>
+          <a:xfrm>
+            <a:off x="1627632" y="3090672"/>
+            <a:ext cx="4206240" cy="329184"/>
+          </a:xfrm>
+          <a:prstGeom prst="rect">
+            <a:avLst/>
+          </a:prstGeom>
+          <a:noFill/>
+          <a:ln/>
+        </p:spPr>
+        <p:txBody>
+          <a:bodyPr wrap="square" lIns="0" tIns="0" rIns="0" bIns="0" rtlCol="0" anchor="ctr"/>
+          <a:lstStyle/>
+          <a:p>
+            <a:pPr indent="0" marL="0">
+              <a:buNone/>
             </a:pPr>
             <a:r>
               <a:rPr lang="en-US" sz="1400" dirty="0">
@@ -8229,7 +8579,7 @@
                   <a:schemeClr val="tx1"/>
                 </a:solidFill>
               </a:rPr>
-              <a:t>목적: 모델별 성능 비교 · INT8 효과</a:t>
+              <a:t>모델별 성능 비교 · INT8 효과</a:t>
             </a:r>
             <a:endParaRPr lang="en-US" sz="1400" dirty="0"/>
           </a:p>
@@ -8237,13 +8587,35 @@
       </p:sp>
       <p:sp>
         <p:nvSpPr>
-          <p:cNvPr id="6" name="limit-h"/>
+          <p:cNvPr id="14" name="limit-card"/>
+          <p:cNvSpPr/>
+          <p:nvPr/>
+        </p:nvSpPr>
+        <p:spPr>
+          <a:xfrm>
+            <a:off x="548640" y="3794760"/>
+            <a:ext cx="5394960" cy="2423160"/>
+          </a:xfrm>
+          <a:prstGeom prst="roundRect">
+            <a:avLst>
+              <a:gd name="adj" fmla="val 3019"/>
+            </a:avLst>
+          </a:prstGeom>
+          <a:solidFill>
+            <a:schemeClr val="bg2"/>
+          </a:solidFill>
+          <a:ln/>
+        </p:spPr>
+      </p:sp>
+      <p:sp>
+        <p:nvSpPr>
+          <p:cNvPr id="15" name="limit-h"/>
           <p:cNvSpPr txBox="1"/>
           <p:nvPr/>
         </p:nvSpPr>
         <p:spPr>
           <a:xfrm>
-            <a:off x="822960" y="3611880"/>
+            <a:off x="822960" y="3904488"/>
             <a:ext cx="4572000" cy="320040"/>
           </a:xfrm>
           <a:prstGeom prst="rect">
@@ -8273,7 +8645,7 @@
       </p:sp>
       <p:pic>
         <p:nvPicPr>
-          <p:cNvPr id="7" name="bg-0" descr="C:\Users\user\_se4nchoi\batteryvision\docs\submission\build\img\bg_green.jpg">    </p:cNvPr>
+          <p:cNvPr id="16" name="bg-0" descr="C:\Users\user\_se4nchoi\batteryvision\docs\submission\build\img\bg_green.jpg">    </p:cNvPr>
           <p:cNvPicPr>
             <a:picLocks noChangeAspect="1"/>
           </p:cNvPicPr>
@@ -8287,8 +8659,8 @@
         </p:blipFill>
         <p:spPr>
           <a:xfrm>
-            <a:off x="822960" y="4023360"/>
-            <a:ext cx="1508760" cy="1508760"/>
+            <a:off x="822960" y="4297680"/>
+            <a:ext cx="1325880" cy="1325880"/>
           </a:xfrm>
           <a:prstGeom prst="rect">
             <a:avLst/>
@@ -8297,14 +8669,14 @@
       </p:pic>
       <p:sp>
         <p:nvSpPr>
-          <p:cNvPr id="8" name="bg-l-0"/>
+          <p:cNvPr id="17" name="bg-l-0"/>
           <p:cNvSpPr txBox="1"/>
           <p:nvPr/>
         </p:nvSpPr>
         <p:spPr>
           <a:xfrm>
-            <a:off x="822960" y="5577840"/>
-            <a:ext cx="1508760" cy="274320"/>
+            <a:off x="822960" y="5641848"/>
+            <a:ext cx="1325880" cy="237744"/>
           </a:xfrm>
           <a:prstGeom prst="rect">
             <a:avLst/>
@@ -8333,7 +8705,7 @@
       </p:sp>
       <p:pic>
         <p:nvPicPr>
-          <p:cNvPr id="9" name="bg-1" descr="C:\Users\user\_se4nchoi\batteryvision\docs\submission\build\img\bg_grey.jpg">    </p:cNvPr>
+          <p:cNvPr id="18" name="bg-1" descr="C:\Users\user\_se4nchoi\batteryvision\docs\submission\build\img\bg_grey.jpg">    </p:cNvPr>
           <p:cNvPicPr>
             <a:picLocks noChangeAspect="1"/>
           </p:cNvPicPr>
@@ -8347,8 +8719,8 @@
         </p:blipFill>
         <p:spPr>
           <a:xfrm>
-            <a:off x="2468880" y="4023360"/>
-            <a:ext cx="1508760" cy="1508760"/>
+            <a:off x="2514600" y="4297680"/>
+            <a:ext cx="1325880" cy="1325880"/>
           </a:xfrm>
           <a:prstGeom prst="rect">
             <a:avLst/>
@@ -8357,14 +8729,14 @@
       </p:pic>
       <p:sp>
         <p:nvSpPr>
-          <p:cNvPr id="10" name="bg-l-1"/>
+          <p:cNvPr id="19" name="bg-l-1"/>
           <p:cNvSpPr txBox="1"/>
           <p:nvPr/>
         </p:nvSpPr>
         <p:spPr>
           <a:xfrm>
-            <a:off x="2468880" y="5577840"/>
-            <a:ext cx="1508760" cy="274320"/>
+            <a:off x="2514600" y="5641848"/>
+            <a:ext cx="1325880" cy="237744"/>
           </a:xfrm>
           <a:prstGeom prst="rect">
             <a:avLst/>
@@ -8393,7 +8765,7 @@
       </p:sp>
       <p:pic>
         <p:nvPicPr>
-          <p:cNvPr id="11" name="bg-2" descr="C:\Users\user\_se4nchoi\batteryvision\docs\submission\build\img\bg_wood.jpg">    </p:cNvPr>
+          <p:cNvPr id="20" name="bg-2" descr="C:\Users\user\_se4nchoi\batteryvision\docs\submission\build\img\bg_wood.jpg">    </p:cNvPr>
           <p:cNvPicPr>
             <a:picLocks noChangeAspect="1"/>
           </p:cNvPicPr>
@@ -8407,8 +8779,8 @@
         </p:blipFill>
         <p:spPr>
           <a:xfrm>
-            <a:off x="4114800" y="4023360"/>
-            <a:ext cx="1508760" cy="1508760"/>
+            <a:off x="4206240" y="4297680"/>
+            <a:ext cx="1325880" cy="1325880"/>
           </a:xfrm>
           <a:prstGeom prst="rect">
             <a:avLst/>
@@ -8417,14 +8789,14 @@
       </p:pic>
       <p:sp>
         <p:nvSpPr>
-          <p:cNvPr id="12" name="bg-l-2"/>
+          <p:cNvPr id="21" name="bg-l-2"/>
           <p:cNvSpPr txBox="1"/>
           <p:nvPr/>
         </p:nvSpPr>
         <p:spPr>
           <a:xfrm>
-            <a:off x="4114800" y="5577840"/>
-            <a:ext cx="1508760" cy="274320"/>
+            <a:off x="4206240" y="5641848"/>
+            <a:ext cx="1325880" cy="237744"/>
           </a:xfrm>
           <a:prstGeom prst="rect">
             <a:avLst/>
@@ -8453,13 +8825,13 @@
       </p:sp>
       <p:sp>
         <p:nvSpPr>
-          <p:cNvPr id="13" name="limit-t"/>
+          <p:cNvPr id="22" name="limit-t"/>
           <p:cNvSpPr txBox="1"/>
           <p:nvPr/>
         </p:nvSpPr>
         <p:spPr>
           <a:xfrm>
-            <a:off x="822960" y="5852160"/>
+            <a:off x="822960" y="5897880"/>
             <a:ext cx="4937760" cy="274320"/>
           </a:xfrm>
           <a:prstGeom prst="rect">
@@ -8489,7 +8861,7 @@
       </p:sp>
       <p:sp>
         <p:nvSpPr>
-          <p:cNvPr id="14" name="grid-h"/>
+          <p:cNvPr id="23" name="grid-h"/>
           <p:cNvSpPr txBox="1"/>
           <p:nvPr/>
         </p:nvSpPr>
@@ -9642,7 +10014,7 @@
       </p:graphicFrame>
       <p:sp>
         <p:nvSpPr>
-          <p:cNvPr id="16" name="legend-card"/>
+          <p:cNvPr id="25" name="legend-card"/>
           <p:cNvSpPr/>
           <p:nvPr/>
         </p:nvSpPr>
@@ -9664,7 +10036,7 @@
       </p:sp>
       <p:sp>
         <p:nvSpPr>
-          <p:cNvPr id="17" name="legend"/>
+          <p:cNvPr id="26" name="legend"/>
           <p:cNvSpPr txBox="1"/>
           <p:nvPr/>
         </p:nvSpPr>
@@ -9748,7 +10120,7 @@
       </p:sp>
       <p:sp>
         <p:nvSpPr>
-          <p:cNvPr id="18" name="credit"/>
+          <p:cNvPr id="27" name="credit"/>
           <p:cNvSpPr txBox="1"/>
           <p:nvPr/>
         </p:nvSpPr>
@@ -9779,36 +10151,6 @@
               <a:t>데이터: Battery Defect Inspection v8 (Roboflow Universe), CC BY 4.0</a:t>
             </a:r>
             <a:endParaRPr lang="en-US" sz="900" dirty="0"/>
-          </a:p>
-        </p:txBody>
-      </p:sp>
-      <p:sp>
-        <p:nvSpPr>
-          <p:cNvPr id="20" name="Text 0"/>
-          <p:cNvSpPr/>
-          <p:nvPr>
-            <p:ph idx="101" type="body" hasCustomPrompt="1"/>
-          </p:nvPr>
-        </p:nvSpPr>
-        <p:spPr>
-          <a:xfrm>
-            <a:off x="548640" y="1005840"/>
-            <a:ext cx="11094415" cy="411480"/>
-          </a:xfrm>
-          <a:prstGeom prst="rect">
-            <a:avLst/>
-          </a:prstGeom>
-          <a:noFill/>
-          <a:ln/>
-        </p:spPr>
-        <p:txBody>
-          <a:bodyPr wrap="square" lIns="0" tIns="0" rIns="0" bIns="0" rtlCol="0" anchor="ctr"/>
-          <a:lstStyle/>
-          <a:p>
-            <a:pPr algn="l" indent="0" marL="0">
-              <a:buNone/>
-            </a:pPr>
-            <a:endParaRPr lang="en-US" sz="1500" dirty="0"/>
           </a:p>
         </p:txBody>
       </p:sp>

</xml_diff>

<commit_message>
Deck: follow user's order (작은 모델 before 숨은 함정), revert 2/3 swap, renumber 결과 분석 rows; benchmark screenshots
Co-Authored-By: Claude Opus 5.5 <noreply@anthropic.com>
</commit_message>
<xml_diff>
--- a/docs/submission/BatteryVision_발표.pptx
+++ b/docs/submission/BatteryVision_발표.pptx
@@ -121,13 +121,13 @@
   <p:extLst>
     <p:ext uri="{521415D9-36F7-43E2-AB2F-B90AF26B5E84}">
       <p14:sectionLst xmlns:p14="http://schemas.microsoft.com/office/powerpoint/2010/main">
-        <p14:section name="도입" id="{23a3f643-68fc-c894-a2b4-ca8ffc357475}">
+        <p14:section name="도입" id="{05a3184a-83d5-6ee7-5b5a-75d762406ad0}">
           <p14:sldIdLst>
             <p14:sldId id="256"/>
             <p14:sldId id="257"/>
           </p14:sldIdLst>
         </p14:section>
-        <p14:section name="실험" id="{baceac97-86f8-dd8c-29e7-01551e168b6f}">
+        <p14:section name="실험" id="{c75d7b2c-b3ca-e551-0f3d-20a1422e5b5a}">
           <p14:sldIdLst>
             <p14:sldId id="258"/>
             <p14:sldId id="259"/>
@@ -137,18 +137,18 @@
             <p14:sldId id="263"/>
           </p14:sldIdLst>
         </p14:section>
-        <p14:section name="최적화" id="{de26dd4a-00d4-ca1e-8a58-1d2d2c89d2d9}">
+        <p14:section name="최적화" id="{4418b4e2-95b9-bc88-21c9-31e48a91f65e}">
           <p14:sldIdLst>
             <p14:sldId id="264"/>
           </p14:sldIdLst>
         </p14:section>
-        <p14:section name="검증" id="{1c50a450-3aec-e836-af0c-3de5e8fa1ad1}">
+        <p14:section name="검증" id="{88b3e689-2d9b-2601-c4e9-a25e890eec97}">
           <p14:sldIdLst>
             <p14:sldId id="265"/>
             <p14:sldId id="266"/>
           </p14:sldIdLst>
         </p14:section>
-        <p14:section name="정리" id="{19763157-0b2f-ef15-3331-995879a9cba5}">
+        <p14:section name="정리" id="{6f429778-5dd0-498f-1482-c2bb7826bedf}">
           <p14:sldIdLst>
             <p14:sldId id="267"/>
             <p14:sldId id="268"/>
@@ -2091,7 +2091,7 @@
           <a:p>
             <a:r>
               <a:rPr lang="en-US" dirty="0"/>
-              <a:t>처음 결과는 mAP 93%로 좋아 보였습니다. 하지만 데이터를 다시 보니 문제가 있었습니다. Roboflow 데이터셋을 통째로 Geti에 올리면서 테스트 153장도 함께 들어갔고, Geti가 이를 다시 나눠 학습했습니다. 그래서 1차 테스트 사진 중 일부는 모델이 학습 때 본 사진일 수 있습니다. 게다가 22장은 학습 사진과 사실상 같은 사진이었습니다. 직접 만든 데이터셋이 아니라서 놓친 부분입니다. 그래서 1차 점수는 모델끼리 비교하는 데만 쓰고, 처음 보는 사진에서의 성능은 2차 세트로 확인했습니다.</a:t>
+              <a:t>왼쪽은 Geti 화면입니다. 세 모델 모두 같은 2,800장으로 학습했고, Geti 점수는 ATSS 86%, 나머지 81%입니다. 다만 Roboflow가 원본마다 증강 사본 3장을 만들어 두었고 Geti가 이를 무작위로 나눴기 때문에, 같은 원본의 사본이 Geti 학습과 테스트에 함께 들어갔을 가능성이 높아 Geti 점수도 낙관적입니다. 오른쪽은 직접 만든 벤치마크로 잰 값인데 순서가 같습니다. 파라미터가 가장 적은 ATSS가 가장 정확했고, 학습에 안 쓴 2차 세트에서도 ATSS가 YOLOX-S보다 훨씬 많이 잡았습니다. 다만 '작다'는 파라미터 기준이고, 연산량은 Tiny가 가장 적습니다. 왜 ATSS가 이겼는지는 가설 단계입니다. ATSS는 992×800으로 학습해 결함을 1.5배 크게 보고, 데이터가 2,800장으로 적어 작은 모델이 덜 과적합했을 수 있습니다. 모델마다 한 번씩만 학습해서 확정할 수는 없습니다.</a:t>
             </a:r>
             <a:endParaRPr lang="en-US" dirty="0"/>
           </a:p>
@@ -2179,7 +2179,7 @@
           <a:p>
             <a:r>
               <a:rPr lang="en-US" dirty="0"/>
-              <a:t>왼쪽은 Geti 화면입니다. 세 모델 모두 같은 2,800장으로 학습했고, Geti 점수는 ATSS 86%, 나머지 81%입니다. 다만 Roboflow가 원본마다 증강 사본 3장을 만들어 두었고 Geti가 이를 무작위로 나눴기 때문에, 같은 원본의 사본이 Geti 학습과 테스트에 함께 들어갔을 가능성이 높아 Geti 점수도 낙관적입니다. 오른쪽은 직접 만든 벤치마크로 잰 값인데 순서가 같습니다. 파라미터가 가장 적은 ATSS가 가장 정확했고, 학습에 안 쓴 2차 세트에서도 ATSS가 YOLOX-S보다 훨씬 많이 잡았습니다. 다만 '작다'는 파라미터 기준이고, 연산량은 Tiny가 가장 적습니다. 왜 ATSS가 이겼는지는 가설 단계입니다. ATSS는 992×800으로 학습해 결함을 1.5배 크게 보고, 데이터가 2,800장으로 적어 작은 모델이 덜 과적합했을 수 있습니다. 모델마다 한 번씩만 학습해서 확정할 수는 없습니다.</a:t>
+              <a:t>처음 결과는 mAP 93%로 좋아 보였습니다. 하지만 데이터를 다시 보니 문제가 있었습니다. Roboflow 데이터셋을 통째로 Geti에 올리면서 테스트 153장도 함께 들어갔고, Geti가 이를 다시 나눠 학습했습니다. 그래서 1차 테스트 사진 중 일부는 모델이 학습 때 본 사진일 수 있습니다. 게다가 22장은 학습 사진과 사실상 같은 사진이었습니다. 직접 만든 데이터셋이 아니라서 놓친 부분입니다. 그래서 1차 점수는 모델끼리 비교하는 데만 쓰고, 처음 보는 사진에서의 성능은 2차 세트로 확인했습니다.</a:t>
             </a:r>
             <a:endParaRPr lang="en-US" dirty="0"/>
           </a:p>
@@ -7646,7 +7646,7 @@
                           <a:ea typeface="Malgun Gothic" pitchFamily="34" charset="-122"/>
                           <a:cs typeface="Malgun Gothic" pitchFamily="34" charset="-120"/>
                         </a:rPr>
-                        <a:t>과대평가 수치 (93%)</a:t>
+                        <a:t>낙관적인 Geti score</a:t>
                       </a:r>
                       <a:endParaRPr lang="en-US" sz="1500" dirty="0">
                         <a:latin typeface="Malgun Gothic" charset="0"/>
@@ -7714,7 +7714,7 @@
                           <a:ea typeface="Malgun Gothic" pitchFamily="34" charset="-122"/>
                           <a:cs typeface="Malgun Gothic" pitchFamily="34" charset="-120"/>
                         </a:rPr>
-                        <a:t>테스트 사진 학습 포함 · 복사본 22장</a:t>
+                        <a:t>증강본이 학습·테스트에 섞임</a:t>
                       </a:r>
                       <a:endParaRPr lang="en-US" sz="1500" dirty="0">
                         <a:latin typeface="Malgun Gothic" charset="0"/>
@@ -7776,13 +7776,287 @@
                       <a:r>
                         <a:rPr lang="en-US" sz="1500" b="1" dirty="0">
                           <a:solidFill>
-                            <a:schemeClr val="accent6"/>
+                            <a:schemeClr val="accent3"/>
                           </a:solidFill>
                           <a:latin typeface="Malgun Gothic" pitchFamily="34" charset="0"/>
                           <a:ea typeface="Malgun Gothic" pitchFamily="34" charset="-122"/>
                           <a:cs typeface="Malgun Gothic" pitchFamily="34" charset="-120"/>
                         </a:rPr>
-                        <a:t>확인</a:t>
+                        <a:t>추정</a:t>
+                      </a:r>
+                      <a:endParaRPr lang="en-US" sz="1500" dirty="0">
+                        <a:latin typeface="Malgun Gothic" charset="0"/>
+                        <a:ea typeface="Malgun Gothic" charset="0"/>
+                        <a:cs typeface="Malgun Gothic" charset="0"/>
+                      </a:endParaRPr>
+                    </a:p>
+                  </a:txBody>
+                  <a:tcPr marL="91440" marR="91440" marT="45720" marB="45720" anchor="ctr">
+                    <a:lnL w="9525" cap="flat" cmpd="sng" algn="ctr">
+                      <a:solidFill>
+                        <a:srgbClr val="3A3F48"/>
+                      </a:solidFill>
+                      <a:prstDash val="solid"/>
+                      <a:round/>
+                      <a:headEnd type="none" w="med" len="med"/>
+                      <a:tailEnd type="none" w="med" len="med"/>
+                    </a:lnL>
+                    <a:lnR w="9525" cap="flat" cmpd="sng" algn="ctr">
+                      <a:solidFill>
+                        <a:srgbClr val="3A3F48"/>
+                      </a:solidFill>
+                      <a:prstDash val="solid"/>
+                      <a:round/>
+                      <a:headEnd type="none" w="med" len="med"/>
+                      <a:tailEnd type="none" w="med" len="med"/>
+                    </a:lnR>
+                    <a:lnT w="9525" cap="flat" cmpd="sng" algn="ctr">
+                      <a:solidFill>
+                        <a:srgbClr val="3A3F48"/>
+                      </a:solidFill>
+                      <a:prstDash val="solid"/>
+                      <a:round/>
+                      <a:headEnd type="none" w="med" len="med"/>
+                      <a:tailEnd type="none" w="med" len="med"/>
+                    </a:lnT>
+                    <a:lnB w="9525" cap="flat" cmpd="sng" algn="ctr">
+                      <a:solidFill>
+                        <a:srgbClr val="3A3F48"/>
+                      </a:solidFill>
+                      <a:prstDash val="solid"/>
+                      <a:round/>
+                      <a:headEnd type="none" w="med" len="med"/>
+                      <a:tailEnd type="none" w="med" len="med"/>
+                    </a:lnB>
+                    <a:solidFill>
+                      <a:srgbClr val="23272F"/>
+                    </a:solidFill>
+                  </a:tcPr>
+                </a:tc>
+              </a:tr>
+              <a:tr h="420624">
+                <a:tc>
+                  <a:txBody>
+                    <a:bodyPr/>
+                    <a:lstStyle/>
+                    <a:p>
+                      <a:pPr algn="ctr" indent="0" marL="0">
+                        <a:buNone/>
+                      </a:pPr>
+                      <a:r>
+                        <a:rPr lang="en-US" sz="1500" dirty="0">
+                          <a:solidFill>
+                            <a:schemeClr val="tx2"/>
+                          </a:solidFill>
+                          <a:latin typeface="Malgun Gothic" pitchFamily="34" charset="0"/>
+                          <a:ea typeface="Malgun Gothic" pitchFamily="34" charset="-122"/>
+                          <a:cs typeface="Malgun Gothic" pitchFamily="34" charset="-120"/>
+                        </a:rPr>
+                        <a:t>4</a:t>
+                      </a:r>
+                      <a:endParaRPr lang="en-US" sz="1500" dirty="0">
+                        <a:latin typeface="Malgun Gothic" charset="0"/>
+                        <a:ea typeface="Malgun Gothic" charset="0"/>
+                        <a:cs typeface="Malgun Gothic" charset="0"/>
+                      </a:endParaRPr>
+                    </a:p>
+                  </a:txBody>
+                  <a:tcPr marL="91440" marR="91440" marT="45720" marB="45720" anchor="ctr">
+                    <a:lnL w="9525" cap="flat" cmpd="sng" algn="ctr">
+                      <a:solidFill>
+                        <a:srgbClr val="3A3F48"/>
+                      </a:solidFill>
+                      <a:prstDash val="solid"/>
+                      <a:round/>
+                      <a:headEnd type="none" w="med" len="med"/>
+                      <a:tailEnd type="none" w="med" len="med"/>
+                    </a:lnL>
+                    <a:lnR w="9525" cap="flat" cmpd="sng" algn="ctr">
+                      <a:solidFill>
+                        <a:srgbClr val="3A3F48"/>
+                      </a:solidFill>
+                      <a:prstDash val="solid"/>
+                      <a:round/>
+                      <a:headEnd type="none" w="med" len="med"/>
+                      <a:tailEnd type="none" w="med" len="med"/>
+                    </a:lnR>
+                    <a:lnT w="9525" cap="flat" cmpd="sng" algn="ctr">
+                      <a:solidFill>
+                        <a:srgbClr val="3A3F48"/>
+                      </a:solidFill>
+                      <a:prstDash val="solid"/>
+                      <a:round/>
+                      <a:headEnd type="none" w="med" len="med"/>
+                      <a:tailEnd type="none" w="med" len="med"/>
+                    </a:lnT>
+                    <a:lnB w="9525" cap="flat" cmpd="sng" algn="ctr">
+                      <a:solidFill>
+                        <a:srgbClr val="3A3F48"/>
+                      </a:solidFill>
+                      <a:prstDash val="solid"/>
+                      <a:round/>
+                      <a:headEnd type="none" w="med" len="med"/>
+                      <a:tailEnd type="none" w="med" len="med"/>
+                    </a:lnB>
+                    <a:solidFill>
+                      <a:srgbClr val="23272F"/>
+                    </a:solidFill>
+                  </a:tcPr>
+                </a:tc>
+                <a:tc>
+                  <a:txBody>
+                    <a:bodyPr/>
+                    <a:lstStyle/>
+                    <a:p>
+                      <a:pPr indent="0" marL="0">
+                        <a:buNone/>
+                      </a:pPr>
+                      <a:r>
+                        <a:rPr lang="en-US" sz="1500" b="1" dirty="0">
+                          <a:solidFill>
+                            <a:schemeClr val="tx1"/>
+                          </a:solidFill>
+                          <a:latin typeface="Malgun Gothic" pitchFamily="34" charset="0"/>
+                          <a:ea typeface="Malgun Gothic" pitchFamily="34" charset="-122"/>
+                          <a:cs typeface="Malgun Gothic" pitchFamily="34" charset="-120"/>
+                        </a:rPr>
+                        <a:t>ATSS 최고평가</a:t>
+                      </a:r>
+                      <a:endParaRPr lang="en-US" sz="1500" dirty="0">
+                        <a:latin typeface="Malgun Gothic" charset="0"/>
+                        <a:ea typeface="Malgun Gothic" charset="0"/>
+                        <a:cs typeface="Malgun Gothic" charset="0"/>
+                      </a:endParaRPr>
+                    </a:p>
+                  </a:txBody>
+                  <a:tcPr marL="91440" marR="91440" marT="45720" marB="45720" anchor="ctr">
+                    <a:lnL w="9525" cap="flat" cmpd="sng" algn="ctr">
+                      <a:solidFill>
+                        <a:srgbClr val="3A3F48"/>
+                      </a:solidFill>
+                      <a:prstDash val="solid"/>
+                      <a:round/>
+                      <a:headEnd type="none" w="med" len="med"/>
+                      <a:tailEnd type="none" w="med" len="med"/>
+                    </a:lnL>
+                    <a:lnR w="9525" cap="flat" cmpd="sng" algn="ctr">
+                      <a:solidFill>
+                        <a:srgbClr val="3A3F48"/>
+                      </a:solidFill>
+                      <a:prstDash val="solid"/>
+                      <a:round/>
+                      <a:headEnd type="none" w="med" len="med"/>
+                      <a:tailEnd type="none" w="med" len="med"/>
+                    </a:lnR>
+                    <a:lnT w="9525" cap="flat" cmpd="sng" algn="ctr">
+                      <a:solidFill>
+                        <a:srgbClr val="3A3F48"/>
+                      </a:solidFill>
+                      <a:prstDash val="solid"/>
+                      <a:round/>
+                      <a:headEnd type="none" w="med" len="med"/>
+                      <a:tailEnd type="none" w="med" len="med"/>
+                    </a:lnT>
+                    <a:lnB w="9525" cap="flat" cmpd="sng" algn="ctr">
+                      <a:solidFill>
+                        <a:srgbClr val="3A3F48"/>
+                      </a:solidFill>
+                      <a:prstDash val="solid"/>
+                      <a:round/>
+                      <a:headEnd type="none" w="med" len="med"/>
+                      <a:tailEnd type="none" w="med" len="med"/>
+                    </a:lnB>
+                    <a:solidFill>
+                      <a:srgbClr val="23272F"/>
+                    </a:solidFill>
+                  </a:tcPr>
+                </a:tc>
+                <a:tc>
+                  <a:txBody>
+                    <a:bodyPr/>
+                    <a:lstStyle/>
+                    <a:p>
+                      <a:pPr indent="0" marL="0">
+                        <a:buNone/>
+                      </a:pPr>
+                      <a:r>
+                        <a:rPr lang="en-US" sz="1500" dirty="0">
+                          <a:solidFill>
+                            <a:schemeClr val="tx1"/>
+                          </a:solidFill>
+                          <a:latin typeface="Malgun Gothic" pitchFamily="34" charset="0"/>
+                          <a:ea typeface="Malgun Gothic" pitchFamily="34" charset="-122"/>
+                          <a:cs typeface="Malgun Gothic" pitchFamily="34" charset="-120"/>
+                        </a:rPr>
+                        <a:t>입력 해상도 992×800 vs 640×640</a:t>
+                      </a:r>
+                      <a:endParaRPr lang="en-US" sz="1500" dirty="0">
+                        <a:latin typeface="Malgun Gothic" charset="0"/>
+                        <a:ea typeface="Malgun Gothic" charset="0"/>
+                        <a:cs typeface="Malgun Gothic" charset="0"/>
+                      </a:endParaRPr>
+                    </a:p>
+                  </a:txBody>
+                  <a:tcPr marL="91440" marR="91440" marT="45720" marB="45720" anchor="ctr">
+                    <a:lnL w="9525" cap="flat" cmpd="sng" algn="ctr">
+                      <a:solidFill>
+                        <a:srgbClr val="3A3F48"/>
+                      </a:solidFill>
+                      <a:prstDash val="solid"/>
+                      <a:round/>
+                      <a:headEnd type="none" w="med" len="med"/>
+                      <a:tailEnd type="none" w="med" len="med"/>
+                    </a:lnL>
+                    <a:lnR w="9525" cap="flat" cmpd="sng" algn="ctr">
+                      <a:solidFill>
+                        <a:srgbClr val="3A3F48"/>
+                      </a:solidFill>
+                      <a:prstDash val="solid"/>
+                      <a:round/>
+                      <a:headEnd type="none" w="med" len="med"/>
+                      <a:tailEnd type="none" w="med" len="med"/>
+                    </a:lnR>
+                    <a:lnT w="9525" cap="flat" cmpd="sng" algn="ctr">
+                      <a:solidFill>
+                        <a:srgbClr val="3A3F48"/>
+                      </a:solidFill>
+                      <a:prstDash val="solid"/>
+                      <a:round/>
+                      <a:headEnd type="none" w="med" len="med"/>
+                      <a:tailEnd type="none" w="med" len="med"/>
+                    </a:lnT>
+                    <a:lnB w="9525" cap="flat" cmpd="sng" algn="ctr">
+                      <a:solidFill>
+                        <a:srgbClr val="3A3F48"/>
+                      </a:solidFill>
+                      <a:prstDash val="solid"/>
+                      <a:round/>
+                      <a:headEnd type="none" w="med" len="med"/>
+                      <a:tailEnd type="none" w="med" len="med"/>
+                    </a:lnB>
+                    <a:solidFill>
+                      <a:srgbClr val="23272F"/>
+                    </a:solidFill>
+                  </a:tcPr>
+                </a:tc>
+                <a:tc>
+                  <a:txBody>
+                    <a:bodyPr/>
+                    <a:lstStyle/>
+                    <a:p>
+                      <a:pPr algn="ctr" indent="0" marL="0">
+                        <a:buNone/>
+                      </a:pPr>
+                      <a:r>
+                        <a:rPr lang="en-US" sz="1500" b="1" dirty="0">
+                          <a:solidFill>
+                            <a:schemeClr val="accent3"/>
+                          </a:solidFill>
+                          <a:latin typeface="Malgun Gothic" pitchFamily="34" charset="0"/>
+                          <a:ea typeface="Malgun Gothic" pitchFamily="34" charset="-122"/>
+                          <a:cs typeface="Malgun Gothic" pitchFamily="34" charset="-120"/>
+                        </a:rPr>
+                        <a:t>추정</a:t>
                       </a:r>
                       <a:endParaRPr lang="en-US" sz="1500" dirty="0">
                         <a:latin typeface="Malgun Gothic" charset="0"/>
@@ -7920,7 +8194,7 @@
                           <a:ea typeface="Malgun Gothic" pitchFamily="34" charset="-122"/>
                           <a:cs typeface="Malgun Gothic" pitchFamily="34" charset="-120"/>
                         </a:rPr>
-                        <a:t>낙관적인 Geti score</a:t>
+                        <a:t>과대평가 수치 (93%)</a:t>
                       </a:r>
                       <a:endParaRPr lang="en-US" sz="1500" dirty="0">
                         <a:latin typeface="Malgun Gothic" charset="0"/>
@@ -7988,7 +8262,7 @@
                           <a:ea typeface="Malgun Gothic" pitchFamily="34" charset="-122"/>
                           <a:cs typeface="Malgun Gothic" pitchFamily="34" charset="-120"/>
                         </a:rPr>
-                        <a:t>증강본이 학습·테스트에 섞임</a:t>
+                        <a:t>테스트 사진 학습 포함 · 복사본 22장</a:t>
                       </a:r>
                       <a:endParaRPr lang="en-US" sz="1500" dirty="0">
                         <a:latin typeface="Malgun Gothic" charset="0"/>
@@ -8050,287 +8324,13 @@
                       <a:r>
                         <a:rPr lang="en-US" sz="1500" b="1" dirty="0">
                           <a:solidFill>
-                            <a:schemeClr val="accent3"/>
+                            <a:schemeClr val="accent6"/>
                           </a:solidFill>
                           <a:latin typeface="Malgun Gothic" pitchFamily="34" charset="0"/>
                           <a:ea typeface="Malgun Gothic" pitchFamily="34" charset="-122"/>
                           <a:cs typeface="Malgun Gothic" pitchFamily="34" charset="-120"/>
                         </a:rPr>
-                        <a:t>추정</a:t>
-                      </a:r>
-                      <a:endParaRPr lang="en-US" sz="1500" dirty="0">
-                        <a:latin typeface="Malgun Gothic" charset="0"/>
-                        <a:ea typeface="Malgun Gothic" charset="0"/>
-                        <a:cs typeface="Malgun Gothic" charset="0"/>
-                      </a:endParaRPr>
-                    </a:p>
-                  </a:txBody>
-                  <a:tcPr marL="91440" marR="91440" marT="45720" marB="45720" anchor="ctr">
-                    <a:lnL w="9525" cap="flat" cmpd="sng" algn="ctr">
-                      <a:solidFill>
-                        <a:srgbClr val="3A3F48"/>
-                      </a:solidFill>
-                      <a:prstDash val="solid"/>
-                      <a:round/>
-                      <a:headEnd type="none" w="med" len="med"/>
-                      <a:tailEnd type="none" w="med" len="med"/>
-                    </a:lnL>
-                    <a:lnR w="9525" cap="flat" cmpd="sng" algn="ctr">
-                      <a:solidFill>
-                        <a:srgbClr val="3A3F48"/>
-                      </a:solidFill>
-                      <a:prstDash val="solid"/>
-                      <a:round/>
-                      <a:headEnd type="none" w="med" len="med"/>
-                      <a:tailEnd type="none" w="med" len="med"/>
-                    </a:lnR>
-                    <a:lnT w="9525" cap="flat" cmpd="sng" algn="ctr">
-                      <a:solidFill>
-                        <a:srgbClr val="3A3F48"/>
-                      </a:solidFill>
-                      <a:prstDash val="solid"/>
-                      <a:round/>
-                      <a:headEnd type="none" w="med" len="med"/>
-                      <a:tailEnd type="none" w="med" len="med"/>
-                    </a:lnT>
-                    <a:lnB w="9525" cap="flat" cmpd="sng" algn="ctr">
-                      <a:solidFill>
-                        <a:srgbClr val="3A3F48"/>
-                      </a:solidFill>
-                      <a:prstDash val="solid"/>
-                      <a:round/>
-                      <a:headEnd type="none" w="med" len="med"/>
-                      <a:tailEnd type="none" w="med" len="med"/>
-                    </a:lnB>
-                    <a:solidFill>
-                      <a:srgbClr val="23272F"/>
-                    </a:solidFill>
-                  </a:tcPr>
-                </a:tc>
-              </a:tr>
-              <a:tr h="420624">
-                <a:tc>
-                  <a:txBody>
-                    <a:bodyPr/>
-                    <a:lstStyle/>
-                    <a:p>
-                      <a:pPr algn="ctr" indent="0" marL="0">
-                        <a:buNone/>
-                      </a:pPr>
-                      <a:r>
-                        <a:rPr lang="en-US" sz="1500" dirty="0">
-                          <a:solidFill>
-                            <a:schemeClr val="tx2"/>
-                          </a:solidFill>
-                          <a:latin typeface="Malgun Gothic" pitchFamily="34" charset="0"/>
-                          <a:ea typeface="Malgun Gothic" pitchFamily="34" charset="-122"/>
-                          <a:cs typeface="Malgun Gothic" pitchFamily="34" charset="-120"/>
-                        </a:rPr>
-                        <a:t>5</a:t>
-                      </a:r>
-                      <a:endParaRPr lang="en-US" sz="1500" dirty="0">
-                        <a:latin typeface="Malgun Gothic" charset="0"/>
-                        <a:ea typeface="Malgun Gothic" charset="0"/>
-                        <a:cs typeface="Malgun Gothic" charset="0"/>
-                      </a:endParaRPr>
-                    </a:p>
-                  </a:txBody>
-                  <a:tcPr marL="91440" marR="91440" marT="45720" marB="45720" anchor="ctr">
-                    <a:lnL w="9525" cap="flat" cmpd="sng" algn="ctr">
-                      <a:solidFill>
-                        <a:srgbClr val="3A3F48"/>
-                      </a:solidFill>
-                      <a:prstDash val="solid"/>
-                      <a:round/>
-                      <a:headEnd type="none" w="med" len="med"/>
-                      <a:tailEnd type="none" w="med" len="med"/>
-                    </a:lnL>
-                    <a:lnR w="9525" cap="flat" cmpd="sng" algn="ctr">
-                      <a:solidFill>
-                        <a:srgbClr val="3A3F48"/>
-                      </a:solidFill>
-                      <a:prstDash val="solid"/>
-                      <a:round/>
-                      <a:headEnd type="none" w="med" len="med"/>
-                      <a:tailEnd type="none" w="med" len="med"/>
-                    </a:lnR>
-                    <a:lnT w="9525" cap="flat" cmpd="sng" algn="ctr">
-                      <a:solidFill>
-                        <a:srgbClr val="3A3F48"/>
-                      </a:solidFill>
-                      <a:prstDash val="solid"/>
-                      <a:round/>
-                      <a:headEnd type="none" w="med" len="med"/>
-                      <a:tailEnd type="none" w="med" len="med"/>
-                    </a:lnT>
-                    <a:lnB w="9525" cap="flat" cmpd="sng" algn="ctr">
-                      <a:solidFill>
-                        <a:srgbClr val="3A3F48"/>
-                      </a:solidFill>
-                      <a:prstDash val="solid"/>
-                      <a:round/>
-                      <a:headEnd type="none" w="med" len="med"/>
-                      <a:tailEnd type="none" w="med" len="med"/>
-                    </a:lnB>
-                    <a:solidFill>
-                      <a:srgbClr val="23272F"/>
-                    </a:solidFill>
-                  </a:tcPr>
-                </a:tc>
-                <a:tc>
-                  <a:txBody>
-                    <a:bodyPr/>
-                    <a:lstStyle/>
-                    <a:p>
-                      <a:pPr indent="0" marL="0">
-                        <a:buNone/>
-                      </a:pPr>
-                      <a:r>
-                        <a:rPr lang="en-US" sz="1500" b="1" dirty="0">
-                          <a:solidFill>
-                            <a:schemeClr val="tx1"/>
-                          </a:solidFill>
-                          <a:latin typeface="Malgun Gothic" pitchFamily="34" charset="0"/>
-                          <a:ea typeface="Malgun Gothic" pitchFamily="34" charset="-122"/>
-                          <a:cs typeface="Malgun Gothic" pitchFamily="34" charset="-120"/>
-                        </a:rPr>
-                        <a:t>ATSS 최고평가</a:t>
-                      </a:r>
-                      <a:endParaRPr lang="en-US" sz="1500" dirty="0">
-                        <a:latin typeface="Malgun Gothic" charset="0"/>
-                        <a:ea typeface="Malgun Gothic" charset="0"/>
-                        <a:cs typeface="Malgun Gothic" charset="0"/>
-                      </a:endParaRPr>
-                    </a:p>
-                  </a:txBody>
-                  <a:tcPr marL="91440" marR="91440" marT="45720" marB="45720" anchor="ctr">
-                    <a:lnL w="9525" cap="flat" cmpd="sng" algn="ctr">
-                      <a:solidFill>
-                        <a:srgbClr val="3A3F48"/>
-                      </a:solidFill>
-                      <a:prstDash val="solid"/>
-                      <a:round/>
-                      <a:headEnd type="none" w="med" len="med"/>
-                      <a:tailEnd type="none" w="med" len="med"/>
-                    </a:lnL>
-                    <a:lnR w="9525" cap="flat" cmpd="sng" algn="ctr">
-                      <a:solidFill>
-                        <a:srgbClr val="3A3F48"/>
-                      </a:solidFill>
-                      <a:prstDash val="solid"/>
-                      <a:round/>
-                      <a:headEnd type="none" w="med" len="med"/>
-                      <a:tailEnd type="none" w="med" len="med"/>
-                    </a:lnR>
-                    <a:lnT w="9525" cap="flat" cmpd="sng" algn="ctr">
-                      <a:solidFill>
-                        <a:srgbClr val="3A3F48"/>
-                      </a:solidFill>
-                      <a:prstDash val="solid"/>
-                      <a:round/>
-                      <a:headEnd type="none" w="med" len="med"/>
-                      <a:tailEnd type="none" w="med" len="med"/>
-                    </a:lnT>
-                    <a:lnB w="9525" cap="flat" cmpd="sng" algn="ctr">
-                      <a:solidFill>
-                        <a:srgbClr val="3A3F48"/>
-                      </a:solidFill>
-                      <a:prstDash val="solid"/>
-                      <a:round/>
-                      <a:headEnd type="none" w="med" len="med"/>
-                      <a:tailEnd type="none" w="med" len="med"/>
-                    </a:lnB>
-                    <a:solidFill>
-                      <a:srgbClr val="23272F"/>
-                    </a:solidFill>
-                  </a:tcPr>
-                </a:tc>
-                <a:tc>
-                  <a:txBody>
-                    <a:bodyPr/>
-                    <a:lstStyle/>
-                    <a:p>
-                      <a:pPr indent="0" marL="0">
-                        <a:buNone/>
-                      </a:pPr>
-                      <a:r>
-                        <a:rPr lang="en-US" sz="1500" dirty="0">
-                          <a:solidFill>
-                            <a:schemeClr val="tx1"/>
-                          </a:solidFill>
-                          <a:latin typeface="Malgun Gothic" pitchFamily="34" charset="0"/>
-                          <a:ea typeface="Malgun Gothic" pitchFamily="34" charset="-122"/>
-                          <a:cs typeface="Malgun Gothic" pitchFamily="34" charset="-120"/>
-                        </a:rPr>
-                        <a:t>입력 해상도 992×800 vs 640×640</a:t>
-                      </a:r>
-                      <a:endParaRPr lang="en-US" sz="1500" dirty="0">
-                        <a:latin typeface="Malgun Gothic" charset="0"/>
-                        <a:ea typeface="Malgun Gothic" charset="0"/>
-                        <a:cs typeface="Malgun Gothic" charset="0"/>
-                      </a:endParaRPr>
-                    </a:p>
-                  </a:txBody>
-                  <a:tcPr marL="91440" marR="91440" marT="45720" marB="45720" anchor="ctr">
-                    <a:lnL w="9525" cap="flat" cmpd="sng" algn="ctr">
-                      <a:solidFill>
-                        <a:srgbClr val="3A3F48"/>
-                      </a:solidFill>
-                      <a:prstDash val="solid"/>
-                      <a:round/>
-                      <a:headEnd type="none" w="med" len="med"/>
-                      <a:tailEnd type="none" w="med" len="med"/>
-                    </a:lnL>
-                    <a:lnR w="9525" cap="flat" cmpd="sng" algn="ctr">
-                      <a:solidFill>
-                        <a:srgbClr val="3A3F48"/>
-                      </a:solidFill>
-                      <a:prstDash val="solid"/>
-                      <a:round/>
-                      <a:headEnd type="none" w="med" len="med"/>
-                      <a:tailEnd type="none" w="med" len="med"/>
-                    </a:lnR>
-                    <a:lnT w="9525" cap="flat" cmpd="sng" algn="ctr">
-                      <a:solidFill>
-                        <a:srgbClr val="3A3F48"/>
-                      </a:solidFill>
-                      <a:prstDash val="solid"/>
-                      <a:round/>
-                      <a:headEnd type="none" w="med" len="med"/>
-                      <a:tailEnd type="none" w="med" len="med"/>
-                    </a:lnT>
-                    <a:lnB w="9525" cap="flat" cmpd="sng" algn="ctr">
-                      <a:solidFill>
-                        <a:srgbClr val="3A3F48"/>
-                      </a:solidFill>
-                      <a:prstDash val="solid"/>
-                      <a:round/>
-                      <a:headEnd type="none" w="med" len="med"/>
-                      <a:tailEnd type="none" w="med" len="med"/>
-                    </a:lnB>
-                    <a:solidFill>
-                      <a:srgbClr val="23272F"/>
-                    </a:solidFill>
-                  </a:tcPr>
-                </a:tc>
-                <a:tc>
-                  <a:txBody>
-                    <a:bodyPr/>
-                    <a:lstStyle/>
-                    <a:p>
-                      <a:pPr algn="ctr" indent="0" marL="0">
-                        <a:buNone/>
-                      </a:pPr>
-                      <a:r>
-                        <a:rPr lang="en-US" sz="1500" b="1" dirty="0">
-                          <a:solidFill>
-                            <a:schemeClr val="accent3"/>
-                          </a:solidFill>
-                          <a:latin typeface="Malgun Gothic" pitchFamily="34" charset="0"/>
-                          <a:ea typeface="Malgun Gothic" pitchFamily="34" charset="-122"/>
-                          <a:cs typeface="Malgun Gothic" pitchFamily="34" charset="-120"/>
-                        </a:rPr>
-                        <a:t>추정</a:t>
+                        <a:t>확인</a:t>
                       </a:r>
                       <a:endParaRPr lang="en-US" sz="1500" dirty="0">
                         <a:latin typeface="Malgun Gothic" charset="0"/>
@@ -13448,335 +13448,15 @@
                   <a:schemeClr val="tx1"/>
                 </a:solidFill>
               </a:rPr>
-              <a:t>높은 수치, 숨은 함정</a:t>
+              <a:t>작은 모델이 더 맵다 ?</a:t>
             </a:r>
             <a:endParaRPr lang="en-US" sz="3200" dirty="0"/>
           </a:p>
         </p:txBody>
       </p:sp>
-      <p:sp>
-        <p:nvSpPr>
-          <p:cNvPr id="3" name="Text 0"/>
-          <p:cNvSpPr/>
-          <p:nvPr>
-            <p:ph idx="101" type="body" hasCustomPrompt="1"/>
-          </p:nvPr>
-        </p:nvSpPr>
-        <p:spPr>
-          <a:xfrm>
-            <a:off x="548640" y="1005840"/>
-            <a:ext cx="11094415" cy="411480"/>
-          </a:xfrm>
-          <a:prstGeom prst="rect">
-            <a:avLst/>
-          </a:prstGeom>
-          <a:noFill/>
-          <a:ln/>
-        </p:spPr>
-        <p:txBody>
-          <a:bodyPr wrap="square" lIns="0" tIns="0" rIns="0" bIns="0" rtlCol="0" anchor="ctr"/>
-          <a:lstStyle/>
-          <a:p>
-            <a:pPr algn="l" indent="0" marL="0">
-              <a:buNone/>
-            </a:pPr>
-            <a:r>
-              <a:rPr lang="en-US" sz="1500" dirty="0">
-                <a:solidFill>
-                  <a:schemeClr val="tx2"/>
-                </a:solidFill>
-              </a:rPr>
-              <a:t>1차 테스트 93%, but 과적합 학습 데이터</a:t>
-            </a:r>
-            <a:endParaRPr lang="en-US" sz="1500" dirty="0"/>
-          </a:p>
-        </p:txBody>
-      </p:sp>
-      <p:sp>
-        <p:nvSpPr>
-          <p:cNvPr id="4" name="stat-0"/>
-          <p:cNvSpPr/>
-          <p:nvPr/>
-        </p:nvSpPr>
-        <p:spPr>
-          <a:xfrm>
-            <a:off x="548640" y="1600200"/>
-            <a:ext cx="3840480" cy="1371600"/>
-          </a:xfrm>
-          <a:prstGeom prst="roundRect">
-            <a:avLst>
-              <a:gd name="adj" fmla="val 5333"/>
-            </a:avLst>
-          </a:prstGeom>
-          <a:solidFill>
-            <a:schemeClr val="bg2"/>
-          </a:solidFill>
-          <a:ln/>
-        </p:spPr>
-      </p:sp>
-      <p:sp>
-        <p:nvSpPr>
-          <p:cNvPr id="5" name="stat-n-0"/>
-          <p:cNvSpPr txBox="1"/>
-          <p:nvPr/>
-        </p:nvSpPr>
-        <p:spPr>
-          <a:xfrm>
-            <a:off x="822960" y="1737360"/>
-            <a:ext cx="3383280" cy="685800"/>
-          </a:xfrm>
-          <a:prstGeom prst="rect">
-            <a:avLst/>
-          </a:prstGeom>
-          <a:noFill/>
-          <a:ln/>
-        </p:spPr>
-        <p:txBody>
-          <a:bodyPr wrap="square" lIns="0" tIns="0" rIns="0" bIns="0" rtlCol="0" anchor="t"/>
-          <a:lstStyle/>
-          <a:p>
-            <a:pPr indent="0" marL="0">
-              <a:buNone/>
-            </a:pPr>
-            <a:r>
-              <a:rPr lang="en-US" sz="3200" b="1" dirty="0">
-                <a:solidFill>
-                  <a:schemeClr val="accent3"/>
-                </a:solidFill>
-              </a:rPr>
-              <a:t>3,673장</a:t>
-            </a:r>
-            <a:endParaRPr lang="en-US" sz="3200" dirty="0"/>
-          </a:p>
-        </p:txBody>
-      </p:sp>
-      <p:sp>
-        <p:nvSpPr>
-          <p:cNvPr id="6" name="stat-l-0"/>
-          <p:cNvSpPr txBox="1"/>
-          <p:nvPr/>
-        </p:nvSpPr>
-        <p:spPr>
-          <a:xfrm>
-            <a:off x="822960" y="2423160"/>
-            <a:ext cx="3383280" cy="365760"/>
-          </a:xfrm>
-          <a:prstGeom prst="rect">
-            <a:avLst/>
-          </a:prstGeom>
-          <a:noFill/>
-          <a:ln/>
-        </p:spPr>
-        <p:txBody>
-          <a:bodyPr wrap="square" lIns="0" tIns="0" rIns="0" bIns="0" rtlCol="0" anchor="t"/>
-          <a:lstStyle/>
-          <a:p>
-            <a:pPr indent="0" marL="0">
-              <a:buNone/>
-            </a:pPr>
-            <a:r>
-              <a:rPr lang="en-US" sz="1400" dirty="0">
-                <a:solidFill>
-                  <a:schemeClr val="tx2"/>
-                </a:solidFill>
-              </a:rPr>
-              <a:t>테스트 153장 포함 업로드</a:t>
-            </a:r>
-            <a:endParaRPr lang="en-US" sz="1400" dirty="0"/>
-          </a:p>
-        </p:txBody>
-      </p:sp>
-      <p:sp>
-        <p:nvSpPr>
-          <p:cNvPr id="7" name="stat-1"/>
-          <p:cNvSpPr/>
-          <p:nvPr/>
-        </p:nvSpPr>
-        <p:spPr>
-          <a:xfrm>
-            <a:off x="548640" y="3108960"/>
-            <a:ext cx="3840480" cy="1371600"/>
-          </a:xfrm>
-          <a:prstGeom prst="roundRect">
-            <a:avLst>
-              <a:gd name="adj" fmla="val 5333"/>
-            </a:avLst>
-          </a:prstGeom>
-          <a:solidFill>
-            <a:schemeClr val="bg2"/>
-          </a:solidFill>
-          <a:ln/>
-        </p:spPr>
-      </p:sp>
-      <p:sp>
-        <p:nvSpPr>
-          <p:cNvPr id="8" name="stat-n-1"/>
-          <p:cNvSpPr txBox="1"/>
-          <p:nvPr/>
-        </p:nvSpPr>
-        <p:spPr>
-          <a:xfrm>
-            <a:off x="822960" y="3246120"/>
-            <a:ext cx="3383280" cy="685800"/>
-          </a:xfrm>
-          <a:prstGeom prst="rect">
-            <a:avLst/>
-          </a:prstGeom>
-          <a:noFill/>
-          <a:ln/>
-        </p:spPr>
-        <p:txBody>
-          <a:bodyPr wrap="square" lIns="0" tIns="0" rIns="0" bIns="0" rtlCol="0" anchor="t"/>
-          <a:lstStyle/>
-          <a:p>
-            <a:pPr indent="0" marL="0">
-              <a:buNone/>
-            </a:pPr>
-            <a:r>
-              <a:rPr lang="en-US" sz="3200" b="1" dirty="0">
-                <a:solidFill>
-                  <a:schemeClr val="accent3"/>
-                </a:solidFill>
-              </a:rPr>
-              <a:t>22장</a:t>
-            </a:r>
-            <a:endParaRPr lang="en-US" sz="3200" dirty="0"/>
-          </a:p>
-        </p:txBody>
-      </p:sp>
-      <p:sp>
-        <p:nvSpPr>
-          <p:cNvPr id="9" name="stat-l-1"/>
-          <p:cNvSpPr txBox="1"/>
-          <p:nvPr/>
-        </p:nvSpPr>
-        <p:spPr>
-          <a:xfrm>
-            <a:off x="822960" y="3931920"/>
-            <a:ext cx="3383280" cy="365760"/>
-          </a:xfrm>
-          <a:prstGeom prst="rect">
-            <a:avLst/>
-          </a:prstGeom>
-          <a:noFill/>
-          <a:ln/>
-        </p:spPr>
-        <p:txBody>
-          <a:bodyPr wrap="square" lIns="0" tIns="0" rIns="0" bIns="0" rtlCol="0" anchor="t"/>
-          <a:lstStyle/>
-          <a:p>
-            <a:pPr indent="0" marL="0">
-              <a:buNone/>
-            </a:pPr>
-            <a:r>
-              <a:rPr lang="en-US" sz="1400" dirty="0">
-                <a:solidFill>
-                  <a:schemeClr val="tx2"/>
-                </a:solidFill>
-              </a:rPr>
-              <a:t>학습 사진의 복사본</a:t>
-            </a:r>
-            <a:endParaRPr lang="en-US" sz="1400" dirty="0"/>
-          </a:p>
-        </p:txBody>
-      </p:sp>
-      <p:sp>
-        <p:nvSpPr>
-          <p:cNvPr id="10" name="stat-2"/>
-          <p:cNvSpPr/>
-          <p:nvPr/>
-        </p:nvSpPr>
-        <p:spPr>
-          <a:xfrm>
-            <a:off x="548640" y="4617720"/>
-            <a:ext cx="3840480" cy="1371600"/>
-          </a:xfrm>
-          <a:prstGeom prst="roundRect">
-            <a:avLst>
-              <a:gd name="adj" fmla="val 5333"/>
-            </a:avLst>
-          </a:prstGeom>
-          <a:solidFill>
-            <a:schemeClr val="bg2"/>
-          </a:solidFill>
-          <a:ln/>
-        </p:spPr>
-      </p:sp>
-      <p:sp>
-        <p:nvSpPr>
-          <p:cNvPr id="11" name="stat-n-2"/>
-          <p:cNvSpPr txBox="1"/>
-          <p:nvPr/>
-        </p:nvSpPr>
-        <p:spPr>
-          <a:xfrm>
-            <a:off x="822960" y="4754880"/>
-            <a:ext cx="3383280" cy="685800"/>
-          </a:xfrm>
-          <a:prstGeom prst="rect">
-            <a:avLst/>
-          </a:prstGeom>
-          <a:noFill/>
-          <a:ln/>
-        </p:spPr>
-        <p:txBody>
-          <a:bodyPr wrap="square" lIns="0" tIns="0" rIns="0" bIns="0" rtlCol="0" anchor="t"/>
-          <a:lstStyle/>
-          <a:p>
-            <a:pPr indent="0" marL="0">
-              <a:buNone/>
-            </a:pPr>
-            <a:r>
-              <a:rPr lang="en-US" sz="3200" b="1" dirty="0">
-                <a:solidFill>
-                  <a:schemeClr val="accent1"/>
-                </a:solidFill>
-              </a:rPr>
-              <a:t>93.3 → 92.9%</a:t>
-            </a:r>
-            <a:endParaRPr lang="en-US" sz="3200" dirty="0"/>
-          </a:p>
-        </p:txBody>
-      </p:sp>
-      <p:sp>
-        <p:nvSpPr>
-          <p:cNvPr id="12" name="stat-l-2"/>
-          <p:cNvSpPr txBox="1"/>
-          <p:nvPr/>
-        </p:nvSpPr>
-        <p:spPr>
-          <a:xfrm>
-            <a:off x="822960" y="5440680"/>
-            <a:ext cx="3383280" cy="365760"/>
-          </a:xfrm>
-          <a:prstGeom prst="rect">
-            <a:avLst/>
-          </a:prstGeom>
-          <a:noFill/>
-          <a:ln/>
-        </p:spPr>
-        <p:txBody>
-          <a:bodyPr wrap="square" lIns="0" tIns="0" rIns="0" bIns="0" rtlCol="0" anchor="t"/>
-          <a:lstStyle/>
-          <a:p>
-            <a:pPr indent="0" marL="0">
-              <a:buNone/>
-            </a:pPr>
-            <a:r>
-              <a:rPr lang="en-US" sz="1400" dirty="0">
-                <a:solidFill>
-                  <a:schemeClr val="tx2"/>
-                </a:solidFill>
-              </a:rPr>
-              <a:t>복사본 제거 후 mAP@50</a:t>
-            </a:r>
-            <a:endParaRPr lang="en-US" sz="1400" dirty="0"/>
-          </a:p>
-        </p:txBody>
-      </p:sp>
       <p:pic>
         <p:nvPicPr>
-          <p:cNvPr id="13" name="dup-0" descr="C:\Users\user\_se4nchoi\batteryvision\docs\submission\build\img\dup_test.jpg">    </p:cNvPr>
+          <p:cNvPr id="3" name="geti-models" descr="C:\Users\user\_se4nchoi\batteryvision\docs\submission\build\img\geti_models.png">    </p:cNvPr>
           <p:cNvPicPr>
             <a:picLocks noChangeAspect="1"/>
           </p:cNvPicPr>
@@ -13790,8 +13470,8 @@
         </p:blipFill>
         <p:spPr>
           <a:xfrm>
-            <a:off x="4617720" y="1600200"/>
-            <a:ext cx="3429000" cy="3429000"/>
+            <a:off x="548640" y="1600200"/>
+            <a:ext cx="4027729" cy="4343400"/>
           </a:xfrm>
           <a:prstGeom prst="rect">
             <a:avLst/>
@@ -13800,18 +13480,18 @@
       </p:pic>
       <p:sp>
         <p:nvSpPr>
-          <p:cNvPr id="14" name="dup-l-0-bg"/>
+          <p:cNvPr id="4" name="geti-caveat-bg"/>
           <p:cNvSpPr/>
           <p:nvPr/>
         </p:nvSpPr>
         <p:spPr>
           <a:xfrm>
-            <a:off x="4617720" y="5166360"/>
-            <a:ext cx="914400" cy="347472"/>
+            <a:off x="548640" y="6080760"/>
+            <a:ext cx="4027729" cy="384048"/>
           </a:xfrm>
           <a:prstGeom prst="roundRect">
             <a:avLst>
-              <a:gd name="adj" fmla="val 13158"/>
+              <a:gd name="adj" fmla="val 11905"/>
             </a:avLst>
           </a:prstGeom>
           <a:solidFill>
@@ -13829,14 +13509,14 @@
       </p:sp>
       <p:sp>
         <p:nvSpPr>
-          <p:cNvPr id="15" name="dup-l-0"/>
+          <p:cNvPr id="5" name="geti-caveat"/>
           <p:cNvSpPr txBox="1"/>
           <p:nvPr/>
         </p:nvSpPr>
         <p:spPr>
           <a:xfrm>
-            <a:off x="4617720" y="5166360"/>
-            <a:ext cx="914400" cy="347472"/>
+            <a:off x="548640" y="6080760"/>
+            <a:ext cx="4027729" cy="384048"/>
           </a:xfrm>
           <a:prstGeom prst="rect">
             <a:avLst/>
@@ -13857,50 +13537,392 @@
                   <a:schemeClr val="accent3"/>
                 </a:solidFill>
               </a:rPr>
-              <a:t>테스트</a:t>
+              <a:t>낙관적인 Geti 점수 (증강본이 학습·테스트에 섞임)</a:t>
             </a:r>
             <a:endParaRPr lang="en-US" sz="1300" dirty="0"/>
           </a:p>
         </p:txBody>
       </p:sp>
-      <p:pic>
-        <p:nvPicPr>
-          <p:cNvPr id="16" name="dup-1" descr="C:\Users\user\_se4nchoi\batteryvision\docs\submission\build\img\dup_train.jpg">    </p:cNvPr>
-          <p:cNvPicPr>
-            <a:picLocks noChangeAspect="1"/>
-          </p:cNvPicPr>
-          <p:nvPr/>
-        </p:nvPicPr>
-        <p:blipFill>
-          <a:blip r:embed="rId2"/>
-          <a:stretch>
-            <a:fillRect/>
-          </a:stretch>
-        </p:blipFill>
-        <p:spPr>
-          <a:xfrm>
-            <a:off x="8183880" y="1600200"/>
-            <a:ext cx="3429000" cy="3429000"/>
-          </a:xfrm>
-          <a:prstGeom prst="rect">
-            <a:avLst/>
-          </a:prstGeom>
-        </p:spPr>
-      </p:pic>
-      <p:sp>
-        <p:nvSpPr>
-          <p:cNvPr id="17" name="dup-l-1-bg"/>
+      <p:sp>
+        <p:nvSpPr>
+          <p:cNvPr id="6" name="own-h"/>
+          <p:cNvSpPr txBox="1"/>
+          <p:nvPr/>
+        </p:nvSpPr>
+        <p:spPr>
+          <a:xfrm>
+            <a:off x="4896409" y="1600200"/>
+            <a:ext cx="6746646" cy="320040"/>
+          </a:xfrm>
+          <a:prstGeom prst="rect">
+            <a:avLst/>
+          </a:prstGeom>
+          <a:noFill/>
+          <a:ln/>
+        </p:spPr>
+        <p:txBody>
+          <a:bodyPr wrap="square" lIns="0" tIns="0" rIns="0" bIns="0" rtlCol="0" anchor="t"/>
+          <a:lstStyle/>
+          <a:p>
+            <a:pPr indent="0" marL="0">
+              <a:buNone/>
+            </a:pPr>
+            <a:r>
+              <a:rPr lang="en-US" sz="1600" b="1" dirty="0">
+                <a:solidFill>
+                  <a:schemeClr val="tx1"/>
+                </a:solidFill>
+              </a:rPr>
+              <a:t>직접 측정 · 1차 테스트</a:t>
+            </a:r>
+            <a:endParaRPr lang="en-US" sz="1600" dirty="0"/>
+          </a:p>
+        </p:txBody>
+      </p:sp>
+      <p:sp>
+        <p:nvSpPr>
+          <p:cNvPr id="7" name="own-col-0"/>
+          <p:cNvSpPr txBox="1"/>
+          <p:nvPr/>
+        </p:nvSpPr>
+        <p:spPr>
+          <a:xfrm>
+            <a:off x="7411009" y="2011680"/>
+            <a:ext cx="1600200" cy="274320"/>
+          </a:xfrm>
+          <a:prstGeom prst="rect">
+            <a:avLst/>
+          </a:prstGeom>
+          <a:noFill/>
+          <a:ln/>
+        </p:spPr>
+        <p:txBody>
+          <a:bodyPr wrap="square" lIns="0" tIns="0" rIns="0" bIns="0" rtlCol="0" anchor="t"/>
+          <a:lstStyle/>
+          <a:p>
+            <a:pPr algn="r" indent="0" marL="0">
+              <a:buNone/>
+            </a:pPr>
+            <a:r>
+              <a:rPr lang="en-US" sz="1200" dirty="0">
+                <a:solidFill>
+                  <a:schemeClr val="tx2"/>
+                </a:solidFill>
+              </a:rPr>
+              <a:t>mAP@50</a:t>
+            </a:r>
+            <a:endParaRPr lang="en-US" sz="1200" dirty="0"/>
+          </a:p>
+        </p:txBody>
+      </p:sp>
+      <p:sp>
+        <p:nvSpPr>
+          <p:cNvPr id="8" name="own-col-1"/>
+          <p:cNvSpPr txBox="1"/>
+          <p:nvPr/>
+        </p:nvSpPr>
+        <p:spPr>
+          <a:xfrm>
+            <a:off x="9056929" y="2011680"/>
+            <a:ext cx="1097280" cy="274320"/>
+          </a:xfrm>
+          <a:prstGeom prst="rect">
+            <a:avLst/>
+          </a:prstGeom>
+          <a:noFill/>
+          <a:ln/>
+        </p:spPr>
+        <p:txBody>
+          <a:bodyPr wrap="square" lIns="0" tIns="0" rIns="0" bIns="0" rtlCol="0" anchor="t"/>
+          <a:lstStyle/>
+          <a:p>
+            <a:pPr algn="r" indent="0" marL="0">
+              <a:buNone/>
+            </a:pPr>
+            <a:r>
+              <a:rPr lang="en-US" sz="1200" dirty="0">
+                <a:solidFill>
+                  <a:schemeClr val="tx2"/>
+                </a:solidFill>
+              </a:rPr>
+              <a:t>scratch AP</a:t>
+            </a:r>
+            <a:endParaRPr lang="en-US" sz="1200" dirty="0"/>
+          </a:p>
+        </p:txBody>
+      </p:sp>
+      <p:sp>
+        <p:nvSpPr>
+          <p:cNvPr id="9" name="own-col-2"/>
+          <p:cNvSpPr txBox="1"/>
+          <p:nvPr/>
+        </p:nvSpPr>
+        <p:spPr>
+          <a:xfrm>
+            <a:off x="10154209" y="2011680"/>
+            <a:ext cx="1051560" cy="274320"/>
+          </a:xfrm>
+          <a:prstGeom prst="rect">
+            <a:avLst/>
+          </a:prstGeom>
+          <a:noFill/>
+          <a:ln/>
+        </p:spPr>
+        <p:txBody>
+          <a:bodyPr wrap="square" lIns="0" tIns="0" rIns="0" bIns="0" rtlCol="0" anchor="t"/>
+          <a:lstStyle/>
+          <a:p>
+            <a:pPr algn="r" indent="0" marL="0">
+              <a:buNone/>
+            </a:pPr>
+            <a:r>
+              <a:rPr lang="en-US" sz="1200" dirty="0">
+                <a:solidFill>
+                  <a:schemeClr val="tx2"/>
+                </a:solidFill>
+              </a:rPr>
+              <a:t>2차 세트</a:t>
+            </a:r>
+            <a:endParaRPr lang="en-US" sz="1200" dirty="0"/>
+          </a:p>
+        </p:txBody>
+      </p:sp>
+      <p:sp>
+        <p:nvSpPr>
+          <p:cNvPr id="10" name="own-row-0"/>
           <p:cNvSpPr/>
           <p:nvPr/>
         </p:nvSpPr>
         <p:spPr>
           <a:xfrm>
-            <a:off x="8183880" y="5166360"/>
-            <a:ext cx="914400" cy="347472"/>
+            <a:off x="4896409" y="2377440"/>
+            <a:ext cx="6746646" cy="1051560"/>
           </a:xfrm>
           <a:prstGeom prst="roundRect">
             <a:avLst>
-              <a:gd name="adj" fmla="val 13158"/>
+              <a:gd name="adj" fmla="val 6957"/>
+            </a:avLst>
+          </a:prstGeom>
+          <a:solidFill>
+            <a:schemeClr val="bg2"/>
+          </a:solidFill>
+          <a:ln/>
+        </p:spPr>
+      </p:sp>
+      <p:sp>
+        <p:nvSpPr>
+          <p:cNvPr id="11" name="own-dot-0"/>
+          <p:cNvSpPr/>
+          <p:nvPr/>
+        </p:nvSpPr>
+        <p:spPr>
+          <a:xfrm>
+            <a:off x="5125009" y="2606040"/>
+            <a:ext cx="146304" cy="146304"/>
+          </a:xfrm>
+          <a:prstGeom prst="ellipse">
+            <a:avLst/>
+          </a:prstGeom>
+          <a:solidFill>
+            <a:schemeClr val="accent4"/>
+          </a:solidFill>
+          <a:ln/>
+        </p:spPr>
+      </p:sp>
+      <p:sp>
+        <p:nvSpPr>
+          <p:cNvPr id="12" name="own-n-0"/>
+          <p:cNvSpPr txBox="1"/>
+          <p:nvPr/>
+        </p:nvSpPr>
+        <p:spPr>
+          <a:xfrm>
+            <a:off x="5353609" y="2514600"/>
+            <a:ext cx="2103120" cy="320040"/>
+          </a:xfrm>
+          <a:prstGeom prst="rect">
+            <a:avLst/>
+          </a:prstGeom>
+          <a:noFill/>
+          <a:ln/>
+        </p:spPr>
+        <p:txBody>
+          <a:bodyPr wrap="square" lIns="0" tIns="0" rIns="0" bIns="0" rtlCol="0" anchor="t"/>
+          <a:lstStyle/>
+          <a:p>
+            <a:pPr indent="0" marL="0">
+              <a:buNone/>
+            </a:pPr>
+            <a:r>
+              <a:rPr lang="en-US" sz="1500" b="1" dirty="0">
+                <a:solidFill>
+                  <a:schemeClr val="tx1"/>
+                </a:solidFill>
+              </a:rPr>
+              <a:t>ATSS-MobileNetV2</a:t>
+            </a:r>
+            <a:endParaRPr lang="en-US" sz="1500" dirty="0"/>
+          </a:p>
+        </p:txBody>
+      </p:sp>
+      <p:sp>
+        <p:nvSpPr>
+          <p:cNvPr id="13" name="own-s-0"/>
+          <p:cNvSpPr txBox="1"/>
+          <p:nvPr/>
+        </p:nvSpPr>
+        <p:spPr>
+          <a:xfrm>
+            <a:off x="5353609" y="2926080"/>
+            <a:ext cx="2103120" cy="274320"/>
+          </a:xfrm>
+          <a:prstGeom prst="rect">
+            <a:avLst/>
+          </a:prstGeom>
+          <a:noFill/>
+          <a:ln/>
+        </p:spPr>
+        <p:txBody>
+          <a:bodyPr wrap="square" lIns="0" tIns="0" rIns="0" bIns="0" rtlCol="0" anchor="t"/>
+          <a:lstStyle/>
+          <a:p>
+            <a:pPr indent="0" marL="0">
+              <a:buNone/>
+            </a:pPr>
+            <a:r>
+              <a:rPr lang="en-US" sz="1200" dirty="0">
+                <a:solidFill>
+                  <a:schemeClr val="tx2"/>
+                </a:solidFill>
+              </a:rPr>
+              <a:t>3.9M · 20.6 GFLOPs</a:t>
+            </a:r>
+            <a:endParaRPr lang="en-US" sz="1200" dirty="0"/>
+          </a:p>
+        </p:txBody>
+      </p:sp>
+      <p:sp>
+        <p:nvSpPr>
+          <p:cNvPr id="14" name="own-m-0"/>
+          <p:cNvSpPr txBox="1"/>
+          <p:nvPr/>
+        </p:nvSpPr>
+        <p:spPr>
+          <a:xfrm>
+            <a:off x="7411009" y="2487168"/>
+            <a:ext cx="1600200" cy="822960"/>
+          </a:xfrm>
+          <a:prstGeom prst="rect">
+            <a:avLst/>
+          </a:prstGeom>
+          <a:noFill/>
+          <a:ln/>
+        </p:spPr>
+        <p:txBody>
+          <a:bodyPr wrap="square" lIns="0" tIns="0" rIns="0" bIns="0" rtlCol="0" anchor="ctr"/>
+          <a:lstStyle/>
+          <a:p>
+            <a:pPr algn="r" indent="0" marL="0">
+              <a:buNone/>
+            </a:pPr>
+            <a:r>
+              <a:rPr lang="en-US" sz="3400" b="1" dirty="0">
+                <a:solidFill>
+                  <a:schemeClr val="accent4"/>
+                </a:solidFill>
+              </a:rPr>
+              <a:t>92.9%</a:t>
+            </a:r>
+            <a:endParaRPr lang="en-US" sz="3400" dirty="0"/>
+          </a:p>
+        </p:txBody>
+      </p:sp>
+      <p:sp>
+        <p:nvSpPr>
+          <p:cNvPr id="15" name="own-a-0"/>
+          <p:cNvSpPr txBox="1"/>
+          <p:nvPr/>
+        </p:nvSpPr>
+        <p:spPr>
+          <a:xfrm>
+            <a:off x="9056929" y="2487168"/>
+            <a:ext cx="1097280" cy="822960"/>
+          </a:xfrm>
+          <a:prstGeom prst="rect">
+            <a:avLst/>
+          </a:prstGeom>
+          <a:noFill/>
+          <a:ln/>
+        </p:spPr>
+        <p:txBody>
+          <a:bodyPr wrap="square" lIns="0" tIns="0" rIns="0" bIns="0" rtlCol="0" anchor="ctr"/>
+          <a:lstStyle/>
+          <a:p>
+            <a:pPr algn="r" indent="0" marL="0">
+              <a:buNone/>
+            </a:pPr>
+            <a:r>
+              <a:rPr lang="en-US" sz="1800" dirty="0">
+                <a:solidFill>
+                  <a:schemeClr val="tx1"/>
+                </a:solidFill>
+              </a:rPr>
+              <a:t>0.86</a:t>
+            </a:r>
+            <a:endParaRPr lang="en-US" sz="1800" dirty="0"/>
+          </a:p>
+        </p:txBody>
+      </p:sp>
+      <p:sp>
+        <p:nvSpPr>
+          <p:cNvPr id="16" name="own-h2-0"/>
+          <p:cNvSpPr txBox="1"/>
+          <p:nvPr/>
+        </p:nvSpPr>
+        <p:spPr>
+          <a:xfrm>
+            <a:off x="10154209" y="2487168"/>
+            <a:ext cx="1051560" cy="822960"/>
+          </a:xfrm>
+          <a:prstGeom prst="rect">
+            <a:avLst/>
+          </a:prstGeom>
+          <a:noFill/>
+          <a:ln/>
+        </p:spPr>
+        <p:txBody>
+          <a:bodyPr wrap="square" lIns="0" tIns="0" rIns="0" bIns="0" rtlCol="0" anchor="ctr"/>
+          <a:lstStyle/>
+          <a:p>
+            <a:pPr algn="r" indent="0" marL="0">
+              <a:buNone/>
+            </a:pPr>
+            <a:r>
+              <a:rPr lang="en-US" sz="1800" b="1" dirty="0">
+                <a:solidFill>
+                  <a:schemeClr val="accent2"/>
+                </a:solidFill>
+              </a:rPr>
+              <a:t>47%</a:t>
+            </a:r>
+            <a:endParaRPr lang="en-US" sz="1800" dirty="0"/>
+          </a:p>
+        </p:txBody>
+      </p:sp>
+      <p:sp>
+        <p:nvSpPr>
+          <p:cNvPr id="17" name="best-badge-bg"/>
+          <p:cNvSpPr/>
+          <p:nvPr/>
+        </p:nvSpPr>
+        <p:spPr>
+          <a:xfrm>
+            <a:off x="6816649" y="2944368"/>
+            <a:ext cx="502920" cy="237744"/>
+          </a:xfrm>
+          <a:prstGeom prst="roundRect">
+            <a:avLst>
+              <a:gd name="adj" fmla="val 19231"/>
             </a:avLst>
           </a:prstGeom>
           <a:solidFill>
@@ -13918,14 +13940,14 @@
       </p:sp>
       <p:sp>
         <p:nvSpPr>
-          <p:cNvPr id="18" name="dup-l-1"/>
+          <p:cNvPr id="18" name="best-badge"/>
           <p:cNvSpPr txBox="1"/>
           <p:nvPr/>
         </p:nvSpPr>
         <p:spPr>
           <a:xfrm>
-            <a:off x="8183880" y="5166360"/>
-            <a:ext cx="914400" cy="347472"/>
+            <a:off x="6816649" y="2944368"/>
+            <a:ext cx="502920" cy="237744"/>
           </a:xfrm>
           <a:prstGeom prst="rect">
             <a:avLst/>
@@ -13946,7 +13968,7 @@
                   <a:schemeClr val="accent1"/>
                 </a:solidFill>
               </a:rPr>
-              <a:t>학습</a:t>
+              <a:t>best</a:t>
             </a:r>
             <a:endParaRPr lang="en-US" sz="1300" dirty="0"/>
           </a:p>
@@ -13954,14 +13976,56 @@
       </p:sp>
       <p:sp>
         <p:nvSpPr>
-          <p:cNvPr id="19" name="dup-cap"/>
+          <p:cNvPr id="19" name="own-row-1"/>
+          <p:cNvSpPr/>
+          <p:nvPr/>
+        </p:nvSpPr>
+        <p:spPr>
+          <a:xfrm>
+            <a:off x="4896409" y="3566160"/>
+            <a:ext cx="6746646" cy="1051560"/>
+          </a:xfrm>
+          <a:prstGeom prst="roundRect">
+            <a:avLst>
+              <a:gd name="adj" fmla="val 6957"/>
+            </a:avLst>
+          </a:prstGeom>
+          <a:solidFill>
+            <a:schemeClr val="bg2"/>
+          </a:solidFill>
+          <a:ln/>
+        </p:spPr>
+      </p:sp>
+      <p:sp>
+        <p:nvSpPr>
+          <p:cNvPr id="20" name="own-dot-1"/>
+          <p:cNvSpPr/>
+          <p:nvPr/>
+        </p:nvSpPr>
+        <p:spPr>
+          <a:xfrm>
+            <a:off x="5125009" y="3794760"/>
+            <a:ext cx="146304" cy="146304"/>
+          </a:xfrm>
+          <a:prstGeom prst="ellipse">
+            <a:avLst/>
+          </a:prstGeom>
+          <a:solidFill>
+            <a:schemeClr val="accent5"/>
+          </a:solidFill>
+          <a:ln/>
+        </p:spPr>
+      </p:sp>
+      <p:sp>
+        <p:nvSpPr>
+          <p:cNvPr id="21" name="own-n-1"/>
           <p:cNvSpPr txBox="1"/>
           <p:nvPr/>
         </p:nvSpPr>
         <p:spPr>
           <a:xfrm>
-            <a:off x="9144000" y="5166360"/>
-            <a:ext cx="2468880" cy="347472"/>
+            <a:off x="5353609" y="3703320"/>
+            <a:ext cx="2103120" cy="320040"/>
           </a:xfrm>
           <a:prstGeom prst="rect">
             <a:avLst/>
@@ -13970,10 +14034,46 @@
           <a:ln/>
         </p:spPr>
         <p:txBody>
-          <a:bodyPr wrap="square" lIns="0" tIns="0" rIns="0" bIns="0" rtlCol="0" anchor="ctr"/>
+          <a:bodyPr wrap="square" lIns="0" tIns="0" rIns="0" bIns="0" rtlCol="0" anchor="t"/>
           <a:lstStyle/>
           <a:p>
-            <a:pPr algn="r" indent="0" marL="0">
+            <a:pPr indent="0" marL="0">
+              <a:buNone/>
+            </a:pPr>
+            <a:r>
+              <a:rPr lang="en-US" sz="1500" b="1" dirty="0">
+                <a:solidFill>
+                  <a:schemeClr val="tx1"/>
+                </a:solidFill>
+              </a:rPr>
+              <a:t>YOLOX-S</a:t>
+            </a:r>
+            <a:endParaRPr lang="en-US" sz="1500" dirty="0"/>
+          </a:p>
+        </p:txBody>
+      </p:sp>
+      <p:sp>
+        <p:nvSpPr>
+          <p:cNvPr id="22" name="own-s-1"/>
+          <p:cNvSpPr txBox="1"/>
+          <p:nvPr/>
+        </p:nvSpPr>
+        <p:spPr>
+          <a:xfrm>
+            <a:off x="5353609" y="4114800"/>
+            <a:ext cx="2103120" cy="274320"/>
+          </a:xfrm>
+          <a:prstGeom prst="rect">
+            <a:avLst/>
+          </a:prstGeom>
+          <a:noFill/>
+          <a:ln/>
+        </p:spPr>
+        <p:txBody>
+          <a:bodyPr wrap="square" lIns="0" tIns="0" rIns="0" bIns="0" rtlCol="0" anchor="t"/>
+          <a:lstStyle/>
+          <a:p>
+            <a:pPr indent="0" marL="0">
               <a:buNone/>
             </a:pPr>
             <a:r>
@@ -13982,9 +14082,404 @@
                   <a:schemeClr val="tx2"/>
                 </a:solidFill>
               </a:rPr>
-              <a:t>dHash 거리 4 / 256</a:t>
+              <a:t>9M · 26.8 GFLOPs</a:t>
             </a:r>
             <a:endParaRPr lang="en-US" sz="1200" dirty="0"/>
+          </a:p>
+        </p:txBody>
+      </p:sp>
+      <p:sp>
+        <p:nvSpPr>
+          <p:cNvPr id="23" name="own-m-1"/>
+          <p:cNvSpPr txBox="1"/>
+          <p:nvPr/>
+        </p:nvSpPr>
+        <p:spPr>
+          <a:xfrm>
+            <a:off x="7411009" y="3675888"/>
+            <a:ext cx="1600200" cy="822960"/>
+          </a:xfrm>
+          <a:prstGeom prst="rect">
+            <a:avLst/>
+          </a:prstGeom>
+          <a:noFill/>
+          <a:ln/>
+        </p:spPr>
+        <p:txBody>
+          <a:bodyPr wrap="square" lIns="0" tIns="0" rIns="0" bIns="0" rtlCol="0" anchor="ctr"/>
+          <a:lstStyle/>
+          <a:p>
+            <a:pPr algn="r" indent="0" marL="0">
+              <a:buNone/>
+            </a:pPr>
+            <a:r>
+              <a:rPr lang="en-US" sz="3400" b="1" dirty="0">
+                <a:solidFill>
+                  <a:schemeClr val="accent5"/>
+                </a:solidFill>
+              </a:rPr>
+              <a:t>89.2%</a:t>
+            </a:r>
+            <a:endParaRPr lang="en-US" sz="3400" dirty="0"/>
+          </a:p>
+        </p:txBody>
+      </p:sp>
+      <p:sp>
+        <p:nvSpPr>
+          <p:cNvPr id="24" name="own-a-1"/>
+          <p:cNvSpPr txBox="1"/>
+          <p:nvPr/>
+        </p:nvSpPr>
+        <p:spPr>
+          <a:xfrm>
+            <a:off x="9056929" y="3675888"/>
+            <a:ext cx="1097280" cy="822960"/>
+          </a:xfrm>
+          <a:prstGeom prst="rect">
+            <a:avLst/>
+          </a:prstGeom>
+          <a:noFill/>
+          <a:ln/>
+        </p:spPr>
+        <p:txBody>
+          <a:bodyPr wrap="square" lIns="0" tIns="0" rIns="0" bIns="0" rtlCol="0" anchor="ctr"/>
+          <a:lstStyle/>
+          <a:p>
+            <a:pPr algn="r" indent="0" marL="0">
+              <a:buNone/>
+            </a:pPr>
+            <a:r>
+              <a:rPr lang="en-US" sz="1800" dirty="0">
+                <a:solidFill>
+                  <a:schemeClr val="tx1"/>
+                </a:solidFill>
+              </a:rPr>
+              <a:t>0.78</a:t>
+            </a:r>
+            <a:endParaRPr lang="en-US" sz="1800" dirty="0"/>
+          </a:p>
+        </p:txBody>
+      </p:sp>
+      <p:sp>
+        <p:nvSpPr>
+          <p:cNvPr id="25" name="own-h2-1"/>
+          <p:cNvSpPr txBox="1"/>
+          <p:nvPr/>
+        </p:nvSpPr>
+        <p:spPr>
+          <a:xfrm>
+            <a:off x="10154209" y="3675888"/>
+            <a:ext cx="1051560" cy="822960"/>
+          </a:xfrm>
+          <a:prstGeom prst="rect">
+            <a:avLst/>
+          </a:prstGeom>
+          <a:noFill/>
+          <a:ln/>
+        </p:spPr>
+        <p:txBody>
+          <a:bodyPr wrap="square" lIns="0" tIns="0" rIns="0" bIns="0" rtlCol="0" anchor="ctr"/>
+          <a:lstStyle/>
+          <a:p>
+            <a:pPr algn="r" indent="0" marL="0">
+              <a:buNone/>
+            </a:pPr>
+            <a:r>
+              <a:rPr lang="en-US" sz="1800" b="1" dirty="0">
+                <a:solidFill>
+                  <a:schemeClr val="accent2"/>
+                </a:solidFill>
+              </a:rPr>
+              <a:t>3%</a:t>
+            </a:r>
+            <a:endParaRPr lang="en-US" sz="1800" dirty="0"/>
+          </a:p>
+        </p:txBody>
+      </p:sp>
+      <p:sp>
+        <p:nvSpPr>
+          <p:cNvPr id="26" name="own-row-2"/>
+          <p:cNvSpPr/>
+          <p:nvPr/>
+        </p:nvSpPr>
+        <p:spPr>
+          <a:xfrm>
+            <a:off x="4896409" y="4754880"/>
+            <a:ext cx="6746646" cy="1051560"/>
+          </a:xfrm>
+          <a:prstGeom prst="roundRect">
+            <a:avLst>
+              <a:gd name="adj" fmla="val 6957"/>
+            </a:avLst>
+          </a:prstGeom>
+          <a:solidFill>
+            <a:schemeClr val="bg2"/>
+          </a:solidFill>
+          <a:ln/>
+        </p:spPr>
+      </p:sp>
+      <p:sp>
+        <p:nvSpPr>
+          <p:cNvPr id="27" name="own-dot-2"/>
+          <p:cNvSpPr/>
+          <p:nvPr/>
+        </p:nvSpPr>
+        <p:spPr>
+          <a:xfrm>
+            <a:off x="5125009" y="4983480"/>
+            <a:ext cx="146304" cy="146304"/>
+          </a:xfrm>
+          <a:prstGeom prst="ellipse">
+            <a:avLst/>
+          </a:prstGeom>
+          <a:solidFill>
+            <a:schemeClr val="accent6"/>
+          </a:solidFill>
+          <a:ln/>
+        </p:spPr>
+      </p:sp>
+      <p:sp>
+        <p:nvSpPr>
+          <p:cNvPr id="28" name="own-n-2"/>
+          <p:cNvSpPr txBox="1"/>
+          <p:nvPr/>
+        </p:nvSpPr>
+        <p:spPr>
+          <a:xfrm>
+            <a:off x="5353609" y="4892040"/>
+            <a:ext cx="2103120" cy="320040"/>
+          </a:xfrm>
+          <a:prstGeom prst="rect">
+            <a:avLst/>
+          </a:prstGeom>
+          <a:noFill/>
+          <a:ln/>
+        </p:spPr>
+        <p:txBody>
+          <a:bodyPr wrap="square" lIns="0" tIns="0" rIns="0" bIns="0" rtlCol="0" anchor="t"/>
+          <a:lstStyle/>
+          <a:p>
+            <a:pPr indent="0" marL="0">
+              <a:buNone/>
+            </a:pPr>
+            <a:r>
+              <a:rPr lang="en-US" sz="1500" b="1" dirty="0">
+                <a:solidFill>
+                  <a:schemeClr val="tx1"/>
+                </a:solidFill>
+              </a:rPr>
+              <a:t>YOLOX-Tiny</a:t>
+            </a:r>
+            <a:endParaRPr lang="en-US" sz="1500" dirty="0"/>
+          </a:p>
+        </p:txBody>
+      </p:sp>
+      <p:sp>
+        <p:nvSpPr>
+          <p:cNvPr id="29" name="own-s-2"/>
+          <p:cNvSpPr txBox="1"/>
+          <p:nvPr/>
+        </p:nvSpPr>
+        <p:spPr>
+          <a:xfrm>
+            <a:off x="5353609" y="5303520"/>
+            <a:ext cx="2103120" cy="274320"/>
+          </a:xfrm>
+          <a:prstGeom prst="rect">
+            <a:avLst/>
+          </a:prstGeom>
+          <a:noFill/>
+          <a:ln/>
+        </p:spPr>
+        <p:txBody>
+          <a:bodyPr wrap="square" lIns="0" tIns="0" rIns="0" bIns="0" rtlCol="0" anchor="t"/>
+          <a:lstStyle/>
+          <a:p>
+            <a:pPr indent="0" marL="0">
+              <a:buNone/>
+            </a:pPr>
+            <a:r>
+              <a:rPr lang="en-US" sz="1200" dirty="0">
+                <a:solidFill>
+                  <a:schemeClr val="tx2"/>
+                </a:solidFill>
+              </a:rPr>
+              <a:t>5.06M · 6.45 GFLOPs</a:t>
+            </a:r>
+            <a:endParaRPr lang="en-US" sz="1200" dirty="0"/>
+          </a:p>
+        </p:txBody>
+      </p:sp>
+      <p:sp>
+        <p:nvSpPr>
+          <p:cNvPr id="30" name="own-m-2"/>
+          <p:cNvSpPr txBox="1"/>
+          <p:nvPr/>
+        </p:nvSpPr>
+        <p:spPr>
+          <a:xfrm>
+            <a:off x="7411009" y="4864608"/>
+            <a:ext cx="1600200" cy="822960"/>
+          </a:xfrm>
+          <a:prstGeom prst="rect">
+            <a:avLst/>
+          </a:prstGeom>
+          <a:noFill/>
+          <a:ln/>
+        </p:spPr>
+        <p:txBody>
+          <a:bodyPr wrap="square" lIns="0" tIns="0" rIns="0" bIns="0" rtlCol="0" anchor="ctr"/>
+          <a:lstStyle/>
+          <a:p>
+            <a:pPr algn="r" indent="0" marL="0">
+              <a:buNone/>
+            </a:pPr>
+            <a:r>
+              <a:rPr lang="en-US" sz="3400" b="1" dirty="0">
+                <a:solidFill>
+                  <a:schemeClr val="accent6"/>
+                </a:solidFill>
+              </a:rPr>
+              <a:t>83.2%</a:t>
+            </a:r>
+            <a:endParaRPr lang="en-US" sz="3400" dirty="0"/>
+          </a:p>
+        </p:txBody>
+      </p:sp>
+      <p:sp>
+        <p:nvSpPr>
+          <p:cNvPr id="31" name="own-a-2"/>
+          <p:cNvSpPr txBox="1"/>
+          <p:nvPr/>
+        </p:nvSpPr>
+        <p:spPr>
+          <a:xfrm>
+            <a:off x="9056929" y="4864608"/>
+            <a:ext cx="1097280" cy="822960"/>
+          </a:xfrm>
+          <a:prstGeom prst="rect">
+            <a:avLst/>
+          </a:prstGeom>
+          <a:noFill/>
+          <a:ln/>
+        </p:spPr>
+        <p:txBody>
+          <a:bodyPr wrap="square" lIns="0" tIns="0" rIns="0" bIns="0" rtlCol="0" anchor="ctr"/>
+          <a:lstStyle/>
+          <a:p>
+            <a:pPr algn="r" indent="0" marL="0">
+              <a:buNone/>
+            </a:pPr>
+            <a:r>
+              <a:rPr lang="en-US" sz="1800" dirty="0">
+                <a:solidFill>
+                  <a:schemeClr val="tx1"/>
+                </a:solidFill>
+              </a:rPr>
+              <a:t>0.66</a:t>
+            </a:r>
+            <a:endParaRPr lang="en-US" sz="1800" dirty="0"/>
+          </a:p>
+        </p:txBody>
+      </p:sp>
+      <p:sp>
+        <p:nvSpPr>
+          <p:cNvPr id="32" name="own-h2-2"/>
+          <p:cNvSpPr txBox="1"/>
+          <p:nvPr/>
+        </p:nvSpPr>
+        <p:spPr>
+          <a:xfrm>
+            <a:off x="10154209" y="4864608"/>
+            <a:ext cx="1051560" cy="822960"/>
+          </a:xfrm>
+          <a:prstGeom prst="rect">
+            <a:avLst/>
+          </a:prstGeom>
+          <a:noFill/>
+          <a:ln/>
+        </p:spPr>
+        <p:txBody>
+          <a:bodyPr wrap="square" lIns="0" tIns="0" rIns="0" bIns="0" rtlCol="0" anchor="ctr"/>
+          <a:lstStyle/>
+          <a:p>
+            <a:pPr algn="r" indent="0" marL="0">
+              <a:buNone/>
+            </a:pPr>
+            <a:r>
+              <a:rPr lang="en-US" sz="1800" b="1" dirty="0">
+                <a:solidFill>
+                  <a:schemeClr val="accent2"/>
+                </a:solidFill>
+              </a:rPr>
+              <a:t>47%</a:t>
+            </a:r>
+            <a:endParaRPr lang="en-US" sz="1800" dirty="0"/>
+          </a:p>
+        </p:txBody>
+      </p:sp>
+      <p:sp>
+        <p:nvSpPr>
+          <p:cNvPr id="33" name="own-note-bg"/>
+          <p:cNvSpPr/>
+          <p:nvPr/>
+        </p:nvSpPr>
+        <p:spPr>
+          <a:xfrm>
+            <a:off x="4896409" y="5943600"/>
+            <a:ext cx="6746646" cy="384048"/>
+          </a:xfrm>
+          <a:prstGeom prst="roundRect">
+            <a:avLst>
+              <a:gd name="adj" fmla="val 11905"/>
+            </a:avLst>
+          </a:prstGeom>
+          <a:solidFill>
+            <a:schemeClr val="accent1">
+              <a:alpha val="20000"/>
+            </a:schemeClr>
+          </a:solidFill>
+          <a:ln w="12700">
+            <a:solidFill>
+              <a:schemeClr val="accent1"/>
+            </a:solidFill>
+            <a:prstDash val="solid"/>
+          </a:ln>
+        </p:spPr>
+      </p:sp>
+      <p:sp>
+        <p:nvSpPr>
+          <p:cNvPr id="34" name="own-note"/>
+          <p:cNvSpPr txBox="1"/>
+          <p:nvPr/>
+        </p:nvSpPr>
+        <p:spPr>
+          <a:xfrm>
+            <a:off x="4896409" y="5943600"/>
+            <a:ext cx="6746646" cy="384048"/>
+          </a:xfrm>
+          <a:prstGeom prst="rect">
+            <a:avLst/>
+          </a:prstGeom>
+          <a:noFill/>
+          <a:ln/>
+        </p:spPr>
+        <p:txBody>
+          <a:bodyPr wrap="square" lIns="0" tIns="0" rIns="0" bIns="0" rtlCol="0" anchor="ctr"/>
+          <a:lstStyle/>
+          <a:p>
+            <a:pPr algn="ctr" indent="0" marL="0">
+              <a:buNone/>
+            </a:pPr>
+            <a:r>
+              <a:rPr lang="en-US" sz="1300" b="1" dirty="0">
+                <a:solidFill>
+                  <a:schemeClr val="accent1"/>
+                </a:solidFill>
+              </a:rPr>
+              <a:t>32px 미만 박스 AP: ATSS 0.86 · YOLOX-S 0.80</a:t>
+            </a:r>
+            <a:endParaRPr lang="en-US" sz="1300" dirty="0"/>
           </a:p>
         </p:txBody>
       </p:sp>
@@ -14090,15 +14585,335 @@
                   <a:schemeClr val="tx1"/>
                 </a:solidFill>
               </a:rPr>
-              <a:t>작은 모델이 더 맵다 ?</a:t>
+              <a:t>높은 수치, 숨은 함정</a:t>
             </a:r>
             <a:endParaRPr lang="en-US" sz="3200" dirty="0"/>
           </a:p>
         </p:txBody>
       </p:sp>
+      <p:sp>
+        <p:nvSpPr>
+          <p:cNvPr id="3" name="Text 0"/>
+          <p:cNvSpPr/>
+          <p:nvPr>
+            <p:ph idx="101" type="body" hasCustomPrompt="1"/>
+          </p:nvPr>
+        </p:nvSpPr>
+        <p:spPr>
+          <a:xfrm>
+            <a:off x="548640" y="1005840"/>
+            <a:ext cx="11094415" cy="411480"/>
+          </a:xfrm>
+          <a:prstGeom prst="rect">
+            <a:avLst/>
+          </a:prstGeom>
+          <a:noFill/>
+          <a:ln/>
+        </p:spPr>
+        <p:txBody>
+          <a:bodyPr wrap="square" lIns="0" tIns="0" rIns="0" bIns="0" rtlCol="0" anchor="ctr"/>
+          <a:lstStyle/>
+          <a:p>
+            <a:pPr algn="l" indent="0" marL="0">
+              <a:buNone/>
+            </a:pPr>
+            <a:r>
+              <a:rPr lang="en-US" sz="1500" dirty="0">
+                <a:solidFill>
+                  <a:schemeClr val="tx2"/>
+                </a:solidFill>
+              </a:rPr>
+              <a:t>1차 테스트 93%, but 과적합 학습 데이터</a:t>
+            </a:r>
+            <a:endParaRPr lang="en-US" sz="1500" dirty="0"/>
+          </a:p>
+        </p:txBody>
+      </p:sp>
+      <p:sp>
+        <p:nvSpPr>
+          <p:cNvPr id="4" name="stat-0"/>
+          <p:cNvSpPr/>
+          <p:nvPr/>
+        </p:nvSpPr>
+        <p:spPr>
+          <a:xfrm>
+            <a:off x="548640" y="1600200"/>
+            <a:ext cx="3840480" cy="1371600"/>
+          </a:xfrm>
+          <a:prstGeom prst="roundRect">
+            <a:avLst>
+              <a:gd name="adj" fmla="val 5333"/>
+            </a:avLst>
+          </a:prstGeom>
+          <a:solidFill>
+            <a:schemeClr val="bg2"/>
+          </a:solidFill>
+          <a:ln/>
+        </p:spPr>
+      </p:sp>
+      <p:sp>
+        <p:nvSpPr>
+          <p:cNvPr id="5" name="stat-n-0"/>
+          <p:cNvSpPr txBox="1"/>
+          <p:nvPr/>
+        </p:nvSpPr>
+        <p:spPr>
+          <a:xfrm>
+            <a:off x="822960" y="1737360"/>
+            <a:ext cx="3383280" cy="685800"/>
+          </a:xfrm>
+          <a:prstGeom prst="rect">
+            <a:avLst/>
+          </a:prstGeom>
+          <a:noFill/>
+          <a:ln/>
+        </p:spPr>
+        <p:txBody>
+          <a:bodyPr wrap="square" lIns="0" tIns="0" rIns="0" bIns="0" rtlCol="0" anchor="t"/>
+          <a:lstStyle/>
+          <a:p>
+            <a:pPr indent="0" marL="0">
+              <a:buNone/>
+            </a:pPr>
+            <a:r>
+              <a:rPr lang="en-US" sz="3200" b="1" dirty="0">
+                <a:solidFill>
+                  <a:schemeClr val="accent3"/>
+                </a:solidFill>
+              </a:rPr>
+              <a:t>3,673장</a:t>
+            </a:r>
+            <a:endParaRPr lang="en-US" sz="3200" dirty="0"/>
+          </a:p>
+        </p:txBody>
+      </p:sp>
+      <p:sp>
+        <p:nvSpPr>
+          <p:cNvPr id="6" name="stat-l-0"/>
+          <p:cNvSpPr txBox="1"/>
+          <p:nvPr/>
+        </p:nvSpPr>
+        <p:spPr>
+          <a:xfrm>
+            <a:off x="822960" y="2423160"/>
+            <a:ext cx="3383280" cy="365760"/>
+          </a:xfrm>
+          <a:prstGeom prst="rect">
+            <a:avLst/>
+          </a:prstGeom>
+          <a:noFill/>
+          <a:ln/>
+        </p:spPr>
+        <p:txBody>
+          <a:bodyPr wrap="square" lIns="0" tIns="0" rIns="0" bIns="0" rtlCol="0" anchor="t"/>
+          <a:lstStyle/>
+          <a:p>
+            <a:pPr indent="0" marL="0">
+              <a:buNone/>
+            </a:pPr>
+            <a:r>
+              <a:rPr lang="en-US" sz="1400" dirty="0">
+                <a:solidFill>
+                  <a:schemeClr val="tx2"/>
+                </a:solidFill>
+              </a:rPr>
+              <a:t>테스트 153장 포함 업로드</a:t>
+            </a:r>
+            <a:endParaRPr lang="en-US" sz="1400" dirty="0"/>
+          </a:p>
+        </p:txBody>
+      </p:sp>
+      <p:sp>
+        <p:nvSpPr>
+          <p:cNvPr id="7" name="stat-1"/>
+          <p:cNvSpPr/>
+          <p:nvPr/>
+        </p:nvSpPr>
+        <p:spPr>
+          <a:xfrm>
+            <a:off x="548640" y="3108960"/>
+            <a:ext cx="3840480" cy="1371600"/>
+          </a:xfrm>
+          <a:prstGeom prst="roundRect">
+            <a:avLst>
+              <a:gd name="adj" fmla="val 5333"/>
+            </a:avLst>
+          </a:prstGeom>
+          <a:solidFill>
+            <a:schemeClr val="bg2"/>
+          </a:solidFill>
+          <a:ln/>
+        </p:spPr>
+      </p:sp>
+      <p:sp>
+        <p:nvSpPr>
+          <p:cNvPr id="8" name="stat-n-1"/>
+          <p:cNvSpPr txBox="1"/>
+          <p:nvPr/>
+        </p:nvSpPr>
+        <p:spPr>
+          <a:xfrm>
+            <a:off x="822960" y="3246120"/>
+            <a:ext cx="3383280" cy="685800"/>
+          </a:xfrm>
+          <a:prstGeom prst="rect">
+            <a:avLst/>
+          </a:prstGeom>
+          <a:noFill/>
+          <a:ln/>
+        </p:spPr>
+        <p:txBody>
+          <a:bodyPr wrap="square" lIns="0" tIns="0" rIns="0" bIns="0" rtlCol="0" anchor="t"/>
+          <a:lstStyle/>
+          <a:p>
+            <a:pPr indent="0" marL="0">
+              <a:buNone/>
+            </a:pPr>
+            <a:r>
+              <a:rPr lang="en-US" sz="3200" b="1" dirty="0">
+                <a:solidFill>
+                  <a:schemeClr val="accent3"/>
+                </a:solidFill>
+              </a:rPr>
+              <a:t>22장</a:t>
+            </a:r>
+            <a:endParaRPr lang="en-US" sz="3200" dirty="0"/>
+          </a:p>
+        </p:txBody>
+      </p:sp>
+      <p:sp>
+        <p:nvSpPr>
+          <p:cNvPr id="9" name="stat-l-1"/>
+          <p:cNvSpPr txBox="1"/>
+          <p:nvPr/>
+        </p:nvSpPr>
+        <p:spPr>
+          <a:xfrm>
+            <a:off x="822960" y="3931920"/>
+            <a:ext cx="3383280" cy="365760"/>
+          </a:xfrm>
+          <a:prstGeom prst="rect">
+            <a:avLst/>
+          </a:prstGeom>
+          <a:noFill/>
+          <a:ln/>
+        </p:spPr>
+        <p:txBody>
+          <a:bodyPr wrap="square" lIns="0" tIns="0" rIns="0" bIns="0" rtlCol="0" anchor="t"/>
+          <a:lstStyle/>
+          <a:p>
+            <a:pPr indent="0" marL="0">
+              <a:buNone/>
+            </a:pPr>
+            <a:r>
+              <a:rPr lang="en-US" sz="1400" dirty="0">
+                <a:solidFill>
+                  <a:schemeClr val="tx2"/>
+                </a:solidFill>
+              </a:rPr>
+              <a:t>학습 사진의 복사본</a:t>
+            </a:r>
+            <a:endParaRPr lang="en-US" sz="1400" dirty="0"/>
+          </a:p>
+        </p:txBody>
+      </p:sp>
+      <p:sp>
+        <p:nvSpPr>
+          <p:cNvPr id="10" name="stat-2"/>
+          <p:cNvSpPr/>
+          <p:nvPr/>
+        </p:nvSpPr>
+        <p:spPr>
+          <a:xfrm>
+            <a:off x="548640" y="4617720"/>
+            <a:ext cx="3840480" cy="1371600"/>
+          </a:xfrm>
+          <a:prstGeom prst="roundRect">
+            <a:avLst>
+              <a:gd name="adj" fmla="val 5333"/>
+            </a:avLst>
+          </a:prstGeom>
+          <a:solidFill>
+            <a:schemeClr val="bg2"/>
+          </a:solidFill>
+          <a:ln/>
+        </p:spPr>
+      </p:sp>
+      <p:sp>
+        <p:nvSpPr>
+          <p:cNvPr id="11" name="stat-n-2"/>
+          <p:cNvSpPr txBox="1"/>
+          <p:nvPr/>
+        </p:nvSpPr>
+        <p:spPr>
+          <a:xfrm>
+            <a:off x="822960" y="4754880"/>
+            <a:ext cx="3383280" cy="685800"/>
+          </a:xfrm>
+          <a:prstGeom prst="rect">
+            <a:avLst/>
+          </a:prstGeom>
+          <a:noFill/>
+          <a:ln/>
+        </p:spPr>
+        <p:txBody>
+          <a:bodyPr wrap="square" lIns="0" tIns="0" rIns="0" bIns="0" rtlCol="0" anchor="t"/>
+          <a:lstStyle/>
+          <a:p>
+            <a:pPr indent="0" marL="0">
+              <a:buNone/>
+            </a:pPr>
+            <a:r>
+              <a:rPr lang="en-US" sz="3200" b="1" dirty="0">
+                <a:solidFill>
+                  <a:schemeClr val="accent1"/>
+                </a:solidFill>
+              </a:rPr>
+              <a:t>93.3 → 92.9%</a:t>
+            </a:r>
+            <a:endParaRPr lang="en-US" sz="3200" dirty="0"/>
+          </a:p>
+        </p:txBody>
+      </p:sp>
+      <p:sp>
+        <p:nvSpPr>
+          <p:cNvPr id="12" name="stat-l-2"/>
+          <p:cNvSpPr txBox="1"/>
+          <p:nvPr/>
+        </p:nvSpPr>
+        <p:spPr>
+          <a:xfrm>
+            <a:off x="822960" y="5440680"/>
+            <a:ext cx="3383280" cy="365760"/>
+          </a:xfrm>
+          <a:prstGeom prst="rect">
+            <a:avLst/>
+          </a:prstGeom>
+          <a:noFill/>
+          <a:ln/>
+        </p:spPr>
+        <p:txBody>
+          <a:bodyPr wrap="square" lIns="0" tIns="0" rIns="0" bIns="0" rtlCol="0" anchor="t"/>
+          <a:lstStyle/>
+          <a:p>
+            <a:pPr indent="0" marL="0">
+              <a:buNone/>
+            </a:pPr>
+            <a:r>
+              <a:rPr lang="en-US" sz="1400" dirty="0">
+                <a:solidFill>
+                  <a:schemeClr val="tx2"/>
+                </a:solidFill>
+              </a:rPr>
+              <a:t>복사본 제거 후 mAP@50</a:t>
+            </a:r>
+            <a:endParaRPr lang="en-US" sz="1400" dirty="0"/>
+          </a:p>
+        </p:txBody>
+      </p:sp>
       <p:pic>
         <p:nvPicPr>
-          <p:cNvPr id="3" name="geti-models" descr="C:\Users\user\_se4nchoi\batteryvision\docs\submission\build\img\geti_models.png">    </p:cNvPr>
+          <p:cNvPr id="13" name="dup-0" descr="C:\Users\user\_se4nchoi\batteryvision\docs\submission\build\img\dup_test.jpg">    </p:cNvPr>
           <p:cNvPicPr>
             <a:picLocks noChangeAspect="1"/>
           </p:cNvPicPr>
@@ -14112,8 +14927,8 @@
         </p:blipFill>
         <p:spPr>
           <a:xfrm>
-            <a:off x="548640" y="1600200"/>
-            <a:ext cx="4027729" cy="4343400"/>
+            <a:off x="4617720" y="1600200"/>
+            <a:ext cx="3429000" cy="3429000"/>
           </a:xfrm>
           <a:prstGeom prst="rect">
             <a:avLst/>
@@ -14122,18 +14937,18 @@
       </p:pic>
       <p:sp>
         <p:nvSpPr>
-          <p:cNvPr id="4" name="geti-caveat-bg"/>
+          <p:cNvPr id="14" name="dup-l-0-bg"/>
           <p:cNvSpPr/>
           <p:nvPr/>
         </p:nvSpPr>
         <p:spPr>
           <a:xfrm>
-            <a:off x="548640" y="6080760"/>
-            <a:ext cx="4027729" cy="384048"/>
+            <a:off x="4617720" y="5166360"/>
+            <a:ext cx="914400" cy="347472"/>
           </a:xfrm>
           <a:prstGeom prst="roundRect">
             <a:avLst>
-              <a:gd name="adj" fmla="val 11905"/>
+              <a:gd name="adj" fmla="val 13158"/>
             </a:avLst>
           </a:prstGeom>
           <a:solidFill>
@@ -14151,14 +14966,14 @@
       </p:sp>
       <p:sp>
         <p:nvSpPr>
-          <p:cNvPr id="5" name="geti-caveat"/>
+          <p:cNvPr id="15" name="dup-l-0"/>
           <p:cNvSpPr txBox="1"/>
           <p:nvPr/>
         </p:nvSpPr>
         <p:spPr>
           <a:xfrm>
-            <a:off x="548640" y="6080760"/>
-            <a:ext cx="4027729" cy="384048"/>
+            <a:off x="4617720" y="5166360"/>
+            <a:ext cx="914400" cy="347472"/>
           </a:xfrm>
           <a:prstGeom prst="rect">
             <a:avLst/>
@@ -14179,392 +14994,50 @@
                   <a:schemeClr val="accent3"/>
                 </a:solidFill>
               </a:rPr>
-              <a:t>낙관적인 Geti 점수 (증강본이 학습·테스트에 섞임)</a:t>
+              <a:t>테스트</a:t>
             </a:r>
             <a:endParaRPr lang="en-US" sz="1300" dirty="0"/>
           </a:p>
         </p:txBody>
       </p:sp>
-      <p:sp>
-        <p:nvSpPr>
-          <p:cNvPr id="6" name="own-h"/>
-          <p:cNvSpPr txBox="1"/>
-          <p:nvPr/>
-        </p:nvSpPr>
-        <p:spPr>
-          <a:xfrm>
-            <a:off x="4896409" y="1600200"/>
-            <a:ext cx="6746646" cy="320040"/>
-          </a:xfrm>
-          <a:prstGeom prst="rect">
-            <a:avLst/>
-          </a:prstGeom>
-          <a:noFill/>
-          <a:ln/>
-        </p:spPr>
-        <p:txBody>
-          <a:bodyPr wrap="square" lIns="0" tIns="0" rIns="0" bIns="0" rtlCol="0" anchor="t"/>
-          <a:lstStyle/>
-          <a:p>
-            <a:pPr indent="0" marL="0">
-              <a:buNone/>
-            </a:pPr>
-            <a:r>
-              <a:rPr lang="en-US" sz="1600" b="1" dirty="0">
-                <a:solidFill>
-                  <a:schemeClr val="tx1"/>
-                </a:solidFill>
-              </a:rPr>
-              <a:t>직접 측정 · 1차 테스트</a:t>
-            </a:r>
-            <a:endParaRPr lang="en-US" sz="1600" dirty="0"/>
-          </a:p>
-        </p:txBody>
-      </p:sp>
-      <p:sp>
-        <p:nvSpPr>
-          <p:cNvPr id="7" name="own-col-0"/>
-          <p:cNvSpPr txBox="1"/>
-          <p:nvPr/>
-        </p:nvSpPr>
-        <p:spPr>
-          <a:xfrm>
-            <a:off x="7411009" y="2011680"/>
-            <a:ext cx="1600200" cy="274320"/>
-          </a:xfrm>
-          <a:prstGeom prst="rect">
-            <a:avLst/>
-          </a:prstGeom>
-          <a:noFill/>
-          <a:ln/>
-        </p:spPr>
-        <p:txBody>
-          <a:bodyPr wrap="square" lIns="0" tIns="0" rIns="0" bIns="0" rtlCol="0" anchor="t"/>
-          <a:lstStyle/>
-          <a:p>
-            <a:pPr algn="r" indent="0" marL="0">
-              <a:buNone/>
-            </a:pPr>
-            <a:r>
-              <a:rPr lang="en-US" sz="1200" dirty="0">
-                <a:solidFill>
-                  <a:schemeClr val="tx2"/>
-                </a:solidFill>
-              </a:rPr>
-              <a:t>mAP@50</a:t>
-            </a:r>
-            <a:endParaRPr lang="en-US" sz="1200" dirty="0"/>
-          </a:p>
-        </p:txBody>
-      </p:sp>
-      <p:sp>
-        <p:nvSpPr>
-          <p:cNvPr id="8" name="own-col-1"/>
-          <p:cNvSpPr txBox="1"/>
-          <p:nvPr/>
-        </p:nvSpPr>
-        <p:spPr>
-          <a:xfrm>
-            <a:off x="9056929" y="2011680"/>
-            <a:ext cx="1097280" cy="274320"/>
-          </a:xfrm>
-          <a:prstGeom prst="rect">
-            <a:avLst/>
-          </a:prstGeom>
-          <a:noFill/>
-          <a:ln/>
-        </p:spPr>
-        <p:txBody>
-          <a:bodyPr wrap="square" lIns="0" tIns="0" rIns="0" bIns="0" rtlCol="0" anchor="t"/>
-          <a:lstStyle/>
-          <a:p>
-            <a:pPr algn="r" indent="0" marL="0">
-              <a:buNone/>
-            </a:pPr>
-            <a:r>
-              <a:rPr lang="en-US" sz="1200" dirty="0">
-                <a:solidFill>
-                  <a:schemeClr val="tx2"/>
-                </a:solidFill>
-              </a:rPr>
-              <a:t>scratch AP</a:t>
-            </a:r>
-            <a:endParaRPr lang="en-US" sz="1200" dirty="0"/>
-          </a:p>
-        </p:txBody>
-      </p:sp>
-      <p:sp>
-        <p:nvSpPr>
-          <p:cNvPr id="9" name="own-col-2"/>
-          <p:cNvSpPr txBox="1"/>
-          <p:nvPr/>
-        </p:nvSpPr>
-        <p:spPr>
-          <a:xfrm>
-            <a:off x="10154209" y="2011680"/>
-            <a:ext cx="1051560" cy="274320"/>
-          </a:xfrm>
-          <a:prstGeom prst="rect">
-            <a:avLst/>
-          </a:prstGeom>
-          <a:noFill/>
-          <a:ln/>
-        </p:spPr>
-        <p:txBody>
-          <a:bodyPr wrap="square" lIns="0" tIns="0" rIns="0" bIns="0" rtlCol="0" anchor="t"/>
-          <a:lstStyle/>
-          <a:p>
-            <a:pPr algn="r" indent="0" marL="0">
-              <a:buNone/>
-            </a:pPr>
-            <a:r>
-              <a:rPr lang="en-US" sz="1200" dirty="0">
-                <a:solidFill>
-                  <a:schemeClr val="tx2"/>
-                </a:solidFill>
-              </a:rPr>
-              <a:t>2차 세트</a:t>
-            </a:r>
-            <a:endParaRPr lang="en-US" sz="1200" dirty="0"/>
-          </a:p>
-        </p:txBody>
-      </p:sp>
-      <p:sp>
-        <p:nvSpPr>
-          <p:cNvPr id="10" name="own-row-0"/>
+      <p:pic>
+        <p:nvPicPr>
+          <p:cNvPr id="16" name="dup-1" descr="C:\Users\user\_se4nchoi\batteryvision\docs\submission\build\img\dup_train.jpg">    </p:cNvPr>
+          <p:cNvPicPr>
+            <a:picLocks noChangeAspect="1"/>
+          </p:cNvPicPr>
+          <p:nvPr/>
+        </p:nvPicPr>
+        <p:blipFill>
+          <a:blip r:embed="rId2"/>
+          <a:stretch>
+            <a:fillRect/>
+          </a:stretch>
+        </p:blipFill>
+        <p:spPr>
+          <a:xfrm>
+            <a:off x="8183880" y="1600200"/>
+            <a:ext cx="3429000" cy="3429000"/>
+          </a:xfrm>
+          <a:prstGeom prst="rect">
+            <a:avLst/>
+          </a:prstGeom>
+        </p:spPr>
+      </p:pic>
+      <p:sp>
+        <p:nvSpPr>
+          <p:cNvPr id="17" name="dup-l-1-bg"/>
           <p:cNvSpPr/>
           <p:nvPr/>
         </p:nvSpPr>
         <p:spPr>
           <a:xfrm>
-            <a:off x="4896409" y="2377440"/>
-            <a:ext cx="6746646" cy="1051560"/>
+            <a:off x="8183880" y="5166360"/>
+            <a:ext cx="914400" cy="347472"/>
           </a:xfrm>
           <a:prstGeom prst="roundRect">
             <a:avLst>
-              <a:gd name="adj" fmla="val 6957"/>
-            </a:avLst>
-          </a:prstGeom>
-          <a:solidFill>
-            <a:schemeClr val="bg2"/>
-          </a:solidFill>
-          <a:ln/>
-        </p:spPr>
-      </p:sp>
-      <p:sp>
-        <p:nvSpPr>
-          <p:cNvPr id="11" name="own-dot-0"/>
-          <p:cNvSpPr/>
-          <p:nvPr/>
-        </p:nvSpPr>
-        <p:spPr>
-          <a:xfrm>
-            <a:off x="5125009" y="2606040"/>
-            <a:ext cx="146304" cy="146304"/>
-          </a:xfrm>
-          <a:prstGeom prst="ellipse">
-            <a:avLst/>
-          </a:prstGeom>
-          <a:solidFill>
-            <a:schemeClr val="accent4"/>
-          </a:solidFill>
-          <a:ln/>
-        </p:spPr>
-      </p:sp>
-      <p:sp>
-        <p:nvSpPr>
-          <p:cNvPr id="12" name="own-n-0"/>
-          <p:cNvSpPr txBox="1"/>
-          <p:nvPr/>
-        </p:nvSpPr>
-        <p:spPr>
-          <a:xfrm>
-            <a:off x="5353609" y="2514600"/>
-            <a:ext cx="2103120" cy="320040"/>
-          </a:xfrm>
-          <a:prstGeom prst="rect">
-            <a:avLst/>
-          </a:prstGeom>
-          <a:noFill/>
-          <a:ln/>
-        </p:spPr>
-        <p:txBody>
-          <a:bodyPr wrap="square" lIns="0" tIns="0" rIns="0" bIns="0" rtlCol="0" anchor="t"/>
-          <a:lstStyle/>
-          <a:p>
-            <a:pPr indent="0" marL="0">
-              <a:buNone/>
-            </a:pPr>
-            <a:r>
-              <a:rPr lang="en-US" sz="1500" b="1" dirty="0">
-                <a:solidFill>
-                  <a:schemeClr val="tx1"/>
-                </a:solidFill>
-              </a:rPr>
-              <a:t>ATSS-MobileNetV2</a:t>
-            </a:r>
-            <a:endParaRPr lang="en-US" sz="1500" dirty="0"/>
-          </a:p>
-        </p:txBody>
-      </p:sp>
-      <p:sp>
-        <p:nvSpPr>
-          <p:cNvPr id="13" name="own-s-0"/>
-          <p:cNvSpPr txBox="1"/>
-          <p:nvPr/>
-        </p:nvSpPr>
-        <p:spPr>
-          <a:xfrm>
-            <a:off x="5353609" y="2926080"/>
-            <a:ext cx="2103120" cy="274320"/>
-          </a:xfrm>
-          <a:prstGeom prst="rect">
-            <a:avLst/>
-          </a:prstGeom>
-          <a:noFill/>
-          <a:ln/>
-        </p:spPr>
-        <p:txBody>
-          <a:bodyPr wrap="square" lIns="0" tIns="0" rIns="0" bIns="0" rtlCol="0" anchor="t"/>
-          <a:lstStyle/>
-          <a:p>
-            <a:pPr indent="0" marL="0">
-              <a:buNone/>
-            </a:pPr>
-            <a:r>
-              <a:rPr lang="en-US" sz="1200" dirty="0">
-                <a:solidFill>
-                  <a:schemeClr val="tx2"/>
-                </a:solidFill>
-              </a:rPr>
-              <a:t>3.9M · 20.6 GFLOPs</a:t>
-            </a:r>
-            <a:endParaRPr lang="en-US" sz="1200" dirty="0"/>
-          </a:p>
-        </p:txBody>
-      </p:sp>
-      <p:sp>
-        <p:nvSpPr>
-          <p:cNvPr id="14" name="own-m-0"/>
-          <p:cNvSpPr txBox="1"/>
-          <p:nvPr/>
-        </p:nvSpPr>
-        <p:spPr>
-          <a:xfrm>
-            <a:off x="7411009" y="2487168"/>
-            <a:ext cx="1600200" cy="822960"/>
-          </a:xfrm>
-          <a:prstGeom prst="rect">
-            <a:avLst/>
-          </a:prstGeom>
-          <a:noFill/>
-          <a:ln/>
-        </p:spPr>
-        <p:txBody>
-          <a:bodyPr wrap="square" lIns="0" tIns="0" rIns="0" bIns="0" rtlCol="0" anchor="ctr"/>
-          <a:lstStyle/>
-          <a:p>
-            <a:pPr algn="r" indent="0" marL="0">
-              <a:buNone/>
-            </a:pPr>
-            <a:r>
-              <a:rPr lang="en-US" sz="3400" b="1" dirty="0">
-                <a:solidFill>
-                  <a:schemeClr val="accent4"/>
-                </a:solidFill>
-              </a:rPr>
-              <a:t>92.9%</a:t>
-            </a:r>
-            <a:endParaRPr lang="en-US" sz="3400" dirty="0"/>
-          </a:p>
-        </p:txBody>
-      </p:sp>
-      <p:sp>
-        <p:nvSpPr>
-          <p:cNvPr id="15" name="own-a-0"/>
-          <p:cNvSpPr txBox="1"/>
-          <p:nvPr/>
-        </p:nvSpPr>
-        <p:spPr>
-          <a:xfrm>
-            <a:off x="9056929" y="2487168"/>
-            <a:ext cx="1097280" cy="822960"/>
-          </a:xfrm>
-          <a:prstGeom prst="rect">
-            <a:avLst/>
-          </a:prstGeom>
-          <a:noFill/>
-          <a:ln/>
-        </p:spPr>
-        <p:txBody>
-          <a:bodyPr wrap="square" lIns="0" tIns="0" rIns="0" bIns="0" rtlCol="0" anchor="ctr"/>
-          <a:lstStyle/>
-          <a:p>
-            <a:pPr algn="r" indent="0" marL="0">
-              <a:buNone/>
-            </a:pPr>
-            <a:r>
-              <a:rPr lang="en-US" sz="1800" dirty="0">
-                <a:solidFill>
-                  <a:schemeClr val="tx1"/>
-                </a:solidFill>
-              </a:rPr>
-              <a:t>0.86</a:t>
-            </a:r>
-            <a:endParaRPr lang="en-US" sz="1800" dirty="0"/>
-          </a:p>
-        </p:txBody>
-      </p:sp>
-      <p:sp>
-        <p:nvSpPr>
-          <p:cNvPr id="16" name="own-h2-0"/>
-          <p:cNvSpPr txBox="1"/>
-          <p:nvPr/>
-        </p:nvSpPr>
-        <p:spPr>
-          <a:xfrm>
-            <a:off x="10154209" y="2487168"/>
-            <a:ext cx="1051560" cy="822960"/>
-          </a:xfrm>
-          <a:prstGeom prst="rect">
-            <a:avLst/>
-          </a:prstGeom>
-          <a:noFill/>
-          <a:ln/>
-        </p:spPr>
-        <p:txBody>
-          <a:bodyPr wrap="square" lIns="0" tIns="0" rIns="0" bIns="0" rtlCol="0" anchor="ctr"/>
-          <a:lstStyle/>
-          <a:p>
-            <a:pPr algn="r" indent="0" marL="0">
-              <a:buNone/>
-            </a:pPr>
-            <a:r>
-              <a:rPr lang="en-US" sz="1800" b="1" dirty="0">
-                <a:solidFill>
-                  <a:schemeClr val="accent2"/>
-                </a:solidFill>
-              </a:rPr>
-              <a:t>47%</a:t>
-            </a:r>
-            <a:endParaRPr lang="en-US" sz="1800" dirty="0"/>
-          </a:p>
-        </p:txBody>
-      </p:sp>
-      <p:sp>
-        <p:nvSpPr>
-          <p:cNvPr id="17" name="best-badge-bg"/>
-          <p:cNvSpPr/>
-          <p:nvPr/>
-        </p:nvSpPr>
-        <p:spPr>
-          <a:xfrm>
-            <a:off x="6816649" y="2944368"/>
-            <a:ext cx="502920" cy="237744"/>
-          </a:xfrm>
-          <a:prstGeom prst="roundRect">
-            <a:avLst>
-              <a:gd name="adj" fmla="val 19231"/>
+              <a:gd name="adj" fmla="val 13158"/>
             </a:avLst>
           </a:prstGeom>
           <a:solidFill>
@@ -14582,14 +15055,14 @@
       </p:sp>
       <p:sp>
         <p:nvSpPr>
-          <p:cNvPr id="18" name="best-badge"/>
+          <p:cNvPr id="18" name="dup-l-1"/>
           <p:cNvSpPr txBox="1"/>
           <p:nvPr/>
         </p:nvSpPr>
         <p:spPr>
           <a:xfrm>
-            <a:off x="6816649" y="2944368"/>
-            <a:ext cx="502920" cy="237744"/>
+            <a:off x="8183880" y="5166360"/>
+            <a:ext cx="914400" cy="347472"/>
           </a:xfrm>
           <a:prstGeom prst="rect">
             <a:avLst/>
@@ -14610,7 +15083,7 @@
                   <a:schemeClr val="accent1"/>
                 </a:solidFill>
               </a:rPr>
-              <a:t>best</a:t>
+              <a:t>학습</a:t>
             </a:r>
             <a:endParaRPr lang="en-US" sz="1300" dirty="0"/>
           </a:p>
@@ -14618,56 +15091,14 @@
       </p:sp>
       <p:sp>
         <p:nvSpPr>
-          <p:cNvPr id="19" name="own-row-1"/>
-          <p:cNvSpPr/>
-          <p:nvPr/>
-        </p:nvSpPr>
-        <p:spPr>
-          <a:xfrm>
-            <a:off x="4896409" y="3566160"/>
-            <a:ext cx="6746646" cy="1051560"/>
-          </a:xfrm>
-          <a:prstGeom prst="roundRect">
-            <a:avLst>
-              <a:gd name="adj" fmla="val 6957"/>
-            </a:avLst>
-          </a:prstGeom>
-          <a:solidFill>
-            <a:schemeClr val="bg2"/>
-          </a:solidFill>
-          <a:ln/>
-        </p:spPr>
-      </p:sp>
-      <p:sp>
-        <p:nvSpPr>
-          <p:cNvPr id="20" name="own-dot-1"/>
-          <p:cNvSpPr/>
-          <p:nvPr/>
-        </p:nvSpPr>
-        <p:spPr>
-          <a:xfrm>
-            <a:off x="5125009" y="3794760"/>
-            <a:ext cx="146304" cy="146304"/>
-          </a:xfrm>
-          <a:prstGeom prst="ellipse">
-            <a:avLst/>
-          </a:prstGeom>
-          <a:solidFill>
-            <a:schemeClr val="accent5"/>
-          </a:solidFill>
-          <a:ln/>
-        </p:spPr>
-      </p:sp>
-      <p:sp>
-        <p:nvSpPr>
-          <p:cNvPr id="21" name="own-n-1"/>
+          <p:cNvPr id="19" name="dup-cap"/>
           <p:cNvSpPr txBox="1"/>
           <p:nvPr/>
         </p:nvSpPr>
         <p:spPr>
           <a:xfrm>
-            <a:off x="5353609" y="3703320"/>
-            <a:ext cx="2103120" cy="320040"/>
+            <a:off x="9144000" y="5166360"/>
+            <a:ext cx="2468880" cy="347472"/>
           </a:xfrm>
           <a:prstGeom prst="rect">
             <a:avLst/>
@@ -14676,46 +15107,10 @@
           <a:ln/>
         </p:spPr>
         <p:txBody>
-          <a:bodyPr wrap="square" lIns="0" tIns="0" rIns="0" bIns="0" rtlCol="0" anchor="t"/>
+          <a:bodyPr wrap="square" lIns="0" tIns="0" rIns="0" bIns="0" rtlCol="0" anchor="ctr"/>
           <a:lstStyle/>
           <a:p>
-            <a:pPr indent="0" marL="0">
-              <a:buNone/>
-            </a:pPr>
-            <a:r>
-              <a:rPr lang="en-US" sz="1500" b="1" dirty="0">
-                <a:solidFill>
-                  <a:schemeClr val="tx1"/>
-                </a:solidFill>
-              </a:rPr>
-              <a:t>YOLOX-S</a:t>
-            </a:r>
-            <a:endParaRPr lang="en-US" sz="1500" dirty="0"/>
-          </a:p>
-        </p:txBody>
-      </p:sp>
-      <p:sp>
-        <p:nvSpPr>
-          <p:cNvPr id="22" name="own-s-1"/>
-          <p:cNvSpPr txBox="1"/>
-          <p:nvPr/>
-        </p:nvSpPr>
-        <p:spPr>
-          <a:xfrm>
-            <a:off x="5353609" y="4114800"/>
-            <a:ext cx="2103120" cy="274320"/>
-          </a:xfrm>
-          <a:prstGeom prst="rect">
-            <a:avLst/>
-          </a:prstGeom>
-          <a:noFill/>
-          <a:ln/>
-        </p:spPr>
-        <p:txBody>
-          <a:bodyPr wrap="square" lIns="0" tIns="0" rIns="0" bIns="0" rtlCol="0" anchor="t"/>
-          <a:lstStyle/>
-          <a:p>
-            <a:pPr indent="0" marL="0">
+            <a:pPr algn="r" indent="0" marL="0">
               <a:buNone/>
             </a:pPr>
             <a:r>
@@ -14724,404 +15119,9 @@
                   <a:schemeClr val="tx2"/>
                 </a:solidFill>
               </a:rPr>
-              <a:t>9M · 26.8 GFLOPs</a:t>
+              <a:t>dHash 거리 4 / 256</a:t>
             </a:r>
             <a:endParaRPr lang="en-US" sz="1200" dirty="0"/>
-          </a:p>
-        </p:txBody>
-      </p:sp>
-      <p:sp>
-        <p:nvSpPr>
-          <p:cNvPr id="23" name="own-m-1"/>
-          <p:cNvSpPr txBox="1"/>
-          <p:nvPr/>
-        </p:nvSpPr>
-        <p:spPr>
-          <a:xfrm>
-            <a:off x="7411009" y="3675888"/>
-            <a:ext cx="1600200" cy="822960"/>
-          </a:xfrm>
-          <a:prstGeom prst="rect">
-            <a:avLst/>
-          </a:prstGeom>
-          <a:noFill/>
-          <a:ln/>
-        </p:spPr>
-        <p:txBody>
-          <a:bodyPr wrap="square" lIns="0" tIns="0" rIns="0" bIns="0" rtlCol="0" anchor="ctr"/>
-          <a:lstStyle/>
-          <a:p>
-            <a:pPr algn="r" indent="0" marL="0">
-              <a:buNone/>
-            </a:pPr>
-            <a:r>
-              <a:rPr lang="en-US" sz="3400" b="1" dirty="0">
-                <a:solidFill>
-                  <a:schemeClr val="accent5"/>
-                </a:solidFill>
-              </a:rPr>
-              <a:t>89.2%</a:t>
-            </a:r>
-            <a:endParaRPr lang="en-US" sz="3400" dirty="0"/>
-          </a:p>
-        </p:txBody>
-      </p:sp>
-      <p:sp>
-        <p:nvSpPr>
-          <p:cNvPr id="24" name="own-a-1"/>
-          <p:cNvSpPr txBox="1"/>
-          <p:nvPr/>
-        </p:nvSpPr>
-        <p:spPr>
-          <a:xfrm>
-            <a:off x="9056929" y="3675888"/>
-            <a:ext cx="1097280" cy="822960"/>
-          </a:xfrm>
-          <a:prstGeom prst="rect">
-            <a:avLst/>
-          </a:prstGeom>
-          <a:noFill/>
-          <a:ln/>
-        </p:spPr>
-        <p:txBody>
-          <a:bodyPr wrap="square" lIns="0" tIns="0" rIns="0" bIns="0" rtlCol="0" anchor="ctr"/>
-          <a:lstStyle/>
-          <a:p>
-            <a:pPr algn="r" indent="0" marL="0">
-              <a:buNone/>
-            </a:pPr>
-            <a:r>
-              <a:rPr lang="en-US" sz="1800" dirty="0">
-                <a:solidFill>
-                  <a:schemeClr val="tx1"/>
-                </a:solidFill>
-              </a:rPr>
-              <a:t>0.78</a:t>
-            </a:r>
-            <a:endParaRPr lang="en-US" sz="1800" dirty="0"/>
-          </a:p>
-        </p:txBody>
-      </p:sp>
-      <p:sp>
-        <p:nvSpPr>
-          <p:cNvPr id="25" name="own-h2-1"/>
-          <p:cNvSpPr txBox="1"/>
-          <p:nvPr/>
-        </p:nvSpPr>
-        <p:spPr>
-          <a:xfrm>
-            <a:off x="10154209" y="3675888"/>
-            <a:ext cx="1051560" cy="822960"/>
-          </a:xfrm>
-          <a:prstGeom prst="rect">
-            <a:avLst/>
-          </a:prstGeom>
-          <a:noFill/>
-          <a:ln/>
-        </p:spPr>
-        <p:txBody>
-          <a:bodyPr wrap="square" lIns="0" tIns="0" rIns="0" bIns="0" rtlCol="0" anchor="ctr"/>
-          <a:lstStyle/>
-          <a:p>
-            <a:pPr algn="r" indent="0" marL="0">
-              <a:buNone/>
-            </a:pPr>
-            <a:r>
-              <a:rPr lang="en-US" sz="1800" b="1" dirty="0">
-                <a:solidFill>
-                  <a:schemeClr val="accent2"/>
-                </a:solidFill>
-              </a:rPr>
-              <a:t>3%</a:t>
-            </a:r>
-            <a:endParaRPr lang="en-US" sz="1800" dirty="0"/>
-          </a:p>
-        </p:txBody>
-      </p:sp>
-      <p:sp>
-        <p:nvSpPr>
-          <p:cNvPr id="26" name="own-row-2"/>
-          <p:cNvSpPr/>
-          <p:nvPr/>
-        </p:nvSpPr>
-        <p:spPr>
-          <a:xfrm>
-            <a:off x="4896409" y="4754880"/>
-            <a:ext cx="6746646" cy="1051560"/>
-          </a:xfrm>
-          <a:prstGeom prst="roundRect">
-            <a:avLst>
-              <a:gd name="adj" fmla="val 6957"/>
-            </a:avLst>
-          </a:prstGeom>
-          <a:solidFill>
-            <a:schemeClr val="bg2"/>
-          </a:solidFill>
-          <a:ln/>
-        </p:spPr>
-      </p:sp>
-      <p:sp>
-        <p:nvSpPr>
-          <p:cNvPr id="27" name="own-dot-2"/>
-          <p:cNvSpPr/>
-          <p:nvPr/>
-        </p:nvSpPr>
-        <p:spPr>
-          <a:xfrm>
-            <a:off x="5125009" y="4983480"/>
-            <a:ext cx="146304" cy="146304"/>
-          </a:xfrm>
-          <a:prstGeom prst="ellipse">
-            <a:avLst/>
-          </a:prstGeom>
-          <a:solidFill>
-            <a:schemeClr val="accent6"/>
-          </a:solidFill>
-          <a:ln/>
-        </p:spPr>
-      </p:sp>
-      <p:sp>
-        <p:nvSpPr>
-          <p:cNvPr id="28" name="own-n-2"/>
-          <p:cNvSpPr txBox="1"/>
-          <p:nvPr/>
-        </p:nvSpPr>
-        <p:spPr>
-          <a:xfrm>
-            <a:off x="5353609" y="4892040"/>
-            <a:ext cx="2103120" cy="320040"/>
-          </a:xfrm>
-          <a:prstGeom prst="rect">
-            <a:avLst/>
-          </a:prstGeom>
-          <a:noFill/>
-          <a:ln/>
-        </p:spPr>
-        <p:txBody>
-          <a:bodyPr wrap="square" lIns="0" tIns="0" rIns="0" bIns="0" rtlCol="0" anchor="t"/>
-          <a:lstStyle/>
-          <a:p>
-            <a:pPr indent="0" marL="0">
-              <a:buNone/>
-            </a:pPr>
-            <a:r>
-              <a:rPr lang="en-US" sz="1500" b="1" dirty="0">
-                <a:solidFill>
-                  <a:schemeClr val="tx1"/>
-                </a:solidFill>
-              </a:rPr>
-              <a:t>YOLOX-Tiny</a:t>
-            </a:r>
-            <a:endParaRPr lang="en-US" sz="1500" dirty="0"/>
-          </a:p>
-        </p:txBody>
-      </p:sp>
-      <p:sp>
-        <p:nvSpPr>
-          <p:cNvPr id="29" name="own-s-2"/>
-          <p:cNvSpPr txBox="1"/>
-          <p:nvPr/>
-        </p:nvSpPr>
-        <p:spPr>
-          <a:xfrm>
-            <a:off x="5353609" y="5303520"/>
-            <a:ext cx="2103120" cy="274320"/>
-          </a:xfrm>
-          <a:prstGeom prst="rect">
-            <a:avLst/>
-          </a:prstGeom>
-          <a:noFill/>
-          <a:ln/>
-        </p:spPr>
-        <p:txBody>
-          <a:bodyPr wrap="square" lIns="0" tIns="0" rIns="0" bIns="0" rtlCol="0" anchor="t"/>
-          <a:lstStyle/>
-          <a:p>
-            <a:pPr indent="0" marL="0">
-              <a:buNone/>
-            </a:pPr>
-            <a:r>
-              <a:rPr lang="en-US" sz="1200" dirty="0">
-                <a:solidFill>
-                  <a:schemeClr val="tx2"/>
-                </a:solidFill>
-              </a:rPr>
-              <a:t>5.06M · 6.45 GFLOPs</a:t>
-            </a:r>
-            <a:endParaRPr lang="en-US" sz="1200" dirty="0"/>
-          </a:p>
-        </p:txBody>
-      </p:sp>
-      <p:sp>
-        <p:nvSpPr>
-          <p:cNvPr id="30" name="own-m-2"/>
-          <p:cNvSpPr txBox="1"/>
-          <p:nvPr/>
-        </p:nvSpPr>
-        <p:spPr>
-          <a:xfrm>
-            <a:off x="7411009" y="4864608"/>
-            <a:ext cx="1600200" cy="822960"/>
-          </a:xfrm>
-          <a:prstGeom prst="rect">
-            <a:avLst/>
-          </a:prstGeom>
-          <a:noFill/>
-          <a:ln/>
-        </p:spPr>
-        <p:txBody>
-          <a:bodyPr wrap="square" lIns="0" tIns="0" rIns="0" bIns="0" rtlCol="0" anchor="ctr"/>
-          <a:lstStyle/>
-          <a:p>
-            <a:pPr algn="r" indent="0" marL="0">
-              <a:buNone/>
-            </a:pPr>
-            <a:r>
-              <a:rPr lang="en-US" sz="3400" b="1" dirty="0">
-                <a:solidFill>
-                  <a:schemeClr val="accent6"/>
-                </a:solidFill>
-              </a:rPr>
-              <a:t>83.2%</a:t>
-            </a:r>
-            <a:endParaRPr lang="en-US" sz="3400" dirty="0"/>
-          </a:p>
-        </p:txBody>
-      </p:sp>
-      <p:sp>
-        <p:nvSpPr>
-          <p:cNvPr id="31" name="own-a-2"/>
-          <p:cNvSpPr txBox="1"/>
-          <p:nvPr/>
-        </p:nvSpPr>
-        <p:spPr>
-          <a:xfrm>
-            <a:off x="9056929" y="4864608"/>
-            <a:ext cx="1097280" cy="822960"/>
-          </a:xfrm>
-          <a:prstGeom prst="rect">
-            <a:avLst/>
-          </a:prstGeom>
-          <a:noFill/>
-          <a:ln/>
-        </p:spPr>
-        <p:txBody>
-          <a:bodyPr wrap="square" lIns="0" tIns="0" rIns="0" bIns="0" rtlCol="0" anchor="ctr"/>
-          <a:lstStyle/>
-          <a:p>
-            <a:pPr algn="r" indent="0" marL="0">
-              <a:buNone/>
-            </a:pPr>
-            <a:r>
-              <a:rPr lang="en-US" sz="1800" dirty="0">
-                <a:solidFill>
-                  <a:schemeClr val="tx1"/>
-                </a:solidFill>
-              </a:rPr>
-              <a:t>0.66</a:t>
-            </a:r>
-            <a:endParaRPr lang="en-US" sz="1800" dirty="0"/>
-          </a:p>
-        </p:txBody>
-      </p:sp>
-      <p:sp>
-        <p:nvSpPr>
-          <p:cNvPr id="32" name="own-h2-2"/>
-          <p:cNvSpPr txBox="1"/>
-          <p:nvPr/>
-        </p:nvSpPr>
-        <p:spPr>
-          <a:xfrm>
-            <a:off x="10154209" y="4864608"/>
-            <a:ext cx="1051560" cy="822960"/>
-          </a:xfrm>
-          <a:prstGeom prst="rect">
-            <a:avLst/>
-          </a:prstGeom>
-          <a:noFill/>
-          <a:ln/>
-        </p:spPr>
-        <p:txBody>
-          <a:bodyPr wrap="square" lIns="0" tIns="0" rIns="0" bIns="0" rtlCol="0" anchor="ctr"/>
-          <a:lstStyle/>
-          <a:p>
-            <a:pPr algn="r" indent="0" marL="0">
-              <a:buNone/>
-            </a:pPr>
-            <a:r>
-              <a:rPr lang="en-US" sz="1800" b="1" dirty="0">
-                <a:solidFill>
-                  <a:schemeClr val="accent2"/>
-                </a:solidFill>
-              </a:rPr>
-              <a:t>47%</a:t>
-            </a:r>
-            <a:endParaRPr lang="en-US" sz="1800" dirty="0"/>
-          </a:p>
-        </p:txBody>
-      </p:sp>
-      <p:sp>
-        <p:nvSpPr>
-          <p:cNvPr id="33" name="own-note-bg"/>
-          <p:cNvSpPr/>
-          <p:nvPr/>
-        </p:nvSpPr>
-        <p:spPr>
-          <a:xfrm>
-            <a:off x="4896409" y="5943600"/>
-            <a:ext cx="6746646" cy="384048"/>
-          </a:xfrm>
-          <a:prstGeom prst="roundRect">
-            <a:avLst>
-              <a:gd name="adj" fmla="val 11905"/>
-            </a:avLst>
-          </a:prstGeom>
-          <a:solidFill>
-            <a:schemeClr val="accent1">
-              <a:alpha val="20000"/>
-            </a:schemeClr>
-          </a:solidFill>
-          <a:ln w="12700">
-            <a:solidFill>
-              <a:schemeClr val="accent1"/>
-            </a:solidFill>
-            <a:prstDash val="solid"/>
-          </a:ln>
-        </p:spPr>
-      </p:sp>
-      <p:sp>
-        <p:nvSpPr>
-          <p:cNvPr id="34" name="own-note"/>
-          <p:cNvSpPr txBox="1"/>
-          <p:nvPr/>
-        </p:nvSpPr>
-        <p:spPr>
-          <a:xfrm>
-            <a:off x="4896409" y="5943600"/>
-            <a:ext cx="6746646" cy="384048"/>
-          </a:xfrm>
-          <a:prstGeom prst="rect">
-            <a:avLst/>
-          </a:prstGeom>
-          <a:noFill/>
-          <a:ln/>
-        </p:spPr>
-        <p:txBody>
-          <a:bodyPr wrap="square" lIns="0" tIns="0" rIns="0" bIns="0" rtlCol="0" anchor="ctr"/>
-          <a:lstStyle/>
-          <a:p>
-            <a:pPr algn="ctr" indent="0" marL="0">
-              <a:buNone/>
-            </a:pPr>
-            <a:r>
-              <a:rPr lang="en-US" sz="1300" b="1" dirty="0">
-                <a:solidFill>
-                  <a:schemeClr val="accent1"/>
-                </a:solidFill>
-              </a:rPr>
-              <a:t>32px 미만 박스 AP: ATSS 0.86 · YOLOX-S 0.80</a:t>
-            </a:r>
-            <a:endParaRPr lang="en-US" sz="1300" dirty="0"/>
           </a:p>
         </p:txBody>
       </p:sp>
@@ -17743,20 +17743,104 @@
           </a:p>
         </p:txBody>
       </p:sp>
-      <p:sp>
-        <p:nvSpPr>
-          <p:cNvPr id="3" name="flow-0-bg"/>
+      <p:pic>
+        <p:nvPicPr>
+          <p:cNvPr id="3" name="bench-detail" descr="C:\Users\user\_se4nchoi\batteryvision\docs\submission\build\img\bench_detail.png">    </p:cNvPr>
+          <p:cNvPicPr>
+            <a:picLocks noChangeAspect="1"/>
+          </p:cNvPicPr>
+          <p:nvPr/>
+        </p:nvPicPr>
+        <p:blipFill>
+          <a:blip r:embed="rId1"/>
+          <a:stretch>
+            <a:fillRect/>
+          </a:stretch>
+        </p:blipFill>
+        <p:spPr>
+          <a:xfrm>
+            <a:off x="548640" y="1508760"/>
+            <a:ext cx="6080760" cy="2921731"/>
+          </a:xfrm>
+          <a:prstGeom prst="rect">
+            <a:avLst/>
+          </a:prstGeom>
+        </p:spPr>
+      </p:pic>
+      <p:pic>
+        <p:nvPicPr>
+          <p:cNvPr id="4" name="bench-all" descr="C:\Users\user\_se4nchoi\batteryvision\docs\submission\build\img\bench_all.png">    </p:cNvPr>
+          <p:cNvPicPr>
+            <a:picLocks noChangeAspect="1"/>
+          </p:cNvPicPr>
+          <p:nvPr/>
+        </p:nvPicPr>
+        <p:blipFill>
+          <a:blip r:embed="rId2"/>
+          <a:stretch>
+            <a:fillRect/>
+          </a:stretch>
+        </p:blipFill>
+        <p:spPr>
+          <a:xfrm>
+            <a:off x="548640" y="4521931"/>
+            <a:ext cx="6080760" cy="1786923"/>
+          </a:xfrm>
+          <a:prstGeom prst="rect">
+            <a:avLst/>
+          </a:prstGeom>
+        </p:spPr>
+      </p:pic>
+      <p:sp>
+        <p:nvSpPr>
+          <p:cNvPr id="5" name="bm-h"/>
+          <p:cNvSpPr txBox="1"/>
+          <p:nvPr/>
+        </p:nvSpPr>
+        <p:spPr>
+          <a:xfrm>
+            <a:off x="6949440" y="1508760"/>
+            <a:ext cx="4693615" cy="365760"/>
+          </a:xfrm>
+          <a:prstGeom prst="rect">
+            <a:avLst/>
+          </a:prstGeom>
+          <a:noFill/>
+          <a:ln/>
+        </p:spPr>
+        <p:txBody>
+          <a:bodyPr wrap="square" lIns="0" tIns="0" rIns="0" bIns="0" rtlCol="0" anchor="t"/>
+          <a:lstStyle/>
+          <a:p>
+            <a:pPr indent="0" marL="0">
+              <a:buNone/>
+            </a:pPr>
+            <a:r>
+              <a:rPr lang="en-US" sz="1800" b="1" dirty="0">
+                <a:solidFill>
+                  <a:schemeClr val="accent3"/>
+                </a:solidFill>
+              </a:rPr>
+              <a:t>benchmark.py</a:t>
+            </a:r>
+            <a:endParaRPr lang="en-US" sz="1800" dirty="0"/>
+          </a:p>
+        </p:txBody>
+      </p:sp>
+      <p:sp>
+        <p:nvSpPr>
+          <p:cNvPr id="6" name="flow-0-bg"/>
           <p:cNvSpPr/>
           <p:nvPr/>
         </p:nvSpPr>
         <p:spPr>
           <a:xfrm>
-            <a:off x="548640" y="1600200"/>
-            <a:ext cx="2423160" cy="502920"/>
+            <a:off x="6949440" y="2011680"/>
+            <a:ext cx="4693615" cy="365760"/>
           </a:xfrm>
           <a:prstGeom prst="roundRect">
             <a:avLst>
-              <a:gd name="adj" fmla="val 9091"/>
+              <a:gd name="adj" fmla="val 12500"/>
             </a:avLst>
           </a:prstGeom>
           <a:solidFill>
@@ -17774,14 +17858,14 @@
       </p:sp>
       <p:sp>
         <p:nvSpPr>
-          <p:cNvPr id="4" name="flow-0"/>
+          <p:cNvPr id="7" name="flow-0"/>
           <p:cNvSpPr txBox="1"/>
           <p:nvPr/>
         </p:nvSpPr>
         <p:spPr>
           <a:xfrm>
-            <a:off x="548640" y="1600200"/>
-            <a:ext cx="2423160" cy="502920"/>
+            <a:off x="6949440" y="2011680"/>
+            <a:ext cx="4693615" cy="365760"/>
           </a:xfrm>
           <a:prstGeom prst="rect">
             <a:avLst/>
@@ -17810,54 +17894,18 @@
       </p:sp>
       <p:sp>
         <p:nvSpPr>
-          <p:cNvPr id="5" name="flow-arrow-0"/>
-          <p:cNvSpPr txBox="1"/>
-          <p:nvPr/>
-        </p:nvSpPr>
-        <p:spPr>
-          <a:xfrm>
-            <a:off x="2971800" y="1600200"/>
-            <a:ext cx="429768" cy="502920"/>
-          </a:xfrm>
-          <a:prstGeom prst="rect">
-            <a:avLst/>
-          </a:prstGeom>
-          <a:noFill/>
-          <a:ln/>
-        </p:spPr>
-        <p:txBody>
-          <a:bodyPr wrap="square" lIns="0" tIns="0" rIns="0" bIns="0" rtlCol="0" anchor="ctr"/>
-          <a:lstStyle/>
-          <a:p>
-            <a:pPr algn="ctr" indent="0" marL="0">
-              <a:buNone/>
-            </a:pPr>
-            <a:r>
-              <a:rPr lang="en-US" sz="2000" b="1" dirty="0">
-                <a:solidFill>
-                  <a:schemeClr val="tx2"/>
-                </a:solidFill>
-              </a:rPr>
-              <a:t>→</a:t>
-            </a:r>
-            <a:endParaRPr lang="en-US" sz="2000" dirty="0"/>
-          </a:p>
-        </p:txBody>
-      </p:sp>
-      <p:sp>
-        <p:nvSpPr>
-          <p:cNvPr id="6" name="flow-1-bg"/>
+          <p:cNvPr id="8" name="flow-1-bg"/>
           <p:cNvSpPr/>
           <p:nvPr/>
         </p:nvSpPr>
         <p:spPr>
           <a:xfrm>
-            <a:off x="3401568" y="1600200"/>
-            <a:ext cx="2423160" cy="502920"/>
+            <a:off x="6949440" y="2468880"/>
+            <a:ext cx="4693615" cy="365760"/>
           </a:xfrm>
           <a:prstGeom prst="roundRect">
             <a:avLst>
-              <a:gd name="adj" fmla="val 9091"/>
+              <a:gd name="adj" fmla="val 12500"/>
             </a:avLst>
           </a:prstGeom>
           <a:solidFill>
@@ -17875,14 +17923,14 @@
       </p:sp>
       <p:sp>
         <p:nvSpPr>
-          <p:cNvPr id="7" name="flow-1"/>
+          <p:cNvPr id="9" name="flow-1"/>
           <p:cNvSpPr txBox="1"/>
           <p:nvPr/>
         </p:nvSpPr>
         <p:spPr>
           <a:xfrm>
-            <a:off x="3401568" y="1600200"/>
-            <a:ext cx="2423160" cy="502920"/>
+            <a:off x="6949440" y="2468880"/>
+            <a:ext cx="4693615" cy="365760"/>
           </a:xfrm>
           <a:prstGeom prst="rect">
             <a:avLst/>
@@ -17911,155 +17959,18 @@
       </p:sp>
       <p:sp>
         <p:nvSpPr>
-          <p:cNvPr id="8" name="flow-arrow-1"/>
-          <p:cNvSpPr txBox="1"/>
-          <p:nvPr/>
-        </p:nvSpPr>
-        <p:spPr>
-          <a:xfrm>
-            <a:off x="5824728" y="1600200"/>
-            <a:ext cx="429768" cy="502920"/>
-          </a:xfrm>
-          <a:prstGeom prst="rect">
-            <a:avLst/>
-          </a:prstGeom>
-          <a:noFill/>
-          <a:ln/>
-        </p:spPr>
-        <p:txBody>
-          <a:bodyPr wrap="square" lIns="0" tIns="0" rIns="0" bIns="0" rtlCol="0" anchor="ctr"/>
-          <a:lstStyle/>
-          <a:p>
-            <a:pPr algn="ctr" indent="0" marL="0">
-              <a:buNone/>
-            </a:pPr>
-            <a:r>
-              <a:rPr lang="en-US" sz="2000" b="1" dirty="0">
-                <a:solidFill>
-                  <a:schemeClr val="tx2"/>
-                </a:solidFill>
-              </a:rPr>
-              <a:t>→</a:t>
-            </a:r>
-            <a:endParaRPr lang="en-US" sz="2000" dirty="0"/>
-          </a:p>
-        </p:txBody>
-      </p:sp>
-      <p:sp>
-        <p:nvSpPr>
-          <p:cNvPr id="9" name="flow-2-bg"/>
+          <p:cNvPr id="10" name="flow-2-bg"/>
           <p:cNvSpPr/>
           <p:nvPr/>
         </p:nvSpPr>
         <p:spPr>
           <a:xfrm>
-            <a:off x="6254496" y="1600200"/>
-            <a:ext cx="2423160" cy="502920"/>
+            <a:off x="6949440" y="2926080"/>
+            <a:ext cx="4693615" cy="365760"/>
           </a:xfrm>
           <a:prstGeom prst="roundRect">
             <a:avLst>
-              <a:gd name="adj" fmla="val 9091"/>
-            </a:avLst>
-          </a:prstGeom>
-          <a:solidFill>
-            <a:schemeClr val="accent3">
-              <a:alpha val="20000"/>
-            </a:schemeClr>
-          </a:solidFill>
-          <a:ln w="12700">
-            <a:solidFill>
-              <a:schemeClr val="accent3"/>
-            </a:solidFill>
-            <a:prstDash val="solid"/>
-          </a:ln>
-        </p:spPr>
-      </p:sp>
-      <p:sp>
-        <p:nvSpPr>
-          <p:cNvPr id="10" name="flow-2"/>
-          <p:cNvSpPr txBox="1"/>
-          <p:nvPr/>
-        </p:nvSpPr>
-        <p:spPr>
-          <a:xfrm>
-            <a:off x="6254496" y="1600200"/>
-            <a:ext cx="2423160" cy="502920"/>
-          </a:xfrm>
-          <a:prstGeom prst="rect">
-            <a:avLst/>
-          </a:prstGeom>
-          <a:noFill/>
-          <a:ln/>
-        </p:spPr>
-        <p:txBody>
-          <a:bodyPr wrap="square" lIns="0" tIns="0" rIns="0" bIns="0" rtlCol="0" anchor="ctr"/>
-          <a:lstStyle/>
-          <a:p>
-            <a:pPr algn="ctr" indent="0" marL="0">
-              <a:buNone/>
-            </a:pPr>
-            <a:r>
-              <a:rPr lang="en-US" sz="1300" b="1" dirty="0">
-                <a:solidFill>
-                  <a:schemeClr val="accent3"/>
-                </a:solidFill>
-              </a:rPr>
-              <a:t>benchmark.py</a:t>
-            </a:r>
-            <a:endParaRPr lang="en-US" sz="1300" dirty="0"/>
-          </a:p>
-        </p:txBody>
-      </p:sp>
-      <p:sp>
-        <p:nvSpPr>
-          <p:cNvPr id="11" name="flow-arrow-2"/>
-          <p:cNvSpPr txBox="1"/>
-          <p:nvPr/>
-        </p:nvSpPr>
-        <p:spPr>
-          <a:xfrm>
-            <a:off x="8677656" y="1600200"/>
-            <a:ext cx="429768" cy="502920"/>
-          </a:xfrm>
-          <a:prstGeom prst="rect">
-            <a:avLst/>
-          </a:prstGeom>
-          <a:noFill/>
-          <a:ln/>
-        </p:spPr>
-        <p:txBody>
-          <a:bodyPr wrap="square" lIns="0" tIns="0" rIns="0" bIns="0" rtlCol="0" anchor="ctr"/>
-          <a:lstStyle/>
-          <a:p>
-            <a:pPr algn="ctr" indent="0" marL="0">
-              <a:buNone/>
-            </a:pPr>
-            <a:r>
-              <a:rPr lang="en-US" sz="2000" b="1" dirty="0">
-                <a:solidFill>
-                  <a:schemeClr val="tx2"/>
-                </a:solidFill>
-              </a:rPr>
-              <a:t>→</a:t>
-            </a:r>
-            <a:endParaRPr lang="en-US" sz="2000" dirty="0"/>
-          </a:p>
-        </p:txBody>
-      </p:sp>
-      <p:sp>
-        <p:nvSpPr>
-          <p:cNvPr id="12" name="flow-3-bg"/>
-          <p:cNvSpPr/>
-          <p:nvPr/>
-        </p:nvSpPr>
-        <p:spPr>
-          <a:xfrm>
-            <a:off x="9107424" y="1600200"/>
-            <a:ext cx="2423160" cy="502920"/>
-          </a:xfrm>
-          <a:prstGeom prst="roundRect">
-            <a:avLst>
-              <a:gd name="adj" fmla="val 9091"/>
+              <a:gd name="adj" fmla="val 12500"/>
             </a:avLst>
           </a:prstGeom>
           <a:solidFill>
@@ -18077,14 +17988,14 @@
       </p:sp>
       <p:sp>
         <p:nvSpPr>
-          <p:cNvPr id="13" name="flow-3"/>
+          <p:cNvPr id="11" name="flow-2"/>
           <p:cNvSpPr txBox="1"/>
           <p:nvPr/>
         </p:nvSpPr>
         <p:spPr>
           <a:xfrm>
-            <a:off x="9107424" y="1600200"/>
-            <a:ext cx="2423160" cy="502920"/>
+            <a:off x="6949440" y="2926080"/>
+            <a:ext cx="4693615" cy="365760"/>
           </a:xfrm>
           <a:prstGeom prst="rect">
             <a:avLst/>
@@ -18105,7 +18016,7 @@
                   <a:schemeClr val="accent6"/>
                 </a:solidFill>
               </a:rPr>
-              <a:t>결과 JSON → 대시보드</a:t>
+              <a:t>결과 → 대시보드</a:t>
             </a:r>
             <a:endParaRPr lang="en-US" sz="1300" dirty="0"/>
           </a:p>
@@ -18113,36 +18024,14 @@
       </p:sp>
       <p:sp>
         <p:nvSpPr>
-          <p:cNvPr id="14" name="bm-0"/>
-          <p:cNvSpPr/>
-          <p:nvPr/>
-        </p:nvSpPr>
-        <p:spPr>
-          <a:xfrm>
-            <a:off x="548640" y="2423160"/>
-            <a:ext cx="3566160" cy="1783080"/>
-          </a:xfrm>
-          <a:prstGeom prst="roundRect">
-            <a:avLst>
-              <a:gd name="adj" fmla="val 4103"/>
-            </a:avLst>
-          </a:prstGeom>
-          <a:solidFill>
-            <a:schemeClr val="bg2"/>
-          </a:solidFill>
-          <a:ln/>
-        </p:spPr>
-      </p:sp>
-      <p:sp>
-        <p:nvSpPr>
-          <p:cNvPr id="15" name="bm-h-0"/>
+          <p:cNvPr id="12" name="bm-m-h"/>
           <p:cNvSpPr txBox="1"/>
           <p:nvPr/>
         </p:nvSpPr>
         <p:spPr>
           <a:xfrm>
-            <a:off x="822960" y="2697480"/>
-            <a:ext cx="3017520" cy="457200"/>
+            <a:off x="6949440" y="3474720"/>
+            <a:ext cx="4693615" cy="320040"/>
           </a:xfrm>
           <a:prstGeom prst="rect">
             <a:avLst/>
@@ -18158,27 +18047,63 @@
               <a:buNone/>
             </a:pPr>
             <a:r>
-              <a:rPr lang="en-US" sz="2200" b="1" dirty="0">
+              <a:rPr lang="en-US" sz="1600" b="1" dirty="0">
+                <a:solidFill>
+                  <a:schemeClr val="tx1"/>
+                </a:solidFill>
+              </a:rPr>
+              <a:t>측정</a:t>
+            </a:r>
+            <a:endParaRPr lang="en-US" sz="1600" dirty="0"/>
+          </a:p>
+        </p:txBody>
+      </p:sp>
+      <p:sp>
+        <p:nvSpPr>
+          <p:cNvPr id="13" name="bm-k-0"/>
+          <p:cNvSpPr txBox="1"/>
+          <p:nvPr/>
+        </p:nvSpPr>
+        <p:spPr>
+          <a:xfrm>
+            <a:off x="6949440" y="3886200"/>
+            <a:ext cx="1508760" cy="347472"/>
+          </a:xfrm>
+          <a:prstGeom prst="rect">
+            <a:avLst/>
+          </a:prstGeom>
+          <a:noFill/>
+          <a:ln/>
+        </p:spPr>
+        <p:txBody>
+          <a:bodyPr wrap="square" lIns="0" tIns="0" rIns="0" bIns="0" rtlCol="0" anchor="ctr"/>
+          <a:lstStyle/>
+          <a:p>
+            <a:pPr indent="0" marL="0">
+              <a:buNone/>
+            </a:pPr>
+            <a:r>
+              <a:rPr lang="en-US" sz="1400" b="1" dirty="0">
                 <a:solidFill>
                   <a:schemeClr val="accent4"/>
                 </a:solidFill>
               </a:rPr>
               <a:t>정확도</a:t>
             </a:r>
-            <a:endParaRPr lang="en-US" sz="2200" dirty="0"/>
-          </a:p>
-        </p:txBody>
-      </p:sp>
-      <p:sp>
-        <p:nvSpPr>
-          <p:cNvPr id="16" name="bm-d-0"/>
+            <a:endParaRPr lang="en-US" sz="1400" dirty="0"/>
+          </a:p>
+        </p:txBody>
+      </p:sp>
+      <p:sp>
+        <p:nvSpPr>
+          <p:cNvPr id="14" name="bm-v-0"/>
           <p:cNvSpPr txBox="1"/>
           <p:nvPr/>
         </p:nvSpPr>
         <p:spPr>
           <a:xfrm>
-            <a:off x="822960" y="3337560"/>
-            <a:ext cx="3017520" cy="548640"/>
+            <a:off x="8503920" y="3886200"/>
+            <a:ext cx="3139135" cy="347472"/>
           </a:xfrm>
           <a:prstGeom prst="rect">
             <a:avLst/>
@@ -18187,56 +18112,34 @@
           <a:ln/>
         </p:spPr>
         <p:txBody>
-          <a:bodyPr wrap="square" lIns="0" tIns="0" rIns="0" bIns="0" rtlCol="0" anchor="t"/>
+          <a:bodyPr wrap="square" lIns="0" tIns="0" rIns="0" bIns="0" rtlCol="0" anchor="ctr"/>
           <a:lstStyle/>
           <a:p>
             <a:pPr indent="0" marL="0">
               <a:buNone/>
             </a:pPr>
             <a:r>
-              <a:rPr lang="en-US" sz="1500" dirty="0">
+              <a:rPr lang="en-US" sz="1400" dirty="0">
                 <a:solidFill>
                   <a:schemeClr val="tx2"/>
                 </a:solidFill>
               </a:rPr>
-              <a:t>mAP@50 · 클래스별 AP</a:t>
+              <a:t>mAP · 클래스별 AP</a:t>
             </a:r>
-            <a:endParaRPr lang="en-US" sz="1500" dirty="0"/>
-          </a:p>
-        </p:txBody>
-      </p:sp>
-      <p:sp>
-        <p:nvSpPr>
-          <p:cNvPr id="17" name="bm-1"/>
-          <p:cNvSpPr/>
-          <p:nvPr/>
-        </p:nvSpPr>
-        <p:spPr>
-          <a:xfrm>
-            <a:off x="4297680" y="2423160"/>
-            <a:ext cx="3566160" cy="1783080"/>
-          </a:xfrm>
-          <a:prstGeom prst="roundRect">
-            <a:avLst>
-              <a:gd name="adj" fmla="val 4103"/>
-            </a:avLst>
-          </a:prstGeom>
-          <a:solidFill>
-            <a:schemeClr val="bg2"/>
-          </a:solidFill>
-          <a:ln/>
-        </p:spPr>
-      </p:sp>
-      <p:sp>
-        <p:nvSpPr>
-          <p:cNvPr id="18" name="bm-h-1"/>
+            <a:endParaRPr lang="en-US" sz="1400" dirty="0"/>
+          </a:p>
+        </p:txBody>
+      </p:sp>
+      <p:sp>
+        <p:nvSpPr>
+          <p:cNvPr id="15" name="bm-k-1"/>
           <p:cNvSpPr txBox="1"/>
           <p:nvPr/>
         </p:nvSpPr>
         <p:spPr>
           <a:xfrm>
-            <a:off x="4572000" y="2697480"/>
-            <a:ext cx="3017520" cy="457200"/>
+            <a:off x="6949440" y="4288536"/>
+            <a:ext cx="1508760" cy="347472"/>
           </a:xfrm>
           <a:prstGeom prst="rect">
             <a:avLst/>
@@ -18245,34 +18148,34 @@
           <a:ln/>
         </p:spPr>
         <p:txBody>
-          <a:bodyPr wrap="square" lIns="0" tIns="0" rIns="0" bIns="0" rtlCol="0" anchor="t"/>
+          <a:bodyPr wrap="square" lIns="0" tIns="0" rIns="0" bIns="0" rtlCol="0" anchor="ctr"/>
           <a:lstStyle/>
           <a:p>
             <a:pPr indent="0" marL="0">
               <a:buNone/>
             </a:pPr>
             <a:r>
-              <a:rPr lang="en-US" sz="2200" b="1" dirty="0">
+              <a:rPr lang="en-US" sz="1400" b="1" dirty="0">
                 <a:solidFill>
                   <a:schemeClr val="accent2"/>
                 </a:solidFill>
               </a:rPr>
               <a:t>판정</a:t>
             </a:r>
-            <a:endParaRPr lang="en-US" sz="2200" dirty="0"/>
-          </a:p>
-        </p:txBody>
-      </p:sp>
-      <p:sp>
-        <p:nvSpPr>
-          <p:cNvPr id="19" name="bm-d-1"/>
+            <a:endParaRPr lang="en-US" sz="1400" dirty="0"/>
+          </a:p>
+        </p:txBody>
+      </p:sp>
+      <p:sp>
+        <p:nvSpPr>
+          <p:cNvPr id="16" name="bm-v-1"/>
           <p:cNvSpPr txBox="1"/>
           <p:nvPr/>
         </p:nvSpPr>
         <p:spPr>
           <a:xfrm>
-            <a:off x="4572000" y="3337560"/>
-            <a:ext cx="3017520" cy="548640"/>
+            <a:off x="8503920" y="4288536"/>
+            <a:ext cx="3139135" cy="347472"/>
           </a:xfrm>
           <a:prstGeom prst="rect">
             <a:avLst/>
@@ -18281,56 +18184,34 @@
           <a:ln/>
         </p:spPr>
         <p:txBody>
-          <a:bodyPr wrap="square" lIns="0" tIns="0" rIns="0" bIns="0" rtlCol="0" anchor="t"/>
+          <a:bodyPr wrap="square" lIns="0" tIns="0" rIns="0" bIns="0" rtlCol="0" anchor="ctr"/>
           <a:lstStyle/>
           <a:p>
             <a:pPr indent="0" marL="0">
               <a:buNone/>
             </a:pPr>
             <a:r>
-              <a:rPr lang="en-US" sz="1500" dirty="0">
+              <a:rPr lang="en-US" sz="1400" dirty="0">
                 <a:solidFill>
                   <a:schemeClr val="tx2"/>
                 </a:solidFill>
               </a:rPr>
-              <a:t>PASS · REVIEW · REJECT · 놓친 셀</a:t>
+              <a:t>PASS · REVIEW · REJECT</a:t>
             </a:r>
-            <a:endParaRPr lang="en-US" sz="1500" dirty="0"/>
-          </a:p>
-        </p:txBody>
-      </p:sp>
-      <p:sp>
-        <p:nvSpPr>
-          <p:cNvPr id="20" name="bm-2"/>
-          <p:cNvSpPr/>
-          <p:nvPr/>
-        </p:nvSpPr>
-        <p:spPr>
-          <a:xfrm>
-            <a:off x="8046720" y="2423160"/>
-            <a:ext cx="3566160" cy="1783080"/>
-          </a:xfrm>
-          <a:prstGeom prst="roundRect">
-            <a:avLst>
-              <a:gd name="adj" fmla="val 4103"/>
-            </a:avLst>
-          </a:prstGeom>
-          <a:solidFill>
-            <a:schemeClr val="bg2"/>
-          </a:solidFill>
-          <a:ln/>
-        </p:spPr>
-      </p:sp>
-      <p:sp>
-        <p:nvSpPr>
-          <p:cNvPr id="21" name="bm-h-2"/>
+            <a:endParaRPr lang="en-US" sz="1400" dirty="0"/>
+          </a:p>
+        </p:txBody>
+      </p:sp>
+      <p:sp>
+        <p:nvSpPr>
+          <p:cNvPr id="17" name="bm-k-2"/>
           <p:cNvSpPr txBox="1"/>
           <p:nvPr/>
         </p:nvSpPr>
         <p:spPr>
           <a:xfrm>
-            <a:off x="8321040" y="2697480"/>
-            <a:ext cx="3017520" cy="457200"/>
+            <a:off x="6949440" y="4690872"/>
+            <a:ext cx="1508760" cy="347472"/>
           </a:xfrm>
           <a:prstGeom prst="rect">
             <a:avLst/>
@@ -18339,34 +18220,34 @@
           <a:ln/>
         </p:spPr>
         <p:txBody>
-          <a:bodyPr wrap="square" lIns="0" tIns="0" rIns="0" bIns="0" rtlCol="0" anchor="t"/>
+          <a:bodyPr wrap="square" lIns="0" tIns="0" rIns="0" bIns="0" rtlCol="0" anchor="ctr"/>
           <a:lstStyle/>
           <a:p>
             <a:pPr indent="0" marL="0">
               <a:buNone/>
             </a:pPr>
             <a:r>
-              <a:rPr lang="en-US" sz="2200" b="1" dirty="0">
+              <a:rPr lang="en-US" sz="1400" b="1" dirty="0">
                 <a:solidFill>
                   <a:schemeClr val="accent3"/>
                 </a:solidFill>
               </a:rPr>
               <a:t>기준값 sweep</a:t>
             </a:r>
-            <a:endParaRPr lang="en-US" sz="2200" dirty="0"/>
-          </a:p>
-        </p:txBody>
-      </p:sp>
-      <p:sp>
-        <p:nvSpPr>
-          <p:cNvPr id="22" name="bm-d-2"/>
+            <a:endParaRPr lang="en-US" sz="1400" dirty="0"/>
+          </a:p>
+        </p:txBody>
+      </p:sp>
+      <p:sp>
+        <p:nvSpPr>
+          <p:cNvPr id="18" name="bm-v-2"/>
           <p:cNvSpPr txBox="1"/>
           <p:nvPr/>
         </p:nvSpPr>
         <p:spPr>
           <a:xfrm>
-            <a:off x="8321040" y="3337560"/>
-            <a:ext cx="3017520" cy="548640"/>
+            <a:off x="8503920" y="4690872"/>
+            <a:ext cx="3139135" cy="347472"/>
           </a:xfrm>
           <a:prstGeom prst="rect">
             <a:avLst/>
@@ -18375,56 +18256,34 @@
           <a:ln/>
         </p:spPr>
         <p:txBody>
-          <a:bodyPr wrap="square" lIns="0" tIns="0" rIns="0" bIns="0" rtlCol="0" anchor="t"/>
+          <a:bodyPr wrap="square" lIns="0" tIns="0" rIns="0" bIns="0" rtlCol="0" anchor="ctr"/>
           <a:lstStyle/>
           <a:p>
             <a:pPr indent="0" marL="0">
               <a:buNone/>
             </a:pPr>
             <a:r>
-              <a:rPr lang="en-US" sz="1500" dirty="0">
+              <a:rPr lang="en-US" sz="1400" dirty="0">
                 <a:solidFill>
                   <a:schemeClr val="tx2"/>
                 </a:solidFill>
               </a:rPr>
               <a:t>0.05 ~ 0.95</a:t>
             </a:r>
-            <a:endParaRPr lang="en-US" sz="1500" dirty="0"/>
-          </a:p>
-        </p:txBody>
-      </p:sp>
-      <p:sp>
-        <p:nvSpPr>
-          <p:cNvPr id="23" name="bm-3"/>
-          <p:cNvSpPr/>
-          <p:nvPr/>
-        </p:nvSpPr>
-        <p:spPr>
-          <a:xfrm>
-            <a:off x="548640" y="4389120"/>
-            <a:ext cx="3566160" cy="1783080"/>
-          </a:xfrm>
-          <a:prstGeom prst="roundRect">
-            <a:avLst>
-              <a:gd name="adj" fmla="val 4103"/>
-            </a:avLst>
-          </a:prstGeom>
-          <a:solidFill>
-            <a:schemeClr val="bg2"/>
-          </a:solidFill>
-          <a:ln/>
-        </p:spPr>
-      </p:sp>
-      <p:sp>
-        <p:nvSpPr>
-          <p:cNvPr id="24" name="bm-h-3"/>
+            <a:endParaRPr lang="en-US" sz="1400" dirty="0"/>
+          </a:p>
+        </p:txBody>
+      </p:sp>
+      <p:sp>
+        <p:nvSpPr>
+          <p:cNvPr id="19" name="bm-k-3"/>
           <p:cNvSpPr txBox="1"/>
           <p:nvPr/>
         </p:nvSpPr>
         <p:spPr>
           <a:xfrm>
-            <a:off x="822960" y="4663440"/>
-            <a:ext cx="3017520" cy="457200"/>
+            <a:off x="6949440" y="5093208"/>
+            <a:ext cx="1508760" cy="347472"/>
           </a:xfrm>
           <a:prstGeom prst="rect">
             <a:avLst/>
@@ -18433,34 +18292,34 @@
           <a:ln/>
         </p:spPr>
         <p:txBody>
-          <a:bodyPr wrap="square" lIns="0" tIns="0" rIns="0" bIns="0" rtlCol="0" anchor="t"/>
+          <a:bodyPr wrap="square" lIns="0" tIns="0" rIns="0" bIns="0" rtlCol="0" anchor="ctr"/>
           <a:lstStyle/>
           <a:p>
             <a:pPr indent="0" marL="0">
               <a:buNone/>
             </a:pPr>
             <a:r>
-              <a:rPr lang="en-US" sz="2200" b="1" dirty="0">
+              <a:rPr lang="en-US" sz="1400" b="1" dirty="0">
                 <a:solidFill>
                   <a:schemeClr val="accent5"/>
                 </a:solidFill>
               </a:rPr>
               <a:t>견고성</a:t>
             </a:r>
-            <a:endParaRPr lang="en-US" sz="2200" dirty="0"/>
-          </a:p>
-        </p:txBody>
-      </p:sp>
-      <p:sp>
-        <p:nvSpPr>
-          <p:cNvPr id="25" name="bm-d-3"/>
+            <a:endParaRPr lang="en-US" sz="1400" dirty="0"/>
+          </a:p>
+        </p:txBody>
+      </p:sp>
+      <p:sp>
+        <p:nvSpPr>
+          <p:cNvPr id="20" name="bm-v-3"/>
           <p:cNvSpPr txBox="1"/>
           <p:nvPr/>
         </p:nvSpPr>
         <p:spPr>
           <a:xfrm>
-            <a:off x="822960" y="5303520"/>
-            <a:ext cx="3017520" cy="548640"/>
+            <a:off x="8503920" y="5093208"/>
+            <a:ext cx="3139135" cy="347472"/>
           </a:xfrm>
           <a:prstGeom prst="rect">
             <a:avLst/>
@@ -18469,56 +18328,34 @@
           <a:ln/>
         </p:spPr>
         <p:txBody>
-          <a:bodyPr wrap="square" lIns="0" tIns="0" rIns="0" bIns="0" rtlCol="0" anchor="t"/>
+          <a:bodyPr wrap="square" lIns="0" tIns="0" rIns="0" bIns="0" rtlCol="0" anchor="ctr"/>
           <a:lstStyle/>
           <a:p>
             <a:pPr indent="0" marL="0">
               <a:buNone/>
             </a:pPr>
             <a:r>
-              <a:rPr lang="en-US" sz="1500" dirty="0">
+              <a:rPr lang="en-US" sz="1400" dirty="0">
                 <a:solidFill>
                   <a:schemeClr val="tx2"/>
                 </a:solidFill>
               </a:rPr>
-              <a:t>blur · 어둡게 · 노이즈 · JPEG</a:t>
+              <a:t>blur · 노이즈 · JPEG</a:t>
             </a:r>
-            <a:endParaRPr lang="en-US" sz="1500" dirty="0"/>
-          </a:p>
-        </p:txBody>
-      </p:sp>
-      <p:sp>
-        <p:nvSpPr>
-          <p:cNvPr id="26" name="bm-4"/>
-          <p:cNvSpPr/>
-          <p:nvPr/>
-        </p:nvSpPr>
-        <p:spPr>
-          <a:xfrm>
-            <a:off x="4297680" y="4389120"/>
-            <a:ext cx="3566160" cy="1783080"/>
-          </a:xfrm>
-          <a:prstGeom prst="roundRect">
-            <a:avLst>
-              <a:gd name="adj" fmla="val 4103"/>
-            </a:avLst>
-          </a:prstGeom>
-          <a:solidFill>
-            <a:schemeClr val="bg2"/>
-          </a:solidFill>
-          <a:ln/>
-        </p:spPr>
-      </p:sp>
-      <p:sp>
-        <p:nvSpPr>
-          <p:cNvPr id="27" name="bm-h-4"/>
+            <a:endParaRPr lang="en-US" sz="1400" dirty="0"/>
+          </a:p>
+        </p:txBody>
+      </p:sp>
+      <p:sp>
+        <p:nvSpPr>
+          <p:cNvPr id="21" name="bm-k-4"/>
           <p:cNvSpPr txBox="1"/>
           <p:nvPr/>
         </p:nvSpPr>
         <p:spPr>
           <a:xfrm>
-            <a:off x="4572000" y="4663440"/>
-            <a:ext cx="3017520" cy="457200"/>
+            <a:off x="6949440" y="5495544"/>
+            <a:ext cx="1508760" cy="347472"/>
           </a:xfrm>
           <a:prstGeom prst="rect">
             <a:avLst/>
@@ -18527,34 +18364,34 @@
           <a:ln/>
         </p:spPr>
         <p:txBody>
-          <a:bodyPr wrap="square" lIns="0" tIns="0" rIns="0" bIns="0" rtlCol="0" anchor="t"/>
+          <a:bodyPr wrap="square" lIns="0" tIns="0" rIns="0" bIns="0" rtlCol="0" anchor="ctr"/>
           <a:lstStyle/>
           <a:p>
             <a:pPr indent="0" marL="0">
               <a:buNone/>
             </a:pPr>
             <a:r>
-              <a:rPr lang="en-US" sz="2200" b="1" dirty="0">
+              <a:rPr lang="en-US" sz="1400" b="1" dirty="0">
                 <a:solidFill>
                   <a:schemeClr val="accent3"/>
                 </a:solidFill>
               </a:rPr>
               <a:t>중복 검사</a:t>
             </a:r>
-            <a:endParaRPr lang="en-US" sz="2200" dirty="0"/>
-          </a:p>
-        </p:txBody>
-      </p:sp>
-      <p:sp>
-        <p:nvSpPr>
-          <p:cNvPr id="28" name="bm-d-4"/>
+            <a:endParaRPr lang="en-US" sz="1400" dirty="0"/>
+          </a:p>
+        </p:txBody>
+      </p:sp>
+      <p:sp>
+        <p:nvSpPr>
+          <p:cNvPr id="22" name="bm-v-4"/>
           <p:cNvSpPr txBox="1"/>
           <p:nvPr/>
         </p:nvSpPr>
         <p:spPr>
           <a:xfrm>
-            <a:off x="4572000" y="5303520"/>
-            <a:ext cx="3017520" cy="548640"/>
+            <a:off x="8503920" y="5495544"/>
+            <a:ext cx="3139135" cy="347472"/>
           </a:xfrm>
           <a:prstGeom prst="rect">
             <a:avLst/>
@@ -18563,56 +18400,34 @@
           <a:ln/>
         </p:spPr>
         <p:txBody>
-          <a:bodyPr wrap="square" lIns="0" tIns="0" rIns="0" bIns="0" rtlCol="0" anchor="t"/>
+          <a:bodyPr wrap="square" lIns="0" tIns="0" rIns="0" bIns="0" rtlCol="0" anchor="ctr"/>
           <a:lstStyle/>
           <a:p>
             <a:pPr indent="0" marL="0">
               <a:buNone/>
             </a:pPr>
             <a:r>
-              <a:rPr lang="en-US" sz="1500" dirty="0">
+              <a:rPr lang="en-US" sz="1400" dirty="0">
                 <a:solidFill>
                   <a:schemeClr val="tx2"/>
                 </a:solidFill>
               </a:rPr>
-              <a:t>dHash → 복사본 22장 발견</a:t>
+              <a:t>복사본 22장 발견</a:t>
             </a:r>
-            <a:endParaRPr lang="en-US" sz="1500" dirty="0"/>
-          </a:p>
-        </p:txBody>
-      </p:sp>
-      <p:sp>
-        <p:nvSpPr>
-          <p:cNvPr id="29" name="bm-5"/>
-          <p:cNvSpPr/>
-          <p:nvPr/>
-        </p:nvSpPr>
-        <p:spPr>
-          <a:xfrm>
-            <a:off x="8046720" y="4389120"/>
-            <a:ext cx="3566160" cy="1783080"/>
-          </a:xfrm>
-          <a:prstGeom prst="roundRect">
-            <a:avLst>
-              <a:gd name="adj" fmla="val 4103"/>
-            </a:avLst>
-          </a:prstGeom>
-          <a:solidFill>
-            <a:schemeClr val="bg2"/>
-          </a:solidFill>
-          <a:ln/>
-        </p:spPr>
-      </p:sp>
-      <p:sp>
-        <p:nvSpPr>
-          <p:cNvPr id="30" name="bm-h-5"/>
+            <a:endParaRPr lang="en-US" sz="1400" dirty="0"/>
+          </a:p>
+        </p:txBody>
+      </p:sp>
+      <p:sp>
+        <p:nvSpPr>
+          <p:cNvPr id="23" name="bm-k-5"/>
           <p:cNvSpPr txBox="1"/>
           <p:nvPr/>
         </p:nvSpPr>
         <p:spPr>
           <a:xfrm>
-            <a:off x="8321040" y="4663440"/>
-            <a:ext cx="3017520" cy="457200"/>
+            <a:off x="6949440" y="5897880"/>
+            <a:ext cx="1508760" cy="347472"/>
           </a:xfrm>
           <a:prstGeom prst="rect">
             <a:avLst/>
@@ -18621,34 +18436,34 @@
           <a:ln/>
         </p:spPr>
         <p:txBody>
-          <a:bodyPr wrap="square" lIns="0" tIns="0" rIns="0" bIns="0" rtlCol="0" anchor="t"/>
+          <a:bodyPr wrap="square" lIns="0" tIns="0" rIns="0" bIns="0" rtlCol="0" anchor="ctr"/>
           <a:lstStyle/>
           <a:p>
             <a:pPr indent="0" marL="0">
               <a:buNone/>
             </a:pPr>
             <a:r>
-              <a:rPr lang="en-US" sz="2200" b="1" dirty="0">
+              <a:rPr lang="en-US" sz="1400" b="1" dirty="0">
                 <a:solidFill>
                   <a:schemeClr val="accent6"/>
                 </a:solidFill>
               </a:rPr>
               <a:t>속도</a:t>
             </a:r>
-            <a:endParaRPr lang="en-US" sz="2200" dirty="0"/>
-          </a:p>
-        </p:txBody>
-      </p:sp>
-      <p:sp>
-        <p:nvSpPr>
-          <p:cNvPr id="31" name="bm-d-5"/>
+            <a:endParaRPr lang="en-US" sz="1400" dirty="0"/>
+          </a:p>
+        </p:txBody>
+      </p:sp>
+      <p:sp>
+        <p:nvSpPr>
+          <p:cNvPr id="24" name="bm-v-5"/>
           <p:cNvSpPr txBox="1"/>
           <p:nvPr/>
         </p:nvSpPr>
         <p:spPr>
           <a:xfrm>
-            <a:off x="8321040" y="5303520"/>
-            <a:ext cx="3017520" cy="548640"/>
+            <a:off x="8503920" y="5897880"/>
+            <a:ext cx="3139135" cy="347472"/>
           </a:xfrm>
           <a:prstGeom prst="rect">
             <a:avLst/>
@@ -18657,21 +18472,21 @@
           <a:ln/>
         </p:spPr>
         <p:txBody>
-          <a:bodyPr wrap="square" lIns="0" tIns="0" rIns="0" bIns="0" rtlCol="0" anchor="t"/>
+          <a:bodyPr wrap="square" lIns="0" tIns="0" rIns="0" bIns="0" rtlCol="0" anchor="ctr"/>
           <a:lstStyle/>
           <a:p>
             <a:pPr indent="0" marL="0">
               <a:buNone/>
             </a:pPr>
             <a:r>
-              <a:rPr lang="en-US" sz="1500" dirty="0">
+              <a:rPr lang="en-US" sz="1400" dirty="0">
                 <a:solidFill>
                   <a:schemeClr val="tx2"/>
                 </a:solidFill>
               </a:rPr>
-              <a:t>CPU · iGPU · 사진 1장씩</a:t>
+              <a:t>CPU · iGPU</a:t>
             </a:r>
-            <a:endParaRPr lang="en-US" sz="1500" dirty="0"/>
+            <a:endParaRPr lang="en-US" sz="1400" dirty="0"/>
           </a:p>
         </p:txBody>
       </p:sp>

</xml_diff>